<commit_message>
Fixes 1-6: remove rather-than contrasts, correct forward references, Meridian case study in Unit 4 facilitator file, Unit 12 force numbering, widen rule 13 check; rebuild decks
</commit_message>
<xml_diff>
--- a/Unit decks/Unit 01 - Behavioural Strategy Fundamentals.pptx
+++ b/Unit decks/Unit 01 - Behavioural Strategy Fundamentals.pptx
@@ -739,7 +739,7 @@
 Ask first, before opening the content: “Think of the last major strategic decision your team made. Was the final call driven more by instinct or deliberate analysis?” Take 2–3 responses. This primes the System 1 / System 2 distinction before it appears on screen.
 Content:
 To understand this internal hidden thinking architecture, the dual-process framework developed by Nobel laureate Daniel Kahneman provides a powerful framework for understanding how strategic thinking unfolds in practice.
-Kahneman’s dual-process framework reveals that strategic thinking is a dynamic interaction between two internal systems rather than a single linear path. System 1 provides fast, pattern-based intuition, while System 2 offers the slow effortful analysis required for complexity.
+Kahneman’s dual-process framework reveals that strategic thinking is a dynamic interaction between two internal systems. System 1 provides fast, pattern-based intuition, while System 2 offers the slow effortful analysis required for complexity.
 For those with a mandate for strategy management, the ability to recognise which system is dominant is the difference between a reactive impulse and a disciplined well thought through choice.
 SYSTEM 1 — Fast Thinking (automatic, intuitive, emotionally driven): operates below conscious awareness; draws on pattern recognition and past experience; produces rapid, confident judgements; vulnerable to cognitive biases; dominant in high-pressure strategy sessions.
 In practice: The gut feeling a leader has about a market opportunity — formed in seconds from years of experience.
@@ -1160,7 +1160,7 @@
               <a:rPr lang="en-US" dirty="0"/>
               <a:t>2.4 · GROUP DEBRIEF
 Group debrief: After individual exploration, go around the group and ask each person to name one bias and one organisational signal they recognised. Build a live picture of the group’s collective blind spots.
-Watch for (facilitation caution): Participants may want to name other people’s biases rather than their own. Gently redirect: “We’re here to understand the patterns so we can design better processes.”
+Watch for (facilitation caution): Participants may drift towards naming other people’s biases. Gently redirect: “We’re here to understand the patterns so we can design better processes.”
 Key point to close on: Emphasise that biases are predictable patterns that show up in processes. The goal is making them visible so they can be managed deliberately. This framing reduces defensiveness and opens engagement.
 FAMILY 3 · INTEREST BIASES
 Self-Interest Bias: Favouring options that protect personal exposure or advantage.
@@ -1184,16 +1184,16 @@
   Warning signs: Strategy meetings have limited open debate; decisions appear unanimous; Dissenting views are rarely documented in board or committee minutes; Post-decision, everyone claims to have agreed from the start.
 Authority Bias: Deferring excessively to senior leaders or experts regardless of data.
   Strategic impact: Causes organisations to defer to senior leaders or renowned experts without sufficient scrutiny, even when evidence contradicts their views; Milgram's (1963) obedience research and Cialdini's authority principle both demonstrate its power in institutional settings.
-  Warning signs: Analysis is routinely shaped to match leadership expectations; 'The CEO thinks...' closes debate rather than opening it; External experts' recommendations are adopted with minimal internal scrutiny.
+  Warning signs: Analysis is routinely shaped to match leadership expectations; 'The CEO thinks...' closes debate; External experts' recommendations are adopted with minimal internal scrutiny.
 Groupthink: Prioritising group harmony over critical, objective evaluation.
   Strategic impact: Produces poorly examined strategic choices made in pursuit of harmony; eliminates productive conflict needed for rigorous strategy development; Janis (1972) documented groupthink in high-stakes decisions, noting that cohesive teams are most vulnerable.
   Warning signs: Strategy decisions consistently appear unanimous; structured dissent is absent; Internal critics or whistleblowers are marginalised; Post-mortems reveal concerns that were privately held but never voiced during planning.
 Availability Bias (Social): Giving undue weight to opinions voiced most confidently or frequently.
-  Strategic impact: Causes strategy to be disproportionately shaped by the most recent, vivid, or loudly advocated examples rather than systematic evidence; Elevates anecdote over data — Tversky &amp; Kahneman (1973) showed availability of recall drives perceived probability.
+  Strategic impact: Causes strategy to be disproportionately shaped by the most recent, vivid, or loudly advocated examples, with systematic evidence sidelined; Elevates anecdote over data — Tversky &amp; Kahneman (1973) showed availability of recall drives perceived probability.
   Warning signs: Strategy discussions reference the same handful of case studies repeatedly; Recent events have outsized influence on strategic direction; Quieter but more analytically rigorous voices are consistently overlooked.
 Halo Effect: Allowing a person's reputation or status to influence judgement beyond the evidence.
   Strategic impact: Leads organisations to over-rely on high-reputation leaders, advisors, or partner firms, reducing scrutiny of their strategic recommendations; Past success in one domain is assumed to transfer to unrelated ones — Rosenzweig's The Halo Effect (2007) demonstrates this in corporate strategy research.
-  Warning signs: Decisions linked to high-profile executives or consultancies receive materially less challenge; Board oversight of star performers is lighter than for others; Failures associated with admired leaders are attributed to external factors rather than judgement.
+  Warning signs: Decisions linked to high-profile executives or consultancies receive materially less challenge; Board oversight of star performers is lighter than for others; Failures associated with admired leaders are attributed to external factors, leaving judgement unexamined.
 Key sources: Kahneman &amp; Tversky (1974, 1979) · Kahneman (2011) · Janis (1972) · Thaler (1980) · Christensen (1997) · Rosenzweig (2007) · McKinsey Quarterly (2010) · Edmondson (1999) · Asch (1951) · Jensen &amp; Meckling (1976) · Page (2007) · Kerr (1975)
 Participant reflection (participant file, 2.4): “Which of the four bias families resonates most strongly with you personally? Which do you recognise most clearly in your organisation’s culture? What is one specific way this bias has shaped a strategic decision recently?”
 Transition: move to Section 3 · Intelligence — Why.</a:t>
@@ -1683,7 +1683,7 @@
               <a:t>KEY LEARNING OUTCOMES (identical in the participant and facilitator files)
 1. Critically examine the influence of human judgement and organisational dynamics on strategic decision-making.
 2. Recognise the behavioural conditions that strengthen or weaken objectivity, decision quality and organisational performance.
-3. Interpret strategic issues from an integrated enterprise perspective rather than from a single functional position.
+3. Interpret strategic issues from an integrated enterprise perspective.
 Each section slide carries that section’s two learning outcomes.</a:t>
             </a:r>
             <a:endParaRPr lang="en-US" dirty="0"/>
@@ -1985,8 +1985,8 @@
 Ask (Phase 1 — Diagnosis): “Is your current strategic diagnosis based on data you deliberately sought — or data that happened to be available?”
 PHASE 2 · OPTION GENERATION — Solution space narrowed before debate
 This phase should be the most generative in the strategy process. It is where imagination, expertise, and creative tension produce the range of paths from which a choice will eventually be made. In practice, it is often the most constrained. The constraint is the invisible narrowing that happens before options are ever formally tabled — through social dynamics, professional filters, and unspoken norms about what is realistic to propose.
-- Status Quo Bias is the most pervasive. The current strategy naturally pulls thinking toward what already exists. Instead of exploring bold or different options, teams tend to make small adjustments to the current approach.
-- Functional and Silo Bias means that options tend to be generated within organisational lanes rather than across them. The genuinely transformative options — those that require cross-functional integration and new ways of working — are structurally disadvantaged in the generation process.
+- Status Quo Bias is the most pervasive. The current strategy naturally pulls thinking toward what already exists. Teams tend to make small adjustments to the current approach and leave bold or different options unexplored.
+- Functional and Silo Bias means that options tend to be generated inside each organisational lane. The genuinely transformative options — those that require cross-functional integration and new ways of working — are structurally disadvantaged in the generation process.
 - Career-Risk Bias is perhaps the most damaging and least visible. Leaders and their teams have a well-developed instinct for what it is safe to propose. Radical options carry personal risk for the people who advocate them. So they do not get advocated. They may not even get thought.
 - Groupthink and Conformity Bias operate in the room itself. Once a dominant view begins to form — even loosely — the social pressure to align with it grows. Dissenting options require social courage as well as intellectual effort. In most rooms, courage is in shorter supply than intelligence.
 The options that reach a decision are the options that survived a social and professional filter that operated before the formal process began.
@@ -2200,7 +2200,7 @@
 The Strategic Outcome: Strategic Paralysis: Strategy is reduced to incrementalism. Leaders favour “safe” bets to avoid the personal cost of failure.
 Impact on Thinking Architecture: System 1 Hijack: The brain is in “threat mode.” Dissent is viewed as dangerous, triggering Conformity and Career-Risk Biases.
 NARCISSISM-DOMINATED
-The Emotional Driver: Ego &amp; Grandiosity: The strategy serves as a monument to the leader’s identity rather than a response to the market.
+The Emotional Driver: Ego &amp; Grandiosity: The strategy serves as a monument to the leader’s identity, detached from the market.
 The Strategic Outcome: Strategic Delusion: Grandiose plans are launched with zero operational grounding. “Vision” is treated as infallible, overriding data.
 Impact on Thinking Architecture: Validation Loop: System 2 is used exclusively to justify the leader’s Overconfidence and Illusion of Control. Confirmation Bias is institutionalised.
 GROUNDED CONFIDENCE
@@ -2398,7 +2398,7 @@
               <a:rPr lang="en-US" dirty="0"/>
               <a:t>4.4 · DEBIASING PRINCIPLES FOR STRATEGY MANAGEMENT
 Time: 10–12 minutes.
-Say (framing the section): “Awareness is not enough. The goal is to change how we design our strategy processes.” This is where the unit becomes actionable.
+Say (framing the section): “The goal now is to change how we design our strategy processes.” This is where the unit becomes actionable.
 Content: Awareness alone does not change outcomes. Without deliberate intervention, the same biases will continue to shape strategic conversations and decisions.
 What matters is how strategy processes are designed — who speaks, how options are generated, how challenge is introduced, and how decisions are tested. These design choices determine whether thinking becomes clearer or more distorted.
 The principles below — adopted from the works of Kahneman, Lovallo, Sibony, Huy, Lencioni, and Edmondson — provide practical ways to strengthen the quality of the strategy management process:
@@ -2406,8 +2406,8 @@
 2. Name the emotional temperature before the strategic content. At the start of any critical conversation — strategy, performance, or course correction — surface the emotional state in the room. A simple question such as “What emotions are people bringing into this discussion that might affect how we think?” helps shift the group from reactive thinking to deliberate engagement. This strengthens focus, reduces hidden tension, and enables more honest dialogue.
 3. Assign a designated challenger role. In all high-stakes decisions, including strategy formulation, assign a rotating challenger role. The responsibility is to test assumptions, question prevailing views, and present credible alternatives. This ensures decisions are pressure-tested before and during execution, reducing the risk of blind spots and unchallenged momentum.
 4. Use pre-mortem analysis as standard practice. Apply pre-mortems before setting direction and before major initiatives, launches, or execution phases. Ask: “If this fails, what are the most likely reasons?” This surfaces risks early, improves planning quality, and strengthens execution readiness by addressing failure points in advance.
-5. Make the reference class visible. At every stage — planning, execution, and review — ground decisions in real-world evidence. Compare current plans and performance against similar initiatives in comparable conditions. This reduces overconfidence, improves forecasting, and anchors judgement in reality rather than internal assumptions.
-6. Create after-action protocols. Institutionalise regular, structured learning reviews throughout execution, from start to finish. Focus on understanding what the environment revealed, and how thinking and decisions shaped outcomes. This builds an ongoing learning system that strengthens adaptation, rather than relying on retrospective analysis after results are already fixed.
+5. Make the reference class visible. At every stage — planning, execution, and review — ground decisions in real-world evidence. Compare current plans and performance against similar initiatives in comparable conditions. This reduces overconfidence, improves forecasting, and anchors judgement in external reality.
+6. Create after-action protocols. Institutionalise regular, structured learning reviews throughout execution, from start to finish. Focus on understanding what the environment revealed, and how thinking and decisions shaped outcomes. This builds an ongoing learning system that strengthens adaptation while results can still be influenced.
 Participant activity (participant file, Section 4.4): participants click each numbered principle, read all six silently and select the one they feel is most absent from their current practice. Allow 3 minutes for individual reading.
 Group debrief. Ask: “Which principle does your organisation consistently skip — and what does that cost you?” Then: “Which one could you introduce into your very next strategy meeting without needing anyone’s permission?”
 Participant reflection (participant file, 4.4): “Which of these six principles do you currently apply most consistently? Which is most absent from your current practice? What would it look like to introduce one of the absent principles into your next important decision or meeting?”
@@ -2697,7 +2697,7 @@
 PILLAR 1 · COGNITIVE INTEGRATION: CONNECTING THE DOTS
 This is about breaking down the “I’m an expert in my area” silos. If Marketing only sees customers and Finance only sees costs, they are both looking at a fragmented reality.
 The Goal: Build a single version of the truth.
-How it works: You stop letting departments “defend” their own data. Instead, you force them to explain how their information affects everyone else.
+How it works: You require every department to explain how its information affects everyone else.
 In Practice: A “Stress Test” where the team asks: “If the Finance data is right, does the Marketing plan still make sense?”
 PILLAR 2 · BEHAVIOURAL GUARDRAILS: PUTTING UP SAFETY NETS
 Smart people make bad choices when they rush. Guardrails are simple rules that force your brain to slow down and switch from “Gut Feel” (System 1) to “Logic” (System 2).
@@ -3604,7 +3604,7 @@
 C1 · I Know My Biases — I actively work to identify the patterns in my thinking that may not serve the organisation’s interests — particularly in the areas of overconfidence, confirmation, and status quo bias.
 1. When I receive information that confirms my existing view of a situation, I actively look for what it might be missing, overstating, or leaving out.
 2. I can name two or three specific patterns in my own thinking that have led me toward a poor call or a missed signal — and I actively watch for them.
-3. When something I championed does not go as expected, I examine what in my reasoning contributed to it — rather than attributing the outcome primarily to external factors.
+3. When something I championed does not go as expected, I examine what in my reasoning contributed to it.
 4. I regularly and deliberately seek out perspectives that challenge how I am reading a situation, particularly from people who are likely to see it differently from me.
 C2 · I Manage My Emotional Impact — I recognise that my emotional state — visible or not — sets the climate for how those around me think, speak up, and engage. I take responsibility for that climate.
 1. I am aware, in real time, of how my visible enthusiasm, scepticism, or frustration shapes what others feel able to say or contribute in the room.
@@ -3613,17 +3613,17 @@
 4. I can point to a recent moment where I visibly reconsidered my position based on input from someone with less authority or experience than me.
 C3 · I Build Psychological Safety Deliberately — I create the conditions in which honest, constructive challenge is expected and protected. I am the first to be challenged and the last to shut challenge down.
 1. The people I lead know — from observable evidence — that they can push back on a view I have taken publicly without personal or professional risk.
-2. In conversations I lead, I actively and specifically invite challenge and dissenting views, rather than waiting for them to be volunteered.
-3. When someone challenges my thinking, my first visible response is to engage with what they have raised — rather than to qualify, defend, or redirect.
+2. In conversations I lead, I actively and specifically invite challenge and dissenting views before anyone volunteers them.
+3. When someone challenges my thinking, my first visible response is to engage with what they have raised.
 4. I recognise and acknowledge intellectual honesty — including views that are inconvenient or that cut against the prevailing direction — at least as visibly as I recognise agreement.
 C4 · I Use Process to Protect Quality — I do not rely on my own judgement alone. I use structured approaches to counteract the predictable failures of unassisted human reasoning.
-1. Before committing to a significant course of action, I use at least one deliberate, structured approach to pressure-test my thinking — rather than relying on instinct and experience alone.
+1. Before committing to a significant course of action, I use at least one deliberate, structured approach to pressure-test my thinking alongside instinct and experience.
 2. I actively look for relevant precedents or comparable situations that can help calibrate my assumptions before I commit to a direction.
 3. I separate the work of opening up possibilities from the work of narrowing down and committing — to reduce the risk of settling prematurely on a preferred path.
 4. I can recall a specific moment where a structured or deliberately designed thinking process led me to a different conclusion than my initial instinct would have.
 C5 · I Treat People as the Strategy — I invest in the human quality of my team’s thinking as well as in frameworks and data. I know that the best process produces the best outcome.
 1. I invest deliberate attention in how the people I lead think and engage with each other, as well as in the quality of what they produce.
-2. I design conversations and working sessions to draw out the best available thinking in the room, rather than to validate a direction that has already formed.
+2. I design conversations and working sessions to draw out the best available thinking in the room before a direction forms.
 3. I treat the diversity of experience, background, and perspective in my team as something that actively improves the quality of what we arrive at together.
 4. I can point to evidence that the way my team thinks and works together produces better outcomes than individual expertise or data alone would.</a:t>
             </a:r>
@@ -4857,7 +4857,7 @@
       </p:grpSpPr>
       <p:pic>
         <p:nvPicPr>
-          <p:cNvPr id="2" name="Image 0" descr="/home/claude/deck/logo.png">    </p:cNvPr>
+          <p:cNvPr id="2" name="Image 0" descr="logo.png">    </p:cNvPr>
           <p:cNvPicPr>
             <a:picLocks noChangeAspect="1"/>
           </p:cNvPicPr>
@@ -7616,7 +7616,7 @@
         <p:spPr>
           <a:xfrm>
             <a:off x="1600200" y="1691640"/>
-            <a:ext cx="4128516" cy="731520"/>
+            <a:ext cx="4128516" cy="987552"/>
           </a:xfrm>
           <a:prstGeom prst="rect">
             <a:avLst/>
@@ -7654,8 +7654,8 @@
         </p:nvSpPr>
         <p:spPr>
           <a:xfrm>
-            <a:off x="777240" y="2560320"/>
-            <a:ext cx="4951476" cy="3657600"/>
+            <a:off x="777240" y="2816352"/>
+            <a:ext cx="4951476" cy="3401568"/>
           </a:xfrm>
           <a:prstGeom prst="rect">
             <a:avLst/>
@@ -8376,7 +8376,7 @@
         <p:spPr>
           <a:xfrm>
             <a:off x="2743200" y="2240280"/>
-            <a:ext cx="8961120" cy="548640"/>
+            <a:ext cx="8961120" cy="868680"/>
           </a:xfrm>
           <a:prstGeom prst="rect">
             <a:avLst/>
@@ -8414,7 +8414,7 @@
         </p:nvSpPr>
         <p:spPr>
           <a:xfrm>
-            <a:off x="2743200" y="3108960"/>
+            <a:off x="2743200" y="3246120"/>
             <a:ext cx="8229600" cy="457200"/>
           </a:xfrm>
           <a:prstGeom prst="rect">
@@ -8453,7 +8453,7 @@
         </p:nvSpPr>
         <p:spPr>
           <a:xfrm>
-            <a:off x="2743200" y="3685032"/>
+            <a:off x="2743200" y="3822192"/>
             <a:ext cx="384048" cy="384048"/>
           </a:xfrm>
           <a:prstGeom prst="ellipse">
@@ -8486,7 +8486,7 @@
         </p:blipFill>
         <p:spPr>
           <a:xfrm>
-            <a:off x="2839212" y="3781044"/>
+            <a:off x="2839212" y="3918204"/>
             <a:ext cx="192024" cy="192024"/>
           </a:xfrm>
           <a:prstGeom prst="rect">
@@ -8502,7 +8502,7 @@
         </p:nvSpPr>
         <p:spPr>
           <a:xfrm>
-            <a:off x="3291840" y="3611880"/>
+            <a:off x="3291840" y="3749040"/>
             <a:ext cx="8412480" cy="1097280"/>
           </a:xfrm>
           <a:prstGeom prst="rect">
@@ -8541,7 +8541,7 @@
         </p:nvSpPr>
         <p:spPr>
           <a:xfrm>
-            <a:off x="2743200" y="4873752"/>
+            <a:off x="2743200" y="5010912"/>
             <a:ext cx="384048" cy="384048"/>
           </a:xfrm>
           <a:prstGeom prst="ellipse">
@@ -8574,7 +8574,7 @@
         </p:blipFill>
         <p:spPr>
           <a:xfrm>
-            <a:off x="2839212" y="4969764"/>
+            <a:off x="2839212" y="5106924"/>
             <a:ext cx="192024" cy="192024"/>
           </a:xfrm>
           <a:prstGeom prst="rect">
@@ -8590,7 +8590,7 @@
         </p:nvSpPr>
         <p:spPr>
           <a:xfrm>
-            <a:off x="3291840" y="4800600"/>
+            <a:off x="3291840" y="4937760"/>
             <a:ext cx="8412480" cy="1097280"/>
           </a:xfrm>
           <a:prstGeom prst="rect">
@@ -10476,7 +10476,7 @@
                 <a:ea typeface="Calibri" pitchFamily="34" charset="-122"/>
                 <a:cs typeface="Calibri" pitchFamily="34" charset="-120"/>
               </a:rPr>
-              <a:t>Interpret strategic issues from an integrated enterprise perspective rather than from a single functional position.</a:t>
+              <a:t>Interpret strategic issues from an integrated enterprise perspective.</a:t>
             </a:r>
             <a:endParaRPr lang="en-US" sz="2600" dirty="0"/>
           </a:p>
@@ -11326,7 +11326,7 @@
         <p:spPr>
           <a:xfrm>
             <a:off x="2743200" y="2240280"/>
-            <a:ext cx="8961120" cy="548640"/>
+            <a:ext cx="8961120" cy="868680"/>
           </a:xfrm>
           <a:prstGeom prst="rect">
             <a:avLst/>
@@ -11364,7 +11364,7 @@
         </p:nvSpPr>
         <p:spPr>
           <a:xfrm>
-            <a:off x="2743200" y="3108960"/>
+            <a:off x="2743200" y="3246120"/>
             <a:ext cx="8229600" cy="457200"/>
           </a:xfrm>
           <a:prstGeom prst="rect">
@@ -11403,7 +11403,7 @@
         </p:nvSpPr>
         <p:spPr>
           <a:xfrm>
-            <a:off x="2743200" y="3685032"/>
+            <a:off x="2743200" y="3822192"/>
             <a:ext cx="384048" cy="384048"/>
           </a:xfrm>
           <a:prstGeom prst="ellipse">
@@ -11436,7 +11436,7 @@
         </p:blipFill>
         <p:spPr>
           <a:xfrm>
-            <a:off x="2839212" y="3781044"/>
+            <a:off x="2839212" y="3918204"/>
             <a:ext cx="192024" cy="192024"/>
           </a:xfrm>
           <a:prstGeom prst="rect">
@@ -11452,7 +11452,7 @@
         </p:nvSpPr>
         <p:spPr>
           <a:xfrm>
-            <a:off x="3291840" y="3611880"/>
+            <a:off x="3291840" y="3749040"/>
             <a:ext cx="8412480" cy="1097280"/>
           </a:xfrm>
           <a:prstGeom prst="rect">
@@ -11491,7 +11491,7 @@
         </p:nvSpPr>
         <p:spPr>
           <a:xfrm>
-            <a:off x="2743200" y="4873752"/>
+            <a:off x="2743200" y="5010912"/>
             <a:ext cx="384048" cy="384048"/>
           </a:xfrm>
           <a:prstGeom prst="ellipse">
@@ -11524,7 +11524,7 @@
         </p:blipFill>
         <p:spPr>
           <a:xfrm>
-            <a:off x="2839212" y="4969764"/>
+            <a:off x="2839212" y="5106924"/>
             <a:ext cx="192024" cy="192024"/>
           </a:xfrm>
           <a:prstGeom prst="rect">
@@ -11540,7 +11540,7 @@
         </p:nvSpPr>
         <p:spPr>
           <a:xfrm>
-            <a:off x="3291840" y="4800600"/>
+            <a:off x="3291840" y="4937760"/>
             <a:ext cx="8412480" cy="1097280"/>
           </a:xfrm>
           <a:prstGeom prst="rect">
@@ -11904,7 +11904,7 @@
         <p:spPr>
           <a:xfrm>
             <a:off x="7283196" y="1691640"/>
-            <a:ext cx="4128516" cy="731520"/>
+            <a:ext cx="4128516" cy="987552"/>
           </a:xfrm>
           <a:prstGeom prst="rect">
             <a:avLst/>
@@ -11942,8 +11942,8 @@
         </p:nvSpPr>
         <p:spPr>
           <a:xfrm>
-            <a:off x="6460236" y="2560320"/>
-            <a:ext cx="4951476" cy="3657600"/>
+            <a:off x="6460236" y="2816352"/>
+            <a:ext cx="4951476" cy="3401568"/>
           </a:xfrm>
           <a:prstGeom prst="rect">
             <a:avLst/>
@@ -14387,7 +14387,7 @@
         <p:spPr>
           <a:xfrm>
             <a:off x="2743200" y="2240280"/>
-            <a:ext cx="8961120" cy="548640"/>
+            <a:ext cx="8961120" cy="868680"/>
           </a:xfrm>
           <a:prstGeom prst="rect">
             <a:avLst/>
@@ -14425,7 +14425,7 @@
         </p:nvSpPr>
         <p:spPr>
           <a:xfrm>
-            <a:off x="2743200" y="3108960"/>
+            <a:off x="2743200" y="3246120"/>
             <a:ext cx="8229600" cy="457200"/>
           </a:xfrm>
           <a:prstGeom prst="rect">
@@ -14464,7 +14464,7 @@
         </p:nvSpPr>
         <p:spPr>
           <a:xfrm>
-            <a:off x="2743200" y="3685032"/>
+            <a:off x="2743200" y="3822192"/>
             <a:ext cx="384048" cy="384048"/>
           </a:xfrm>
           <a:prstGeom prst="ellipse">
@@ -14497,7 +14497,7 @@
         </p:blipFill>
         <p:spPr>
           <a:xfrm>
-            <a:off x="2839212" y="3781044"/>
+            <a:off x="2839212" y="3918204"/>
             <a:ext cx="192024" cy="192024"/>
           </a:xfrm>
           <a:prstGeom prst="rect">
@@ -14513,7 +14513,7 @@
         </p:nvSpPr>
         <p:spPr>
           <a:xfrm>
-            <a:off x="3291840" y="3611880"/>
+            <a:off x="3291840" y="3749040"/>
             <a:ext cx="8412480" cy="1097280"/>
           </a:xfrm>
           <a:prstGeom prst="rect">
@@ -14552,7 +14552,7 @@
         </p:nvSpPr>
         <p:spPr>
           <a:xfrm>
-            <a:off x="2743200" y="4873752"/>
+            <a:off x="2743200" y="5010912"/>
             <a:ext cx="384048" cy="384048"/>
           </a:xfrm>
           <a:prstGeom prst="ellipse">
@@ -14585,7 +14585,7 @@
         </p:blipFill>
         <p:spPr>
           <a:xfrm>
-            <a:off x="2839212" y="4969764"/>
+            <a:off x="2839212" y="5106924"/>
             <a:ext cx="192024" cy="192024"/>
           </a:xfrm>
           <a:prstGeom prst="rect">
@@ -14601,7 +14601,7 @@
         </p:nvSpPr>
         <p:spPr>
           <a:xfrm>
-            <a:off x="3291840" y="4800600"/>
+            <a:off x="3291840" y="4937760"/>
             <a:ext cx="8412480" cy="1097280"/>
           </a:xfrm>
           <a:prstGeom prst="rect">
@@ -17432,7 +17432,7 @@
         <p:spPr>
           <a:xfrm>
             <a:off x="2743200" y="2240280"/>
-            <a:ext cx="8961120" cy="548640"/>
+            <a:ext cx="8961120" cy="868680"/>
           </a:xfrm>
           <a:prstGeom prst="rect">
             <a:avLst/>
@@ -17470,7 +17470,7 @@
         </p:nvSpPr>
         <p:spPr>
           <a:xfrm>
-            <a:off x="2743200" y="3108960"/>
+            <a:off x="2743200" y="3246120"/>
             <a:ext cx="8229600" cy="457200"/>
           </a:xfrm>
           <a:prstGeom prst="rect">
@@ -17509,7 +17509,7 @@
         </p:nvSpPr>
         <p:spPr>
           <a:xfrm>
-            <a:off x="2743200" y="3685032"/>
+            <a:off x="2743200" y="3822192"/>
             <a:ext cx="384048" cy="384048"/>
           </a:xfrm>
           <a:prstGeom prst="ellipse">
@@ -17542,7 +17542,7 @@
         </p:blipFill>
         <p:spPr>
           <a:xfrm>
-            <a:off x="2839212" y="3781044"/>
+            <a:off x="2839212" y="3918204"/>
             <a:ext cx="192024" cy="192024"/>
           </a:xfrm>
           <a:prstGeom prst="rect">
@@ -17558,7 +17558,7 @@
         </p:nvSpPr>
         <p:spPr>
           <a:xfrm>
-            <a:off x="3291840" y="3611880"/>
+            <a:off x="3291840" y="3749040"/>
             <a:ext cx="8412480" cy="1097280"/>
           </a:xfrm>
           <a:prstGeom prst="rect">
@@ -17597,7 +17597,7 @@
         </p:nvSpPr>
         <p:spPr>
           <a:xfrm>
-            <a:off x="2743200" y="4873752"/>
+            <a:off x="2743200" y="5010912"/>
             <a:ext cx="384048" cy="384048"/>
           </a:xfrm>
           <a:prstGeom prst="ellipse">
@@ -17630,7 +17630,7 @@
         </p:blipFill>
         <p:spPr>
           <a:xfrm>
-            <a:off x="2839212" y="4969764"/>
+            <a:off x="2839212" y="5106924"/>
             <a:ext cx="192024" cy="192024"/>
           </a:xfrm>
           <a:prstGeom prst="rect">
@@ -17646,7 +17646,7 @@
         </p:nvSpPr>
         <p:spPr>
           <a:xfrm>
-            <a:off x="3291840" y="4800600"/>
+            <a:off x="3291840" y="4937760"/>
             <a:ext cx="8412480" cy="1097280"/>
           </a:xfrm>
           <a:prstGeom prst="rect">
@@ -18568,7 +18568,7 @@
         <p:spPr>
           <a:xfrm>
             <a:off x="7191756" y="1691640"/>
-            <a:ext cx="4219956" cy="640080"/>
+            <a:ext cx="4219956" cy="923544"/>
           </a:xfrm>
           <a:prstGeom prst="rect">
             <a:avLst/>
@@ -18606,8 +18606,8 @@
         </p:nvSpPr>
         <p:spPr>
           <a:xfrm>
-            <a:off x="6460236" y="2468880"/>
-            <a:ext cx="4951476" cy="1188720"/>
+            <a:off x="6460236" y="2752344"/>
+            <a:ext cx="4951476" cy="905256"/>
           </a:xfrm>
           <a:prstGeom prst="rect">
             <a:avLst/>
@@ -18876,7 +18876,7 @@
         <p:spPr>
           <a:xfrm>
             <a:off x="7191756" y="4251960"/>
-            <a:ext cx="4219956" cy="640080"/>
+            <a:ext cx="4219956" cy="923544"/>
           </a:xfrm>
           <a:prstGeom prst="rect">
             <a:avLst/>
@@ -18914,8 +18914,8 @@
         </p:nvSpPr>
         <p:spPr>
           <a:xfrm>
-            <a:off x="6460236" y="5029200"/>
-            <a:ext cx="4951476" cy="1188720"/>
+            <a:off x="6460236" y="5312664"/>
+            <a:ext cx="4951476" cy="905256"/>
           </a:xfrm>
           <a:prstGeom prst="rect">
             <a:avLst/>
@@ -19255,7 +19255,7 @@
         <p:spPr>
           <a:xfrm>
             <a:off x="4565904" y="2514600"/>
-            <a:ext cx="3057144" cy="987552"/>
+            <a:ext cx="3057144" cy="539496"/>
           </a:xfrm>
           <a:prstGeom prst="rect">
             <a:avLst/>
@@ -19293,8 +19293,8 @@
         </p:nvSpPr>
         <p:spPr>
           <a:xfrm>
-            <a:off x="4565904" y="3639312"/>
-            <a:ext cx="3057144" cy="1664208"/>
+            <a:off x="4565904" y="3191256"/>
+            <a:ext cx="3057144" cy="2112264"/>
           </a:xfrm>
           <a:prstGeom prst="rect">
             <a:avLst/>
@@ -21285,7 +21285,7 @@
         <p:spPr>
           <a:xfrm>
             <a:off x="777240" y="2514600"/>
-            <a:ext cx="3057144" cy="923544"/>
+            <a:ext cx="3057144" cy="507492"/>
           </a:xfrm>
           <a:prstGeom prst="rect">
             <a:avLst/>
@@ -21323,8 +21323,8 @@
         </p:nvSpPr>
         <p:spPr>
           <a:xfrm>
-            <a:off x="777240" y="3575304"/>
-            <a:ext cx="3057144" cy="2642616"/>
+            <a:off x="777240" y="3159252"/>
+            <a:ext cx="3057144" cy="3058668"/>
           </a:xfrm>
           <a:prstGeom prst="rect">
             <a:avLst/>
@@ -21820,7 +21820,7 @@
         <p:spPr>
           <a:xfrm>
             <a:off x="2743200" y="2240280"/>
-            <a:ext cx="8961120" cy="548640"/>
+            <a:ext cx="8961120" cy="868680"/>
           </a:xfrm>
           <a:prstGeom prst="rect">
             <a:avLst/>
@@ -21858,7 +21858,7 @@
         </p:nvSpPr>
         <p:spPr>
           <a:xfrm>
-            <a:off x="2743200" y="3108960"/>
+            <a:off x="2743200" y="3246120"/>
             <a:ext cx="8229600" cy="457200"/>
           </a:xfrm>
           <a:prstGeom prst="rect">
@@ -21897,7 +21897,7 @@
         </p:nvSpPr>
         <p:spPr>
           <a:xfrm>
-            <a:off x="2743200" y="3685032"/>
+            <a:off x="2743200" y="3822192"/>
             <a:ext cx="384048" cy="384048"/>
           </a:xfrm>
           <a:prstGeom prst="ellipse">
@@ -21930,7 +21930,7 @@
         </p:blipFill>
         <p:spPr>
           <a:xfrm>
-            <a:off x="2839212" y="3781044"/>
+            <a:off x="2839212" y="3918204"/>
             <a:ext cx="192024" cy="192024"/>
           </a:xfrm>
           <a:prstGeom prst="rect">
@@ -21946,7 +21946,7 @@
         </p:nvSpPr>
         <p:spPr>
           <a:xfrm>
-            <a:off x="3291840" y="3611880"/>
+            <a:off x="3291840" y="3749040"/>
             <a:ext cx="8412480" cy="1097280"/>
           </a:xfrm>
           <a:prstGeom prst="rect">
@@ -21985,7 +21985,7 @@
         </p:nvSpPr>
         <p:spPr>
           <a:xfrm>
-            <a:off x="2743200" y="4873752"/>
+            <a:off x="2743200" y="5010912"/>
             <a:ext cx="384048" cy="384048"/>
           </a:xfrm>
           <a:prstGeom prst="ellipse">
@@ -22018,7 +22018,7 @@
         </p:blipFill>
         <p:spPr>
           <a:xfrm>
-            <a:off x="2839212" y="4969764"/>
+            <a:off x="2839212" y="5106924"/>
             <a:ext cx="192024" cy="192024"/>
           </a:xfrm>
           <a:prstGeom prst="rect">
@@ -22034,7 +22034,7 @@
         </p:nvSpPr>
         <p:spPr>
           <a:xfrm>
-            <a:off x="3291840" y="4800600"/>
+            <a:off x="3291840" y="4937760"/>
             <a:ext cx="8412480" cy="1097280"/>
           </a:xfrm>
           <a:prstGeom prst="rect">
@@ -22778,7 +22778,7 @@
         <p:spPr>
           <a:xfrm>
             <a:off x="2743200" y="2240280"/>
-            <a:ext cx="8961120" cy="548640"/>
+            <a:ext cx="8961120" cy="868680"/>
           </a:xfrm>
           <a:prstGeom prst="rect">
             <a:avLst/>
@@ -22816,7 +22816,7 @@
         </p:nvSpPr>
         <p:spPr>
           <a:xfrm>
-            <a:off x="2743200" y="3108960"/>
+            <a:off x="2743200" y="3246120"/>
             <a:ext cx="8229600" cy="457200"/>
           </a:xfrm>
           <a:prstGeom prst="rect">
@@ -22855,7 +22855,7 @@
         </p:nvSpPr>
         <p:spPr>
           <a:xfrm>
-            <a:off x="2743200" y="3685032"/>
+            <a:off x="2743200" y="3822192"/>
             <a:ext cx="384048" cy="384048"/>
           </a:xfrm>
           <a:prstGeom prst="ellipse">
@@ -22888,7 +22888,7 @@
         </p:blipFill>
         <p:spPr>
           <a:xfrm>
-            <a:off x="2839212" y="3781044"/>
+            <a:off x="2839212" y="3918204"/>
             <a:ext cx="192024" cy="192024"/>
           </a:xfrm>
           <a:prstGeom prst="rect">
@@ -22904,7 +22904,7 @@
         </p:nvSpPr>
         <p:spPr>
           <a:xfrm>
-            <a:off x="3291840" y="3611880"/>
+            <a:off x="3291840" y="3749040"/>
             <a:ext cx="8412480" cy="1097280"/>
           </a:xfrm>
           <a:prstGeom prst="rect">
@@ -22943,7 +22943,7 @@
         </p:nvSpPr>
         <p:spPr>
           <a:xfrm>
-            <a:off x="2743200" y="4873752"/>
+            <a:off x="2743200" y="5010912"/>
             <a:ext cx="384048" cy="384048"/>
           </a:xfrm>
           <a:prstGeom prst="ellipse">
@@ -22976,7 +22976,7 @@
         </p:blipFill>
         <p:spPr>
           <a:xfrm>
-            <a:off x="2839212" y="4969764"/>
+            <a:off x="2839212" y="5106924"/>
             <a:ext cx="192024" cy="192024"/>
           </a:xfrm>
           <a:prstGeom prst="rect">
@@ -22992,7 +22992,7 @@
         </p:nvSpPr>
         <p:spPr>
           <a:xfrm>
-            <a:off x="3291840" y="4800600"/>
+            <a:off x="3291840" y="4937760"/>
             <a:ext cx="8412480" cy="1097280"/>
           </a:xfrm>
           <a:prstGeom prst="rect">

</xml_diff>

<commit_message>
Enrich unit deck presenter notes with professional insights
</commit_message>
<xml_diff>
--- a/Unit decks/Unit 01 - Behavioural Strategy Fundamentals.pptx
+++ b/Unit decks/Unit 01 - Behavioural Strategy Fundamentals.pptx
@@ -650,6 +650,23 @@
             </a:r>
             <a:endParaRPr lang="en-US" dirty="0"/>
           </a:p>
+          <a:p/>
+          <a:p>
+            <a:r>
+              <a:t>Professional insights:</a:t>
+            </a:r>
+          </a:p>
+          <a:p/>
+          <a:p>
+            <a:r>
+              <a:t>Same evidence, different conclusions: When two groups read the same evidence and reach opposite conclusions, the difference usually sits in the interpretive framework each brings to it. Every strategic assessment is shaped partly by the evidence and partly by the assumptions of the people assessing it. Honest strategy separates the two. Use this with “The way we think”.</a:t>
+            </a:r>
+          </a:p>
+          <a:p>
+            <a:r>
+              <a:t>Source: Journal, 7 March 2026 — Professional Insights</a:t>
+            </a:r>
+          </a:p>
         </p:txBody>
       </p:sp>
       <p:sp>
@@ -751,6 +768,34 @@
             </a:r>
             <a:endParaRPr lang="en-US" dirty="0"/>
           </a:p>
+          <a:p/>
+          <a:p>
+            <a:r>
+              <a:t>Professional insights:</a:t>
+            </a:r>
+          </a:p>
+          <a:p/>
+          <a:p>
+            <a:r>
+              <a:t>The urge to be seen doing something: Under pressure, the most dangerous leadership reflex is the urge to be seen to be doing something. The discipline to slow down, think clearly and act from assessed calm is one of the rarest leadership capacities. Use this to show System 1 under pressure.</a:t>
+            </a:r>
+          </a:p>
+          <a:p>
+            <a:r>
+              <a:t>Source: Journal, 18 January 2026 — Professional Insights: Leadership</a:t>
+            </a:r>
+          </a:p>
+          <a:p/>
+          <a:p>
+            <a:r>
+              <a:t>The considered word: Authority makes a leader’s snap judgements louder than intended. Before endorsing a direction in the room, build in a deliberate pause (“let me sit with that and come back to you tomorrow”) so people act on the considered judgement. Use this to show System 2 as a leadership habit.</a:t>
+            </a:r>
+          </a:p>
+          <a:p>
+            <a:r>
+              <a:t>Source: Journal, 26 May 2026 — Professional Insights: Leadership</a:t>
+            </a:r>
+          </a:p>
         </p:txBody>
       </p:sp>
       <p:sp>
@@ -856,6 +901,23 @@
             </a:r>
             <a:endParaRPr lang="en-US" dirty="0"/>
           </a:p>
+          <a:p/>
+          <a:p>
+            <a:r>
+              <a:t>Professional insights:</a:t>
+            </a:r>
+          </a:p>
+          <a:p/>
+          <a:p>
+            <a:r>
+              <a:t>Knowledge, capability and wisdom: Organisations can hold deep technical expertise and still make poor choices when judgement lacks the discipline of purpose. Fragmentation around personalities distorts collective direction. Use this with the six partial readings of the elephant: each expert is accurate about their part.</a:t>
+            </a:r>
+          </a:p>
+          <a:p>
+            <a:r>
+              <a:t>Source: Journal, 31 August 2026 — Professional Insights: Strategy</a:t>
+            </a:r>
+          </a:p>
         </p:txBody>
       </p:sp>
       <p:sp>
@@ -946,6 +1008,23 @@
 Participant reflection (participant file, 2.3): “In your own organisation, where does the ‘Elephant Problem’ most clearly show up? Which functions or perspectives tend to see very different parts of the same strategic reality?”</a:t>
             </a:r>
             <a:endParaRPr lang="en-US" dirty="0"/>
+          </a:p>
+          <a:p/>
+          <a:p>
+            <a:r>
+              <a:t>Professional insights:</a:t>
+            </a:r>
+          </a:p>
+          <a:p/>
+          <a:p>
+            <a:r>
+              <a:t>The person who does not fit the template: A team that is too uniform will be blind to the moments it was never built for. When building a team, deliberately include the person who does not fit the template; that person often solves the problem no one else can see.</a:t>
+            </a:r>
+          </a:p>
+          <a:p>
+            <a:r>
+              <a:t>Source: Journal, 18 April 2026 — Professional Insights: Leadership</a:t>
+            </a:r>
           </a:p>
         </p:txBody>
       </p:sp>
@@ -1074,6 +1153,34 @@
             </a:r>
             <a:endParaRPr lang="en-US" dirty="0"/>
           </a:p>
+          <a:p/>
+          <a:p>
+            <a:r>
+              <a:t>Professional insights:</a:t>
+            </a:r>
+          </a:p>
+          <a:p/>
+          <a:p>
+            <a:r>
+              <a:t>Overconfidence after a win: Overconfidence after a significant victory is one of the most dangerous leadership conditions. Build a habit of consultation that holds regardless of how strong the last result felt.</a:t>
+            </a:r>
+          </a:p>
+          <a:p>
+            <a:r>
+              <a:t>Source: Journal, 6 April 2026 — Professional Insights: Leadership</a:t>
+            </a:r>
+          </a:p>
+          <a:p/>
+          <a:p>
+            <a:r>
+              <a:t>Committing before counting the cost: The leader who promises the board a delivery date in the heat of the meeting, or announces a pricing change before the commercial modelling is done, shows the planning fallacy at work. One discipline: no public commitment to a number, date or outcome above an agreed threshold without a 24-hour pause.</a:t>
+            </a:r>
+          </a:p>
+          <a:p>
+            <a:r>
+              <a:t>Source: Journal, 22 April 2026 — Professional Insights: Leadership</a:t>
+            </a:r>
+          </a:p>
         </p:txBody>
       </p:sp>
       <p:sp>
@@ -1200,6 +1307,34 @@
             </a:r>
             <a:endParaRPr lang="en-US" dirty="0"/>
           </a:p>
+          <a:p/>
+          <a:p>
+            <a:r>
+              <a:t>Professional insights:</a:t>
+            </a:r>
+          </a:p>
+          <a:p/>
+          <a:p>
+            <a:r>
+              <a:t>Engineered blind spots: A leader who fills the room with people who agree has engineered a blind spot and called it harmony. Unwelcome accuracy is worth more than pleasant confirmation. Seek out the person willing to say what the agreeable majority will not, and protect them from the cost honesty usually carries. Use this with Groupthink and Authority.</a:t>
+            </a:r>
+          </a:p>
+          <a:p>
+            <a:r>
+              <a:t>Source: Journal, 16 June 2026 — Professional Insights: Leadership</a:t>
+            </a:r>
+          </a:p>
+          <a:p/>
+          <a:p>
+            <a:r>
+              <a:t>Informal pressure: Informal social pressure can overpower formally held beliefs. No policy is needed; the presence of particular people is enough to change behaviour. This is culture operating through signals, belonging and perceived approval. Use this with Conformity.</a:t>
+            </a:r>
+          </a:p>
+          <a:p>
+            <a:r>
+              <a:t>Source: Journal, 27 September 2026 — Professional Insights: Culture</a:t>
+            </a:r>
+          </a:p>
         </p:txBody>
       </p:sp>
       <p:sp>
@@ -1596,6 +1731,23 @@
             </a:r>
             <a:endParaRPr lang="en-US" dirty="0"/>
           </a:p>
+          <a:p/>
+          <a:p>
+            <a:r>
+              <a:t>Professional insights:</a:t>
+            </a:r>
+          </a:p>
+          <a:p/>
+          <a:p>
+            <a:r>
+              <a:t>Complementary capability: Sustainable execution rarely depends on one dominant function. Value is produced when differentiated capabilities are deliberately integrated around a common purpose. Use this with “Does my ‘Done’ actually create more work for you?”</a:t>
+            </a:r>
+          </a:p>
+          <a:p>
+            <a:r>
+              <a:t>Source: Journal, 9 September 2026 — Professional Insights: Strategy</a:t>
+            </a:r>
+          </a:p>
         </p:txBody>
       </p:sp>
       <p:sp>
@@ -1995,6 +2147,34 @@
             </a:r>
             <a:endParaRPr lang="en-US" dirty="0"/>
           </a:p>
+          <a:p/>
+          <a:p>
+            <a:r>
+              <a:t>Professional insights:</a:t>
+            </a:r>
+          </a:p>
+          <a:p/>
+          <a:p>
+            <a:r>
+              <a:t>Deciding first: Organisations often decide first and then use analysis to validate the decision. Sound strategy needs enough humility to let evidence alter the chosen path. Use this with Confirmation bias in Phase 1.</a:t>
+            </a:r>
+          </a:p>
+          <a:p>
+            <a:r>
+              <a:t>Source: Journal, 17 September 2026 — Professional Insights: Strategy</a:t>
+            </a:r>
+          </a:p>
+          <a:p/>
+          <a:p>
+            <a:r>
+              <a:t>Disciplined diagnosis: Consequential decisions require leaders to separate facts from framing, individual interests from institutional interests, and genuine risk from manufactured urgency. Use this across Phases 1 and 2.</a:t>
+            </a:r>
+          </a:p>
+          <a:p>
+            <a:r>
+              <a:t>Source: Journal, 14 August 2026 — Professional Insights: Strategy</a:t>
+            </a:r>
+          </a:p>
         </p:txBody>
       </p:sp>
       <p:sp>
@@ -2103,6 +2283,34 @@
             </a:r>
             <a:endParaRPr lang="en-US" dirty="0"/>
           </a:p>
+          <a:p/>
+          <a:p>
+            <a:r>
+              <a:t>Professional insights:</a:t>
+            </a:r>
+          </a:p>
+          <a:p/>
+          <a:p>
+            <a:r>
+              <a:t>The sunk-cost trap: Organisations often continue weak initiatives because money, reputation or effort has already been invested, defending yesterday’s choice at the expense of tomorrow’s outcome. Sound strategy needs the courage to discontinue an unsuitable course, absorb the immediate cost and return to the principles that should govern the decision.</a:t>
+            </a:r>
+          </a:p>
+          <a:p>
+            <a:r>
+              <a:t>Source: Journal, 22 July 2026 — Professional Insights: Strategy</a:t>
+            </a:r>
+          </a:p>
+          <a:p/>
+          <a:p>
+            <a:r>
+              <a:t>Outcomes taken as proof: Senior teams routinely read good outcomes as evidence of sound process. A deal closes or a launch lands, and the messy path that produced it is quietly adopted as the method. Ask participants to pick one recent win and audit how it happened separately from what it produced. Use this with Phase 4 · Execution.</a:t>
+            </a:r>
+          </a:p>
+          <a:p>
+            <a:r>
+              <a:t>Source: Journal, 24 April 2026 — Professional Insights: Culture</a:t>
+            </a:r>
+          </a:p>
         </p:txBody>
       </p:sp>
       <p:sp>
@@ -2213,6 +2421,45 @@
             </a:r>
             <a:endParaRPr lang="en-US" dirty="0"/>
           </a:p>
+          <a:p/>
+          <a:p>
+            <a:r>
+              <a:t>Professional insights:</a:t>
+            </a:r>
+          </a:p>
+          <a:p/>
+          <a:p>
+            <a:r>
+              <a:t>Fear-Dominated: A technically correct leader can still generate fear, silence or defensive behaviour through the way they exercise authority. Leaders need to examine what their habitual responses create around them, alongside what their decisions accomplish.</a:t>
+            </a:r>
+          </a:p>
+          <a:p>
+            <a:r>
+              <a:t>Source: Journal, 30 September 2026 — Professional Insights: Leadership</a:t>
+            </a:r>
+          </a:p>
+          <a:p/>
+          <a:p>
+            <a:r>
+              <a:t>Narcissism-Dominated: When advisers reinforce the posture the leader already wants to adopt, the leadership team becomes an echo chamber. People learn that influence is gained through agreement, and the culture loses the ability to challenge damaging assumptions.</a:t>
+            </a:r>
+          </a:p>
+          <a:p>
+            <a:r>
+              <a:t>Source: Journal, 17 July 2026 — Professional Insights: Culture</a:t>
+            </a:r>
+          </a:p>
+          <a:p/>
+          <a:p>
+            <a:r>
+              <a:t>Grounded Confidence: In a crisis, organisations with a culture of calm, evidence-based thinking hold their nerve better than those that follow the emotional temperature of the room. Build the capacity for calm assessment before you need it.</a:t>
+            </a:r>
+          </a:p>
+          <a:p>
+            <a:r>
+              <a:t>Source: Journal, 13 January 2026 — Professional Insights: Culture</a:t>
+            </a:r>
+          </a:p>
         </p:txBody>
       </p:sp>
       <p:sp>
@@ -2312,6 +2559,34 @@
             </a:r>
             <a:endParaRPr lang="en-US" dirty="0"/>
           </a:p>
+          <a:p/>
+          <a:p>
+            <a:r>
+              <a:t>Professional insights:</a:t>
+            </a:r>
+          </a:p>
+          <a:p/>
+          <a:p>
+            <a:r>
+              <a:t>Psychological Safety: Part of an organisation’s culture is what people believe will happen to them if they try something and it fails. Where the prevailing belief is that failure is punished, people stop trying, whatever the stated values say. Examine what people saw happen to the last person who took a risk and got it wrong.</a:t>
+            </a:r>
+          </a:p>
+          <a:p>
+            <a:r>
+              <a:t>Source: Journal, 13 May 2026 — Professional Insights: Culture</a:t>
+            </a:r>
+          </a:p>
+          <a:p/>
+          <a:p>
+            <a:r>
+              <a:t>Morale Drain: Cultures become healthier when people can voice concern, disappointment or uncertainty without being labelled negative or disloyal. Suppressed emotion moves underground.</a:t>
+            </a:r>
+          </a:p>
+          <a:p>
+            <a:r>
+              <a:t>Source: Journal, 5 September 2026 — Professional Insights: Culture</a:t>
+            </a:r>
+          </a:p>
         </p:txBody>
       </p:sp>
       <p:sp>
@@ -2415,6 +2690,34 @@
             </a:r>
             <a:endParaRPr lang="en-US" dirty="0"/>
           </a:p>
+          <a:p/>
+          <a:p>
+            <a:r>
+              <a:t>Professional insights:</a:t>
+            </a:r>
+          </a:p>
+          <a:p/>
+          <a:p>
+            <a:r>
+              <a:t>Principle 3 · Designated challenger: Most flawed plans survive because dissent was quietly designed out of the room. Before the next significant decision, invite the one person most likely to disagree and hear them out fully.</a:t>
+            </a:r>
+          </a:p>
+          <a:p>
+            <a:r>
+              <a:t>Source: Journal, 5 June 2026 — Professional Insights: Leadership</a:t>
+            </a:r>
+          </a:p>
+          <a:p/>
+          <a:p>
+            <a:r>
+              <a:t>Verification before response: A common and costly strategic failure is acting at the speed of assumption on information that was heard and never confirmed. Build an explicit verification step into decision-making before any significant response.</a:t>
+            </a:r>
+          </a:p>
+          <a:p>
+            <a:r>
+              <a:t>Source: Journal, 13 April 2026 — Professional Insights: Strategy</a:t>
+            </a:r>
+          </a:p>
         </p:txBody>
       </p:sp>
       <p:sp>
@@ -2716,6 +3019,34 @@
             </a:r>
             <a:endParaRPr lang="en-US" dirty="0"/>
           </a:p>
+          <a:p/>
+          <a:p>
+            <a:r>
+              <a:t>Professional insights:</a:t>
+            </a:r>
+          </a:p>
+          <a:p/>
+          <a:p>
+            <a:r>
+              <a:t>Cognitive Integration: The most accurate intelligence about what the organisation’s decisions are producing is often held by those furthest from the decision-making centre. Build explicit structures that bring this intelligence from the edges into the rooms where decisions are made.</a:t>
+            </a:r>
+          </a:p>
+          <a:p>
+            <a:r>
+              <a:t>Source: Journal, 2 April 2026 — Professional Insights: Culture</a:t>
+            </a:r>
+          </a:p>
+          <a:p/>
+          <a:p>
+            <a:r>
+              <a:t>Behavioural Guardrails: Leaders who decide by who is loudest in the room, ahead of what is most true in the data, consistently make poor calls. Good judgement goes beneath the surface presentation and the political pressure to what is actually true.</a:t>
+            </a:r>
+          </a:p>
+          <a:p>
+            <a:r>
+              <a:t>Source: Journal, 14 January 2026 — Professional Insights: Leadership</a:t>
+            </a:r>
+          </a:p>
         </p:txBody>
       </p:sp>
       <p:sp>
@@ -2917,6 +3248,34 @@
             </a:r>
             <a:endParaRPr lang="en-US" dirty="0"/>
           </a:p>
+          <a:p/>
+          <a:p>
+            <a:r>
+              <a:t>Professional insights:</a:t>
+            </a:r>
+          </a:p>
+          <a:p/>
+          <a:p>
+            <a:r>
+              <a:t>Blind Ideation · Halo Effect: Cultures become vulnerable when prestige determines whose ideas matter. Healthy cultures combine competence with humility and value overlooked contributors.</a:t>
+            </a:r>
+          </a:p>
+          <a:p>
+            <a:r>
+              <a:t>Source: Journal, 31 August 2026 — Professional Insights: Culture</a:t>
+            </a:r>
+          </a:p>
+          <a:p/>
+          <a:p>
+            <a:r>
+              <a:t>Insight from every level: Leaders who assume strategic insight belongs only to the senior tier miss what the rest of the organisation sees. The next strategic insight may come from the youngest person on the team.</a:t>
+            </a:r>
+          </a:p>
+          <a:p>
+            <a:r>
+              <a:t>Source: Journal, 29 March 2026 — Professional Insights</a:t>
+            </a:r>
+          </a:p>
         </p:txBody>
       </p:sp>
       <p:sp>
@@ -3014,6 +3373,34 @@
 Transition: move to Section 6 · Application — In Practice.</a:t>
             </a:r>
             <a:endParaRPr lang="en-US" dirty="0"/>
+          </a:p>
+          <a:p/>
+          <a:p>
+            <a:r>
+              <a:t>Professional insights:</a:t>
+            </a:r>
+          </a:p>
+          <a:p/>
+          <a:p>
+            <a:r>
+              <a:t>Strategic Post-Mortems: Shame is what cultures produce when failure is punished and never processed. When people are more afraid of being found wrong than of being wrong, they hide problems until those problems become crises. Build a culture where people can say “I got this wrong” before it becomes “we failed”.</a:t>
+            </a:r>
+          </a:p>
+          <a:p>
+            <a:r>
+              <a:t>Source: Journal, 6 January 2026 — Professional Insights: Culture</a:t>
+            </a:r>
+          </a:p>
+          <a:p/>
+          <a:p>
+            <a:r>
+              <a:t>Public Cognitive Humility: Teams that only ever hear the polished version stop believing any of it. Name one of your own missteps openly to the people you lead; the candour builds the credibility that spin erodes.</a:t>
+            </a:r>
+          </a:p>
+          <a:p>
+            <a:r>
+              <a:t>Source: Journal, 22 May 2026 — Professional Insights: Leadership</a:t>
+            </a:r>
           </a:p>
         </p:txBody>
       </p:sp>
@@ -3628,6 +4015,23 @@
 4. I can point to evidence that the way my team thinks and works together produces better outcomes than individual expertise or data alone would.</a:t>
             </a:r>
             <a:endParaRPr lang="en-US" dirty="0"/>
+          </a:p>
+          <a:p/>
+          <a:p>
+            <a:r>
+              <a:t>Professional insights:</a:t>
+            </a:r>
+          </a:p>
+          <a:p/>
+          <a:p>
+            <a:r>
+              <a:t>C1 · I Know My Biases: Leaders need mechanisms that reveal their blind spots as well as their strengths. Acknowledging difficulty deepens trust when it comes with responsibility, learning and perseverance.</a:t>
+            </a:r>
+          </a:p>
+          <a:p>
+            <a:r>
+              <a:t>Source: Journal, 14 September 2026 — Professional Insights: Leadership</a:t>
+            </a:r>
           </a:p>
         </p:txBody>
       </p:sp>

</xml_diff>

<commit_message>
Unit 1 deck: journal insights in the facilitator notes
</commit_message>
<xml_diff>
--- a/Unit decks/Unit 01 - Behavioural Strategy Fundamentals.pptx
+++ b/Unit decks/Unit 01 - Behavioural Strategy Fundamentals.pptx
@@ -931,6 +931,39 @@
               <a:t>Professional insights:</a:t>
             </a:r>
           </a:p>
+          <a:p/>
+          <a:p>
+            <a:r>
+              <a:t>How we think · same evidence, different conclusions: When two groups read the same evidence and reach opposite conclusions, the difference usually sits in the interpretive framework each brings to it. Every strategic assessment is shaped partly by the evidence and partly by the assumptions of the people assessing it. Honest strategy separates the two.</a:t>
+            </a:r>
+          </a:p>
+          <a:p>
+            <a:r>
+              <a:t>Source: Journal, 7 March 2026 — Professional Insights</a:t>
+            </a:r>
+          </a:p>
+          <a:p/>
+          <a:p>
+            <a:r>
+              <a:t>How we decide · emotion in the decision: Decisions made under emotional pressure can create consequences far beyond the immediate issue. Emotion, group reinforcement and reputational anxiety can drive consequential decisions without sufficient reflection. Separate the presenting problem from the emotional reaction around it and test whether the proposed response is proportionate.</a:t>
+            </a:r>
+          </a:p>
+          <a:p>
+            <a:r>
+              <a:t>Source: Journal, 13 August 2026 — Professional Insights: Strategy</a:t>
+            </a:r>
+          </a:p>
+          <a:p/>
+          <a:p>
+            <a:r>
+              <a:t>How we behave · the gap between intention and action: The gap between stated intention and actual behaviour is one of the most revealing leadership diagnostics available. Build accountability into the space between the commitment and the moment of execution, so that what people sincerely intend is what they do when the pressure of circumstances arrives.</a:t>
+            </a:r>
+          </a:p>
+          <a:p>
+            <a:r>
+              <a:t>Source: Journal, 20 February 2026 — Professional Insights: Leadership</a:t>
+            </a:r>
+          </a:p>
           <a:p>
             <a:endParaRPr lang="en-ZA" b="1" dirty="0"/>
           </a:p>
@@ -1631,6 +1664,28 @@
             </a:r>
             <a:endParaRPr lang="en-ZA" dirty="0"/>
           </a:p>
+          <a:p/>
+          <a:p>
+            <a:r>
+              <a:t>A disciplined pause: Strategy is weakened when leaders become so committed to movement that they ignore capability gaps. A disciplined pause can prevent an expensive failure later. Use this to show System 2 at work.</a:t>
+            </a:r>
+          </a:p>
+          <a:p>
+            <a:r>
+              <a:t>Source: Journal, 1 August 2026 — Professional Insights: Strategy</a:t>
+            </a:r>
+          </a:p>
+          <a:p/>
+          <a:p>
+            <a:r>
+              <a:t>Room to say “We do not yet know”: Strong organisations need room to say “We do not yet know” without reading uncertainty as incompetence. That humility improves learning and stops assumptions from hardening prematurely into facts.</a:t>
+            </a:r>
+          </a:p>
+          <a:p>
+            <a:r>
+              <a:t>Source: Journal, 3 September 2026 — Professional Insights: Culture</a:t>
+            </a:r>
+          </a:p>
           <a:p>
             <a:endParaRPr lang="en-ZA" dirty="0"/>
           </a:p>
@@ -2311,6 +2366,39 @@
               <a:t>Professional Insight</a:t>
             </a:r>
           </a:p>
+          <a:p/>
+          <a:p>
+            <a:r>
+              <a:t>Knowledge, capability and wisdom: Organisations can hold deep technical expertise and still make poor choices when judgement lacks the discipline of purpose. Fragmentation around personalities distorts collective direction. Use this with the six partial readings of the elephant: each expert is accurate about their part.</a:t>
+            </a:r>
+          </a:p>
+          <a:p>
+            <a:r>
+              <a:t>Source: Journal, 31 August 2026 — Professional Insights: Strategy</a:t>
+            </a:r>
+          </a:p>
+          <a:p/>
+          <a:p>
+            <a:r>
+              <a:t>Function and enterprise: Finance optimises finance, HR optimises HR, operations optimises operations, and each may perform well individually while the enterprise struggles collectively. Coherence grows when people routinely ask two questions: “What is my function responsible for?” and “What does the organisation need from my function for the whole to succeed?”</a:t>
+            </a:r>
+          </a:p>
+          <a:p>
+            <a:r>
+              <a:t>Source: Journal, 3 October 2026 — Professional Insights: Culture</a:t>
+            </a:r>
+          </a:p>
+          <a:p/>
+          <a:p>
+            <a:r>
+              <a:t>The person who does not fit the template: A team that is too uniform will be blind to the moments it was never built for. When building a team, deliberately include the person who does not fit the template; that person often solves the problem no one else can see.</a:t>
+            </a:r>
+          </a:p>
+          <a:p>
+            <a:r>
+              <a:t>Source: Journal, 18 April 2026 — Professional Insights: Leadership</a:t>
+            </a:r>
+          </a:p>
           <a:p>
             <a:br>
               <a:rPr lang="en-ZA" dirty="0"/>
@@ -4495,6 +4583,61 @@
               <a:t>Professional Insights</a:t>
             </a:r>
             <a:endParaRPr lang="en-ZA" dirty="0"/>
+          </a:p>
+          <a:p/>
+          <a:p>
+            <a:r>
+              <a:t>Action-Oriented · overconfidence after a win: Overconfidence after a significant victory is one of the most dangerous leadership conditions. Build a habit of consultation that holds regardless of how strong the last result felt.</a:t>
+            </a:r>
+          </a:p>
+          <a:p>
+            <a:r>
+              <a:t>Source: Journal, 6 April 2026 — Professional Insights: Leadership</a:t>
+            </a:r>
+          </a:p>
+          <a:p/>
+          <a:p>
+            <a:r>
+              <a:t>Action-Oriented · committing before counting the cost: The leader who promises the board a delivery date in the heat of the meeting, or announces a pricing change before the commercial modelling is done, shows the planning fallacy at work. One discipline: no public commitment to a number, date or outcome above an agreed threshold without a 24-hour pause.</a:t>
+            </a:r>
+          </a:p>
+          <a:p>
+            <a:r>
+              <a:t>Source: Journal, 22 April 2026 — Professional Insights: Leadership</a:t>
+            </a:r>
+          </a:p>
+          <a:p/>
+          <a:p>
+            <a:r>
+              <a:t>Stability · previous success and present discernment: Past evidence matters, yet it cannot substitute for present discernment. Organisations need institutional memory without becoming prisoners of historical formulas. What worked before is one input to present thinking.</a:t>
+            </a:r>
+          </a:p>
+          <a:p>
+            <a:r>
+              <a:t>Source: Journal, 28 September 2026 — Professional Insights: Strategy</a:t>
+            </a:r>
+          </a:p>
+          <a:p/>
+          <a:p>
+            <a:r>
+              <a:t>Social · engineered blind spots: A leader who fills the room with people who agree has engineered a blind spot and called it harmony. Unwelcome accuracy is worth more than pleasant confirmation. Seek out the person willing to say what the agreeable majority will not, and protect them from the cost honesty usually carries. Use this with Groupthink and Authority.</a:t>
+            </a:r>
+          </a:p>
+          <a:p>
+            <a:r>
+              <a:t>Source: Journal, 16 June 2026 — Professional Insights: Leadership</a:t>
+            </a:r>
+          </a:p>
+          <a:p/>
+          <a:p>
+            <a:r>
+              <a:t>Social · informal pressure: Informal social pressure can overpower formally held beliefs. No policy is needed; the presence of particular people is enough to change behaviour. This is culture operating through signals, belonging and perceived approval. Use this with Conformity.</a:t>
+            </a:r>
+          </a:p>
+          <a:p>
+            <a:r>
+              <a:t>Source: Journal, 27 September 2026 — Professional Insights: Culture</a:t>
+            </a:r>
           </a:p>
           <a:p>
             <a:pPr marL="0" indent="0">
@@ -5836,6 +5979,39 @@
             </a:r>
             <a:endParaRPr lang="en-ZA" dirty="0"/>
           </a:p>
+          <a:p/>
+          <a:p>
+            <a:r>
+              <a:t>Complementary capability: Sustainable execution rarely depends on one dominant function. Value is produced when differentiated capabilities are deliberately integrated around a common purpose. Use this with the first point of the three-point check.</a:t>
+            </a:r>
+          </a:p>
+          <a:p>
+            <a:r>
+              <a:t>Source: Journal, 9 September 2026 — Professional Insights: Strategy</a:t>
+            </a:r>
+          </a:p>
+          <a:p/>
+          <a:p>
+            <a:r>
+              <a:t>Where culture is tested: Examine the interfaces where culture is actually tested: hand-offs between functions, resource conflicts, decision disagreements and responses to mistakes. These moments reveal whether people experience themselves as contributors to one whole or as representatives protecting separate territories. Use this with the White Space.</a:t>
+            </a:r>
+          </a:p>
+          <a:p>
+            <a:r>
+              <a:t>Source: Journal, 2 October 2026 — Professional Insights: Culture</a:t>
+            </a:r>
+          </a:p>
+          <a:p/>
+          <a:p>
+            <a:r>
+              <a:t>Invisible walls: People can work in the same organisation, attend the same meetings and share the same corporate values while remaining separated by invisible walls: functional silos, hierarchy, professional status, historical conflict or assumptions about whose contribution matters most. Ask the group: what invisible walls are preventing capable people from becoming an integrated organisation?</a:t>
+            </a:r>
+          </a:p>
+          <a:p>
+            <a:r>
+              <a:t>Source: Journal, 4 October 2026 — Professional Insights: Culture</a:t>
+            </a:r>
+          </a:p>
           <a:p>
             <a:endParaRPr lang="en-US" dirty="0"/>
           </a:p>
@@ -6585,6 +6761,61 @@
               <a:t>Professional Insights</a:t>
             </a:r>
             <a:endParaRPr lang="en-ZA" dirty="0"/>
+          </a:p>
+          <a:p/>
+          <a:p>
+            <a:r>
+              <a:t>Misallocated Capital · where the resources go: Cultures are revealed by their budget allocations and recognition rituals. List the three things the team has invested most resource in over the last quarter and the three things it has most publicly celebrated. If those lists do not match the stated values, the values on the wall are decoration.</a:t>
+            </a:r>
+          </a:p>
+          <a:p>
+            <a:r>
+              <a:t>Source: Journal, 26 April 2026 — Professional Insights: Culture</a:t>
+            </a:r>
+          </a:p>
+          <a:p/>
+          <a:p>
+            <a:r>
+              <a:t>Strategic Inertia · programmes that outlive their purpose: Senior leaders accumulate programmes built to reproduce past breakthroughs. Identify one programme, ritual or initiative that exists mainly because something like it succeeded before, and pull the data on whether it still produces the original effect. If the case for keeping it is mostly nostalgia, schedule its sunset this quarter.</a:t>
+            </a:r>
+          </a:p>
+          <a:p>
+            <a:r>
+              <a:t>Source: Journal, 6 May 2026 — Professional Insights: Leadership</a:t>
+            </a:r>
+          </a:p>
+          <a:p/>
+          <a:p>
+            <a:r>
+              <a:t>Execution Failure · failing, or still maturing: Strategic outcomes are usually cumulative. Capability, trust, customer loyalty and operational discipline are built through repeated investments whose effects may not be immediately visible. Good execution distinguishes between an initiative that is failing and one whose results have not yet matured, while using evidence to test whether the underlying assumptions remain valid.</a:t>
+            </a:r>
+          </a:p>
+          <a:p>
+            <a:r>
+              <a:t>Source: Journal, 1 October 2026 — Professional Insights: Strategy</a:t>
+            </a:r>
+          </a:p>
+          <a:p/>
+          <a:p>
+            <a:r>
+              <a:t>Innovation Suppression · protect the truth-teller: Organisations often face the most intense resistance to necessary truth from the people who should be most invested in hearing it. Build the protection of truth-tellers into the structure of the culture as well as the values statement.</a:t>
+            </a:r>
+          </a:p>
+          <a:p>
+            <a:r>
+              <a:t>Source: Journal, 7 February 2026 — Professional Insights: Culture</a:t>
+            </a:r>
+          </a:p>
+          <a:p/>
+          <a:p>
+            <a:r>
+              <a:t>Purpose Drift · small accommodations: Drift happens through a series of small accommodations that go unchallenged. What is tolerated becomes what is normal, and by the time the values have shifted no one can point to the moment it happened. Leaders who want to protect what the organisation stands for must challenge early drift.</a:t>
+            </a:r>
+          </a:p>
+          <a:p>
+            <a:r>
+              <a:t>Source: Journal, 16 April 2026 — Professional Insights: Culture</a:t>
+            </a:r>
           </a:p>
           <a:p>
             <a:r>
@@ -8105,6 +8336,72 @@
             </a:r>
             <a:endParaRPr dirty="0"/>
           </a:p>
+          <a:p/>
+          <a:p>
+            <a:r>
+              <a:t>Phase 1 · deciding first: Organisations often decide first and then use analysis to validate the decision. Sound strategy needs enough humility to let evidence alter the chosen path. Use this with Confirmation Bias.</a:t>
+            </a:r>
+          </a:p>
+          <a:p>
+            <a:r>
+              <a:t>Source: Journal, 17 September 2026 — Professional Insights: Strategy</a:t>
+            </a:r>
+          </a:p>
+          <a:p/>
+          <a:p>
+            <a:r>
+              <a:t>Phase 1 · diagnosis beneath visible behaviour: Organisations misdiagnose problems when they address visible symptoms without examining the beliefs producing them. Persistent silo behaviour or poor accountability may survive new processes because the underlying assumptions remain intact. Ask what is happening, and what logic keeps making this behaviour reasonable to the people practising it.</a:t>
+            </a:r>
+          </a:p>
+          <a:p>
+            <a:r>
+              <a:t>Source: Journal, 2 October 2026 — Professional Insights: Strategy</a:t>
+            </a:r>
+          </a:p>
+          <a:p/>
+          <a:p>
+            <a:r>
+              <a:t>Phases 1 and 2 · disciplined diagnosis: Consequential decisions require leaders to separate facts from framing, individual interests from institutional interests, and genuine risk from manufactured urgency.</a:t>
+            </a:r>
+          </a:p>
+          <a:p>
+            <a:r>
+              <a:t>Source: Journal, 14 August 2026 — Professional Insights: Strategy</a:t>
+            </a:r>
+          </a:p>
+          <a:p/>
+          <a:p>
+            <a:r>
+              <a:t>Phase 3 · the sunk-cost trap: Organisations often continue weak initiatives because money, reputation or effort has already been invested, defending yesterday’s choice at the expense of tomorrow’s outcome. Sound strategy needs the courage to discontinue an unsuitable course, absorb the immediate cost and return to the principles that should govern the decision.</a:t>
+            </a:r>
+          </a:p>
+          <a:p>
+            <a:r>
+              <a:t>Source: Journal, 22 July 2026 — Professional Insights: Strategy</a:t>
+            </a:r>
+          </a:p>
+          <a:p/>
+          <a:p>
+            <a:r>
+              <a:t>Phase 4 · outcomes taken as proof: Senior teams routinely read good outcomes as evidence of sound process. A deal closes or a launch lands, and the messy path that produced it is quietly adopted as the method. Ask participants to pick one recent win and audit how it happened separately from what it produced.</a:t>
+            </a:r>
+          </a:p>
+          <a:p>
+            <a:r>
+              <a:t>Source: Journal, 24 April 2026 — Professional Insights: Culture</a:t>
+            </a:r>
+          </a:p>
+          <a:p/>
+          <a:p>
+            <a:r>
+              <a:t>Phase 4 · line of sight: Leaders have a responsibility to allocate work and to create line of sight between contribution and collective purpose. When people understand where they fit, responsibility becomes more meaningful and coordination becomes easier. Use this with the Phase 4 scanner question.</a:t>
+            </a:r>
+          </a:p>
+          <a:p>
+            <a:r>
+              <a:t>Source: Journal, 3 October 2026 — Professional Insights: Leadership</a:t>
+            </a:r>
+          </a:p>
         </p:txBody>
       </p:sp>
       <p:sp>
@@ -8680,6 +8977,72 @@
             <a:r>
               <a:rPr dirty="0"/>
               <a:t>Professional insights:</a:t>
+            </a:r>
+          </a:p>
+          <a:p/>
+          <a:p>
+            <a:r>
+              <a:t>Emotional maturity · alert without becoming absorbed: When leaders become psychologically captured by a threat, organisations often inherit that preoccupation through excessive controls, defensive decisions or distorted priorities. Mature leadership keeps problems in proportion and preserves enough internal steadiness to continue exercising judgement.</a:t>
+            </a:r>
+          </a:p>
+          <a:p>
+            <a:r>
+              <a:t>Source: Journal, 4 October 2026 — Professional Insights: Leadership</a:t>
+            </a:r>
+          </a:p>
+          <a:p/>
+          <a:p>
+            <a:r>
+              <a:t>Fear-Dominated · what authority creates: A technically correct leader can still generate fear, silence or defensive behaviour through the way they exercise authority. Leaders need to examine what their habitual responses create around them, alongside what their decisions accomplish.</a:t>
+            </a:r>
+          </a:p>
+          <a:p>
+            <a:r>
+              <a:t>Source: Journal, 30 September 2026 — Professional Insights: Leadership</a:t>
+            </a:r>
+          </a:p>
+          <a:p/>
+          <a:p>
+            <a:r>
+              <a:t>Fear-Dominated · anxiety that governs decisions: The danger arises when internal anxiety begins governing external decisions. Fear can produce unnecessary control, rushed decisions, avoidance or constant changes in direction.</a:t>
+            </a:r>
+          </a:p>
+          <a:p>
+            <a:r>
+              <a:t>Source: Journal, 3 October 2026 — Professional Insights: Leadership</a:t>
+            </a:r>
+          </a:p>
+          <a:p/>
+          <a:p>
+            <a:r>
+              <a:t>Narcissism-Dominated · the echo chamber: When advisers reinforce the posture the leader already wants to adopt, the leadership team becomes an echo chamber. People learn that influence is gained through agreement, and the culture loses the ability to challenge damaging assumptions.</a:t>
+            </a:r>
+          </a:p>
+          <a:p>
+            <a:r>
+              <a:t>Source: Journal, 17 July 2026 — Professional Insights: Culture</a:t>
+            </a:r>
+          </a:p>
+          <a:p/>
+          <a:p>
+            <a:r>
+              <a:t>Narcissism-Dominated · secure identity: Leaders who derive too much identity from position, recognition or being right can experience disagreement as a personal threat. Secure leaders have greater capacity to listen, share authority, acknowledge mistakes and recognise others. Inner security becomes an organisational capability.</a:t>
+            </a:r>
+          </a:p>
+          <a:p>
+            <a:r>
+              <a:t>Source: Journal, 2 October 2026 — Professional Insights: Leadership</a:t>
+            </a:r>
+          </a:p>
+          <a:p/>
+          <a:p>
+            <a:r>
+              <a:t>Grounded Confidence · calm before the crisis: In a crisis, organisations with a culture of calm, evidence-based thinking hold their nerve better than those that follow the emotional temperature of the room. Build the capacity for calm assessment before you need it.</a:t>
+            </a:r>
+          </a:p>
+          <a:p>
+            <a:r>
+              <a:t>Source: Journal, 13 January 2026 — Professional Insights: Culture</a:t>
             </a:r>
           </a:p>
           <a:p>
@@ -8898,6 +9261,39 @@
               <a:t>Professional insights:</a:t>
             </a:r>
           </a:p>
+          <a:p/>
+          <a:p>
+            <a:r>
+              <a:t>Psychological Safety: Part of an organisation’s culture is what people believe will happen to them if they try something and it fails. Where the prevailing belief is that failure is punished, people stop trying, whatever the stated values say. Examine what people saw happen to the last person who took a risk and got it wrong.</a:t>
+            </a:r>
+          </a:p>
+          <a:p>
+            <a:r>
+              <a:t>Source: Journal, 13 May 2026 — Professional Insights: Culture</a:t>
+            </a:r>
+          </a:p>
+          <a:p/>
+          <a:p>
+            <a:r>
+              <a:t>Morale Drain: Cultures become healthier when people can voice concern, disappointment or uncertainty without being labelled negative or disloyal. Suppressed emotion moves underground.</a:t>
+            </a:r>
+          </a:p>
+          <a:p>
+            <a:r>
+              <a:t>Source: Journal, 5 September 2026 — Professional Insights: Culture</a:t>
+            </a:r>
+          </a:p>
+          <a:p/>
+          <a:p>
+            <a:r>
+              <a:t>Values Alignment: An organisation may repeatedly communicate integrity, collaboration or accountability while rewarding behaviour that contradicts those values. Employees learn that the real culture is encoded in consequences. Culture becomes credible when what leaders praise publicly, tolerate privately and reward materially tells the same story.</a:t>
+            </a:r>
+          </a:p>
+          <a:p>
+            <a:r>
+              <a:t>Source: Journal, 1 October 2026 — Professional Insights: Culture</a:t>
+            </a:r>
+          </a:p>
           <a:p>
             <a:endParaRPr dirty="0"/>
           </a:p>
@@ -9261,6 +9657,45 @@
           <a:p>
             <a:endParaRPr dirty="0"/>
           </a:p>
+          <a:p/>
+          <a:p>
+            <a:r>
+              <a:t>Professional insights:</a:t>
+            </a:r>
+          </a:p>
+          <a:p/>
+          <a:p>
+            <a:r>
+              <a:t>Listen before you reframe: Cultures that move straight from “here is what changed” to “here is what we need you to do next” produce resistance they cannot explain. The resistance signals that people do not yet feel understood. In a restructure, a strategic pivot or a change in leadership, listening is the load-bearing wall. Use this with signals 2 and 6.</a:t>
+            </a:r>
+          </a:p>
+          <a:p>
+            <a:r>
+              <a:t>Source: Journal, 25 June 2026 — Professional Insights: Culture</a:t>
+            </a:r>
+          </a:p>
+          <a:p/>
+          <a:p>
+            <a:r>
+              <a:t>Emotionally honest leadership: Leaders do not strengthen people by pretending that fear, disappointment or grief do not exist. Mature leadership makes space for reality while helping people move from raw emotion toward reflection, meaning and renewed trust. Use this with signal 1.</a:t>
+            </a:r>
+          </a:p>
+          <a:p>
+            <a:r>
+              <a:t>Source: Journal, 5 September 2026 — Professional Insights: Leadership</a:t>
+            </a:r>
+          </a:p>
+          <a:p/>
+          <a:p>
+            <a:r>
+              <a:t>Emotion processed in the right place: The leader who has no outlet for genuine emotion carries it into every decision. The leader who processes it appropriately can remain clear-headed in the most emotionally charged situations.</a:t>
+            </a:r>
+          </a:p>
+          <a:p>
+            <a:r>
+              <a:t>Source: Journal, 27 January 2026 — Professional Insights: Leadership</a:t>
+            </a:r>
+          </a:p>
         </p:txBody>
       </p:sp>
       <p:sp>
@@ -9690,6 +10125,39 @@
               <a:t>
 Group debrief. Ask: “Which principle does your organisation consistently skip — and what does that cost you?” Then: “Which one could you introduce into your very next strategy meeting without needing anyone’s permission?”
 Professional insights:</a:t>
+            </a:r>
+          </a:p>
+          <a:p/>
+          <a:p>
+            <a:r>
+              <a:t>Principle 3 · designated challenger: Most flawed plans survive because dissent was quietly designed out of the room. Before the next significant decision, invite the one person most likely to disagree and hear them out fully.</a:t>
+            </a:r>
+          </a:p>
+          <a:p>
+            <a:r>
+              <a:t>Source: Journal, 5 June 2026 — Professional Insights: Leadership</a:t>
+            </a:r>
+          </a:p>
+          <a:p/>
+          <a:p>
+            <a:r>
+              <a:t>Verification before response: A common and costly strategic failure is acting at the speed of assumption on information that was heard and never confirmed. Build an explicit verification step into decision-making before any significant response.</a:t>
+            </a:r>
+          </a:p>
+          <a:p>
+            <a:r>
+              <a:t>Source: Journal, 13 April 2026 — Professional Insights: Strategy</a:t>
+            </a:r>
+          </a:p>
+          <a:p/>
+          <a:p>
+            <a:r>
+              <a:t>Principle 6 · lessons that change something: Review organisational history to recognise the patterns that must be interrupted; recurring problems treated as isolated events return. Reviews create little value when lessons remain conversational. Insight must eventually alter decisions, controls, resource allocation and expected behaviour.</a:t>
+            </a:r>
+          </a:p>
+          <a:p>
+            <a:r>
+              <a:t>Source: Journal, 10 August 2026 — Professional Insights: Strategy</a:t>
             </a:r>
           </a:p>
           <a:p>
@@ -10052,6 +10520,23 @@
 </a:t>
             </a:r>
           </a:p>
+          <a:p/>
+          <a:p>
+            <a:r>
+              <a:t>Professional insights:</a:t>
+            </a:r>
+          </a:p>
+          <a:p/>
+          <a:p>
+            <a:r>
+              <a:t>From “Me” to “We”: A healthy culture creates conditions in which different contributions can genuinely be joined together. This requires a shared identity strong enough to transcend functional identity, relationships strong enough to carry disagreement, and an understanding that no single part can independently produce the whole organisational outcome.</a:t>
+            </a:r>
+          </a:p>
+          <a:p>
+            <a:r>
+              <a:t>Source: Journal, 4 October 2026 — Professional Insights: Culture</a:t>
+            </a:r>
+          </a:p>
         </p:txBody>
       </p:sp>
       <p:sp>
@@ -10341,6 +10826,39 @@
               <a:t>Professional insights:</a:t>
             </a:r>
           </a:p>
+          <a:p/>
+          <a:p>
+            <a:r>
+              <a:t>Cognitive Integration: The most accurate intelligence about what the organisation’s decisions are producing is often held by those furthest from the decision-making centre. Build explicit structures that bring this intelligence from the edges into the rooms where decisions are made.</a:t>
+            </a:r>
+          </a:p>
+          <a:p>
+            <a:r>
+              <a:t>Source: Journal, 2 April 2026 — Professional Insights: Culture</a:t>
+            </a:r>
+          </a:p>
+          <a:p/>
+          <a:p>
+            <a:r>
+              <a:t>Behavioural Guardrails: Leaders who decide by who is loudest in the room, ahead of what is most true in the data, consistently make poor calls. Good judgement goes beneath the surface presentation and the political pressure to what is actually true.</a:t>
+            </a:r>
+          </a:p>
+          <a:p>
+            <a:r>
+              <a:t>Source: Journal, 14 January 2026 — Professional Insights: Leadership</a:t>
+            </a:r>
+          </a:p>
+          <a:p/>
+          <a:p>
+            <a:r>
+              <a:t>Emotional Stabilisation: Leadership maturity includes the ability to acknowledge uncertainty without transferring anxiety throughout the organisation. Steadiness means remaining sufficiently grounded to assess reality clearly and respond proportionately.</a:t>
+            </a:r>
+          </a:p>
+          <a:p>
+            <a:r>
+              <a:t>Source: Journal, 3 October 2026 — Professional Insights: Leadership</a:t>
+            </a:r>
+          </a:p>
           <a:p>
             <a:endParaRPr dirty="0"/>
           </a:p>
@@ -10924,6 +11442,28 @@
               <a:t>Professional insights:</a:t>
             </a:r>
           </a:p>
+          <a:p/>
+          <a:p>
+            <a:r>
+              <a:t>Blind Ideation · Halo Effect: Cultures become vulnerable when prestige determines whose ideas matter. Healthy cultures combine competence with humility and value overlooked contributors.</a:t>
+            </a:r>
+          </a:p>
+          <a:p>
+            <a:r>
+              <a:t>Source: Journal, 31 August 2026 — Professional Insights: Culture</a:t>
+            </a:r>
+          </a:p>
+          <a:p/>
+          <a:p>
+            <a:r>
+              <a:t>Insight from every level: Leaders who assume strategic insight belongs only to the senior tier miss what the rest of the organisation sees. The next strategic insight may come from the youngest person on the team.</a:t>
+            </a:r>
+          </a:p>
+          <a:p>
+            <a:r>
+              <a:t>Source: Journal, 29 March 2026 — Professional Insights</a:t>
+            </a:r>
+          </a:p>
           <a:p>
             <a:endParaRPr dirty="0"/>
           </a:p>
@@ -11162,6 +11702,17 @@
             <a:r>
               <a:rPr dirty="0"/>
               <a:t>Source: Journal, 22 May 2026 — Professional Insights: Leadership</a:t>
+            </a:r>
+          </a:p>
+          <a:p/>
+          <a:p>
+            <a:r>
+              <a:t>Public Cognitive Humility · self-examination: When something goes wrong, positional power makes it easy to locate failure elsewhere: in the team, the environment, the systems or the execution. Ask “Who failed?” and also “What did my decisions, assumptions, signals or omissions make possible?”</a:t>
+            </a:r>
+          </a:p>
+          <a:p>
+            <a:r>
+              <a:t>Source: Journal, 1 October 2026 — Professional Insights: Leadership</a:t>
             </a:r>
           </a:p>
         </p:txBody>
@@ -11788,6 +12339,23 @@
               <a:t>Transition: move to Section 6.1 · The Five Commitments.</a:t>
             </a:r>
           </a:p>
+          <a:p/>
+          <a:p>
+            <a:r>
+              <a:t>Professional insights:</a:t>
+            </a:r>
+          </a:p>
+          <a:p/>
+          <a:p>
+            <a:r>
+              <a:t>A common reference point: Integration requires a common reference point. When every function interprets priorities primarily through its own objectives, coherence becomes difficult. Shared strategic intent provides the reference against which local decisions can be aligned. Use this in the debrief of the Enterprise Task.</a:t>
+            </a:r>
+          </a:p>
+          <a:p>
+            <a:r>
+              <a:t>Source: Journal, 4 October 2026 — Professional Insights: Strategy</a:t>
+            </a:r>
+          </a:p>
         </p:txBody>
       </p:sp>
       <p:sp>
@@ -11900,6 +12468,23 @@
               <a:t>Complete the commitment self-assessment on 6.1 section and the three reflections.</a:t>
             </a:r>
           </a:p>
+          <a:p/>
+          <a:p>
+            <a:r>
+              <a:t>Professional insights:</a:t>
+            </a:r>
+          </a:p>
+          <a:p/>
+          <a:p>
+            <a:r>
+              <a:t>C1 · I Know My Biases: Leaders need mechanisms that reveal their blind spots as well as their strengths. Acknowledging difficulty deepens trust when it comes with responsibility, learning and perseverance.</a:t>
+            </a:r>
+          </a:p>
+          <a:p>
+            <a:r>
+              <a:t>Source: Journal, 14 September 2026 — Professional Insights: Leadership</a:t>
+            </a:r>
+          </a:p>
         </p:txBody>
       </p:sp>
       <p:sp>
@@ -12589,6 +13174,45 @@
           </a:p>
           <a:p>
             <a:endParaRPr lang="en-US" dirty="0"/>
+          </a:p>
+          <a:p/>
+          <a:p>
+            <a:r>
+              <a:t>Professional insights:</a:t>
+            </a:r>
+          </a:p>
+          <a:p/>
+          <a:p>
+            <a:r>
+              <a:t>Direction Failure · the whole before the parts: Organisations often let functions, departments and individuals pursue objectives without enough understanding of how those objectives contribute to the larger organisational intent. The result can be excellent local performance without coherent enterprise progress. Start with the whole, then locate each part within it.</a:t>
+            </a:r>
+          </a:p>
+          <a:p>
+            <a:r>
+              <a:t>Source: Journal, 3 October 2026 — Professional Insights: Strategy</a:t>
+            </a:r>
+          </a:p>
+          <a:p/>
+          <a:p>
+            <a:r>
+              <a:t>Influence Failure · symbolic compliance: Strategies, values, policies and governance structures may all exist formally while everyday decisions follow an entirely different logic. Test whether those artefacts meaningfully govern resource allocation, priorities and behaviour.</a:t>
+            </a:r>
+          </a:p>
+          <a:p>
+            <a:r>
+              <a:t>Source: Journal, 1 October 2026 — Professional Insights: Strategy</a:t>
+            </a:r>
+          </a:p>
+          <a:p/>
+          <a:p>
+            <a:r>
+              <a:t>Grounding Failure · the connections between the parts: Organisations frequently possess capable functions, talented individuals and substantial resources and still struggle to convert them into collective results. The problem may lie in the quality of the connections between the parts. Strategy must determine how those contributions fit together around the outcome the organisation is trying to create.</a:t>
+            </a:r>
+          </a:p>
+          <a:p>
+            <a:r>
+              <a:t>Source: Journal, 4 October 2026 — Professional Insights: Strategy</a:t>
+            </a:r>
           </a:p>
         </p:txBody>
       </p:sp>
@@ -13271,6 +13895,23 @@
           </a:p>
           <a:p>
             <a:endParaRPr lang="en-US" dirty="0"/>
+          </a:p>
+          <a:p/>
+          <a:p>
+            <a:r>
+              <a:t>Professional insights:</a:t>
+            </a:r>
+          </a:p>
+          <a:p/>
+          <a:p>
+            <a:r>
+              <a:t>The people who must make it happen: Strategy execution requires more than communicating priorities. People need to understand where the organisation is going, what the larger outcome is, and how their particular contribution connects to it. Without that connection, organisations can generate significant activity while producing fragmented results. Use this with the idea that people sit on both sides of strategy.</a:t>
+            </a:r>
+          </a:p>
+          <a:p>
+            <a:r>
+              <a:t>Source: Journal, 3 October 2026 — Professional Insights: Strategy</a:t>
+            </a:r>
           </a:p>
         </p:txBody>
       </p:sp>

</xml_diff>

<commit_message>
Unit 1 deck: journal insights placed inside the presenter notes
</commit_message>
<xml_diff>
--- a/Unit decks/Unit 01 - Behavioural Strategy Fundamentals.pptx
+++ b/Unit decks/Unit 01 - Behavioural Strategy Fundamentals.pptx
@@ -330,25 +330,11 @@
               <a:t>UNIT 1 · BEHAVIOURAL STRATEGY FUNDAMENTALS
 Module 1 · Foundation · Unit 1 · Unscored
 Unit intent (Facilitator Guide):
-</a:t>
-            </a:r>
-          </a:p>
-          <a:p>
-            <a:endParaRPr lang="en-US" dirty="0"/>
-          </a:p>
-          <a:p>
+P</a:t>
+            </a:r>
             <a:r>
               <a:rPr dirty="0"/>
-              <a:t>Source detail (S2R® manuscript):</a:t>
-            </a:r>
-          </a:p>
-          <a:p>
-            <a:endParaRPr dirty="0"/>
-          </a:p>
-          <a:p>
-            <a:r>
-              <a:rPr dirty="0"/>
-              <a:t>Programme context: Strategy2Results®. Collective Intelligence for Execution. Where Strategy Meets the People Who Execute It.</a:t>
+              <a:t>rogramme context: Strategy2Results®. Collective Intelligence for Execution. Where Strategy Meets the People Who Execute It.</a:t>
             </a:r>
             <a:endParaRPr lang="en-ZA" dirty="0"/>
           </a:p>
@@ -714,6 +700,30 @@
             </a:r>
           </a:p>
           <a:p>
+            <a:endParaRPr lang="en-GB" dirty="0"/>
+          </a:p>
+          <a:p>
+            <a:r>
+              <a:rPr lang="en-GB" dirty="0"/>
+              <a:t>Same evidence, different conclusions.</a:t>
+            </a:r>
+          </a:p>
+          <a:p>
+            <a:r>
+              <a:rPr lang="en-GB" dirty="0"/>
+              <a:t>When two groups read the same evidence and reach opposite conclusions, the difference usually sits in the interpretive framework each brings to it. Every strategic assessment is shaped partly by the evidence and partly by the assumptions of the people assessing it. Honest strategy separates the two.</a:t>
+            </a:r>
+          </a:p>
+          <a:p>
+            <a:r>
+              <a:rPr lang="en-GB" dirty="0"/>
+              <a:t>Source: Journal, 7 March 2026 — Professional Insights</a:t>
+            </a:r>
+          </a:p>
+          <a:p>
+            <a:endParaRPr lang="en-GB" dirty="0"/>
+          </a:p>
+          <a:p>
             <a:r>
               <a:rPr lang="en-ZA" dirty="0"/>
               <a:t>So the first behavioural question in strategy is </a:t>
@@ -773,6 +783,30 @@
             </a:r>
           </a:p>
           <a:p>
+            <a:endParaRPr lang="en-GB" dirty="0"/>
+          </a:p>
+          <a:p>
+            <a:r>
+              <a:rPr lang="en-GB" dirty="0"/>
+              <a:t>Emotion in the decision.</a:t>
+            </a:r>
+          </a:p>
+          <a:p>
+            <a:r>
+              <a:rPr lang="en-GB" dirty="0"/>
+              <a:t>Decisions made under emotional pressure can create consequences far beyond the immediate issue. Emotion, group reinforcement and reputational anxiety can drive consequential decisions without sufficient reflection. Separate the presenting problem from the emotional reaction around it and test whether the proposed response is proportionate.</a:t>
+            </a:r>
+          </a:p>
+          <a:p>
+            <a:r>
+              <a:rPr lang="en-GB" dirty="0"/>
+              <a:t>Source: Journal, 13 August 2026 — Professional Insights: Strategy</a:t>
+            </a:r>
+          </a:p>
+          <a:p>
+            <a:endParaRPr lang="en-GB" dirty="0"/>
+          </a:p>
+          <a:p>
             <a:r>
               <a:rPr lang="en-ZA" dirty="0"/>
               <a:t>So the second question becomes: </a:t>
@@ -834,6 +868,30 @@
             </a:r>
           </a:p>
           <a:p>
+            <a:endParaRPr lang="en-GB" dirty="0"/>
+          </a:p>
+          <a:p>
+            <a:r>
+              <a:rPr lang="en-GB" dirty="0"/>
+              <a:t>The gap between intention and action.</a:t>
+            </a:r>
+          </a:p>
+          <a:p>
+            <a:r>
+              <a:rPr lang="en-GB" dirty="0"/>
+              <a:t>The gap between stated intention and actual behaviour is one of the most revealing leadership diagnostics available. Build accountability into the space between the commitment and the moment of execution, so that what people sincerely intend is what they do when the pressure of circumstances arrives.</a:t>
+            </a:r>
+          </a:p>
+          <a:p>
+            <a:r>
+              <a:rPr lang="en-GB" dirty="0"/>
+              <a:t>Source: Journal, 20 February 2026 — Professional Insights: Leadership</a:t>
+            </a:r>
+          </a:p>
+          <a:p>
+            <a:endParaRPr lang="en-GB" dirty="0"/>
+          </a:p>
+          <a:p>
             <a:r>
               <a:rPr lang="en-ZA" dirty="0"/>
               <a:t>So the third question is: </a:t>
@@ -904,68 +962,6 @@
               <a:rPr lang="en-ZA" dirty="0"/>
               <a:t>Allow a short pair discussion before moving on.</a:t>
             </a:r>
-          </a:p>
-          <a:p>
-            <a:endParaRPr lang="en-ZA" b="1" dirty="0"/>
-          </a:p>
-          <a:p>
-            <a:pPr marL="0" marR="0" lvl="0" indent="0" algn="l" defTabSz="914400" rtl="0" eaLnBrk="1" fontAlgn="auto" latinLnBrk="0" hangingPunct="1">
-              <a:lnSpc>
-                <a:spcPct val="100000"/>
-              </a:lnSpc>
-              <a:spcBef>
-                <a:spcPts val="0"/>
-              </a:spcBef>
-              <a:spcAft>
-                <a:spcPts val="0"/>
-              </a:spcAft>
-              <a:buClrTx/>
-              <a:buSzTx/>
-              <a:buFontTx/>
-              <a:buNone/>
-              <a:tabLst/>
-              <a:defRPr/>
-            </a:pPr>
-            <a:r>
-              <a:rPr lang="en-ZA" b="1" dirty="0"/>
-              <a:t>Professional insights:</a:t>
-            </a:r>
-          </a:p>
-          <a:p/>
-          <a:p>
-            <a:r>
-              <a:t>How we think · same evidence, different conclusions: When two groups read the same evidence and reach opposite conclusions, the difference usually sits in the interpretive framework each brings to it. Every strategic assessment is shaped partly by the evidence and partly by the assumptions of the people assessing it. Honest strategy separates the two.</a:t>
-            </a:r>
-          </a:p>
-          <a:p>
-            <a:r>
-              <a:t>Source: Journal, 7 March 2026 — Professional Insights</a:t>
-            </a:r>
-          </a:p>
-          <a:p/>
-          <a:p>
-            <a:r>
-              <a:t>How we decide · emotion in the decision: Decisions made under emotional pressure can create consequences far beyond the immediate issue. Emotion, group reinforcement and reputational anxiety can drive consequential decisions without sufficient reflection. Separate the presenting problem from the emotional reaction around it and test whether the proposed response is proportionate.</a:t>
-            </a:r>
-          </a:p>
-          <a:p>
-            <a:r>
-              <a:t>Source: Journal, 13 August 2026 — Professional Insights: Strategy</a:t>
-            </a:r>
-          </a:p>
-          <a:p/>
-          <a:p>
-            <a:r>
-              <a:t>How we behave · the gap between intention and action: The gap between stated intention and actual behaviour is one of the most revealing leadership diagnostics available. Build accountability into the space between the commitment and the moment of execution, so that what people sincerely intend is what they do when the pressure of circumstances arrives.</a:t>
-            </a:r>
-          </a:p>
-          <a:p>
-            <a:r>
-              <a:t>Source: Journal, 20 February 2026 — Professional Insights: Leadership</a:t>
-            </a:r>
-          </a:p>
-          <a:p>
-            <a:endParaRPr lang="en-ZA" b="1" dirty="0"/>
           </a:p>
           <a:p>
             <a:endParaRPr lang="en-ZA" b="1" dirty="0"/>
@@ -1185,9 +1181,6 @@
             <a:br>
               <a:rPr lang="en-ZA" dirty="0"/>
             </a:br>
-            <a:endParaRPr lang="en-ZA" dirty="0"/>
-          </a:p>
-          <a:p>
             <a:r>
               <a:rPr lang="en-ZA" b="1" dirty="0"/>
               <a:t>SYSTEM 1 — FAST THINKING</a:t>
@@ -1372,6 +1365,95 @@
             <a:endParaRPr lang="en-ZA" dirty="0"/>
           </a:p>
           <a:p>
+            <a:endParaRPr lang="en-GB" dirty="0"/>
+          </a:p>
+          <a:p>
+            <a:r>
+              <a:rPr lang="en-GB" dirty="0"/>
+              <a:t>A disciplined pause.</a:t>
+            </a:r>
+          </a:p>
+          <a:p>
+            <a:r>
+              <a:rPr lang="en-GB" dirty="0"/>
+              <a:t>Strategy is weakened when leaders become so committed to movement that they ignore capability gaps. A disciplined pause can prevent an expensive failure later.</a:t>
+            </a:r>
+          </a:p>
+          <a:p>
+            <a:r>
+              <a:rPr lang="en-GB" dirty="0"/>
+              <a:t>Source: Journal, 1 August 2026 — Professional Insights: Strategy</a:t>
+            </a:r>
+          </a:p>
+          <a:p>
+            <a:endParaRPr lang="en-ZA" dirty="0"/>
+          </a:p>
+          <a:p>
+            <a:r>
+              <a:rPr lang="en-ZA" b="1" dirty="0"/>
+              <a:t>LAND THE TWO SYSTEMS</a:t>
+            </a:r>
+          </a:p>
+          <a:p>
+            <a:r>
+              <a:rPr lang="en-ZA" dirty="0"/>
+              <a:t>Draw participants' attention to the two cards.</a:t>
+            </a:r>
+          </a:p>
+          <a:p>
+            <a:r>
+              <a:rPr lang="en-ZA" b="1" dirty="0"/>
+              <a:t>System 1 gives us speed.</a:t>
+            </a:r>
+            <a:br>
+              <a:rPr lang="en-ZA" b="1" dirty="0"/>
+            </a:br>
+            <a:r>
+              <a:rPr lang="en-ZA" b="1" dirty="0"/>
+              <a:t>System 2 gives us scrutiny.</a:t>
+            </a:r>
+            <a:endParaRPr lang="en-ZA" dirty="0"/>
+          </a:p>
+          <a:p>
+            <a:r>
+              <a:rPr lang="en-ZA" dirty="0"/>
+              <a:t>Both have a place in strategy.</a:t>
+            </a:r>
+          </a:p>
+          <a:p>
+            <a:endParaRPr lang="en-ZA" dirty="0"/>
+          </a:p>
+          <a:p>
+            <a:r>
+              <a:rPr lang="en-ZA" dirty="0"/>
+              <a:t>The challenge arises when </a:t>
+            </a:r>
+            <a:r>
+              <a:rPr lang="en-ZA" b="1" dirty="0"/>
+              <a:t>fast thinking produces a judgement in a situation that requires deeper examination—and we never recognise that we needed to slow down.</a:t>
+            </a:r>
+            <a:endParaRPr lang="en-ZA" dirty="0"/>
+          </a:p>
+          <a:p>
+            <a:r>
+              <a:rPr lang="en-ZA" dirty="0"/>
+              <a:t>For anyone responsible for strategy, the capability is therefore not simply knowing about System 1 and System 2.</a:t>
+            </a:r>
+          </a:p>
+          <a:p>
+            <a:r>
+              <a:rPr lang="en-ZA" dirty="0"/>
+              <a:t>It is being able to ask:</a:t>
+            </a:r>
+          </a:p>
+          <a:p>
+            <a:r>
+              <a:rPr lang="en-ZA" b="1" dirty="0"/>
+              <a:t>“What kind of thinking does this decision require from us?”</a:t>
+            </a:r>
+            <a:endParaRPr lang="en-ZA" dirty="0"/>
+          </a:p>
+          <a:p>
             <a:br>
               <a:rPr lang="en-ZA" dirty="0"/>
             </a:br>
@@ -1380,67 +1462,40 @@
           <a:p>
             <a:r>
               <a:rPr lang="en-ZA" b="1" dirty="0"/>
-              <a:t>LAND THE TWO SYSTEMS</a:t>
-            </a:r>
-          </a:p>
-          <a:p>
-            <a:r>
-              <a:rPr lang="en-ZA" dirty="0"/>
-              <a:t>Draw participants' attention to the two cards.</a:t>
-            </a:r>
-          </a:p>
-          <a:p>
-            <a:r>
-              <a:rPr lang="en-ZA" b="1" dirty="0"/>
-              <a:t>System 1 gives us speed.</a:t>
-            </a:r>
-            <a:br>
-              <a:rPr lang="en-ZA" b="1" dirty="0"/>
-            </a:br>
-            <a:r>
-              <a:rPr lang="en-ZA" b="1" dirty="0"/>
-              <a:t>System 2 gives us scrutiny.</a:t>
+              <a:t>PARTICIPANT DISCUSSION</a:t>
+            </a:r>
+          </a:p>
+          <a:p>
+            <a:r>
+              <a:rPr lang="en-ZA" dirty="0"/>
+              <a:t>Ask:</a:t>
+            </a:r>
+          </a:p>
+          <a:p>
+            <a:r>
+              <a:rPr lang="en-ZA" b="1" dirty="0"/>
+              <a:t>“Under what conditions does System 1 tend to take over in your organisation?”</a:t>
             </a:r>
             <a:endParaRPr lang="en-ZA" dirty="0"/>
           </a:p>
           <a:p>
             <a:r>
               <a:rPr lang="en-ZA" dirty="0"/>
-              <a:t>Both have a place in strategy.</a:t>
-            </a:r>
-          </a:p>
-          <a:p>
+              <a:t>Then probe:</a:t>
+            </a:r>
+          </a:p>
+          <a:p>
+            <a:r>
+              <a:rPr lang="en-ZA" b="1" dirty="0"/>
+              <a:t>“What does that actually look like in the meeting room?”</a:t>
+            </a:r>
             <a:endParaRPr lang="en-ZA" dirty="0"/>
           </a:p>
           <a:p>
             <a:r>
               <a:rPr lang="en-ZA" dirty="0"/>
-              <a:t>The challenge arises when </a:t>
-            </a:r>
-            <a:r>
-              <a:rPr lang="en-ZA" b="1" dirty="0"/>
-              <a:t>fast thinking produces a judgement in a situation that requires deeper examination—and we never recognise that we needed to slow down.</a:t>
-            </a:r>
-            <a:endParaRPr lang="en-ZA" dirty="0"/>
-          </a:p>
-          <a:p>
-            <a:r>
-              <a:rPr lang="en-ZA" dirty="0"/>
-              <a:t>For anyone responsible for strategy, the capability is therefore not simply knowing about System 1 and System 2.</a:t>
-            </a:r>
-          </a:p>
-          <a:p>
-            <a:r>
-              <a:rPr lang="en-ZA" dirty="0"/>
-              <a:t>It is being able to ask:</a:t>
-            </a:r>
-          </a:p>
-          <a:p>
-            <a:r>
-              <a:rPr lang="en-ZA" b="1" dirty="0"/>
-              <a:t>“What kind of thinking does this decision require from us?”</a:t>
-            </a:r>
-            <a:endParaRPr lang="en-ZA" dirty="0"/>
+              <a:t>Listen for examples such as time pressure, hierarchy, strong personalities, familiarity, crisis, fatigue, previous success, consensus or pressure to demonstrate action.</a:t>
+            </a:r>
           </a:p>
           <a:p>
             <a:br>
@@ -1451,39 +1506,65 @@
           <a:p>
             <a:r>
               <a:rPr lang="en-ZA" b="1" dirty="0"/>
-              <a:t>PARTICIPANT DISCUSSION</a:t>
-            </a:r>
-          </a:p>
-          <a:p>
-            <a:r>
-              <a:rPr lang="en-ZA" dirty="0"/>
-              <a:t>Ask:</a:t>
-            </a:r>
-          </a:p>
-          <a:p>
-            <a:r>
-              <a:rPr lang="en-ZA" b="1" dirty="0"/>
-              <a:t>“Under what conditions does System 1 tend to take over in your organisation?”</a:t>
+              <a:t>KEY FACILITATION POINT</a:t>
+            </a:r>
+          </a:p>
+          <a:p>
+            <a:r>
+              <a:rPr lang="en-ZA" dirty="0"/>
+              <a:t>The objective is </a:t>
+            </a:r>
+            <a:r>
+              <a:rPr lang="en-ZA" b="1" dirty="0"/>
+              <a:t>not to eliminate System 1</a:t>
+            </a:r>
+            <a:r>
+              <a:rPr lang="en-ZA" dirty="0"/>
+              <a:t>.</a:t>
+            </a:r>
+          </a:p>
+          <a:p>
+            <a:r>
+              <a:rPr lang="en-ZA" dirty="0"/>
+              <a:t>Experienced leaders need intuition. Pattern recognition is part of expertise.</a:t>
+            </a:r>
+          </a:p>
+          <a:p>
+            <a:r>
+              <a:rPr lang="en-ZA" dirty="0"/>
+              <a:t>The discipline is knowing </a:t>
+            </a:r>
+            <a:r>
+              <a:rPr lang="en-ZA" b="1" dirty="0"/>
+              <a:t>when intuition is enough and when the stakes, uncertainty or complexity require us to deliberately engage System 2.</a:t>
             </a:r>
             <a:endParaRPr lang="en-ZA" dirty="0"/>
           </a:p>
           <a:p>
             <a:r>
               <a:rPr lang="en-ZA" dirty="0"/>
-              <a:t>Then probe:</a:t>
-            </a:r>
-          </a:p>
-          <a:p>
-            <a:r>
-              <a:rPr lang="en-ZA" b="1" dirty="0"/>
-              <a:t>“What does that actually look like in the meeting room?”</a:t>
-            </a:r>
-            <a:endParaRPr lang="en-ZA" dirty="0"/>
-          </a:p>
-          <a:p>
-            <a:r>
-              <a:rPr lang="en-ZA" dirty="0"/>
-              <a:t>Listen for examples such as time pressure, hierarchy, strong personalities, familiarity, crisis, fatigue, previous success, consensus or pressure to demonstrate action.</a:t>
+              <a:t>And sometimes that requires creating the conditions to slow the room down.</a:t>
+            </a:r>
+          </a:p>
+          <a:p>
+            <a:endParaRPr lang="en-GB" dirty="0"/>
+          </a:p>
+          <a:p>
+            <a:r>
+              <a:rPr lang="en-GB" dirty="0"/>
+              <a:t>Room to say “We do not yet know”.</a:t>
+            </a:r>
+          </a:p>
+          <a:p>
+            <a:r>
+              <a:rPr lang="en-GB" dirty="0"/>
+              <a:t>Strong organisations need room to say “We do not yet know” without reading uncertainty as incompetence. That humility improves learning and stops assumptions from hardening prematurely into facts.</a:t>
+            </a:r>
+          </a:p>
+          <a:p>
+            <a:r>
+              <a:rPr lang="en-GB" dirty="0"/>
+              <a:t>Source: Journal, 3 September 2026 — Professional Insights: Culture</a:t>
             </a:r>
           </a:p>
           <a:p>
@@ -1495,45 +1576,28 @@
           <a:p>
             <a:r>
               <a:rPr lang="en-ZA" b="1" dirty="0"/>
-              <a:t>KEY FACILITATION POINT</a:t>
-            </a:r>
-          </a:p>
-          <a:p>
-            <a:r>
-              <a:rPr lang="en-ZA" dirty="0"/>
-              <a:t>The objective is </a:t>
-            </a:r>
-            <a:r>
-              <a:rPr lang="en-ZA" b="1" dirty="0"/>
-              <a:t>not to eliminate System 1</a:t>
-            </a:r>
-            <a:r>
-              <a:rPr lang="en-ZA" dirty="0"/>
-              <a:t>.</a:t>
-            </a:r>
-          </a:p>
-          <a:p>
-            <a:r>
-              <a:rPr lang="en-ZA" dirty="0"/>
-              <a:t>Experienced leaders need intuition. Pattern recognition is part of expertise.</a:t>
-            </a:r>
-          </a:p>
-          <a:p>
-            <a:r>
-              <a:rPr lang="en-ZA" dirty="0"/>
-              <a:t>The discipline is knowing </a:t>
-            </a:r>
-            <a:r>
-              <a:rPr lang="en-ZA" b="1" dirty="0"/>
-              <a:t>when intuition is enough and when the stakes, uncertainty or complexity require us to deliberately engage System 2.</a:t>
+              <a:t>PARTICIPANT REFLECTION</a:t>
+            </a:r>
+          </a:p>
+          <a:p>
+            <a:r>
+              <a:rPr lang="en-ZA" b="1" dirty="0"/>
+              <a:t>Think of a significant strategic decision you were recently involved in. Which system appeared to dominate? What conditions made that more likely?</a:t>
             </a:r>
             <a:endParaRPr lang="en-ZA" dirty="0"/>
           </a:p>
           <a:p>
             <a:r>
               <a:rPr lang="en-ZA" dirty="0"/>
-              <a:t>And sometimes that requires creating the conditions to slow the room down.</a:t>
-            </a:r>
+              <a:t>Then ask:</a:t>
+            </a:r>
+          </a:p>
+          <a:p>
+            <a:r>
+              <a:rPr lang="en-ZA" b="1" dirty="0"/>
+              <a:t>“Looking back, was that the kind of thinking the decision required?”</a:t>
+            </a:r>
+            <a:endParaRPr lang="en-ZA" dirty="0"/>
           </a:p>
           <a:p>
             <a:br>
@@ -1544,150 +1608,60 @@
           <a:p>
             <a:r>
               <a:rPr lang="en-ZA" b="1" dirty="0"/>
-              <a:t>PARTICIPANT REFLECTION</a:t>
-            </a:r>
-          </a:p>
-          <a:p>
-            <a:r>
-              <a:rPr lang="en-ZA" b="1" dirty="0"/>
-              <a:t>Think of a significant strategic decision you were recently involved in. Which system appeared to dominate? What conditions made that more likely?</a:t>
+              <a:t>The urge to be seen doing something</a:t>
             </a:r>
             <a:endParaRPr lang="en-ZA" dirty="0"/>
           </a:p>
           <a:p>
             <a:r>
               <a:rPr lang="en-ZA" dirty="0"/>
-              <a:t>Then ask:</a:t>
-            </a:r>
-          </a:p>
-          <a:p>
-            <a:r>
-              <a:rPr lang="en-ZA" b="1" dirty="0"/>
-              <a:t>“Looking back, was that the kind of thinking the decision required?”</a:t>
+              <a:t>Under pressure, leaders can feel compelled to demonstrate action. But speed of response is not always quality of response.</a:t>
+            </a:r>
+          </a:p>
+          <a:p>
+            <a:r>
+              <a:rPr lang="en-ZA" b="1" dirty="0"/>
+              <a:t>The discipline to slow down, think clearly and act from assessed calm is one of the rarest leadership capacities.</a:t>
             </a:r>
             <a:endParaRPr lang="en-ZA" dirty="0"/>
           </a:p>
           <a:p>
-            <a:br>
-              <a:rPr lang="en-ZA" dirty="0"/>
-            </a:br>
+            <a:r>
+              <a:rPr lang="en-ZA" dirty="0"/>
+              <a:t>Use this to demonstrate how pressure can increase reliance on System 1.</a:t>
+            </a:r>
+          </a:p>
+          <a:p>
             <a:endParaRPr lang="en-ZA" dirty="0"/>
           </a:p>
           <a:p>
             <a:r>
-              <a:rPr lang="en-ZA" b="1" dirty="0"/>
-              <a:t>PROFESSIONAL INSIGHTS</a:t>
-            </a:r>
-          </a:p>
-          <a:p>
-            <a:r>
-              <a:rPr lang="en-ZA" b="1" dirty="0"/>
-              <a:t>The urge to be seen doing something</a:t>
+              <a:rPr lang="en-ZA" dirty="0"/>
+              <a:t>A leader's position gives weight to what they say. A quick reaction from the most senior person in the room can become organisational direction before it was ever intended to be.</a:t>
+            </a:r>
+          </a:p>
+          <a:p>
+            <a:r>
+              <a:rPr lang="en-ZA" dirty="0"/>
+              <a:t>Sometimes System 2 begins with something as simple as:</a:t>
+            </a:r>
+          </a:p>
+          <a:p>
+            <a:r>
+              <a:rPr lang="en-ZA" b="1" dirty="0"/>
+              <a:t>“Let me think about that before we decide.”</a:t>
             </a:r>
             <a:endParaRPr lang="en-ZA" dirty="0"/>
           </a:p>
           <a:p>
             <a:r>
               <a:rPr lang="en-ZA" dirty="0"/>
-              <a:t>Under pressure, leaders can feel compelled to demonstrate action. But speed of response is not always quality of response.</a:t>
-            </a:r>
-          </a:p>
-          <a:p>
-            <a:r>
-              <a:rPr lang="en-ZA" b="1" dirty="0"/>
-              <a:t>The discipline to slow down, think clearly and act from assessed calm is one of the rarest leadership capacities.</a:t>
-            </a:r>
-            <a:endParaRPr lang="en-ZA" dirty="0"/>
-          </a:p>
-          <a:p>
-            <a:r>
-              <a:rPr lang="en-ZA" dirty="0"/>
-              <a:t>Use this to demonstrate how pressure can increase reliance on System 1.</a:t>
-            </a:r>
-          </a:p>
-          <a:p>
-            <a:endParaRPr lang="en-ZA" dirty="0"/>
-          </a:p>
-          <a:p>
-            <a:r>
-              <a:rPr lang="en-ZA" dirty="0"/>
-              <a:t>A leader's position gives weight to what they say. A quick reaction from the most senior person in the room can become organisational direction before it was ever intended to be.</a:t>
-            </a:r>
-          </a:p>
-          <a:p>
-            <a:r>
-              <a:rPr lang="en-ZA" dirty="0"/>
-              <a:t>Sometimes System 2 begins with something as simple as:</a:t>
-            </a:r>
-          </a:p>
-          <a:p>
-            <a:r>
-              <a:rPr lang="en-ZA" b="1" dirty="0"/>
-              <a:t>“Let me think about that before we decide.”</a:t>
-            </a:r>
-            <a:endParaRPr lang="en-ZA" dirty="0"/>
-          </a:p>
-          <a:p>
-            <a:r>
-              <a:rPr lang="en-ZA" dirty="0"/>
               <a:t>The pause is not indecision. </a:t>
             </a:r>
             <a:r>
               <a:rPr lang="en-ZA" b="1" dirty="0"/>
               <a:t>It is a deliberate thinking discipline.</a:t>
             </a:r>
-          </a:p>
-          <a:p>
-            <a:endParaRPr lang="en-ZA" b="1" dirty="0"/>
-          </a:p>
-          <a:p>
-            <a:pPr marL="0" marR="0" lvl="0" indent="0" algn="l" defTabSz="914400" rtl="0" eaLnBrk="1" fontAlgn="auto" latinLnBrk="0" hangingPunct="1">
-              <a:lnSpc>
-                <a:spcPct val="100000"/>
-              </a:lnSpc>
-              <a:spcBef>
-                <a:spcPts val="0"/>
-              </a:spcBef>
-              <a:spcAft>
-                <a:spcPts val="0"/>
-              </a:spcAft>
-              <a:buClrTx/>
-              <a:buSzTx/>
-              <a:buFontTx/>
-              <a:buNone/>
-              <a:tabLst/>
-              <a:defRPr/>
-            </a:pPr>
-            <a:r>
-              <a:rPr lang="en-ZA" b="1" dirty="0"/>
-              <a:t>Professional Insights</a:t>
-            </a:r>
-            <a:endParaRPr lang="en-ZA" dirty="0"/>
-          </a:p>
-          <a:p/>
-          <a:p>
-            <a:r>
-              <a:t>A disciplined pause: Strategy is weakened when leaders become so committed to movement that they ignore capability gaps. A disciplined pause can prevent an expensive failure later. Use this to show System 2 at work.</a:t>
-            </a:r>
-          </a:p>
-          <a:p>
-            <a:r>
-              <a:t>Source: Journal, 1 August 2026 — Professional Insights: Strategy</a:t>
-            </a:r>
-          </a:p>
-          <a:p/>
-          <a:p>
-            <a:r>
-              <a:t>Room to say “We do not yet know”: Strong organisations need room to say “We do not yet know” without reading uncertainty as incompetence. That humility improves learning and stops assumptions from hardening prematurely into facts.</a:t>
-            </a:r>
-          </a:p>
-          <a:p>
-            <a:r>
-              <a:t>Source: Journal, 3 September 2026 — Professional Insights: Culture</a:t>
-            </a:r>
-          </a:p>
-          <a:p>
-            <a:endParaRPr lang="en-ZA" dirty="0"/>
           </a:p>
           <a:p>
             <a:endParaRPr lang="en-ZA" b="1" dirty="0"/>
@@ -2159,6 +2133,27 @@
             <a:endParaRPr lang="en-ZA" dirty="0"/>
           </a:p>
           <a:p>
+            <a:endParaRPr lang="en-GB" dirty="0"/>
+          </a:p>
+          <a:p>
+            <a:r>
+              <a:rPr lang="en-GB" dirty="0"/>
+              <a:t>Knowledge, capability and wisdom.</a:t>
+            </a:r>
+          </a:p>
+          <a:p>
+            <a:r>
+              <a:rPr lang="en-GB" dirty="0"/>
+              <a:t>Organisations can hold deep technical expertise and still make poor choices when judgement lacks the discipline of purpose. Fragmentation around personalities distorts collective direction.</a:t>
+            </a:r>
+          </a:p>
+          <a:p>
+            <a:r>
+              <a:rPr lang="en-GB" dirty="0"/>
+              <a:t>Source: Journal, 31 August 2026 — Professional Insights: Strategy</a:t>
+            </a:r>
+          </a:p>
+          <a:p>
             <a:br>
               <a:rPr lang="en-ZA" dirty="0"/>
             </a:br>
@@ -2249,6 +2244,27 @@
             </a:r>
           </a:p>
           <a:p>
+            <a:endParaRPr lang="en-GB" dirty="0"/>
+          </a:p>
+          <a:p>
+            <a:r>
+              <a:rPr lang="en-GB" dirty="0"/>
+              <a:t>Function and enterprise.</a:t>
+            </a:r>
+          </a:p>
+          <a:p>
+            <a:r>
+              <a:rPr lang="en-GB" dirty="0"/>
+              <a:t>Finance optimises finance, HR optimises HR, operations optimises operations, and each may perform well individually while the enterprise struggles collectively. Coherence grows when people routinely ask two questions: “What is my function responsible for?” and “What does the organisation need from my function for the whole to succeed?”</a:t>
+            </a:r>
+          </a:p>
+          <a:p>
+            <a:r>
+              <a:rPr lang="en-GB" dirty="0"/>
+              <a:t>Source: Journal, 3 October 2026 — Professional Insights: Culture</a:t>
+            </a:r>
+          </a:p>
+          <a:p>
             <a:br>
               <a:rPr lang="en-ZA" dirty="0"/>
             </a:br>
@@ -2348,6 +2364,27 @@
             <a:endParaRPr lang="en-ZA" dirty="0"/>
           </a:p>
           <a:p>
+            <a:endParaRPr lang="en-GB" dirty="0"/>
+          </a:p>
+          <a:p>
+            <a:r>
+              <a:rPr lang="en-GB" dirty="0"/>
+              <a:t>The person who does not fit the template.</a:t>
+            </a:r>
+          </a:p>
+          <a:p>
+            <a:r>
+              <a:rPr lang="en-GB" dirty="0"/>
+              <a:t>A team that is too uniform will be blind to the moments it was never built for. When building a team, deliberately include the person who does not fit the template; that person often solves the problem no one else can see.</a:t>
+            </a:r>
+          </a:p>
+          <a:p>
+            <a:r>
+              <a:rPr lang="en-GB" dirty="0"/>
+              <a:t>Source: Journal, 18 April 2026 — Professional Insights: Leadership</a:t>
+            </a:r>
+          </a:p>
+          <a:p>
             <a:endParaRPr lang="en-ZA" b="1" dirty="0"/>
           </a:p>
           <a:p>
@@ -2356,57 +2393,6 @@
               <a:t>The challenge is not that people see different parts of the elephant. The challenge is whether those different perspectives can be brought together to understand the whole.</a:t>
             </a:r>
             <a:endParaRPr lang="en-ZA" dirty="0"/>
-          </a:p>
-          <a:p>
-            <a:endParaRPr lang="en-ZA" b="1" dirty="0"/>
-          </a:p>
-          <a:p>
-            <a:r>
-              <a:rPr lang="en-ZA" b="1" dirty="0"/>
-              <a:t>Professional Insight</a:t>
-            </a:r>
-          </a:p>
-          <a:p/>
-          <a:p>
-            <a:r>
-              <a:t>Knowledge, capability and wisdom: Organisations can hold deep technical expertise and still make poor choices when judgement lacks the discipline of purpose. Fragmentation around personalities distorts collective direction. Use this with the six partial readings of the elephant: each expert is accurate about their part.</a:t>
-            </a:r>
-          </a:p>
-          <a:p>
-            <a:r>
-              <a:t>Source: Journal, 31 August 2026 — Professional Insights: Strategy</a:t>
-            </a:r>
-          </a:p>
-          <a:p/>
-          <a:p>
-            <a:r>
-              <a:t>Function and enterprise: Finance optimises finance, HR optimises HR, operations optimises operations, and each may perform well individually while the enterprise struggles collectively. Coherence grows when people routinely ask two questions: “What is my function responsible for?” and “What does the organisation need from my function for the whole to succeed?”</a:t>
-            </a:r>
-          </a:p>
-          <a:p>
-            <a:r>
-              <a:t>Source: Journal, 3 October 2026 — Professional Insights: Culture</a:t>
-            </a:r>
-          </a:p>
-          <a:p/>
-          <a:p>
-            <a:r>
-              <a:t>The person who does not fit the template: A team that is too uniform will be blind to the moments it was never built for. When building a team, deliberately include the person who does not fit the template; that person often solves the problem no one else can see.</a:t>
-            </a:r>
-          </a:p>
-          <a:p>
-            <a:r>
-              <a:t>Source: Journal, 18 April 2026 — Professional Insights: Leadership</a:t>
-            </a:r>
-          </a:p>
-          <a:p>
-            <a:br>
-              <a:rPr lang="en-ZA" dirty="0"/>
-            </a:br>
-            <a:endParaRPr lang="en-ZA" dirty="0"/>
-          </a:p>
-          <a:p>
-            <a:endParaRPr dirty="0"/>
           </a:p>
         </p:txBody>
       </p:sp>
@@ -2972,6 +2958,27 @@
             <a:endParaRPr lang="en-ZA" dirty="0"/>
           </a:p>
           <a:p>
+            <a:endParaRPr lang="en-GB" dirty="0"/>
+          </a:p>
+          <a:p>
+            <a:r>
+              <a:rPr lang="en-GB" dirty="0"/>
+              <a:t>Committing before counting the cost.</a:t>
+            </a:r>
+          </a:p>
+          <a:p>
+            <a:r>
+              <a:rPr lang="en-GB" dirty="0"/>
+              <a:t>The leader who promises the board a delivery date in the heat of the meeting, or announces a pricing change before the commercial modelling is done, shows the planning fallacy at work. One discipline: no public commitment to a number, date or outcome above an agreed threshold without a 24-hour pause.</a:t>
+            </a:r>
+          </a:p>
+          <a:p>
+            <a:r>
+              <a:rPr lang="en-GB" dirty="0"/>
+              <a:t>Source: Journal, 22 April 2026 — Professional Insights: Leadership</a:t>
+            </a:r>
+          </a:p>
+          <a:p>
             <a:endParaRPr lang="en-ZA" b="1" dirty="0"/>
           </a:p>
           <a:p>
@@ -3025,6 +3032,27 @@
             <a:r>
               <a:rPr lang="en-ZA" b="1" dirty="0"/>
               <a:t>Success can become part of the conditions that make overconfidence possible.</a:t>
+            </a:r>
+          </a:p>
+          <a:p>
+            <a:endParaRPr lang="en-GB" dirty="0"/>
+          </a:p>
+          <a:p>
+            <a:r>
+              <a:rPr lang="en-GB" dirty="0"/>
+              <a:t>Overconfidence after a win.</a:t>
+            </a:r>
+          </a:p>
+          <a:p>
+            <a:r>
+              <a:rPr lang="en-GB" dirty="0"/>
+              <a:t>Overconfidence after a significant victory is one of the most dangerous leadership conditions. Build a habit of consultation that holds regardless of how strong the last result felt.</a:t>
+            </a:r>
+          </a:p>
+          <a:p>
+            <a:r>
+              <a:rPr lang="en-GB" dirty="0"/>
+              <a:t>Source: Journal, 6 April 2026 — Professional Insights: Leadership</a:t>
             </a:r>
           </a:p>
           <a:p>
@@ -3390,6 +3418,27 @@
             <a:endParaRPr lang="en-ZA" dirty="0"/>
           </a:p>
           <a:p>
+            <a:endParaRPr lang="en-GB" dirty="0"/>
+          </a:p>
+          <a:p>
+            <a:r>
+              <a:rPr lang="en-GB" dirty="0"/>
+              <a:t>Previous success and present discernment.</a:t>
+            </a:r>
+          </a:p>
+          <a:p>
+            <a:r>
+              <a:rPr lang="en-GB" dirty="0"/>
+              <a:t>Past evidence matters, yet it cannot substitute for present discernment. Organisations need institutional memory without becoming prisoners of historical formulas. What worked before is one input to present thinking.</a:t>
+            </a:r>
+          </a:p>
+          <a:p>
+            <a:r>
+              <a:rPr lang="en-GB" dirty="0"/>
+              <a:t>Source: Journal, 28 September 2026 — Professional Insights: Strategy</a:t>
+            </a:r>
+          </a:p>
+          <a:p>
             <a:endParaRPr lang="en-ZA" b="1" dirty="0"/>
           </a:p>
           <a:p>
@@ -4123,6 +4172,27 @@
             </a:r>
           </a:p>
           <a:p>
+            <a:endParaRPr lang="en-GB" dirty="0"/>
+          </a:p>
+          <a:p>
+            <a:r>
+              <a:rPr lang="en-GB" dirty="0"/>
+              <a:t>Informal pressure.</a:t>
+            </a:r>
+          </a:p>
+          <a:p>
+            <a:r>
+              <a:rPr lang="en-GB" dirty="0"/>
+              <a:t>Informal social pressure can overpower formally held beliefs. No policy is needed; the presence of particular people is enough to change behaviour. This is culture operating through signals, belonging and perceived approval.</a:t>
+            </a:r>
+          </a:p>
+          <a:p>
+            <a:r>
+              <a:rPr lang="en-GB" dirty="0"/>
+              <a:t>Source: Journal, 27 September 2026 — Professional Insights: Culture</a:t>
+            </a:r>
+          </a:p>
+          <a:p>
             <a:endParaRPr lang="en-ZA" b="1" dirty="0"/>
           </a:p>
           <a:p>
@@ -4216,6 +4286,27 @@
               <a:t>The result: what begins as influence can gradually become agreement, and agreement can begin to look like evidence.</a:t>
             </a:r>
             <a:endParaRPr lang="en-ZA" dirty="0"/>
+          </a:p>
+          <a:p>
+            <a:endParaRPr lang="en-GB" dirty="0"/>
+          </a:p>
+          <a:p>
+            <a:r>
+              <a:rPr lang="en-GB" dirty="0"/>
+              <a:t>Engineered blind spots.</a:t>
+            </a:r>
+          </a:p>
+          <a:p>
+            <a:r>
+              <a:rPr lang="en-GB" dirty="0"/>
+              <a:t>A leader who fills the room with people who agree has engineered a blind spot and called it harmony. Unwelcome accuracy is worth more than pleasant confirmation. Seek out the person willing to say what the agreeable majority will not, and protect them from the cost honesty usually carries.</a:t>
+            </a:r>
+          </a:p>
+          <a:p>
+            <a:r>
+              <a:rPr lang="en-GB" dirty="0"/>
+              <a:t>Source: Journal, 16 June 2026 — Professional Insights: Leadership</a:t>
+            </a:r>
           </a:p>
           <a:p>
             <a:endParaRPr lang="en-ZA" b="1" dirty="0"/>
@@ -4553,97 +4644,6 @@
               <a:rPr lang="en-ZA" dirty="0"/>
               <a:t>Organisational signals that the bias is at play.</a:t>
             </a:r>
-          </a:p>
-          <a:p>
-            <a:pPr marL="228600" indent="-228600">
-              <a:buAutoNum type="arabicPeriod"/>
-            </a:pPr>
-            <a:endParaRPr lang="en-ZA" dirty="0"/>
-          </a:p>
-          <a:p>
-            <a:pPr marL="0" marR="0" lvl="0" indent="0" algn="l" defTabSz="914400" rtl="0" eaLnBrk="1" fontAlgn="auto" latinLnBrk="0" hangingPunct="1">
-              <a:lnSpc>
-                <a:spcPct val="100000"/>
-              </a:lnSpc>
-              <a:spcBef>
-                <a:spcPts val="0"/>
-              </a:spcBef>
-              <a:spcAft>
-                <a:spcPts val="0"/>
-              </a:spcAft>
-              <a:buClrTx/>
-              <a:buSzTx/>
-              <a:buFontTx/>
-              <a:buNone/>
-              <a:tabLst/>
-              <a:defRPr/>
-            </a:pPr>
-            <a:r>
-              <a:rPr lang="en-ZA" b="1" dirty="0"/>
-              <a:t>Professional Insights</a:t>
-            </a:r>
-            <a:endParaRPr lang="en-ZA" dirty="0"/>
-          </a:p>
-          <a:p/>
-          <a:p>
-            <a:r>
-              <a:t>Action-Oriented · overconfidence after a win: Overconfidence after a significant victory is one of the most dangerous leadership conditions. Build a habit of consultation that holds regardless of how strong the last result felt.</a:t>
-            </a:r>
-          </a:p>
-          <a:p>
-            <a:r>
-              <a:t>Source: Journal, 6 April 2026 — Professional Insights: Leadership</a:t>
-            </a:r>
-          </a:p>
-          <a:p/>
-          <a:p>
-            <a:r>
-              <a:t>Action-Oriented · committing before counting the cost: The leader who promises the board a delivery date in the heat of the meeting, or announces a pricing change before the commercial modelling is done, shows the planning fallacy at work. One discipline: no public commitment to a number, date or outcome above an agreed threshold without a 24-hour pause.</a:t>
-            </a:r>
-          </a:p>
-          <a:p>
-            <a:r>
-              <a:t>Source: Journal, 22 April 2026 — Professional Insights: Leadership</a:t>
-            </a:r>
-          </a:p>
-          <a:p/>
-          <a:p>
-            <a:r>
-              <a:t>Stability · previous success and present discernment: Past evidence matters, yet it cannot substitute for present discernment. Organisations need institutional memory without becoming prisoners of historical formulas. What worked before is one input to present thinking.</a:t>
-            </a:r>
-          </a:p>
-          <a:p>
-            <a:r>
-              <a:t>Source: Journal, 28 September 2026 — Professional Insights: Strategy</a:t>
-            </a:r>
-          </a:p>
-          <a:p/>
-          <a:p>
-            <a:r>
-              <a:t>Social · engineered blind spots: A leader who fills the room with people who agree has engineered a blind spot and called it harmony. Unwelcome accuracy is worth more than pleasant confirmation. Seek out the person willing to say what the agreeable majority will not, and protect them from the cost honesty usually carries. Use this with Groupthink and Authority.</a:t>
-            </a:r>
-          </a:p>
-          <a:p>
-            <a:r>
-              <a:t>Source: Journal, 16 June 2026 — Professional Insights: Leadership</a:t>
-            </a:r>
-          </a:p>
-          <a:p/>
-          <a:p>
-            <a:r>
-              <a:t>Social · informal pressure: Informal social pressure can overpower formally held beliefs. No policy is needed; the presence of particular people is enough to change behaviour. This is culture operating through signals, belonging and perceived approval. Use this with Conformity.</a:t>
-            </a:r>
-          </a:p>
-          <a:p>
-            <a:r>
-              <a:t>Source: Journal, 27 September 2026 — Professional Insights: Culture</a:t>
-            </a:r>
-          </a:p>
-          <a:p>
-            <a:pPr marL="0" indent="0">
-              <a:buNone/>
-            </a:pPr>
-            <a:endParaRPr dirty="0"/>
           </a:p>
         </p:txBody>
       </p:sp>
@@ -5636,6 +5636,27 @@
             </a:r>
           </a:p>
           <a:p>
+            <a:endParaRPr lang="en-GB" dirty="0"/>
+          </a:p>
+          <a:p>
+            <a:r>
+              <a:rPr lang="en-GB" dirty="0"/>
+              <a:t>Complementary capability.</a:t>
+            </a:r>
+          </a:p>
+          <a:p>
+            <a:r>
+              <a:rPr lang="en-GB" dirty="0"/>
+              <a:t>Sustainable execution rarely depends on one dominant function. Value is produced when differentiated capabilities are deliberately integrated around a common purpose.</a:t>
+            </a:r>
+          </a:p>
+          <a:p>
+            <a:r>
+              <a:rPr lang="en-GB" dirty="0"/>
+              <a:t>Source: Journal, 9 September 2026 — Professional Insights: Strategy</a:t>
+            </a:r>
+          </a:p>
+          <a:p>
             <a:endParaRPr lang="en-ZA" dirty="0"/>
           </a:p>
           <a:p>
@@ -5846,6 +5867,27 @@
             </a:r>
           </a:p>
           <a:p>
+            <a:endParaRPr lang="en-GB" dirty="0"/>
+          </a:p>
+          <a:p>
+            <a:r>
+              <a:rPr lang="en-GB" dirty="0"/>
+              <a:t>Where culture is tested.</a:t>
+            </a:r>
+          </a:p>
+          <a:p>
+            <a:r>
+              <a:rPr lang="en-GB" dirty="0"/>
+              <a:t>Examine the interfaces where culture is actually tested: hand-offs between functions, resource conflicts, decision disagreements and responses to mistakes. These moments reveal whether people experience themselves as contributors to one whole or as representatives protecting separate territories.</a:t>
+            </a:r>
+          </a:p>
+          <a:p>
+            <a:r>
+              <a:rPr lang="en-GB" dirty="0"/>
+              <a:t>Source: Journal, 2 October 2026 — Professional Insights: Culture</a:t>
+            </a:r>
+          </a:p>
+          <a:p>
             <a:endParaRPr lang="en-ZA" b="1" dirty="0"/>
           </a:p>
           <a:p>
@@ -5935,6 +5977,27 @@
             <a:endParaRPr lang="en-ZA" dirty="0"/>
           </a:p>
           <a:p>
+            <a:endParaRPr lang="en-GB" dirty="0"/>
+          </a:p>
+          <a:p>
+            <a:r>
+              <a:rPr lang="en-GB" dirty="0"/>
+              <a:t>Invisible walls.</a:t>
+            </a:r>
+          </a:p>
+          <a:p>
+            <a:r>
+              <a:rPr lang="en-GB" dirty="0"/>
+              <a:t>People can work in the same organisation, attend the same meetings and share the same corporate values while remaining separated by invisible walls: functional silos, hierarchy, professional status, historical conflict or assumptions about whose contribution matters most. Ask the group: what invisible walls are preventing capable people from becoming an integrated organisation?</a:t>
+            </a:r>
+          </a:p>
+          <a:p>
+            <a:r>
+              <a:rPr lang="en-GB" dirty="0"/>
+              <a:t>Source: Journal, 4 October 2026 — Professional Insights: Culture</a:t>
+            </a:r>
+          </a:p>
+          <a:p>
             <a:endParaRPr lang="en-ZA" dirty="0"/>
           </a:p>
           <a:p>
@@ -5948,72 +6011,6 @@
               <a:rPr lang="en-ZA" dirty="0"/>
               <a:t>Because there is a hidden cost of behaviours which in a organisation translates to strategic costs.</a:t>
             </a:r>
-          </a:p>
-          <a:p>
-            <a:endParaRPr lang="en-ZA" dirty="0"/>
-          </a:p>
-          <a:p>
-            <a:endParaRPr lang="en-ZA" b="1" dirty="0"/>
-          </a:p>
-          <a:p>
-            <a:pPr marL="0" marR="0" lvl="0" indent="0" algn="l" defTabSz="914400" rtl="0" eaLnBrk="1" fontAlgn="auto" latinLnBrk="0" hangingPunct="1">
-              <a:lnSpc>
-                <a:spcPct val="100000"/>
-              </a:lnSpc>
-              <a:spcBef>
-                <a:spcPts val="0"/>
-              </a:spcBef>
-              <a:spcAft>
-                <a:spcPts val="0"/>
-              </a:spcAft>
-              <a:buClrTx/>
-              <a:buSzTx/>
-              <a:buFontTx/>
-              <a:buNone/>
-              <a:tabLst/>
-              <a:defRPr/>
-            </a:pPr>
-            <a:r>
-              <a:rPr lang="en-ZA" b="1" dirty="0"/>
-              <a:t>Professional Insights</a:t>
-            </a:r>
-            <a:endParaRPr lang="en-ZA" dirty="0"/>
-          </a:p>
-          <a:p/>
-          <a:p>
-            <a:r>
-              <a:t>Complementary capability: Sustainable execution rarely depends on one dominant function. Value is produced when differentiated capabilities are deliberately integrated around a common purpose. Use this with the first point of the three-point check.</a:t>
-            </a:r>
-          </a:p>
-          <a:p>
-            <a:r>
-              <a:t>Source: Journal, 9 September 2026 — Professional Insights: Strategy</a:t>
-            </a:r>
-          </a:p>
-          <a:p/>
-          <a:p>
-            <a:r>
-              <a:t>Where culture is tested: Examine the interfaces where culture is actually tested: hand-offs between functions, resource conflicts, decision disagreements and responses to mistakes. These moments reveal whether people experience themselves as contributors to one whole or as representatives protecting separate territories. Use this with the White Space.</a:t>
-            </a:r>
-          </a:p>
-          <a:p>
-            <a:r>
-              <a:t>Source: Journal, 2 October 2026 — Professional Insights: Culture</a:t>
-            </a:r>
-          </a:p>
-          <a:p/>
-          <a:p>
-            <a:r>
-              <a:t>Invisible walls: People can work in the same organisation, attend the same meetings and share the same corporate values while remaining separated by invisible walls: functional silos, hierarchy, professional status, historical conflict or assumptions about whose contribution matters most. Ask the group: what invisible walls are preventing capable people from becoming an integrated organisation?</a:t>
-            </a:r>
-          </a:p>
-          <a:p>
-            <a:r>
-              <a:t>Source: Journal, 4 October 2026 — Professional Insights: Culture</a:t>
-            </a:r>
-          </a:p>
-          <a:p>
-            <a:endParaRPr lang="en-US" dirty="0"/>
           </a:p>
         </p:txBody>
       </p:sp>
@@ -6276,6 +6273,27 @@
             <a:endParaRPr lang="en-ZA" dirty="0"/>
           </a:p>
           <a:p>
+            <a:endParaRPr lang="en-GB" dirty="0"/>
+          </a:p>
+          <a:p>
+            <a:r>
+              <a:rPr lang="en-GB" dirty="0"/>
+              <a:t>Where the resources go.</a:t>
+            </a:r>
+          </a:p>
+          <a:p>
+            <a:r>
+              <a:rPr lang="en-GB" dirty="0"/>
+              <a:t>Cultures are revealed by their budget allocations and recognition rituals. List the three things the team has invested most resource in over the last quarter and the three things it has most publicly celebrated. If those lists do not match the stated values, the values on the wall are decoration.</a:t>
+            </a:r>
+          </a:p>
+          <a:p>
+            <a:r>
+              <a:rPr lang="en-GB" dirty="0"/>
+              <a:t>Source: Journal, 26 April 2026 — Professional Insights: Culture</a:t>
+            </a:r>
+          </a:p>
+          <a:p>
             <a:br>
               <a:rPr lang="en-ZA" dirty="0"/>
             </a:br>
@@ -6377,6 +6395,27 @@
             <a:endParaRPr lang="en-ZA" dirty="0"/>
           </a:p>
           <a:p>
+            <a:endParaRPr lang="en-GB" dirty="0"/>
+          </a:p>
+          <a:p>
+            <a:r>
+              <a:rPr lang="en-GB" dirty="0"/>
+              <a:t>Programmes that outlive their purpose.</a:t>
+            </a:r>
+          </a:p>
+          <a:p>
+            <a:r>
+              <a:rPr lang="en-GB" dirty="0"/>
+              <a:t>Senior leaders accumulate programmes built to reproduce past breakthroughs. Identify one programme, ritual or initiative that exists mainly because something like it succeeded before, and pull the data on whether it still produces the original effect. If the case for keeping it is mostly nostalgia, schedule its sunset this quarter.</a:t>
+            </a:r>
+          </a:p>
+          <a:p>
+            <a:r>
+              <a:rPr lang="en-GB" dirty="0"/>
+              <a:t>Source: Journal, 6 May 2026 — Professional Insights: Leadership</a:t>
+            </a:r>
+          </a:p>
+          <a:p>
             <a:br>
               <a:rPr lang="en-ZA" dirty="0"/>
             </a:br>
@@ -6498,6 +6537,27 @@
             </a:r>
           </a:p>
           <a:p>
+            <a:endParaRPr lang="en-GB" dirty="0"/>
+          </a:p>
+          <a:p>
+            <a:r>
+              <a:rPr lang="en-GB" dirty="0"/>
+              <a:t>Failing, or still maturing.</a:t>
+            </a:r>
+          </a:p>
+          <a:p>
+            <a:r>
+              <a:rPr lang="en-GB" dirty="0"/>
+              <a:t>Strategic outcomes are usually cumulative. Capability, trust, customer loyalty and operational discipline are built through repeated investments whose effects may not be immediately visible. Good execution distinguishes between an initiative that is failing and one whose results have not yet matured, while using evidence to test whether the underlying assumptions remain valid.</a:t>
+            </a:r>
+          </a:p>
+          <a:p>
+            <a:r>
+              <a:rPr lang="en-GB" dirty="0"/>
+              <a:t>Source: Journal, 1 October 2026 — Professional Insights: Strategy</a:t>
+            </a:r>
+          </a:p>
+          <a:p>
             <a:br>
               <a:rPr lang="en-ZA" dirty="0"/>
             </a:br>
@@ -6608,6 +6668,30 @@
             <a:endParaRPr lang="en-ZA" dirty="0"/>
           </a:p>
           <a:p>
+            <a:endParaRPr lang="en-GB" dirty="0"/>
+          </a:p>
+          <a:p>
+            <a:r>
+              <a:rPr lang="en-GB" dirty="0"/>
+              <a:t>Protect the truth-teller.</a:t>
+            </a:r>
+          </a:p>
+          <a:p>
+            <a:r>
+              <a:rPr lang="en-GB" dirty="0"/>
+              <a:t>Organisations often face the most intense resistance to necessary truth from the people who should be most invested in hearing it. Build the protection of truth-tellers into the structure of the culture as well as the values statement.</a:t>
+            </a:r>
+          </a:p>
+          <a:p>
+            <a:r>
+              <a:rPr lang="en-GB" dirty="0"/>
+              <a:t>Source: Journal, 7 February 2026 — Professional Insights: Culture</a:t>
+            </a:r>
+          </a:p>
+          <a:p>
+            <a:endParaRPr lang="en-GB" dirty="0"/>
+          </a:p>
+          <a:p>
             <a:r>
               <a:rPr lang="en-ZA" dirty="0"/>
               <a:t>A strong question to land this:</a:t>
@@ -6720,6 +6804,27 @@
             <a:endParaRPr lang="en-ZA" dirty="0"/>
           </a:p>
           <a:p>
+            <a:endParaRPr lang="en-GB" dirty="0"/>
+          </a:p>
+          <a:p>
+            <a:r>
+              <a:rPr lang="en-GB" dirty="0"/>
+              <a:t>Small accommodations.</a:t>
+            </a:r>
+          </a:p>
+          <a:p>
+            <a:r>
+              <a:rPr lang="en-GB" dirty="0"/>
+              <a:t>Drift happens through a series of small accommodations that go unchallenged. What is tolerated becomes what is normal, and by the time the values have shifted no one can point to the moment it happened. Leaders who want to protect what the organisation stands for must challenge early drift.</a:t>
+            </a:r>
+          </a:p>
+          <a:p>
+            <a:r>
+              <a:rPr lang="en-GB" dirty="0"/>
+              <a:t>Source: Journal, 16 April 2026 — Professional Insights: Culture</a:t>
+            </a:r>
+          </a:p>
+          <a:p>
             <a:br>
               <a:rPr lang="en-ZA" dirty="0"/>
             </a:br>
@@ -6750,71 +6855,6 @@
             <a:r>
               <a:rPr lang="en-ZA" b="1" dirty="0"/>
               <a:t>“Bias begins in judgement. Its cost appears in strategy.”</a:t>
-            </a:r>
-          </a:p>
-          <a:p>
-            <a:endParaRPr lang="en-ZA" b="1" dirty="0"/>
-          </a:p>
-          <a:p>
-            <a:r>
-              <a:rPr lang="en-ZA" b="1" dirty="0"/>
-              <a:t>Professional Insights</a:t>
-            </a:r>
-            <a:endParaRPr lang="en-ZA" dirty="0"/>
-          </a:p>
-          <a:p/>
-          <a:p>
-            <a:r>
-              <a:t>Misallocated Capital · where the resources go: Cultures are revealed by their budget allocations and recognition rituals. List the three things the team has invested most resource in over the last quarter and the three things it has most publicly celebrated. If those lists do not match the stated values, the values on the wall are decoration.</a:t>
-            </a:r>
-          </a:p>
-          <a:p>
-            <a:r>
-              <a:t>Source: Journal, 26 April 2026 — Professional Insights: Culture</a:t>
-            </a:r>
-          </a:p>
-          <a:p/>
-          <a:p>
-            <a:r>
-              <a:t>Strategic Inertia · programmes that outlive their purpose: Senior leaders accumulate programmes built to reproduce past breakthroughs. Identify one programme, ritual or initiative that exists mainly because something like it succeeded before, and pull the data on whether it still produces the original effect. If the case for keeping it is mostly nostalgia, schedule its sunset this quarter.</a:t>
-            </a:r>
-          </a:p>
-          <a:p>
-            <a:r>
-              <a:t>Source: Journal, 6 May 2026 — Professional Insights: Leadership</a:t>
-            </a:r>
-          </a:p>
-          <a:p/>
-          <a:p>
-            <a:r>
-              <a:t>Execution Failure · failing, or still maturing: Strategic outcomes are usually cumulative. Capability, trust, customer loyalty and operational discipline are built through repeated investments whose effects may not be immediately visible. Good execution distinguishes between an initiative that is failing and one whose results have not yet matured, while using evidence to test whether the underlying assumptions remain valid.</a:t>
-            </a:r>
-          </a:p>
-          <a:p>
-            <a:r>
-              <a:t>Source: Journal, 1 October 2026 — Professional Insights: Strategy</a:t>
-            </a:r>
-          </a:p>
-          <a:p/>
-          <a:p>
-            <a:r>
-              <a:t>Innovation Suppression · protect the truth-teller: Organisations often face the most intense resistance to necessary truth from the people who should be most invested in hearing it. Build the protection of truth-tellers into the structure of the culture as well as the values statement.</a:t>
-            </a:r>
-          </a:p>
-          <a:p>
-            <a:r>
-              <a:t>Source: Journal, 7 February 2026 — Professional Insights: Culture</a:t>
-            </a:r>
-          </a:p>
-          <a:p/>
-          <a:p>
-            <a:r>
-              <a:t>Purpose Drift · small accommodations: Drift happens through a series of small accommodations that go unchallenged. What is tolerated becomes what is normal, and by the time the values have shifted no one can point to the moment it happened. Leaders who want to protect what the organisation stands for must challenge early drift.</a:t>
-            </a:r>
-          </a:p>
-          <a:p>
-            <a:r>
-              <a:t>Source: Journal, 16 April 2026 — Professional Insights: Culture</a:t>
             </a:r>
           </a:p>
           <a:p>
@@ -7418,6 +7458,27 @@
             </a:r>
           </a:p>
           <a:p>
+            <a:endParaRPr lang="en-GB" dirty="0"/>
+          </a:p>
+          <a:p>
+            <a:r>
+              <a:rPr lang="en-GB" dirty="0"/>
+              <a:t>Diagnosis beneath visible behaviour.</a:t>
+            </a:r>
+          </a:p>
+          <a:p>
+            <a:r>
+              <a:rPr lang="en-GB" dirty="0"/>
+              <a:t>Organisations misdiagnose problems when they address visible symptoms without examining the beliefs producing them. Persistent silo behaviour or poor accountability may survive new processes because the underlying assumptions remain intact. Ask what is happening, and what logic keeps making this behaviour reasonable to the people practising it.</a:t>
+            </a:r>
+          </a:p>
+          <a:p>
+            <a:r>
+              <a:rPr lang="en-GB" dirty="0"/>
+              <a:t>Source: Journal, 2 October 2026 — Professional Insights: Strategy</a:t>
+            </a:r>
+          </a:p>
+          <a:p>
             <a:endParaRPr lang="en-ZA" dirty="0"/>
           </a:p>
           <a:p>
@@ -7490,6 +7551,27 @@
             </a:r>
           </a:p>
           <a:p>
+            <a:endParaRPr lang="en-GB" dirty="0"/>
+          </a:p>
+          <a:p>
+            <a:r>
+              <a:rPr lang="en-GB" dirty="0"/>
+              <a:t>Deciding first.</a:t>
+            </a:r>
+          </a:p>
+          <a:p>
+            <a:r>
+              <a:rPr lang="en-GB" dirty="0"/>
+              <a:t>Organisations often decide first and then use analysis to validate the decision. Sound strategy needs enough humility to let evidence alter the chosen path.</a:t>
+            </a:r>
+          </a:p>
+          <a:p>
+            <a:r>
+              <a:rPr lang="en-GB" dirty="0"/>
+              <a:t>Source: Journal, 17 September 2026 — Professional Insights: Strategy</a:t>
+            </a:r>
+          </a:p>
+          <a:p>
             <a:endParaRPr lang="en-ZA" b="1" dirty="0"/>
           </a:p>
           <a:p>
@@ -7498,6 +7580,27 @@
               <a:t>A strategy built on a flawed diagnosis can become a well-organised response to a reality the organisation has misread.</a:t>
             </a:r>
             <a:endParaRPr lang="en-ZA" dirty="0"/>
+          </a:p>
+          <a:p>
+            <a:endParaRPr lang="en-GB" dirty="0"/>
+          </a:p>
+          <a:p>
+            <a:r>
+              <a:rPr lang="en-GB" dirty="0"/>
+              <a:t>Disciplined diagnosis.</a:t>
+            </a:r>
+          </a:p>
+          <a:p>
+            <a:r>
+              <a:rPr lang="en-GB" dirty="0"/>
+              <a:t>Consequential decisions require leaders to separate facts from framing, individual interests from institutional interests, and genuine risk from manufactured urgency.</a:t>
+            </a:r>
+          </a:p>
+          <a:p>
+            <a:r>
+              <a:rPr lang="en-GB" dirty="0"/>
+              <a:t>Source: Journal, 14 August 2026 — Professional Insights: Strategy</a:t>
+            </a:r>
           </a:p>
           <a:p>
             <a:endParaRPr lang="en-ZA" b="1" dirty="0"/>
@@ -8013,6 +8116,27 @@
             </a:r>
           </a:p>
           <a:p>
+            <a:endParaRPr lang="en-GB" dirty="0"/>
+          </a:p>
+          <a:p>
+            <a:r>
+              <a:rPr lang="en-GB" dirty="0"/>
+              <a:t>The sunk-cost trap.</a:t>
+            </a:r>
+          </a:p>
+          <a:p>
+            <a:r>
+              <a:rPr lang="en-GB" dirty="0"/>
+              <a:t>Organisations often continue weak initiatives because money, reputation or effort has already been invested, defending yesterday’s choice at the expense of tomorrow’s outcome. Sound strategy needs the courage to discontinue an unsuitable course, absorb the immediate cost and return to the principles that should govern the decision.</a:t>
+            </a:r>
+          </a:p>
+          <a:p>
+            <a:r>
+              <a:rPr lang="en-GB" dirty="0"/>
+              <a:t>Source: Journal, 22 July 2026 — Professional Insights: Strategy</a:t>
+            </a:r>
+          </a:p>
+          <a:p>
             <a:endParaRPr lang="en-ZA" dirty="0"/>
           </a:p>
           <a:p>
@@ -8131,127 +8255,143 @@
             </a:pPr>
             <a:r>
               <a:rPr lang="en-ZA" b="1" dirty="0"/>
-              <a:t>Link to how bias may </a:t>
-            </a:r>
-            <a:r>
-              <a:rPr lang="en-ZA" b="1"/>
-              <a:t>influence execution</a:t>
-            </a:r>
+              <a:t>Link to how bias may influence execution</a:t>
+            </a:r>
+          </a:p>
+          <a:p>
+            <a:endParaRPr lang="en-ZA" dirty="0"/>
+          </a:p>
+          <a:p>
+            <a:r>
+              <a:rPr lang="en-ZA" dirty="0"/>
+              <a:t>The </a:t>
+            </a:r>
+            <a:r>
+              <a:rPr lang="en-ZA" b="1" dirty="0"/>
+              <a:t>Planning Fallacy</a:t>
+            </a:r>
+            <a:r>
+              <a:rPr lang="en-ZA" dirty="0"/>
+              <a:t> means the execution plan may already underestimate the time, resources and complexity required. </a:t>
+            </a:r>
+          </a:p>
+          <a:p>
+            <a:r>
+              <a:rPr lang="en-ZA" dirty="0"/>
+              <a:t>Interdependencies between teams and functions can be underweighted until they become visible during delivery.</a:t>
+            </a:r>
+          </a:p>
+          <a:p>
+            <a:endParaRPr lang="en-ZA" dirty="0"/>
+          </a:p>
+          <a:p>
+            <a:r>
+              <a:rPr lang="en-ZA" b="1" dirty="0"/>
+              <a:t>Confirmation Bias</a:t>
+            </a:r>
+            <a:r>
+              <a:rPr lang="en-ZA" dirty="0"/>
+              <a:t>, in its action-reinforcing form, influences how people interpret execution signals. </a:t>
+            </a:r>
+          </a:p>
+          <a:p>
+            <a:r>
+              <a:rPr lang="en-ZA" dirty="0"/>
+              <a:t>Green indicators are noticed. Amber indicators can be rationalised. Red indicators may be attributed to temporary conditions. </a:t>
+            </a:r>
+          </a:p>
+          <a:p>
+            <a:r>
+              <a:rPr lang="en-ZA" dirty="0"/>
+              <a:t>By the time the evidence becomes undeniable, the opportunity for course correction may have narrowed.</a:t>
+            </a:r>
+          </a:p>
+          <a:p>
+            <a:endParaRPr lang="en-GB" dirty="0"/>
+          </a:p>
+          <a:p>
+            <a:r>
+              <a:rPr lang="en-GB" dirty="0"/>
+              <a:t>Outcomes taken as proof.</a:t>
+            </a:r>
+          </a:p>
+          <a:p>
+            <a:r>
+              <a:rPr lang="en-GB" dirty="0"/>
+              <a:t>Senior teams routinely read good outcomes as evidence of sound process. A deal closes or a launch lands, and the messy path that produced it is quietly adopted as the method. Ask participants to pick one recent win and audit how it happened separately from what it produced.</a:t>
+            </a:r>
+          </a:p>
+          <a:p>
+            <a:r>
+              <a:rPr lang="en-GB" dirty="0"/>
+              <a:t>Source: Journal, 24 April 2026 — Professional Insights: Culture</a:t>
+            </a:r>
+          </a:p>
+          <a:p>
+            <a:endParaRPr lang="en-ZA" dirty="0"/>
+          </a:p>
+          <a:p>
+            <a:r>
+              <a:rPr lang="en-ZA" b="1" dirty="0"/>
+              <a:t>Incentive Bias</a:t>
+            </a:r>
+            <a:r>
+              <a:rPr lang="en-ZA" dirty="0"/>
+              <a:t> can fracture alignment. People naturally pay attention to what they are measured and rewarded for. </a:t>
+            </a:r>
+          </a:p>
+          <a:p>
+            <a:r>
+              <a:rPr lang="en-ZA" dirty="0"/>
+              <a:t>When those incentives do not align with the strategy, individuals and teams can deliver against their own measures while the enterprise outcome falls behind.</a:t>
+            </a:r>
+          </a:p>
+          <a:p>
+            <a:endParaRPr lang="en-ZA" dirty="0"/>
+          </a:p>
+          <a:p>
+            <a:r>
+              <a:rPr lang="en-ZA" b="1" dirty="0"/>
+              <a:t>Self-Interest and Functional Bias</a:t>
+            </a:r>
+            <a:r>
+              <a:rPr lang="en-ZA" dirty="0"/>
+              <a:t> can fragment what the strategy requires to be integrated. Each function executes its part. </a:t>
+            </a:r>
+          </a:p>
+          <a:p>
+            <a:r>
+              <a:rPr lang="en-ZA" dirty="0"/>
+              <a:t>Each team pursues its KPIs. Yet execution often depends on contributions crossing organisational boundaries.</a:t>
+            </a:r>
+          </a:p>
+          <a:p>
+            <a:endParaRPr lang="en-ZA" dirty="0"/>
+          </a:p>
+          <a:p>
+            <a:r>
+              <a:rPr lang="en-ZA" dirty="0"/>
+              <a:t>This is where the </a:t>
+            </a:r>
+            <a:r>
+              <a:rPr lang="en-ZA" b="1" dirty="0"/>
+              <a:t>White Space</a:t>
+            </a:r>
+            <a:r>
+              <a:rPr lang="en-ZA" dirty="0"/>
+              <a:t> we examined earlier becomes particularly important.</a:t>
+            </a:r>
+          </a:p>
+          <a:p>
+            <a:r>
+              <a:rPr lang="en-ZA" dirty="0"/>
+              <a:t>People can perform successfully within their own mandates while the dependencies, hand-offs and competing requirements between those mandates remain unresolved.</a:t>
+            </a:r>
+          </a:p>
+          <a:p>
             <a:endParaRPr lang="en-ZA" b="1" dirty="0"/>
           </a:p>
           <a:p>
-            <a:endParaRPr lang="en-ZA" dirty="0"/>
-          </a:p>
-          <a:p>
-            <a:r>
-              <a:rPr lang="en-ZA" dirty="0"/>
-              <a:t>The </a:t>
-            </a:r>
-            <a:r>
-              <a:rPr lang="en-ZA" b="1" dirty="0"/>
-              <a:t>Planning Fallacy</a:t>
-            </a:r>
-            <a:r>
-              <a:rPr lang="en-ZA" dirty="0"/>
-              <a:t> means the execution plan may already underestimate the time, resources and complexity required. </a:t>
-            </a:r>
-          </a:p>
-          <a:p>
-            <a:r>
-              <a:rPr lang="en-ZA" dirty="0"/>
-              <a:t>Interdependencies between teams and functions can be underweighted until they become visible during delivery.</a:t>
-            </a:r>
-          </a:p>
-          <a:p>
-            <a:endParaRPr lang="en-ZA" dirty="0"/>
-          </a:p>
-          <a:p>
-            <a:r>
-              <a:rPr lang="en-ZA" b="1" dirty="0"/>
-              <a:t>Confirmation Bias</a:t>
-            </a:r>
-            <a:r>
-              <a:rPr lang="en-ZA" dirty="0"/>
-              <a:t>, in its action-reinforcing form, influences how people interpret execution signals. </a:t>
-            </a:r>
-          </a:p>
-          <a:p>
-            <a:r>
-              <a:rPr lang="en-ZA" dirty="0"/>
-              <a:t>Green indicators are noticed. Amber indicators can be rationalised. Red indicators may be attributed to temporary conditions. </a:t>
-            </a:r>
-          </a:p>
-          <a:p>
-            <a:r>
-              <a:rPr lang="en-ZA" dirty="0"/>
-              <a:t>By the time the evidence becomes undeniable, the opportunity for course correction may have narrowed.</a:t>
-            </a:r>
-          </a:p>
-          <a:p>
-            <a:endParaRPr lang="en-ZA" dirty="0"/>
-          </a:p>
-          <a:p>
-            <a:r>
-              <a:rPr lang="en-ZA" b="1" dirty="0"/>
-              <a:t>Incentive Bias</a:t>
-            </a:r>
-            <a:r>
-              <a:rPr lang="en-ZA" dirty="0"/>
-              <a:t> can fracture alignment. People naturally pay attention to what they are measured and rewarded for. </a:t>
-            </a:r>
-          </a:p>
-          <a:p>
-            <a:r>
-              <a:rPr lang="en-ZA" dirty="0"/>
-              <a:t>When those incentives do not align with the strategy, individuals and teams can deliver against their own measures while the enterprise outcome falls behind.</a:t>
-            </a:r>
-          </a:p>
-          <a:p>
-            <a:endParaRPr lang="en-ZA" dirty="0"/>
-          </a:p>
-          <a:p>
-            <a:r>
-              <a:rPr lang="en-ZA" b="1" dirty="0"/>
-              <a:t>Self-Interest and Functional Bias</a:t>
-            </a:r>
-            <a:r>
-              <a:rPr lang="en-ZA" dirty="0"/>
-              <a:t> can fragment what the strategy requires to be integrated. Each function executes its part. </a:t>
-            </a:r>
-          </a:p>
-          <a:p>
-            <a:r>
-              <a:rPr lang="en-ZA" dirty="0"/>
-              <a:t>Each team pursues its KPIs. Yet execution often depends on contributions crossing organisational boundaries.</a:t>
-            </a:r>
-          </a:p>
-          <a:p>
-            <a:endParaRPr lang="en-ZA" dirty="0"/>
-          </a:p>
-          <a:p>
-            <a:r>
-              <a:rPr lang="en-ZA" dirty="0"/>
-              <a:t>This is where the </a:t>
-            </a:r>
-            <a:r>
-              <a:rPr lang="en-ZA" b="1" dirty="0"/>
-              <a:t>White Space</a:t>
-            </a:r>
-            <a:r>
-              <a:rPr lang="en-ZA" dirty="0"/>
-              <a:t> we examined earlier becomes particularly important.</a:t>
-            </a:r>
-          </a:p>
-          <a:p>
-            <a:r>
-              <a:rPr lang="en-ZA" dirty="0"/>
-              <a:t>People can perform successfully within their own mandates while the dependencies, hand-offs and competing requirements between those mandates remain unresolved.</a:t>
-            </a:r>
-          </a:p>
-          <a:p>
-            <a:endParaRPr lang="en-ZA" b="1" dirty="0"/>
-          </a:p>
-          <a:p>
             <a:r>
               <a:rPr lang="en-ZA" b="1" dirty="0"/>
               <a:t>The people delivering the strategy are therefore not passive recipients of a strategy designed elsewhere. </a:t>
@@ -8261,6 +8401,27 @@
             <a:r>
               <a:rPr lang="en-ZA" b="1" dirty="0"/>
               <a:t>Through the decisions, interpretations and behaviours of execution, they continue shaping what the strategy ultimately becomes.</a:t>
+            </a:r>
+          </a:p>
+          <a:p>
+            <a:endParaRPr lang="en-GB" dirty="0"/>
+          </a:p>
+          <a:p>
+            <a:r>
+              <a:rPr lang="en-GB" dirty="0"/>
+              <a:t>Line of sight.</a:t>
+            </a:r>
+          </a:p>
+          <a:p>
+            <a:r>
+              <a:rPr lang="en-GB" dirty="0"/>
+              <a:t>Leaders have a responsibility to allocate work and to create line of sight between contribution and collective purpose. When people understand where they fit, responsibility becomes more meaningful and coordination becomes easier.</a:t>
+            </a:r>
+          </a:p>
+          <a:p>
+            <a:r>
+              <a:rPr lang="en-GB" dirty="0"/>
+              <a:t>Source: Journal, 3 October 2026 — Professional Insights: Leadership</a:t>
             </a:r>
           </a:p>
           <a:p>
@@ -8324,82 +8485,6 @@
             <a:r>
               <a:rPr lang="en-ZA" b="1" dirty="0"/>
               <a:t>ASK and DISCUSS “At which of the four phases is your organisation currently most exposed? </a:t>
-            </a:r>
-          </a:p>
-          <a:p>
-            <a:endParaRPr lang="en-ZA" b="1" dirty="0"/>
-          </a:p>
-          <a:p>
-            <a:r>
-              <a:rPr lang="en-ZA" b="1" dirty="0"/>
-              <a:t>Professional Insights</a:t>
-            </a:r>
-            <a:endParaRPr dirty="0"/>
-          </a:p>
-          <a:p/>
-          <a:p>
-            <a:r>
-              <a:t>Phase 1 · deciding first: Organisations often decide first and then use analysis to validate the decision. Sound strategy needs enough humility to let evidence alter the chosen path. Use this with Confirmation Bias.</a:t>
-            </a:r>
-          </a:p>
-          <a:p>
-            <a:r>
-              <a:t>Source: Journal, 17 September 2026 — Professional Insights: Strategy</a:t>
-            </a:r>
-          </a:p>
-          <a:p/>
-          <a:p>
-            <a:r>
-              <a:t>Phase 1 · diagnosis beneath visible behaviour: Organisations misdiagnose problems when they address visible symptoms without examining the beliefs producing them. Persistent silo behaviour or poor accountability may survive new processes because the underlying assumptions remain intact. Ask what is happening, and what logic keeps making this behaviour reasonable to the people practising it.</a:t>
-            </a:r>
-          </a:p>
-          <a:p>
-            <a:r>
-              <a:t>Source: Journal, 2 October 2026 — Professional Insights: Strategy</a:t>
-            </a:r>
-          </a:p>
-          <a:p/>
-          <a:p>
-            <a:r>
-              <a:t>Phases 1 and 2 · disciplined diagnosis: Consequential decisions require leaders to separate facts from framing, individual interests from institutional interests, and genuine risk from manufactured urgency.</a:t>
-            </a:r>
-          </a:p>
-          <a:p>
-            <a:r>
-              <a:t>Source: Journal, 14 August 2026 — Professional Insights: Strategy</a:t>
-            </a:r>
-          </a:p>
-          <a:p/>
-          <a:p>
-            <a:r>
-              <a:t>Phase 3 · the sunk-cost trap: Organisations often continue weak initiatives because money, reputation or effort has already been invested, defending yesterday’s choice at the expense of tomorrow’s outcome. Sound strategy needs the courage to discontinue an unsuitable course, absorb the immediate cost and return to the principles that should govern the decision.</a:t>
-            </a:r>
-          </a:p>
-          <a:p>
-            <a:r>
-              <a:t>Source: Journal, 22 July 2026 — Professional Insights: Strategy</a:t>
-            </a:r>
-          </a:p>
-          <a:p/>
-          <a:p>
-            <a:r>
-              <a:t>Phase 4 · outcomes taken as proof: Senior teams routinely read good outcomes as evidence of sound process. A deal closes or a launch lands, and the messy path that produced it is quietly adopted as the method. Ask participants to pick one recent win and audit how it happened separately from what it produced.</a:t>
-            </a:r>
-          </a:p>
-          <a:p>
-            <a:r>
-              <a:t>Source: Journal, 24 April 2026 — Professional Insights: Culture</a:t>
-            </a:r>
-          </a:p>
-          <a:p/>
-          <a:p>
-            <a:r>
-              <a:t>Phase 4 · line of sight: Leaders have a responsibility to allocate work and to create line of sight between contribution and collective purpose. When people understand where they fit, responsibility becomes more meaningful and coordination becomes easier. Use this with the Phase 4 scanner question.</a:t>
-            </a:r>
-          </a:p>
-          <a:p>
-            <a:r>
-              <a:t>Source: Journal, 3 October 2026 — Professional Insights: Leadership</a:t>
             </a:r>
           </a:p>
         </p:txBody>
@@ -8731,6 +8816,27 @@
             </a:r>
           </a:p>
           <a:p>
+            <a:endParaRPr lang="en-GB" dirty="0"/>
+          </a:p>
+          <a:p>
+            <a:r>
+              <a:rPr lang="en-GB" dirty="0"/>
+              <a:t>Alert without becoming absorbed.</a:t>
+            </a:r>
+          </a:p>
+          <a:p>
+            <a:r>
+              <a:rPr lang="en-GB" dirty="0"/>
+              <a:t>When leaders become psychologically captured by a threat, organisations often inherit that preoccupation through excessive controls, defensive decisions or distorted priorities. Mature leadership keeps problems in proportion and preserves enough internal steadiness to continue exercising judgement.</a:t>
+            </a:r>
+          </a:p>
+          <a:p>
+            <a:r>
+              <a:rPr lang="en-GB" dirty="0"/>
+              <a:t>Source: Journal, 4 October 2026 — Professional Insights: Leadership</a:t>
+            </a:r>
+          </a:p>
+          <a:p>
             <a:endParaRPr lang="en-ZA" dirty="0"/>
           </a:p>
           <a:p>
@@ -8821,6 +8927,27 @@
             </a:r>
           </a:p>
           <a:p>
+            <a:endParaRPr lang="en-GB" dirty="0"/>
+          </a:p>
+          <a:p>
+            <a:r>
+              <a:rPr lang="en-GB" dirty="0"/>
+              <a:t>What authority creates.</a:t>
+            </a:r>
+          </a:p>
+          <a:p>
+            <a:r>
+              <a:rPr lang="en-GB" dirty="0"/>
+              <a:t>A technically correct leader can still generate fear, silence or defensive behaviour through the way they exercise authority. Leaders need to examine what their habitual responses create around them, alongside what their decisions accomplish.</a:t>
+            </a:r>
+          </a:p>
+          <a:p>
+            <a:r>
+              <a:rPr lang="en-GB" dirty="0"/>
+              <a:t>Source: Journal, 30 September 2026 — Professional Insights: Leadership</a:t>
+            </a:r>
+          </a:p>
+          <a:p>
             <a:endParaRPr lang="en-ZA" b="1" dirty="0"/>
           </a:p>
           <a:p>
@@ -8850,6 +8977,27 @@
             <a:r>
               <a:rPr lang="en-ZA" dirty="0"/>
               <a:t>Fear makes it harder for people to think openly. They may keep quiet, agree with others or avoid challenging senior people. This means important information and different ideas may never enter the conversation.</a:t>
+            </a:r>
+          </a:p>
+          <a:p>
+            <a:endParaRPr lang="en-GB" dirty="0"/>
+          </a:p>
+          <a:p>
+            <a:r>
+              <a:rPr lang="en-GB" dirty="0"/>
+              <a:t>Anxiety that governs decisions.</a:t>
+            </a:r>
+          </a:p>
+          <a:p>
+            <a:r>
+              <a:rPr lang="en-GB" dirty="0"/>
+              <a:t>The danger arises when internal anxiety begins governing external decisions. Fear can produce unnecessary control, rushed decisions, avoidance or constant changes in direction.</a:t>
+            </a:r>
+          </a:p>
+          <a:p>
+            <a:r>
+              <a:rPr lang="en-GB" dirty="0"/>
+              <a:t>Source: Journal, 3 October 2026 — Professional Insights: Leadership</a:t>
             </a:r>
           </a:p>
           <a:p>
@@ -8878,6 +9026,27 @@
             </a:r>
           </a:p>
           <a:p>
+            <a:endParaRPr lang="en-GB" dirty="0"/>
+          </a:p>
+          <a:p>
+            <a:r>
+              <a:rPr lang="en-GB" dirty="0"/>
+              <a:t>The echo chamber.</a:t>
+            </a:r>
+          </a:p>
+          <a:p>
+            <a:r>
+              <a:rPr lang="en-GB" dirty="0"/>
+              <a:t>When advisers reinforce the posture the leader already wants to adopt, the leadership team becomes an echo chamber. People learn that influence is gained through agreement, and the culture loses the ability to challenge damaging assumptions.</a:t>
+            </a:r>
+          </a:p>
+          <a:p>
+            <a:r>
+              <a:rPr lang="en-GB" dirty="0"/>
+              <a:t>Source: Journal, 17 July 2026 — Professional Insights: Culture</a:t>
+            </a:r>
+          </a:p>
+          <a:p>
             <a:endParaRPr lang="en-ZA" b="1" dirty="0"/>
           </a:p>
           <a:p>
@@ -8907,6 +9076,27 @@
             <a:r>
               <a:rPr lang="en-ZA" dirty="0"/>
               <a:t>People look for reasons why the chosen direction is right and stop asking whether it could be wrong. Different views receive less attention, and the same thinking gets repeated and reinforced.</a:t>
+            </a:r>
+          </a:p>
+          <a:p>
+            <a:endParaRPr lang="en-GB" dirty="0"/>
+          </a:p>
+          <a:p>
+            <a:r>
+              <a:rPr lang="en-GB" dirty="0"/>
+              <a:t>Secure identity.</a:t>
+            </a:r>
+          </a:p>
+          <a:p>
+            <a:r>
+              <a:rPr lang="en-GB" dirty="0"/>
+              <a:t>Leaders who derive too much identity from position, recognition or being right can experience disagreement as a personal threat. Secure leaders have greater capacity to listen, share authority, acknowledge mistakes and recognise others. Inner security becomes an organisational capability.</a:t>
+            </a:r>
+          </a:p>
+          <a:p>
+            <a:r>
+              <a:rPr lang="en-GB" dirty="0"/>
+              <a:t>Source: Journal, 2 October 2026 — Professional Insights: Leadership</a:t>
             </a:r>
           </a:p>
           <a:p>
@@ -8948,6 +9138,27 @@
             <a:r>
               <a:rPr lang="en-ZA" dirty="0"/>
               <a:t>The organisation can respond when things change. It can question its assumptions, learn from what is happening and adjust the strategy when needed without losing direction.</a:t>
+            </a:r>
+          </a:p>
+          <a:p>
+            <a:endParaRPr lang="en-GB" dirty="0"/>
+          </a:p>
+          <a:p>
+            <a:r>
+              <a:rPr lang="en-GB" dirty="0"/>
+              <a:t>Calm before the crisis.</a:t>
+            </a:r>
+          </a:p>
+          <a:p>
+            <a:r>
+              <a:rPr lang="en-GB" dirty="0"/>
+              <a:t>In a crisis, organisations with a culture of calm, evidence-based thinking hold their nerve better than those that follow the emotional temperature of the room. Build the capacity for calm assessment before you need it.</a:t>
+            </a:r>
+          </a:p>
+          <a:p>
+            <a:r>
+              <a:rPr lang="en-GB" dirty="0"/>
+              <a:t>Source: Journal, 13 January 2026 — Professional Insights: Culture</a:t>
             </a:r>
           </a:p>
           <a:p>
@@ -8972,84 +9183,6 @@
               <a:t>
 </a:t>
             </a:r>
-          </a:p>
-          <a:p>
-            <a:r>
-              <a:rPr dirty="0"/>
-              <a:t>Professional insights:</a:t>
-            </a:r>
-          </a:p>
-          <a:p/>
-          <a:p>
-            <a:r>
-              <a:t>Emotional maturity · alert without becoming absorbed: When leaders become psychologically captured by a threat, organisations often inherit that preoccupation through excessive controls, defensive decisions or distorted priorities. Mature leadership keeps problems in proportion and preserves enough internal steadiness to continue exercising judgement.</a:t>
-            </a:r>
-          </a:p>
-          <a:p>
-            <a:r>
-              <a:t>Source: Journal, 4 October 2026 — Professional Insights: Leadership</a:t>
-            </a:r>
-          </a:p>
-          <a:p/>
-          <a:p>
-            <a:r>
-              <a:t>Fear-Dominated · what authority creates: A technically correct leader can still generate fear, silence or defensive behaviour through the way they exercise authority. Leaders need to examine what their habitual responses create around them, alongside what their decisions accomplish.</a:t>
-            </a:r>
-          </a:p>
-          <a:p>
-            <a:r>
-              <a:t>Source: Journal, 30 September 2026 — Professional Insights: Leadership</a:t>
-            </a:r>
-          </a:p>
-          <a:p/>
-          <a:p>
-            <a:r>
-              <a:t>Fear-Dominated · anxiety that governs decisions: The danger arises when internal anxiety begins governing external decisions. Fear can produce unnecessary control, rushed decisions, avoidance or constant changes in direction.</a:t>
-            </a:r>
-          </a:p>
-          <a:p>
-            <a:r>
-              <a:t>Source: Journal, 3 October 2026 — Professional Insights: Leadership</a:t>
-            </a:r>
-          </a:p>
-          <a:p/>
-          <a:p>
-            <a:r>
-              <a:t>Narcissism-Dominated · the echo chamber: When advisers reinforce the posture the leader already wants to adopt, the leadership team becomes an echo chamber. People learn that influence is gained through agreement, and the culture loses the ability to challenge damaging assumptions.</a:t>
-            </a:r>
-          </a:p>
-          <a:p>
-            <a:r>
-              <a:t>Source: Journal, 17 July 2026 — Professional Insights: Culture</a:t>
-            </a:r>
-          </a:p>
-          <a:p/>
-          <a:p>
-            <a:r>
-              <a:t>Narcissism-Dominated · secure identity: Leaders who derive too much identity from position, recognition or being right can experience disagreement as a personal threat. Secure leaders have greater capacity to listen, share authority, acknowledge mistakes and recognise others. Inner security becomes an organisational capability.</a:t>
-            </a:r>
-          </a:p>
-          <a:p>
-            <a:r>
-              <a:t>Source: Journal, 2 October 2026 — Professional Insights: Leadership</a:t>
-            </a:r>
-          </a:p>
-          <a:p/>
-          <a:p>
-            <a:r>
-              <a:t>Grounded Confidence · calm before the crisis: In a crisis, organisations with a culture of calm, evidence-based thinking hold their nerve better than those that follow the emotional temperature of the room. Build the capacity for calm assessment before you need it.</a:t>
-            </a:r>
-          </a:p>
-          <a:p>
-            <a:r>
-              <a:t>Source: Journal, 13 January 2026 — Professional Insights: Culture</a:t>
-            </a:r>
-          </a:p>
-          <a:p>
-            <a:endParaRPr lang="en-ZA" dirty="0"/>
-          </a:p>
-          <a:p>
-            <a:endParaRPr lang="en-ZA" dirty="0"/>
           </a:p>
           <a:p>
             <a:r>
@@ -9217,11 +9350,80 @@
               <a:t>
 Each state influences:
 - Engagement Energy — the level of discretionary effort, momentum, and willingness to contribute beyond minimum requirements.
-- Morale Drain — the degree to which emotional fatigue, disappointment, or disengagement reduces capacity and persistence.
-- Friction Load — the amount of hidden resistance, tension, or drag experienced in decisions, collaboration, and follow-through.
-- Psychological Safety — the extent to which individuals feel safe to speak, challenge, admit uncertainty, and take appropriate risk.
-- Values Alignment — the consistency between stated values, observed leadership behaviour, and everyday decisions under pressure.
-Key insight to reinforce: draw attention to the highlight box — “Unacknowledged emotional states silently override rational plans.</a:t>
+- Morale Drain — the degree to which emotional fatigue, disappointment, or disengagement reduces capacity and persistence.</a:t>
+            </a:r>
+          </a:p>
+          <a:p>
+            <a:endParaRPr lang="en-GB" dirty="0"/>
+          </a:p>
+          <a:p>
+            <a:r>
+              <a:rPr lang="en-GB" dirty="0"/>
+              <a:t>Cultures become healthier when people can voice concern, disappointment or uncertainty without being labelled negative or disloyal. Suppressed emotion moves underground.</a:t>
+            </a:r>
+          </a:p>
+          <a:p>
+            <a:r>
+              <a:rPr lang="en-GB" dirty="0"/>
+              <a:t>Source: Journal, 5 September 2026 — Professional Insights: Culture</a:t>
+            </a:r>
+          </a:p>
+          <a:p>
+            <a:endParaRPr lang="en-GB" dirty="0"/>
+          </a:p>
+          <a:p>
+            <a:r>
+              <a:rPr lang="en-US" dirty="0"/>
+              <a:t>- Friction Load — the amount of hidden resistance, tension, or drag experienced in decisions, collaboration, and follow-through.
+- Psychological Safety — the extent to which individuals feel safe to speak, challenge, admit uncertainty, and take appropriate risk.</a:t>
+            </a:r>
+          </a:p>
+          <a:p>
+            <a:endParaRPr lang="en-GB" dirty="0"/>
+          </a:p>
+          <a:p>
+            <a:r>
+              <a:rPr lang="en-GB" dirty="0"/>
+              <a:t>Part of an organisation’s culture is what people believe will happen to them if they try something and it fails. Where the prevailing belief is that failure is punished, people stop trying, whatever the stated values say. Examine what people saw happen to the last person who took a risk and got it wrong.</a:t>
+            </a:r>
+          </a:p>
+          <a:p>
+            <a:r>
+              <a:rPr lang="en-GB" dirty="0"/>
+              <a:t>Source: Journal, 13 May 2026 — Professional Insights: Culture</a:t>
+            </a:r>
+          </a:p>
+          <a:p>
+            <a:endParaRPr lang="en-GB" dirty="0"/>
+          </a:p>
+          <a:p>
+            <a:r>
+              <a:rPr lang="en-US" dirty="0"/>
+              <a:t>- Values Alignment — the consistency between stated values, observed leadership behaviour, and everyday decisions under pressure.</a:t>
+            </a:r>
+          </a:p>
+          <a:p>
+            <a:endParaRPr lang="en-GB" dirty="0"/>
+          </a:p>
+          <a:p>
+            <a:r>
+              <a:rPr lang="en-GB" dirty="0"/>
+              <a:t>An organisation may repeatedly communicate integrity, collaboration or accountability while rewarding behaviour that contradicts those values. Employees learn that the real culture is encoded in consequences. Culture becomes credible when what leaders praise publicly, tolerate privately and reward materially tells the same story.</a:t>
+            </a:r>
+          </a:p>
+          <a:p>
+            <a:r>
+              <a:rPr lang="en-GB" dirty="0"/>
+              <a:t>Source: Journal, 1 October 2026 — Professional Insights: Culture</a:t>
+            </a:r>
+          </a:p>
+          <a:p>
+            <a:endParaRPr lang="en-GB" dirty="0"/>
+          </a:p>
+          <a:p>
+            <a:r>
+              <a:rPr lang="en-US" dirty="0"/>
+              <a:t>Key insight to reinforce: draw attention to the highlight box — “Unacknowledged emotional states silently override rational plans.</a:t>
             </a:r>
           </a:p>
           <a:p>
@@ -9248,54 +9450,6 @@
               <a:rPr lang="en-ZA" dirty="0"/>
               <a:t>.</a:t>
             </a:r>
-          </a:p>
-          <a:p>
-            <a:endParaRPr lang="en-ZA" dirty="0"/>
-          </a:p>
-          <a:p>
-            <a:endParaRPr dirty="0"/>
-          </a:p>
-          <a:p>
-            <a:r>
-              <a:rPr dirty="0"/>
-              <a:t>Professional insights:</a:t>
-            </a:r>
-          </a:p>
-          <a:p/>
-          <a:p>
-            <a:r>
-              <a:t>Psychological Safety: Part of an organisation’s culture is what people believe will happen to them if they try something and it fails. Where the prevailing belief is that failure is punished, people stop trying, whatever the stated values say. Examine what people saw happen to the last person who took a risk and got it wrong.</a:t>
-            </a:r>
-          </a:p>
-          <a:p>
-            <a:r>
-              <a:t>Source: Journal, 13 May 2026 — Professional Insights: Culture</a:t>
-            </a:r>
-          </a:p>
-          <a:p/>
-          <a:p>
-            <a:r>
-              <a:t>Morale Drain: Cultures become healthier when people can voice concern, disappointment or uncertainty without being labelled negative or disloyal. Suppressed emotion moves underground.</a:t>
-            </a:r>
-          </a:p>
-          <a:p>
-            <a:r>
-              <a:t>Source: Journal, 5 September 2026 — Professional Insights: Culture</a:t>
-            </a:r>
-          </a:p>
-          <a:p/>
-          <a:p>
-            <a:r>
-              <a:t>Values Alignment: An organisation may repeatedly communicate integrity, collaboration or accountability while rewarding behaviour that contradicts those values. Employees learn that the real culture is encoded in consequences. Culture becomes credible when what leaders praise publicly, tolerate privately and reward materially tells the same story.</a:t>
-            </a:r>
-          </a:p>
-          <a:p>
-            <a:r>
-              <a:t>Source: Journal, 1 October 2026 — Professional Insights: Culture</a:t>
-            </a:r>
-          </a:p>
-          <a:p>
-            <a:endParaRPr dirty="0"/>
           </a:p>
         </p:txBody>
       </p:sp>
@@ -9475,6 +9629,30 @@
             </a:r>
           </a:p>
           <a:p>
+            <a:endParaRPr lang="en-GB" dirty="0"/>
+          </a:p>
+          <a:p>
+            <a:r>
+              <a:rPr lang="en-GB" dirty="0"/>
+              <a:t>Emotionally honest leadership.</a:t>
+            </a:r>
+          </a:p>
+          <a:p>
+            <a:r>
+              <a:rPr lang="en-GB" dirty="0"/>
+              <a:t>Leaders do not strengthen people by pretending that fear, disappointment or grief do not exist. Mature leadership makes space for reality while helping people move from raw emotion toward reflection, meaning and renewed trust.</a:t>
+            </a:r>
+          </a:p>
+          <a:p>
+            <a:r>
+              <a:rPr lang="en-GB" dirty="0"/>
+              <a:t>Source: Journal, 5 September 2026 — Professional Insights: Leadership</a:t>
+            </a:r>
+          </a:p>
+          <a:p>
+            <a:endParaRPr lang="en-GB" dirty="0"/>
+          </a:p>
+          <a:p>
             <a:r>
               <a:rPr lang="en-ZA" b="1" dirty="0"/>
               <a:t>Ask </a:t>
@@ -9569,6 +9747,27 @@
             </a:r>
           </a:p>
           <a:p>
+            <a:endParaRPr lang="en-GB" dirty="0"/>
+          </a:p>
+          <a:p>
+            <a:r>
+              <a:rPr lang="en-GB" dirty="0"/>
+              <a:t>Listen before you reframe.</a:t>
+            </a:r>
+          </a:p>
+          <a:p>
+            <a:r>
+              <a:rPr lang="en-GB" dirty="0"/>
+              <a:t>Cultures that move straight from “here is what changed” to “here is what we need you to do next” produce resistance they cannot explain. The resistance signals that people do not yet feel understood. In a restructure, a strategic pivot or a change in leadership, listening is the load-bearing wall.</a:t>
+            </a:r>
+          </a:p>
+          <a:p>
+            <a:r>
+              <a:rPr lang="en-GB" dirty="0"/>
+              <a:t>Source: Journal, 25 June 2026 — Professional Insights: Culture</a:t>
+            </a:r>
+          </a:p>
+          <a:p>
             <a:endParaRPr lang="en-ZA" b="1" dirty="0"/>
           </a:p>
           <a:p>
@@ -9645,6 +9844,27 @@
             </a:r>
           </a:p>
           <a:p>
+            <a:endParaRPr lang="en-GB" dirty="0"/>
+          </a:p>
+          <a:p>
+            <a:r>
+              <a:rPr lang="en-GB" dirty="0"/>
+              <a:t>Emotion processed in the right place.</a:t>
+            </a:r>
+          </a:p>
+          <a:p>
+            <a:r>
+              <a:rPr lang="en-GB" dirty="0"/>
+              <a:t>The leader who has no outlet for genuine emotion carries it into every decision. The leader who processes it appropriately can remain clear-headed in the most emotionally charged situations.</a:t>
+            </a:r>
+          </a:p>
+          <a:p>
+            <a:r>
+              <a:rPr lang="en-GB" dirty="0"/>
+              <a:t>Source: Journal, 27 January 2026 — Professional Insights: Leadership</a:t>
+            </a:r>
+          </a:p>
+          <a:p>
             <a:endParaRPr lang="en-ZA" dirty="0"/>
           </a:p>
           <a:p>
@@ -9653,48 +9873,6 @@
               <a:t>“What are people feeling—and what is that feeling causing them to pay attention to, avoid or do?”</a:t>
             </a:r>
             <a:endParaRPr lang="en-ZA" dirty="0"/>
-          </a:p>
-          <a:p>
-            <a:endParaRPr dirty="0"/>
-          </a:p>
-          <a:p/>
-          <a:p>
-            <a:r>
-              <a:t>Professional insights:</a:t>
-            </a:r>
-          </a:p>
-          <a:p/>
-          <a:p>
-            <a:r>
-              <a:t>Listen before you reframe: Cultures that move straight from “here is what changed” to “here is what we need you to do next” produce resistance they cannot explain. The resistance signals that people do not yet feel understood. In a restructure, a strategic pivot or a change in leadership, listening is the load-bearing wall. Use this with signals 2 and 6.</a:t>
-            </a:r>
-          </a:p>
-          <a:p>
-            <a:r>
-              <a:t>Source: Journal, 25 June 2026 — Professional Insights: Culture</a:t>
-            </a:r>
-          </a:p>
-          <a:p/>
-          <a:p>
-            <a:r>
-              <a:t>Emotionally honest leadership: Leaders do not strengthen people by pretending that fear, disappointment or grief do not exist. Mature leadership makes space for reality while helping people move from raw emotion toward reflection, meaning and renewed trust. Use this with signal 1.</a:t>
-            </a:r>
-          </a:p>
-          <a:p>
-            <a:r>
-              <a:t>Source: Journal, 5 September 2026 — Professional Insights: Leadership</a:t>
-            </a:r>
-          </a:p>
-          <a:p/>
-          <a:p>
-            <a:r>
-              <a:t>Emotion processed in the right place: The leader who has no outlet for genuine emotion carries it into every decision. The leader who processes it appropriately can remain clear-headed in the most emotionally charged situations.</a:t>
-            </a:r>
-          </a:p>
-          <a:p>
-            <a:r>
-              <a:t>Source: Journal, 27 January 2026 — Professional Insights: Leadership</a:t>
-            </a:r>
           </a:p>
         </p:txBody>
       </p:sp>
@@ -9813,6 +9991,27 @@
             </a:r>
           </a:p>
           <a:p>
+            <a:endParaRPr lang="en-GB" dirty="0"/>
+          </a:p>
+          <a:p>
+            <a:r>
+              <a:rPr lang="en-GB" dirty="0"/>
+              <a:t>Verification before response.</a:t>
+            </a:r>
+          </a:p>
+          <a:p>
+            <a:r>
+              <a:rPr lang="en-GB" dirty="0"/>
+              <a:t>A common and costly strategic failure is acting at the speed of assumption on information that was heard and never confirmed. Build an explicit verification step into decision-making before any significant response.</a:t>
+            </a:r>
+          </a:p>
+          <a:p>
+            <a:r>
+              <a:rPr lang="en-GB" dirty="0"/>
+              <a:t>Source: Journal, 13 April 2026 — Professional Insights: Strategy</a:t>
+            </a:r>
+          </a:p>
+          <a:p>
             <a:r>
               <a:rPr lang="en-US" dirty="0"/>
               <a:t>
@@ -9970,6 +10169,27 @@
             </a:r>
           </a:p>
           <a:p>
+            <a:endParaRPr lang="en-GB" dirty="0"/>
+          </a:p>
+          <a:p>
+            <a:r>
+              <a:rPr lang="en-GB" dirty="0"/>
+              <a:t>Designated challenger.</a:t>
+            </a:r>
+          </a:p>
+          <a:p>
+            <a:r>
+              <a:rPr lang="en-GB" dirty="0"/>
+              <a:t>Most flawed plans survive because dissent was quietly designed out of the room. Before the next significant decision, invite the one person most likely to disagree and hear them out fully.</a:t>
+            </a:r>
+          </a:p>
+          <a:p>
+            <a:r>
+              <a:rPr lang="en-GB" dirty="0"/>
+              <a:t>Source: Journal, 5 June 2026 — Professional Insights: Leadership</a:t>
+            </a:r>
+          </a:p>
+          <a:p>
             <a:endParaRPr lang="en-ZA" dirty="0"/>
           </a:p>
           <a:p>
@@ -10118,53 +10338,34 @@
               <a:t>Learn while you can still change the outcome.</a:t>
             </a:r>
             <a:endParaRPr lang="en-ZA" dirty="0"/>
+          </a:p>
+          <a:p>
+            <a:endParaRPr lang="en-GB" dirty="0"/>
+          </a:p>
+          <a:p>
+            <a:r>
+              <a:rPr lang="en-GB" dirty="0"/>
+              <a:t>Lessons that change something.</a:t>
+            </a:r>
+          </a:p>
+          <a:p>
+            <a:r>
+              <a:rPr lang="en-GB" dirty="0"/>
+              <a:t>Review organisational history to recognise the patterns that must be interrupted; recurring problems treated as isolated events return. Reviews create little value when lessons remain conversational. Insight must eventually alter decisions, controls, resource allocation and expected behaviour.</a:t>
+            </a:r>
+          </a:p>
+          <a:p>
+            <a:r>
+              <a:rPr lang="en-GB" dirty="0"/>
+              <a:t>Source: Journal, 10 August 2026 — Professional Insights: Strategy</a:t>
+            </a:r>
           </a:p>
           <a:p>
             <a:r>
               <a:rPr lang="en-GB" dirty="0"/>
               <a:t>
-Group debrief. Ask: “Which principle does your organisation consistently skip — and what does that cost you?” Then: “Which one could you introduce into your very next strategy meeting without needing anyone’s permission?”
-Professional insights:</a:t>
-            </a:r>
-          </a:p>
-          <a:p/>
-          <a:p>
-            <a:r>
-              <a:t>Principle 3 · designated challenger: Most flawed plans survive because dissent was quietly designed out of the room. Before the next significant decision, invite the one person most likely to disagree and hear them out fully.</a:t>
-            </a:r>
-          </a:p>
-          <a:p>
-            <a:r>
-              <a:t>Source: Journal, 5 June 2026 — Professional Insights: Leadership</a:t>
-            </a:r>
-          </a:p>
-          <a:p/>
-          <a:p>
-            <a:r>
-              <a:t>Verification before response: A common and costly strategic failure is acting at the speed of assumption on information that was heard and never confirmed. Build an explicit verification step into decision-making before any significant response.</a:t>
-            </a:r>
-          </a:p>
-          <a:p>
-            <a:r>
-              <a:t>Source: Journal, 13 April 2026 — Professional Insights: Strategy</a:t>
-            </a:r>
-          </a:p>
-          <a:p/>
-          <a:p>
-            <a:r>
-              <a:t>Principle 6 · lessons that change something: Review organisational history to recognise the patterns that must be interrupted; recurring problems treated as isolated events return. Reviews create little value when lessons remain conversational. Insight must eventually alter decisions, controls, resource allocation and expected behaviour.</a:t>
-            </a:r>
-          </a:p>
-          <a:p>
-            <a:r>
-              <a:t>Source: Journal, 10 August 2026 — Professional Insights: Strategy</a:t>
-            </a:r>
-          </a:p>
-          <a:p>
-            <a:endParaRPr dirty="0"/>
-          </a:p>
-          <a:p>
-            <a:endParaRPr dirty="0"/>
+Group debrief. Ask: “Which principle does your organisation consistently skip — and what does that cost you?” Then: “Which one could you introduce into your very next strategy meeting without needing anyone’s permission?”</a:t>
+            </a:r>
           </a:p>
         </p:txBody>
       </p:sp>
@@ -10516,24 +10717,21 @@
             <a:r>
               <a:rPr lang="en-US" dirty="0"/>
               <a:t>
-Integration is where the “Me” becomes “We.” It’s the process of trading individual opinions for Collective Intelligence.
-</a:t>
-            </a:r>
-          </a:p>
-          <a:p/>
-          <a:p>
-            <a:r>
-              <a:t>Professional insights:</a:t>
-            </a:r>
-          </a:p>
-          <a:p/>
-          <a:p>
-            <a:r>
-              <a:t>From “Me” to “We”: A healthy culture creates conditions in which different contributions can genuinely be joined together. This requires a shared identity strong enough to transcend functional identity, relationships strong enough to carry disagreement, and an understanding that no single part can independently produce the whole organisational outcome.</a:t>
-            </a:r>
-          </a:p>
-          <a:p>
-            <a:r>
+Integration is where the “Me” becomes “We.” It’s the process of trading individual opinions for Collective Intelligence.</a:t>
+            </a:r>
+          </a:p>
+          <a:p>
+            <a:endParaRPr lang="en-GB" dirty="0"/>
+          </a:p>
+          <a:p>
+            <a:r>
+              <a:rPr lang="en-GB" dirty="0"/>
+              <a:t>A healthy culture creates conditions in which different contributions can genuinely be joined together. This requires a shared identity strong enough to transcend functional identity, relationships strong enough to carry disagreement, and an understanding that no single part can independently produce the whole organisational outcome.</a:t>
+            </a:r>
+          </a:p>
+          <a:p>
+            <a:r>
+              <a:rPr lang="en-GB" dirty="0"/>
               <a:t>Source: Journal, 4 October 2026 — Professional Insights: Culture</a:t>
             </a:r>
           </a:p>
@@ -10719,9 +10917,28 @@
             </a:r>
             <a:r>
               <a:rPr lang="en-US" dirty="0"/>
-              <a:t>A “Stress Test” where the team asks: “If the Finance data is right, does the Marketing plan still make sense?”
-</a:t>
-            </a:r>
+              <a:t>A “Stress Test” where the team asks: “If the Finance data is right, does the Marketing plan still make sense?”</a:t>
+            </a:r>
+          </a:p>
+          <a:p>
+            <a:endParaRPr lang="en-GB" dirty="0"/>
+          </a:p>
+          <a:p>
+            <a:r>
+              <a:rPr lang="en-GB" dirty="0"/>
+              <a:t>The most accurate intelligence about what the organisation’s decisions are producing is often held by those furthest from the decision-making centre. Build explicit structures that bring this intelligence from the edges into the rooms where decisions are made.</a:t>
+            </a:r>
+          </a:p>
+          <a:p>
+            <a:r>
+              <a:rPr lang="en-GB" dirty="0"/>
+              <a:t>Source: Journal, 2 April 2026 — Professional Insights: Culture</a:t>
+            </a:r>
+          </a:p>
+          <a:p>
+            <a:endParaRPr lang="en-GB" dirty="0"/>
+          </a:p>
+          <a:p>
             <a:r>
               <a:rPr lang="en-US" b="1" dirty="0"/>
               <a:t>PILLAR 2 · BEHAVIOURAL GUARDRAILS: PUTTING UP SAFETY NETS</a:t>
@@ -10762,9 +10979,28 @@
             </a:r>
             <a:r>
               <a:rPr lang="en-US" dirty="0"/>
-              <a:t>The Challenge Clock — Dedicate 10 minutes to only finding reasons why the plan won’t work.
-</a:t>
-            </a:r>
+              <a:t>The Challenge Clock — Dedicate 10 minutes to only finding reasons why the plan won’t work.</a:t>
+            </a:r>
+          </a:p>
+          <a:p>
+            <a:endParaRPr lang="en-GB" dirty="0"/>
+          </a:p>
+          <a:p>
+            <a:r>
+              <a:rPr lang="en-GB" dirty="0"/>
+              <a:t>Leaders who decide by who is loudest in the room, ahead of what is most true in the data, consistently make poor calls. Good judgement goes beneath the surface presentation and the political pressure to what is actually true.</a:t>
+            </a:r>
+          </a:p>
+          <a:p>
+            <a:r>
+              <a:rPr lang="en-GB" dirty="0"/>
+              <a:t>Source: Journal, 14 January 2026 — Professional Insights: Leadership</a:t>
+            </a:r>
+          </a:p>
+          <a:p>
+            <a:endParaRPr lang="en-GB" dirty="0"/>
+          </a:p>
+          <a:p>
             <a:r>
               <a:rPr lang="en-US" b="1" dirty="0"/>
               <a:t>PILLAR 3 · EMOTIONAL STABILISATION: CLEARING THE AIR</a:t>
@@ -10809,58 +11045,36 @@
             </a:r>
             <a:r>
               <a:rPr lang="en-US" dirty="0"/>
-              <a:t>Naming the Feeling — Start by saying, “I know we may all be anxious about this deadline. Let’s acknowledge that before we look at the numbers.”
-</a:t>
-            </a:r>
+              <a:t>Naming the Feeling — Start by saying, “I know we may all be anxious about this deadline. Let’s acknowledge that before we look at the numbers.”</a:t>
+            </a:r>
+          </a:p>
+          <a:p>
+            <a:endParaRPr lang="en-GB" dirty="0"/>
+          </a:p>
+          <a:p>
+            <a:r>
+              <a:rPr lang="en-GB" dirty="0"/>
+              <a:t>Leadership maturity includes the ability to acknowledge uncertainty without transferring anxiety throughout the organisation. Steadiness means remaining sufficiently grounded to assess reality clearly and respond proportionately.</a:t>
+            </a:r>
+          </a:p>
+          <a:p>
+            <a:r>
+              <a:rPr lang="en-GB" dirty="0"/>
+              <a:t>Source: Journal, 3 October 2026 — Professional Insights: Leadership</a:t>
+            </a:r>
+          </a:p>
+          <a:p>
+            <a:endParaRPr lang="en-GB" dirty="0"/>
+          </a:p>
+          <a:p>
             <a:r>
               <a:rPr lang="en-US" b="1" dirty="0"/>
               <a:t>Key facilitation point: </a:t>
             </a:r>
             <a:r>
               <a:rPr lang="en-US" dirty="0"/>
-              <a:t>Remind the group that all three pillars are interdependent. A strong Cognitive Integration process will collapse in a fear-dominated climate (Pillar 3 failure). Guardrails will be bypassed if there is no psychological safety to use them (Pillar 3 again). The pillars reinforce each other.
-</a:t>
-            </a:r>
-            <a:r>
-              <a:rPr dirty="0"/>
-              <a:t>Professional insights:</a:t>
-            </a:r>
-          </a:p>
-          <a:p/>
-          <a:p>
-            <a:r>
-              <a:t>Cognitive Integration: The most accurate intelligence about what the organisation’s decisions are producing is often held by those furthest from the decision-making centre. Build explicit structures that bring this intelligence from the edges into the rooms where decisions are made.</a:t>
-            </a:r>
-          </a:p>
-          <a:p>
-            <a:r>
-              <a:t>Source: Journal, 2 April 2026 — Professional Insights: Culture</a:t>
-            </a:r>
-          </a:p>
-          <a:p/>
-          <a:p>
-            <a:r>
-              <a:t>Behavioural Guardrails: Leaders who decide by who is loudest in the room, ahead of what is most true in the data, consistently make poor calls. Good judgement goes beneath the surface presentation and the political pressure to what is actually true.</a:t>
-            </a:r>
-          </a:p>
-          <a:p>
-            <a:r>
-              <a:t>Source: Journal, 14 January 2026 — Professional Insights: Leadership</a:t>
-            </a:r>
-          </a:p>
-          <a:p/>
-          <a:p>
-            <a:r>
-              <a:t>Emotional Stabilisation: Leadership maturity includes the ability to acknowledge uncertainty without transferring anxiety throughout the organisation. Steadiness means remaining sufficiently grounded to assess reality clearly and respond proportionately.</a:t>
-            </a:r>
-          </a:p>
-          <a:p>
-            <a:r>
-              <a:t>Source: Journal, 3 October 2026 — Professional Insights: Leadership</a:t>
-            </a:r>
-          </a:p>
-          <a:p>
-            <a:endParaRPr dirty="0"/>
+              <a:t>Remind the group that all three pillars are interdependent. A strong Cognitive Integration process will collapse in a fear-dominated climate (Pillar 3 failure). Guardrails will be bypassed if there is no psychological safety to use them (Pillar 3 again). The pillars reinforce each other.</a:t>
+            </a:r>
           </a:p>
         </p:txBody>
       </p:sp>
@@ -11390,6 +11604,27 @@
             </a:r>
           </a:p>
           <a:p>
+            <a:endParaRPr lang="en-GB" dirty="0"/>
+          </a:p>
+          <a:p>
+            <a:r>
+              <a:rPr lang="en-GB" dirty="0"/>
+              <a:t>Insight from every level.</a:t>
+            </a:r>
+          </a:p>
+          <a:p>
+            <a:r>
+              <a:rPr lang="en-GB" dirty="0"/>
+              <a:t>Leaders who assume strategic insight belongs only to the senior tier miss what the rest of the organisation sees. The next strategic insight may come from the youngest person on the team.</a:t>
+            </a:r>
+          </a:p>
+          <a:p>
+            <a:r>
+              <a:rPr lang="en-GB" dirty="0"/>
+              <a:t>Source: Journal, 29 March 2026 — Professional Insights</a:t>
+            </a:r>
+          </a:p>
+          <a:p>
             <a:r>
               <a:rPr lang="en-US" dirty="0"/>
               <a:t>
@@ -11405,6 +11640,27 @@
             </a:r>
           </a:p>
           <a:p>
+            <a:endParaRPr lang="en-GB" dirty="0"/>
+          </a:p>
+          <a:p>
+            <a:r>
+              <a:rPr lang="en-GB" dirty="0"/>
+              <a:t>Halo Effect.</a:t>
+            </a:r>
+          </a:p>
+          <a:p>
+            <a:r>
+              <a:rPr lang="en-GB" dirty="0"/>
+              <a:t>Cultures become vulnerable when prestige determines whose ideas matter. Healthy cultures combine competence with humility and value overlooked contributors.</a:t>
+            </a:r>
+          </a:p>
+          <a:p>
+            <a:r>
+              <a:rPr lang="en-GB" dirty="0"/>
+              <a:t>Source: Journal, 31 August 2026 — Professional Insights: Culture</a:t>
+            </a:r>
+          </a:p>
+          <a:p>
             <a:r>
               <a:rPr lang="en-US" dirty="0"/>
               <a:t>
@@ -11434,37 +11690,6 @@
               <a:t>Individual written reflection is required before any verbal group discussion. Prevents the “First Voice” from dominating and triggering Availability Bias.
 </a:t>
             </a:r>
-            <a:endParaRPr dirty="0"/>
-          </a:p>
-          <a:p>
-            <a:r>
-              <a:rPr dirty="0"/>
-              <a:t>Professional insights:</a:t>
-            </a:r>
-          </a:p>
-          <a:p/>
-          <a:p>
-            <a:r>
-              <a:t>Blind Ideation · Halo Effect: Cultures become vulnerable when prestige determines whose ideas matter. Healthy cultures combine competence with humility and value overlooked contributors.</a:t>
-            </a:r>
-          </a:p>
-          <a:p>
-            <a:r>
-              <a:t>Source: Journal, 31 August 2026 — Professional Insights: Culture</a:t>
-            </a:r>
-          </a:p>
-          <a:p/>
-          <a:p>
-            <a:r>
-              <a:t>Insight from every level: Leaders who assume strategic insight belongs only to the senior tier miss what the rest of the organisation sees. The next strategic insight may come from the youngest person on the team.</a:t>
-            </a:r>
-          </a:p>
-          <a:p>
-            <a:r>
-              <a:t>Source: Journal, 29 March 2026 — Professional Insights</a:t>
-            </a:r>
-          </a:p>
-          <a:p>
             <a:endParaRPr dirty="0"/>
           </a:p>
         </p:txBody>
@@ -11600,6 +11825,42 @@
             </a:r>
           </a:p>
           <a:p>
+            <a:endParaRPr lang="en-GB" dirty="0"/>
+          </a:p>
+          <a:p>
+            <a:r>
+              <a:rPr lang="en-GB" dirty="0"/>
+              <a:t>Teams that only ever hear the polished version stop believing any of it. Name one of your own missteps openly to the people you lead; the candour builds the credibility that spin erodes.</a:t>
+            </a:r>
+          </a:p>
+          <a:p>
+            <a:r>
+              <a:rPr lang="en-GB" dirty="0"/>
+              <a:t>Source: Journal, 22 May 2026 — Professional Insights: Leadership</a:t>
+            </a:r>
+          </a:p>
+          <a:p>
+            <a:endParaRPr lang="en-GB" dirty="0"/>
+          </a:p>
+          <a:p>
+            <a:r>
+              <a:rPr lang="en-GB" dirty="0"/>
+              <a:t>Self-examination.</a:t>
+            </a:r>
+          </a:p>
+          <a:p>
+            <a:r>
+              <a:rPr lang="en-GB" dirty="0"/>
+              <a:t>When something goes wrong, positional power makes it easy to locate failure elsewhere: in the team, the environment, the systems or the execution. Ask “Who failed?” and also “What did my decisions, assumptions, signals or omissions make possible?”</a:t>
+            </a:r>
+          </a:p>
+          <a:p>
+            <a:r>
+              <a:rPr lang="en-GB" dirty="0"/>
+              <a:t>Source: Journal, 1 October 2026 — Professional Insights: Leadership</a:t>
+            </a:r>
+          </a:p>
+          <a:p>
             <a:r>
               <a:rPr lang="en-US" dirty="0"/>
               <a:t>
@@ -11656,63 +11917,32 @@
             </a:r>
             <a:r>
               <a:rPr lang="en-US" dirty="0"/>
-              <a:t>Radical transparency regarding why a strategy succeeded or failed. Dismantles Hindsight Bias and provides a database of organisational learning.
-Group debrief. Ask: “Which practice is most immediately implementable in your organisation without needing a mandate from above? What is stopping you from introducing it in your next meeting?”
-Prioritisation exercise: Ask each participant to select their top two or three practices and share one with the group along with the bias it directly addresses. This connects the institutional practices back to the bias families explored in Section 2.
-</a:t>
-            </a:r>
-            <a:r>
-              <a:rPr dirty="0"/>
-              <a:t>Professional insights:</a:t>
-            </a:r>
-          </a:p>
-          <a:p>
-            <a:endParaRPr dirty="0"/>
-          </a:p>
-          <a:p>
-            <a:r>
-              <a:rPr dirty="0"/>
-              <a:t>Strategic Post-Mortems: Shame is what cultures produce when failure is punished and never processed. When people are more afraid of being found wrong than of being wrong, they hide problems until those problems become crises. Build a culture where people can say “I got this wrong” before it becomes “we failed”.</a:t>
-            </a:r>
-          </a:p>
-          <a:p>
-            <a:r>
-              <a:rPr dirty="0"/>
+              <a:t>Radical transparency regarding why a strategy succeeded or failed. Dismantles Hindsight Bias and provides a database of organisational learning.</a:t>
+            </a:r>
+          </a:p>
+          <a:p>
+            <a:endParaRPr lang="en-GB" dirty="0"/>
+          </a:p>
+          <a:p>
+            <a:r>
+              <a:rPr lang="en-GB" dirty="0"/>
+              <a:t>Shame is what cultures produce when failure is punished and never processed. When people are more afraid of being found wrong than of being wrong, they hide problems until those problems become crises. Build a culture where people can say “I got this wrong” before it becomes “we failed”.</a:t>
+            </a:r>
+          </a:p>
+          <a:p>
+            <a:r>
+              <a:rPr lang="en-GB" dirty="0"/>
               <a:t>Source: Journal, 6 January 2026 — Professional Insights: Culture</a:t>
             </a:r>
           </a:p>
           <a:p>
-            <a:endParaRPr dirty="0"/>
-          </a:p>
-          <a:p>
-            <a:r>
-              <a:rPr dirty="0"/>
-              <a:t>Public Cognitive Humility: Teams that only ever hear the polished version stop believing any of it. Name one of your own missteps openly to the people you lead; the </a:t>
-            </a:r>
-            <a:r>
-              <a:rPr dirty="0" err="1"/>
-              <a:t>candour</a:t>
-            </a:r>
-            <a:r>
-              <a:rPr dirty="0"/>
-              <a:t> builds the credibility that spin erodes.</a:t>
-            </a:r>
-          </a:p>
-          <a:p>
-            <a:r>
-              <a:rPr dirty="0"/>
-              <a:t>Source: Journal, 22 May 2026 — Professional Insights: Leadership</a:t>
-            </a:r>
-          </a:p>
-          <a:p/>
-          <a:p>
-            <a:r>
-              <a:t>Public Cognitive Humility · self-examination: When something goes wrong, positional power makes it easy to locate failure elsewhere: in the team, the environment, the systems or the execution. Ask “Who failed?” and also “What did my decisions, assumptions, signals or omissions make possible?”</a:t>
-            </a:r>
-          </a:p>
-          <a:p>
-            <a:r>
-              <a:t>Source: Journal, 1 October 2026 — Professional Insights: Leadership</a:t>
+            <a:endParaRPr lang="en-GB" dirty="0"/>
+          </a:p>
+          <a:p>
+            <a:r>
+              <a:rPr lang="en-US" dirty="0"/>
+              <a:t>Group debrief. Ask: “Which practice is most immediately implementable in your organisation without needing a mandate from above? What is stopping you from introducing it in your next meeting?”
+Prioritisation exercise: Ask each participant to select their top two or three practices and share one with the group along with the bias it directly addresses. This connects the institutional practices back to the bias families explored in Section 2.</a:t>
             </a:r>
           </a:p>
         </p:txBody>
@@ -12306,6 +12536,27 @@
             </a:r>
           </a:p>
           <a:p>
+            <a:endParaRPr lang="en-GB" dirty="0"/>
+          </a:p>
+          <a:p>
+            <a:r>
+              <a:rPr lang="en-GB" dirty="0"/>
+              <a:t>A common reference point.</a:t>
+            </a:r>
+          </a:p>
+          <a:p>
+            <a:r>
+              <a:rPr lang="en-GB" dirty="0"/>
+              <a:t>Integration requires a common reference point. When every function interprets priorities primarily through its own objectives, coherence becomes difficult. Shared strategic intent provides the reference against which local decisions can be aligned.</a:t>
+            </a:r>
+          </a:p>
+          <a:p>
+            <a:r>
+              <a:rPr lang="en-GB" dirty="0"/>
+              <a:t>Source: Journal, 4 October 2026 — Professional Insights: Strategy</a:t>
+            </a:r>
+          </a:p>
+          <a:p>
             <a:endParaRPr lang="en-US" dirty="0"/>
           </a:p>
           <a:p>
@@ -12337,23 +12588,6 @@
             <a:r>
               <a:rPr lang="en-US" dirty="0"/>
               <a:t>Transition: move to Section 6.1 · The Five Commitments.</a:t>
-            </a:r>
-          </a:p>
-          <a:p/>
-          <a:p>
-            <a:r>
-              <a:t>Professional insights:</a:t>
-            </a:r>
-          </a:p>
-          <a:p/>
-          <a:p>
-            <a:r>
-              <a:t>A common reference point: Integration requires a common reference point. When every function interprets priorities primarily through its own objectives, coherence becomes difficult. Shared strategic intent provides the reference against which local decisions can be aligned. Use this in the debrief of the Enterprise Task.</a:t>
-            </a:r>
-          </a:p>
-          <a:p>
-            <a:r>
-              <a:t>Source: Journal, 4 October 2026 — Professional Insights: Strategy</a:t>
             </a:r>
           </a:p>
         </p:txBody>
@@ -12468,20 +12702,24 @@
               <a:t>Complete the commitment self-assessment on 6.1 section and the three reflections.</a:t>
             </a:r>
           </a:p>
-          <a:p/>
-          <a:p>
-            <a:r>
-              <a:t>Professional insights:</a:t>
-            </a:r>
-          </a:p>
-          <a:p/>
-          <a:p>
-            <a:r>
-              <a:t>C1 · I Know My Biases: Leaders need mechanisms that reveal their blind spots as well as their strengths. Acknowledging difficulty deepens trust when it comes with responsibility, learning and perseverance.</a:t>
-            </a:r>
-          </a:p>
-          <a:p>
-            <a:r>
+          <a:p>
+            <a:endParaRPr lang="en-GB" dirty="0"/>
+          </a:p>
+          <a:p>
+            <a:r>
+              <a:rPr lang="en-GB" dirty="0"/>
+              <a:t>C1 · I Know My Biases.</a:t>
+            </a:r>
+          </a:p>
+          <a:p>
+            <a:r>
+              <a:rPr lang="en-GB" dirty="0"/>
+              <a:t>Leaders need mechanisms that reveal their blind spots as well as their strengths. Acknowledging difficulty deepens trust when it comes with responsibility, learning and perseverance.</a:t>
+            </a:r>
+          </a:p>
+          <a:p>
+            <a:r>
+              <a:rPr lang="en-GB" dirty="0"/>
               <a:t>Source: Journal, 14 September 2026 — Professional Insights: Leadership</a:t>
             </a:r>
           </a:p>
@@ -12928,10 +13166,51 @@
           </a:p>
           <a:p>
             <a:r>
-              <a:rPr lang="en-ZA" b="1" dirty="0"/>
-              <a:t>When the organisation is not thinking about strategy with sufficient clarity, coherence and enterprise perspective.</a:t>
-            </a:r>
-            <a:endParaRPr lang="en-ZA" dirty="0"/>
+              <a:rPr lang="en-ZA" dirty="0"/>
+              <a:t>T</a:t>
+            </a:r>
+            <a:r>
+              <a:rPr lang="en-GB" dirty="0"/>
+              <a:t>he whole before the parts.</a:t>
+            </a:r>
+          </a:p>
+          <a:p>
+            <a:r>
+              <a:rPr lang="en-GB" dirty="0"/>
+              <a:t>Organisations often let functions, departments and individuals pursue objectives without enough understanding of how those objectives contribute to the larger organisational intent. The result can be excellent local performance without coherent enterprise progress. Start with the whole, then locate each part within it.</a:t>
+            </a:r>
+          </a:p>
+          <a:p>
+            <a:r>
+              <a:rPr lang="en-GB" dirty="0"/>
+              <a:t>Source: Journal, 3 October 2026 — Professional Insights: Strategy</a:t>
+            </a:r>
+          </a:p>
+          <a:p>
+            <a:endParaRPr lang="en-GB" dirty="0"/>
+          </a:p>
+          <a:p>
+            <a:pPr marL="0" marR="0" lvl="0" indent="0" algn="l" defTabSz="914400" rtl="0" eaLnBrk="1" fontAlgn="auto" latinLnBrk="0" hangingPunct="1">
+              <a:lnSpc>
+                <a:spcPct val="100000"/>
+              </a:lnSpc>
+              <a:spcBef>
+                <a:spcPts val="0"/>
+              </a:spcBef>
+              <a:spcAft>
+                <a:spcPts val="0"/>
+              </a:spcAft>
+              <a:buClrTx/>
+              <a:buSzTx/>
+              <a:buFontTx/>
+              <a:buNone/>
+              <a:tabLst/>
+              <a:defRPr/>
+            </a:pPr>
+            <a:r>
+              <a:rPr lang="en-ZA" b="1" dirty="0"/>
+              <a:t>Here are examples of what happens when the organisation is not thinking about strategy with sufficient clarity, coherence and enterprise perspective:</a:t>
+            </a:r>
           </a:p>
           <a:p>
             <a:endParaRPr lang="en-ZA" b="1" dirty="0"/>
@@ -13017,8 +13296,29 @@
           </a:p>
           <a:p>
             <a:r>
-              <a:rPr lang="en-ZA" b="1" dirty="0"/>
-              <a:t>When people, decisions and organisational conditions are not aligned behind the strategy.</a:t>
+              <a:rPr lang="en-GB" dirty="0"/>
+              <a:t>Symbolic compliance.</a:t>
+            </a:r>
+          </a:p>
+          <a:p>
+            <a:r>
+              <a:rPr lang="en-GB" dirty="0"/>
+              <a:t>Strategies, values, policies and governance structures may all exist formally while everyday decisions follow an entirely different logic. Test whether those artefacts meaningfully govern resource allocation, priorities and behaviour.</a:t>
+            </a:r>
+          </a:p>
+          <a:p>
+            <a:r>
+              <a:rPr lang="en-GB" dirty="0"/>
+              <a:t>Source: Journal, 1 October 2026 — Professional Insights: Strategy</a:t>
+            </a:r>
+          </a:p>
+          <a:p>
+            <a:endParaRPr lang="en-ZA" b="1" dirty="0"/>
+          </a:p>
+          <a:p>
+            <a:r>
+              <a:rPr lang="en-ZA" b="1" dirty="0"/>
+              <a:t>When people, decisions and organisational conditions are not aligned behind the strategy, the following is bound to manifest:</a:t>
             </a:r>
             <a:endParaRPr lang="en-ZA" dirty="0"/>
           </a:p>
@@ -13106,8 +13406,29 @@
           </a:p>
           <a:p>
             <a:r>
-              <a:rPr lang="en-ZA" b="1" dirty="0"/>
-              <a:t>When strategic intent does not translate into coordinated execution and sustained results.</a:t>
+              <a:rPr lang="en-GB" dirty="0"/>
+              <a:t>The connections between the parts.</a:t>
+            </a:r>
+          </a:p>
+          <a:p>
+            <a:r>
+              <a:rPr lang="en-GB" dirty="0"/>
+              <a:t>Organisations frequently possess capable functions, talented individuals and substantial resources and still struggle to convert them into collective results. The problem may lie in the quality of the connections between the parts. Strategy must determine how those contributions fit together around the outcome the organisation is trying to create.</a:t>
+            </a:r>
+          </a:p>
+          <a:p>
+            <a:r>
+              <a:rPr lang="en-GB" dirty="0"/>
+              <a:t>Source: Journal, 4 October 2026 — Professional Insights: Strategy</a:t>
+            </a:r>
+          </a:p>
+          <a:p>
+            <a:endParaRPr lang="en-ZA" b="1" dirty="0"/>
+          </a:p>
+          <a:p>
+            <a:r>
+              <a:rPr lang="en-ZA" b="1" dirty="0"/>
+              <a:t>This is what you are likely to get when strategic intent does not translate into coordinated execution and sustained results:</a:t>
             </a:r>
             <a:endParaRPr lang="en-ZA" dirty="0"/>
           </a:p>
@@ -13158,6 +13479,8 @@
               <a:rPr lang="en-ZA" b="1" dirty="0"/>
               <a:t>predictable failure points in the journey from strategy to results.</a:t>
             </a:r>
+          </a:p>
+          <a:p>
             <a:endParaRPr lang="en-ZA" dirty="0"/>
           </a:p>
           <a:p>
@@ -13170,49 +13493,13 @@
             <a:endParaRPr lang="en-ZA" b="1" dirty="0"/>
           </a:p>
           <a:p>
-            <a:endParaRPr lang="en-ZA" b="1" dirty="0"/>
-          </a:p>
-          <a:p>
-            <a:endParaRPr lang="en-US" dirty="0"/>
-          </a:p>
-          <a:p/>
-          <a:p>
-            <a:r>
-              <a:t>Professional insights:</a:t>
-            </a:r>
-          </a:p>
-          <a:p/>
-          <a:p>
-            <a:r>
-              <a:t>Direction Failure · the whole before the parts: Organisations often let functions, departments and individuals pursue objectives without enough understanding of how those objectives contribute to the larger organisational intent. The result can be excellent local performance without coherent enterprise progress. Start with the whole, then locate each part within it.</a:t>
-            </a:r>
-          </a:p>
-          <a:p>
-            <a:r>
-              <a:t>Source: Journal, 3 October 2026 — Professional Insights: Strategy</a:t>
-            </a:r>
-          </a:p>
-          <a:p/>
-          <a:p>
-            <a:r>
-              <a:t>Influence Failure · symbolic compliance: Strategies, values, policies and governance structures may all exist formally while everyday decisions follow an entirely different logic. Test whether those artefacts meaningfully govern resource allocation, priorities and behaviour.</a:t>
-            </a:r>
-          </a:p>
-          <a:p>
-            <a:r>
-              <a:t>Source: Journal, 1 October 2026 — Professional Insights: Strategy</a:t>
-            </a:r>
-          </a:p>
-          <a:p/>
-          <a:p>
-            <a:r>
-              <a:t>Grounding Failure · the connections between the parts: Organisations frequently possess capable functions, talented individuals and substantial resources and still struggle to convert them into collective results. The problem may lie in the quality of the connections between the parts. Strategy must determine how those contributions fit together around the outcome the organisation is trying to create.</a:t>
-            </a:r>
-          </a:p>
-          <a:p>
-            <a:r>
-              <a:t>Source: Journal, 4 October 2026 — Professional Insights: Strategy</a:t>
-            </a:r>
+            <a:endParaRPr dirty="0"/>
+          </a:p>
+          <a:p>
+            <a:endParaRPr dirty="0"/>
+          </a:p>
+          <a:p>
+            <a:endParaRPr dirty="0"/>
           </a:p>
         </p:txBody>
       </p:sp>
@@ -13896,22 +14183,20 @@
           <a:p>
             <a:endParaRPr lang="en-US" dirty="0"/>
           </a:p>
-          <a:p/>
-          <a:p>
-            <a:r>
-              <a:t>Professional insights:</a:t>
-            </a:r>
-          </a:p>
-          <a:p/>
-          <a:p>
-            <a:r>
-              <a:t>The people who must make it happen: Strategy execution requires more than communicating priorities. People need to understand where the organisation is going, what the larger outcome is, and how their particular contribution connects to it. Without that connection, organisations can generate significant activity while producing fragmented results. Use this with the idea that people sit on both sides of strategy.</a:t>
-            </a:r>
-          </a:p>
-          <a:p>
-            <a:r>
+          <a:p>
+            <a:r>
+              <a:rPr lang="en-GB" dirty="0"/>
+              <a:t>Strategy execution requires more than communicating priorities. People need to understand where the organisation is going, what the larger outcome is, and how their particular contribution connects to it. Without that connection, organisations can generate significant activity while producing fragmented results. </a:t>
+            </a:r>
+          </a:p>
+          <a:p>
+            <a:r>
+              <a:rPr lang="en-GB" dirty="0"/>
               <a:t>Source: Journal, 3 October 2026 — Professional Insights: Strategy</a:t>
             </a:r>
+          </a:p>
+          <a:p>
+            <a:endParaRPr lang="en-US" dirty="0"/>
           </a:p>
         </p:txBody>
       </p:sp>

</xml_diff>

<commit_message>
Unit 1: rename 6.1 to Self Reflection Bias Assessment; commitments renamed areas A1-A5
</commit_message>
<xml_diff>
--- a/Unit decks/Unit 01 - Behavioural Strategy Fundamentals.pptx
+++ b/Unit decks/Unit 01 - Behavioural Strategy Fundamentals.pptx
@@ -12587,7 +12587,7 @@
           <a:p>
             <a:r>
               <a:rPr lang="en-US" dirty="0"/>
-              <a:t>Transition: move to Section 6.1 · The Five Commitments.</a:t>
+              <a:t>Transition: move to Section 6.1 · Self Reflection Bias Assessment.</a:t>
             </a:r>
           </a:p>
         </p:txBody>
@@ -12699,7 +12699,7 @@
           <a:p>
             <a:r>
               <a:rPr lang="en-US" dirty="0"/>
-              <a:t>Complete the commitment self-assessment on 6.1 section and the three reflections.</a:t>
+              <a:t>Complete the Self Reflection Bias Assessment in Section 6.1 and the three reflections.</a:t>
             </a:r>
           </a:p>
           <a:p>
@@ -12708,7 +12708,7 @@
           <a:p>
             <a:r>
               <a:rPr lang="en-GB" dirty="0"/>
-              <a:t>C1 · I Know My Biases.</a:t>
+              <a:t>A1 · I Know My Biases.</a:t>
             </a:r>
           </a:p>
           <a:p>
@@ -30458,7 +30458,7 @@
                 <a:ea typeface="Calibri" pitchFamily="34" charset="-122"/>
                 <a:cs typeface="Calibri" pitchFamily="34" charset="-120"/>
               </a:rPr>
-              <a:t>The Distortion Lab and the Five Commitments Assessment</a:t>
+              <a:t>The Distortion Lab and the Self Reflection Bias Assessment</a:t>
             </a:r>
             <a:endParaRPr lang="en-US" sz="2600" dirty="0"/>
           </a:p>

</xml_diff>

<commit_message>
Unit 1 Section 6: Distortion Lab and Portfolio Artefact removed; 6.1 narrative; Charter consequences per area (How) and drop-down choices; deck to 35 slides
Co-Authored-By: Claude Opus 5.5 <noreply@anthropic.com>

Claude-Session: https://claude.ai/code/session_019DYvUucpyQo7gJYkxUNRPp
</commit_message>
<xml_diff>
--- a/Unit decks/Unit 01 - Behavioural Strategy Fundamentals.pptx
+++ b/Unit decks/Unit 01 - Behavioural Strategy Fundamentals.pptx
@@ -41,9 +41,6 @@
     <p:sldId id="286" r:id="rId32"/>
     <p:sldId id="302" r:id="rId33"/>
     <p:sldId id="287" r:id="rId34"/>
-    <p:sldId id="288" r:id="rId35"/>
-    <p:sldId id="289" r:id="rId36"/>
-    <p:sldId id="290" r:id="rId37"/>
     <p:sldId id="303" r:id="rId38"/>
     <p:sldId id="295" r:id="rId39"/>
   </p:sldIdLst>
@@ -12162,26 +12159,34 @@
           <a:lstStyle/>
           <a:p>
             <a:r>
-              <a:rPr lang="en-US" b="1" dirty="0"/>
               <a:t>SECTION 6 · APPLICATION — IN PRACTICE</a:t>
             </a:r>
-            <a:r>
-              <a:rPr lang="en-US" dirty="0"/>
-              <a:t>
-Application — Behavioural Strategy in Practice
-</a:t>
-            </a:r>
-            <a:r>
-              <a:rPr lang="en-US" b="1" dirty="0"/>
+          </a:p>
+          <a:p>
+            <a:r>
+              <a:t>Application — Behavioural Strategy in Practice</a:t>
+            </a:r>
+          </a:p>
+          <a:p/>
+          <a:p>
+            <a:r>
               <a:t>SECTION LEARNING OUTCOMES:</a:t>
             </a:r>
-            <a:r>
-              <a:rPr lang="en-US" dirty="0"/>
-              <a:t>
-1. Assess your own leadership conduct against the behavioural conditions for sound strategic judgement.
-2. Commit to the development priority with the greatest effect on your strategic judgement.
-Section intent: This is the integration section. Everything learned across Sections 1–5 is now applied — first in a live simulation (the Distortion Lab) and then in a personal self-assessment (Section 6.1). Do not skip the simulation. It is where the concepts become visceral.
-Say (framing for participants): “In every section so far, we have been thinking about bias. Now we are going to experience it. The Distortion Lab is designed to show you how bias operates in real-time, even when you know it exists.”</a:t>
+          </a:p>
+          <a:p>
+            <a:r>
+              <a:t>1. Assess your own leadership conduct against the behavioural conditions for sound strategic judgement.</a:t>
+            </a:r>
+          </a:p>
+          <a:p>
+            <a:r>
+              <a:t>2. Commit to the development priority with the greatest effect on your strategic judgement.</a:t>
+            </a:r>
+          </a:p>
+          <a:p/>
+          <a:p>
+            <a:r>
+              <a:t>Section intent: This is the application section. Participants first turn the unit’s learning on themselves in the Self Reflection Bias Assessment (Section 6.1). Each group then creates its simulated company and writes its Problem Charter (Section 6.2), which opens the Capstone.</a:t>
             </a:r>
           </a:p>
         </p:txBody>
@@ -12204,412 +12209,6 @@
             <a:fld id="{F7021451-1387-4CA6-816F-3879F97B5CBC}" type="slidenum">
               <a:rPr lang="en-US"/>
               <a:t>33</a:t>
-            </a:fld>
-            <a:endParaRPr lang="en-US"/>
-          </a:p>
-        </p:txBody>
-      </p:sp>
-    </p:spTree>
-    <p:extLst>
-      <p:ext uri="{BB962C8B-B14F-4D97-AF65-F5344CB8AC3E}">
-        <p14:creationId xmlns:p14="http://schemas.microsoft.com/office/powerpoint/2010/main" val="1024086991"/>
-      </p:ext>
-    </p:extLst>
-  </p:cSld>
-  <p:clrMapOvr>
-    <a:masterClrMapping/>
-  </p:clrMapOvr>
-</p:notes>
-</file>
-
-<file path=ppt/notesSlides/notesSlide34.xml><?xml version="1.0" encoding="utf-8"?>
-<p:notes xmlns:a="http://schemas.openxmlformats.org/drawingml/2006/main" xmlns:r="http://schemas.openxmlformats.org/officeDocument/2006/relationships" xmlns:p="http://schemas.openxmlformats.org/presentationml/2006/main">
-  <p:cSld>
-    <p:spTree>
-      <p:nvGrpSpPr>
-        <p:cNvPr id="1" name=""/>
-        <p:cNvGrpSpPr/>
-        <p:nvPr/>
-      </p:nvGrpSpPr>
-      <p:grpSpPr>
-        <a:xfrm>
-          <a:off x="0" y="0"/>
-          <a:ext cx="0" cy="0"/>
-          <a:chOff x="0" y="0"/>
-          <a:chExt cx="0" cy="0"/>
-        </a:xfrm>
-      </p:grpSpPr>
-      <p:sp>
-        <p:nvSpPr>
-          <p:cNvPr id="2" name="Slide Image Placeholder 1"/>
-          <p:cNvSpPr>
-            <a:spLocks noGrp="1" noRot="1" noChangeAspect="1"/>
-          </p:cNvSpPr>
-          <p:nvPr>
-            <p:ph type="sldImg"/>
-          </p:nvPr>
-        </p:nvSpPr>
-        <p:spPr/>
-        <p:txBody>
-          <a:bodyPr/>
-          <a:lstStyle/>
-          <a:p>
-            <a:endParaRPr lang="en-ZA"/>
-          </a:p>
-        </p:txBody>
-      </p:sp>
-      <p:sp>
-        <p:nvSpPr>
-          <p:cNvPr id="3" name="Notes Placeholder 2"/>
-          <p:cNvSpPr>
-            <a:spLocks noGrp="1"/>
-          </p:cNvSpPr>
-          <p:nvPr>
-            <p:ph type="body" idx="1"/>
-          </p:nvPr>
-        </p:nvSpPr>
-        <p:spPr/>
-        <p:txBody>
-          <a:bodyPr/>
-          <a:lstStyle/>
-          <a:p>
-            <a:r>
-              <a:rPr lang="en-US" dirty="0"/>
-              <a:t>THE DISTORTION LAB: THE GROWTH DECISION (Integration Simulation · Printable)
-Preparation: Print the exercise using the gold “Print Exercise” button in the facilitator file before the session begins. Each group needs one printed copy, or works from your slides. Groups of 4–6 work best — assign roles across the group so that different functions are represented.
-Participant activity: Participants do this exercise in the session, from the material you give them. Their own file (Section 6 · The Distortion Lab: The Growth Decision) holds only the debrief questions. The Phase 1 group data is in the facilitator file: distribute it separately to each group.
-Running the exercise:</a:t>
-            </a:r>
-          </a:p>
-          <a:p>
-            <a:r>
-              <a:rPr lang="en-US" dirty="0"/>
-              <a:t>
-1. Allow 5 minutes for participants to read the scenario individually and silently.
-</a:t>
-            </a:r>
-          </a:p>
-          <a:p>
-            <a:r>
-              <a:rPr lang="en-US" dirty="0"/>
-              <a:t>2. Assign each participant (or pair) a functional role — do not allow self-selection. Functional attachment to an assigned role is part of the learning.</a:t>
-            </a:r>
-          </a:p>
-          <a:p>
-            <a:r>
-              <a:rPr lang="en-US" dirty="0"/>
-              <a:t>
-3. Send the groups into break-out rooms. Run the group discussion for 5 minutes without facilitator intervention. </a:t>
-            </a:r>
-          </a:p>
-          <a:p>
-            <a:r>
-              <a:rPr lang="en-US" dirty="0"/>
-              <a:t>
-4. Bring the groups back and ask them to share their recommendations.</a:t>
-            </a:r>
-          </a:p>
-          <a:p>
-            <a:endParaRPr lang="en-US" dirty="0"/>
-          </a:p>
-        </p:txBody>
-      </p:sp>
-      <p:sp>
-        <p:nvSpPr>
-          <p:cNvPr id="4" name="Slide Number Placeholder 3"/>
-          <p:cNvSpPr>
-            <a:spLocks noGrp="1"/>
-          </p:cNvSpPr>
-          <p:nvPr>
-            <p:ph type="sldNum" sz="quarter" idx="10"/>
-          </p:nvPr>
-        </p:nvSpPr>
-        <p:spPr/>
-        <p:txBody>
-          <a:bodyPr/>
-          <a:lstStyle/>
-          <a:p>
-            <a:fld id="{F7021451-1387-4CA6-816F-3879F97B5CBC}" type="slidenum">
-              <a:rPr lang="en-US"/>
-              <a:t>34</a:t>
-            </a:fld>
-            <a:endParaRPr lang="en-US"/>
-          </a:p>
-        </p:txBody>
-      </p:sp>
-    </p:spTree>
-    <p:extLst>
-      <p:ext uri="{BB962C8B-B14F-4D97-AF65-F5344CB8AC3E}">
-        <p14:creationId xmlns:p14="http://schemas.microsoft.com/office/powerpoint/2010/main" val="1024086991"/>
-      </p:ext>
-    </p:extLst>
-  </p:cSld>
-  <p:clrMapOvr>
-    <a:masterClrMapping/>
-  </p:clrMapOvr>
-</p:notes>
-</file>
-
-<file path=ppt/notesSlides/notesSlide35.xml><?xml version="1.0" encoding="utf-8"?>
-<p:notes xmlns:a="http://schemas.openxmlformats.org/drawingml/2006/main" xmlns:r="http://schemas.openxmlformats.org/officeDocument/2006/relationships" xmlns:p="http://schemas.openxmlformats.org/presentationml/2006/main">
-  <p:cSld>
-    <p:spTree>
-      <p:nvGrpSpPr>
-        <p:cNvPr id="1" name=""/>
-        <p:cNvGrpSpPr/>
-        <p:nvPr/>
-      </p:nvGrpSpPr>
-      <p:grpSpPr>
-        <a:xfrm>
-          <a:off x="0" y="0"/>
-          <a:ext cx="0" cy="0"/>
-          <a:chOff x="0" y="0"/>
-          <a:chExt cx="0" cy="0"/>
-        </a:xfrm>
-      </p:grpSpPr>
-      <p:sp>
-        <p:nvSpPr>
-          <p:cNvPr id="2" name="Slide Image Placeholder 1"/>
-          <p:cNvSpPr>
-            <a:spLocks noGrp="1" noRot="1" noChangeAspect="1"/>
-          </p:cNvSpPr>
-          <p:nvPr>
-            <p:ph type="sldImg"/>
-          </p:nvPr>
-        </p:nvSpPr>
-        <p:spPr/>
-        <p:txBody>
-          <a:bodyPr/>
-          <a:lstStyle/>
-          <a:p>
-            <a:endParaRPr lang="en-ZA"/>
-          </a:p>
-        </p:txBody>
-      </p:sp>
-      <p:sp>
-        <p:nvSpPr>
-          <p:cNvPr id="3" name="Notes Placeholder 2"/>
-          <p:cNvSpPr>
-            <a:spLocks noGrp="1"/>
-          </p:cNvSpPr>
-          <p:nvPr>
-            <p:ph type="body" idx="1"/>
-          </p:nvPr>
-        </p:nvSpPr>
-        <p:spPr/>
-        <p:txBody>
-          <a:bodyPr/>
-          <a:lstStyle/>
-          <a:p>
-            <a:r>
-              <a:rPr lang="en-US" dirty="0"/>
-              <a:t>PHASE 1 — FRAGMENTED REALITY (Distribute separately to each group)
-Each group receives only its own data (facilitator file: “Distribute separately to each group”).
-Group 1: Finance
-- Margins declining over last 2 years
-- Capital constraints tightening
-- Debt capacity limited
-- Large investments increase financial risk
-Reality: Financial sustainability is under pressure.
-Group 2: Market &amp; Strategy
-- Adjacent markets growing faster than core
-- Competitors expanding aggressively
-- Strong acquisition targets available
-Reality: Growth acceleration is critical to remain competitive.
-Group 3: Operations
-- Plants near full capacity
-- Integration capability limited
-- Previous integration effort struggled
-Reality: Operational system is stretched and fragile.
-Group 4: People &amp; Culture
-- Leadership bandwidth constrained
-- Change fatigue visible
-- Talent retention becoming a concern
-Reality: Organisation may not absorb further strain.
-Round 1 Task: Each group defines a strategic direction based only on their data. Prepare: one strategic recommendation and key rationale.</a:t>
-            </a:r>
-          </a:p>
-        </p:txBody>
-      </p:sp>
-      <p:sp>
-        <p:nvSpPr>
-          <p:cNvPr id="4" name="Slide Number Placeholder 3"/>
-          <p:cNvSpPr>
-            <a:spLocks noGrp="1"/>
-          </p:cNvSpPr>
-          <p:nvPr>
-            <p:ph type="sldNum" sz="quarter" idx="10"/>
-          </p:nvPr>
-        </p:nvSpPr>
-        <p:spPr/>
-        <p:txBody>
-          <a:bodyPr/>
-          <a:lstStyle/>
-          <a:p>
-            <a:fld id="{F7021451-1387-4CA6-816F-3879F97B5CBC}" type="slidenum">
-              <a:rPr lang="en-US"/>
-              <a:t>35</a:t>
-            </a:fld>
-            <a:endParaRPr lang="en-US"/>
-          </a:p>
-        </p:txBody>
-      </p:sp>
-    </p:spTree>
-    <p:extLst>
-      <p:ext uri="{BB962C8B-B14F-4D97-AF65-F5344CB8AC3E}">
-        <p14:creationId xmlns:p14="http://schemas.microsoft.com/office/powerpoint/2010/main" val="1024086991"/>
-      </p:ext>
-    </p:extLst>
-  </p:cSld>
-  <p:clrMapOvr>
-    <a:masterClrMapping/>
-  </p:clrMapOvr>
-</p:notes>
-</file>
-
-<file path=ppt/notesSlides/notesSlide36.xml><?xml version="1.0" encoding="utf-8"?>
-<p:notes xmlns:a="http://schemas.openxmlformats.org/drawingml/2006/main" xmlns:r="http://schemas.openxmlformats.org/officeDocument/2006/relationships" xmlns:p="http://schemas.openxmlformats.org/presentationml/2006/main">
-  <p:cSld>
-    <p:spTree>
-      <p:nvGrpSpPr>
-        <p:cNvPr id="1" name=""/>
-        <p:cNvGrpSpPr/>
-        <p:nvPr/>
-      </p:nvGrpSpPr>
-      <p:grpSpPr>
-        <a:xfrm>
-          <a:off x="0" y="0"/>
-          <a:ext cx="0" cy="0"/>
-          <a:chOff x="0" y="0"/>
-          <a:chExt cx="0" cy="0"/>
-        </a:xfrm>
-      </p:grpSpPr>
-      <p:sp>
-        <p:nvSpPr>
-          <p:cNvPr id="2" name="Slide Image Placeholder 1"/>
-          <p:cNvSpPr>
-            <a:spLocks noGrp="1" noRot="1" noChangeAspect="1"/>
-          </p:cNvSpPr>
-          <p:nvPr>
-            <p:ph type="sldImg"/>
-          </p:nvPr>
-        </p:nvSpPr>
-        <p:spPr/>
-        <p:txBody>
-          <a:bodyPr/>
-          <a:lstStyle/>
-          <a:p>
-            <a:endParaRPr lang="en-ZA"/>
-          </a:p>
-        </p:txBody>
-      </p:sp>
-      <p:sp>
-        <p:nvSpPr>
-          <p:cNvPr id="3" name="Notes Placeholder 2"/>
-          <p:cNvSpPr>
-            <a:spLocks noGrp="1"/>
-          </p:cNvSpPr>
-          <p:nvPr>
-            <p:ph type="body" idx="1"/>
-          </p:nvPr>
-        </p:nvSpPr>
-        <p:spPr/>
-        <p:txBody>
-          <a:bodyPr/>
-          <a:lstStyle/>
-          <a:p>
-            <a:r>
-              <a:rPr lang="en-US" dirty="0"/>
-              <a:t>PHASE 2 — BOARD OPTIONS (Reveal ONLY after Round 1 is complete)
-Ask participants to mark their choice before revealing others.
-Option A · Organic Growth: Invest $40M in capacity expansion. Projected revenue growth: 18–22%. Risk: Moderate.
-Option B · Acquisition: Acquire competitor in adjacent market. Investment: $65M. Projected revenue growth: 35–45%. 40% of similar acquisitions underperform. Risk: High Integration Complexity.
-Option C · Strategic Pause: No major capital investment for 18 months. Focus on capability building and market intelligence. Risk: Competitive Displacement Risk.
-The Task: Given what you now know— what is the right decision for the enterprise, and how do these options help or limit that decision. Define ONE integrated enterprise decision.</a:t>
-            </a:r>
-          </a:p>
-          <a:p>
-            <a:r>
-              <a:rPr lang="en-US" dirty="0"/>
-              <a:t>
-Ask 2 people to suggest what the enterprise decision must be.</a:t>
-            </a:r>
-          </a:p>
-          <a:p>
-            <a:endParaRPr lang="en-GB" dirty="0"/>
-          </a:p>
-          <a:p>
-            <a:r>
-              <a:rPr lang="en-GB" dirty="0"/>
-              <a:t>A common reference point.</a:t>
-            </a:r>
-          </a:p>
-          <a:p>
-            <a:r>
-              <a:rPr lang="en-GB" dirty="0"/>
-              <a:t>Integration requires a common reference point. When every function interprets priorities primarily through its own objectives, coherence becomes difficult. Shared strategic intent provides the reference against which local decisions can be aligned.</a:t>
-            </a:r>
-          </a:p>
-          <a:p>
-            <a:r>
-              <a:rPr lang="en-GB" dirty="0"/>
-              <a:t>Source: Journal, 4 October 2026 — Professional Insights: Strategy</a:t>
-            </a:r>
-          </a:p>
-          <a:p>
-            <a:endParaRPr lang="en-US" dirty="0"/>
-          </a:p>
-          <a:p>
-            <a:r>
-              <a:rPr lang="en-US" dirty="0"/>
-              <a:t>Debrief after the simulation: Return to the three bias families most relevant to the scenario. </a:t>
-            </a:r>
-          </a:p>
-          <a:p>
-            <a:r>
-              <a:rPr lang="en-US" dirty="0"/>
-              <a:t>Ask: “Which biases were operating in this room just now — and did knowing about them protect you from them?” The expected and honest answer is usually: not fully. That is the lesson.</a:t>
-            </a:r>
-          </a:p>
-          <a:p>
-            <a:endParaRPr lang="en-US" dirty="0"/>
-          </a:p>
-          <a:p>
-            <a:r>
-              <a:rPr lang="en-US" dirty="0"/>
-              <a:t>Collective intelligence requires deliberate integration of partial realities.
-The quality of strategy execution is a function of the quality of the thinking environment.</a:t>
-            </a:r>
-          </a:p>
-          <a:p>
-            <a:endParaRPr lang="en-US" dirty="0"/>
-          </a:p>
-          <a:p>
-            <a:r>
-              <a:rPr lang="en-US" dirty="0"/>
-              <a:t>Transition: move to Section 6.1 · Self Reflection Bias Assessment.</a:t>
-            </a:r>
-          </a:p>
-        </p:txBody>
-      </p:sp>
-      <p:sp>
-        <p:nvSpPr>
-          <p:cNvPr id="4" name="Slide Number Placeholder 3"/>
-          <p:cNvSpPr>
-            <a:spLocks noGrp="1"/>
-          </p:cNvSpPr>
-          <p:nvPr>
-            <p:ph type="sldNum" sz="quarter" idx="10"/>
-          </p:nvPr>
-        </p:nvSpPr>
-        <p:spPr/>
-        <p:txBody>
-          <a:bodyPr/>
-          <a:lstStyle/>
-          <a:p>
-            <a:fld id="{F7021451-1387-4CA6-816F-3879F97B5CBC}" type="slidenum">
-              <a:rPr lang="en-US"/>
-              <a:t>36</a:t>
             </a:fld>
             <a:endParaRPr lang="en-US"/>
           </a:p>
@@ -12698,28 +12297,28 @@
           <a:lstStyle/>
           <a:p>
             <a:r>
-              <a:rPr lang="en-US" dirty="0"/>
-              <a:t>Complete the Self Reflection Bias Assessment in Section 6.1 and the three reflections.</a:t>
-            </a:r>
-          </a:p>
-          <a:p>
-            <a:endParaRPr lang="en-GB" dirty="0"/>
-          </a:p>
-          <a:p>
-            <a:r>
-              <a:rPr lang="en-GB" dirty="0"/>
+              <a:t>Complete the Self Reflection Bias Assessment in Section 6.1.</a:t>
+            </a:r>
+          </a:p>
+          <a:p/>
+          <a:p>
+            <a:r>
+              <a:t>Then, as a group, write the Problem Charter in Section 6.2: create your simulated company and record your simulated executive team (Step 1), set out your shared reality (Step 2) and determine the central problem your executive team will address (Step 3). Confirm the Charter record: it becomes Section 1 of your team’s Capstone Blueprint.</a:t>
+            </a:r>
+          </a:p>
+          <a:p/>
+          <a:p>
+            <a:r>
               <a:t>A1 · I Know My Biases.</a:t>
             </a:r>
           </a:p>
           <a:p>
             <a:r>
-              <a:rPr lang="en-GB" dirty="0"/>
               <a:t>Leaders need mechanisms that reveal their blind spots as well as their strengths. Acknowledging difficulty deepens trust when it comes with responsibility, learning and perseverance.</a:t>
             </a:r>
           </a:p>
           <a:p>
             <a:r>
-              <a:rPr lang="en-GB" dirty="0"/>
               <a:t>Source: Journal, 14 September 2026 — Professional Insights: Leadership</a:t>
             </a:r>
           </a:p>
@@ -30458,7 +30057,7 @@
                 <a:ea typeface="Calibri" pitchFamily="34" charset="-122"/>
                 <a:cs typeface="Calibri" pitchFamily="34" charset="-120"/>
               </a:rPr>
-              <a:t>The Distortion Lab and the Self Reflection Bias Assessment</a:t>
+              <a:t>The Self Reflection Bias Assessment and the Problem Charter</a:t>
             </a:r>
             <a:endParaRPr lang="en-US" sz="2600" dirty="0"/>
           </a:p>
@@ -30690,2761 +30289,6 @@
               <a:t>Commit to the development priority with the greatest effect on your strategic judgement.</a:t>
             </a:r>
             <a:endParaRPr lang="en-US" sz="2400" dirty="0"/>
-          </a:p>
-        </p:txBody>
-      </p:sp>
-    </p:spTree>
-  </p:cSld>
-  <p:clrMapOvr>
-    <a:masterClrMapping/>
-  </p:clrMapOvr>
-</p:sld>
-</file>
-
-<file path=ppt/slides/slide34.xml><?xml version="1.0" encoding="utf-8"?>
-<p:sld xmlns:a="http://schemas.openxmlformats.org/drawingml/2006/main" xmlns:r="http://schemas.openxmlformats.org/officeDocument/2006/relationships" xmlns:p="http://schemas.openxmlformats.org/presentationml/2006/main">
-  <p:cSld name="Slide 33">
-    <p:bg>
-      <p:bgPr>
-        <a:solidFill>
-          <a:srgbClr val="FFFFFF"/>
-        </a:solidFill>
-        <a:effectLst/>
-      </p:bgPr>
-    </p:bg>
-    <p:spTree>
-      <p:nvGrpSpPr>
-        <p:cNvPr id="1" name=""/>
-        <p:cNvGrpSpPr/>
-        <p:nvPr/>
-      </p:nvGrpSpPr>
-      <p:grpSpPr>
-        <a:xfrm>
-          <a:off x="0" y="0"/>
-          <a:ext cx="0" cy="0"/>
-          <a:chOff x="0" y="0"/>
-          <a:chExt cx="0" cy="0"/>
-        </a:xfrm>
-      </p:grpSpPr>
-      <p:sp>
-        <p:nvSpPr>
-          <p:cNvPr id="2" name="Text 0"/>
-          <p:cNvSpPr txBox="1"/>
-          <p:nvPr/>
-        </p:nvSpPr>
-        <p:spPr>
-          <a:xfrm>
-            <a:off x="548640" y="411480"/>
-            <a:ext cx="11064240" cy="868680"/>
-          </a:xfrm>
-          <a:prstGeom prst="rect">
-            <a:avLst/>
-          </a:prstGeom>
-          <a:noFill/>
-          <a:ln/>
-        </p:spPr>
-        <p:txBody>
-          <a:bodyPr wrap="square" lIns="0" tIns="0" rIns="0" bIns="0" rtlCol="0" anchor="ctr"/>
-          <a:lstStyle/>
-          <a:p>
-            <a:pPr marL="0" indent="0">
-              <a:buNone/>
-            </a:pPr>
-            <a:r>
-              <a:rPr lang="en-US" sz="3600" b="1" dirty="0">
-                <a:solidFill>
-                  <a:srgbClr val="1A5C2C"/>
-                </a:solidFill>
-                <a:latin typeface="Cambria" pitchFamily="34" charset="0"/>
-                <a:ea typeface="Cambria" pitchFamily="34" charset="-122"/>
-                <a:cs typeface="Cambria" pitchFamily="34" charset="-120"/>
-              </a:rPr>
-              <a:t>The Distortion Lab: The Growth Decision</a:t>
-            </a:r>
-            <a:endParaRPr lang="en-US" sz="3600" dirty="0"/>
-          </a:p>
-        </p:txBody>
-      </p:sp>
-      <p:sp>
-        <p:nvSpPr>
-          <p:cNvPr id="19" name="TextBox 18">
-            <a:extLst>
-              <a:ext uri="{FF2B5EF4-FFF2-40B4-BE49-F238E27FC236}">
-                <a16:creationId xmlns:a16="http://schemas.microsoft.com/office/drawing/2014/main" id="{02C626F8-B2FA-F8CB-AB52-840606A2C915}"/>
-              </a:ext>
-            </a:extLst>
-          </p:cNvPr>
-          <p:cNvSpPr txBox="1"/>
-          <p:nvPr/>
-        </p:nvSpPr>
-        <p:spPr>
-          <a:xfrm>
-            <a:off x="530352" y="1183156"/>
-            <a:ext cx="10881360" cy="329184"/>
-          </a:xfrm>
-          <a:prstGeom prst="rect">
-            <a:avLst/>
-          </a:prstGeom>
-          <a:noFill/>
-        </p:spPr>
-        <p:txBody>
-          <a:bodyPr wrap="none">
-            <a:spAutoFit/>
-          </a:bodyPr>
-          <a:lstStyle/>
-          <a:p>
-            <a:pPr>
-              <a:defRPr sz="1200">
-                <a:solidFill>
-                  <a:srgbClr val="696969"/>
-                </a:solidFill>
-                <a:latin typeface="Aptos"/>
-              </a:defRPr>
-            </a:pPr>
-            <a:r>
-              <a:t>ROUND 1 · THE FUNCTIONAL VIEW</a:t>
-            </a:r>
-          </a:p>
-        </p:txBody>
-      </p:sp>
-      <p:sp>
-        <p:nvSpPr>
-          <p:cNvPr id="21" name="Rounded Rectangle 3">
-            <a:extLst>
-              <a:ext uri="{FF2B5EF4-FFF2-40B4-BE49-F238E27FC236}">
-                <a16:creationId xmlns:a16="http://schemas.microsoft.com/office/drawing/2014/main" id="{EF424D11-E12F-B53E-6BEF-4E01A8774232}"/>
-              </a:ext>
-            </a:extLst>
-          </p:cNvPr>
-          <p:cNvSpPr/>
-          <p:nvPr/>
-        </p:nvSpPr>
-        <p:spPr>
-          <a:xfrm>
-            <a:off x="594360" y="1603780"/>
-            <a:ext cx="10972800" cy="1661438"/>
-          </a:xfrm>
-          <a:prstGeom prst="roundRect">
-            <a:avLst/>
-          </a:prstGeom>
-          <a:solidFill>
-            <a:srgbClr val="EFF6F1"/>
-          </a:solidFill>
-          <a:ln>
-            <a:solidFill>
-              <a:srgbClr val="D2E1D6"/>
-            </a:solidFill>
-          </a:ln>
-        </p:spPr>
-        <p:style>
-          <a:lnRef idx="1">
-            <a:schemeClr val="accent1"/>
-          </a:lnRef>
-          <a:fillRef idx="3">
-            <a:schemeClr val="accent1"/>
-          </a:fillRef>
-          <a:effectRef idx="2">
-            <a:schemeClr val="accent1"/>
-          </a:effectRef>
-          <a:fontRef idx="minor">
-            <a:schemeClr val="lt1"/>
-          </a:fontRef>
-        </p:style>
-        <p:txBody>
-          <a:bodyPr rtlCol="0" anchor="ctr"/>
-          <a:lstStyle/>
-          <a:p>
-            <a:pPr algn="ctr"/>
-            <a:endParaRPr/>
-          </a:p>
-        </p:txBody>
-      </p:sp>
-      <p:sp>
-        <p:nvSpPr>
-          <p:cNvPr id="23" name="TextBox 22">
-            <a:extLst>
-              <a:ext uri="{FF2B5EF4-FFF2-40B4-BE49-F238E27FC236}">
-                <a16:creationId xmlns:a16="http://schemas.microsoft.com/office/drawing/2014/main" id="{33D8E0D2-6C1D-9C32-7AB8-FFD9925B7C8C}"/>
-              </a:ext>
-            </a:extLst>
-          </p:cNvPr>
-          <p:cNvSpPr txBox="1"/>
-          <p:nvPr/>
-        </p:nvSpPr>
-        <p:spPr>
-          <a:xfrm>
-            <a:off x="841248" y="1786660"/>
-            <a:ext cx="10725912" cy="1569660"/>
-          </a:xfrm>
-          <a:prstGeom prst="rect">
-            <a:avLst/>
-          </a:prstGeom>
-          <a:noFill/>
-        </p:spPr>
-        <p:txBody>
-          <a:bodyPr wrap="square">
-            <a:spAutoFit/>
-          </a:bodyPr>
-          <a:lstStyle/>
-          <a:p>
-            <a:pPr>
-              <a:defRPr sz="1400" b="1">
-                <a:solidFill>
-                  <a:srgbClr val="166030"/>
-                </a:solidFill>
-                <a:latin typeface="Aptos"/>
-              </a:defRPr>
-            </a:pPr>
-            <a:r>
-              <a:rPr sz="2400" dirty="0"/>
-              <a:t>APEX MANUFACTURING · Industrial Components</a:t>
-            </a:r>
-          </a:p>
-          <a:p>
-            <a:pPr>
-              <a:defRPr sz="1500">
-                <a:solidFill>
-                  <a:srgbClr val="1E1E1E"/>
-                </a:solidFill>
-                <a:latin typeface="Aptos"/>
-              </a:defRPr>
-            </a:pPr>
-            <a:r>
-              <a:rPr sz="2400" dirty="0"/>
-              <a:t>A mid-sized company with a strong regional reputation. The board wants faster growth while protecting financial stability and operational integrity. The executive team must decide the best strategic direction for the next 12–36 months.</a:t>
-            </a:r>
-          </a:p>
-        </p:txBody>
-      </p:sp>
-      <p:sp>
-        <p:nvSpPr>
-          <p:cNvPr id="25" name="Rounded Rectangle 5">
-            <a:extLst>
-              <a:ext uri="{FF2B5EF4-FFF2-40B4-BE49-F238E27FC236}">
-                <a16:creationId xmlns:a16="http://schemas.microsoft.com/office/drawing/2014/main" id="{CDF4E4B9-C17E-1212-F046-D57558794A40}"/>
-              </a:ext>
-            </a:extLst>
-          </p:cNvPr>
-          <p:cNvSpPr/>
-          <p:nvPr/>
-        </p:nvSpPr>
-        <p:spPr>
-          <a:xfrm>
-            <a:off x="594360" y="4222153"/>
-            <a:ext cx="2578608" cy="1234440"/>
-          </a:xfrm>
-          <a:prstGeom prst="roundRect">
-            <a:avLst/>
-          </a:prstGeom>
-          <a:solidFill>
-            <a:srgbClr val="EFF6F1"/>
-          </a:solidFill>
-          <a:ln>
-            <a:solidFill>
-              <a:srgbClr val="D2E1D6"/>
-            </a:solidFill>
-          </a:ln>
-        </p:spPr>
-        <p:style>
-          <a:lnRef idx="1">
-            <a:schemeClr val="accent1"/>
-          </a:lnRef>
-          <a:fillRef idx="3">
-            <a:schemeClr val="accent1"/>
-          </a:fillRef>
-          <a:effectRef idx="2">
-            <a:schemeClr val="accent1"/>
-          </a:effectRef>
-          <a:fontRef idx="minor">
-            <a:schemeClr val="lt1"/>
-          </a:fontRef>
-        </p:style>
-        <p:txBody>
-          <a:bodyPr rtlCol="0" anchor="ctr"/>
-          <a:lstStyle/>
-          <a:p>
-            <a:pPr algn="ctr"/>
-            <a:endParaRPr sz="2400"/>
-          </a:p>
-        </p:txBody>
-      </p:sp>
-      <p:sp>
-        <p:nvSpPr>
-          <p:cNvPr id="27" name="Oval 26">
-            <a:extLst>
-              <a:ext uri="{FF2B5EF4-FFF2-40B4-BE49-F238E27FC236}">
-                <a16:creationId xmlns:a16="http://schemas.microsoft.com/office/drawing/2014/main" id="{4389E99C-0109-ECCB-FAFF-264CD0D12929}"/>
-              </a:ext>
-            </a:extLst>
-          </p:cNvPr>
-          <p:cNvSpPr/>
-          <p:nvPr/>
-        </p:nvSpPr>
-        <p:spPr>
-          <a:xfrm>
-            <a:off x="740664" y="3502961"/>
-            <a:ext cx="384048" cy="384048"/>
-          </a:xfrm>
-          <a:prstGeom prst="ellipse">
-            <a:avLst/>
-          </a:prstGeom>
-          <a:solidFill>
-            <a:srgbClr val="166030"/>
-          </a:solidFill>
-          <a:ln>
-            <a:solidFill>
-              <a:srgbClr val="166030"/>
-            </a:solidFill>
-          </a:ln>
-        </p:spPr>
-        <p:style>
-          <a:lnRef idx="1">
-            <a:schemeClr val="accent1"/>
-          </a:lnRef>
-          <a:fillRef idx="3">
-            <a:schemeClr val="accent1"/>
-          </a:fillRef>
-          <a:effectRef idx="2">
-            <a:schemeClr val="accent1"/>
-          </a:effectRef>
-          <a:fontRef idx="minor">
-            <a:schemeClr val="lt1"/>
-          </a:fontRef>
-        </p:style>
-        <p:txBody>
-          <a:bodyPr rtlCol="0" anchor="ctr"/>
-          <a:lstStyle/>
-          <a:p>
-            <a:pPr algn="ctr"/>
-            <a:endParaRPr sz="2400"/>
-          </a:p>
-        </p:txBody>
-      </p:sp>
-      <p:sp>
-        <p:nvSpPr>
-          <p:cNvPr id="29" name="TextBox 28">
-            <a:extLst>
-              <a:ext uri="{FF2B5EF4-FFF2-40B4-BE49-F238E27FC236}">
-                <a16:creationId xmlns:a16="http://schemas.microsoft.com/office/drawing/2014/main" id="{1BD73A33-367A-E0E1-CE62-DF6B051FB66E}"/>
-              </a:ext>
-            </a:extLst>
-          </p:cNvPr>
-          <p:cNvSpPr txBox="1"/>
-          <p:nvPr/>
-        </p:nvSpPr>
-        <p:spPr>
-          <a:xfrm>
-            <a:off x="757800" y="3530393"/>
-            <a:ext cx="349776" cy="461665"/>
-          </a:xfrm>
-          <a:prstGeom prst="rect">
-            <a:avLst/>
-          </a:prstGeom>
-          <a:noFill/>
-        </p:spPr>
-        <p:txBody>
-          <a:bodyPr wrap="square">
-            <a:spAutoFit/>
-          </a:bodyPr>
-          <a:lstStyle/>
-          <a:p>
-            <a:pPr algn="ctr">
-              <a:defRPr sz="1200" b="1">
-                <a:solidFill>
-                  <a:srgbClr val="FFFFFF"/>
-                </a:solidFill>
-                <a:latin typeface="Aptos"/>
-              </a:defRPr>
-            </a:pPr>
-            <a:r>
-              <a:rPr sz="2400" dirty="0"/>
-              <a:t>1</a:t>
-            </a:r>
-          </a:p>
-        </p:txBody>
-      </p:sp>
-      <p:sp>
-        <p:nvSpPr>
-          <p:cNvPr id="31" name="TextBox 30">
-            <a:extLst>
-              <a:ext uri="{FF2B5EF4-FFF2-40B4-BE49-F238E27FC236}">
-                <a16:creationId xmlns:a16="http://schemas.microsoft.com/office/drawing/2014/main" id="{C971913A-5784-6464-B3DF-252D6403A69C}"/>
-              </a:ext>
-            </a:extLst>
-          </p:cNvPr>
-          <p:cNvSpPr txBox="1"/>
-          <p:nvPr/>
-        </p:nvSpPr>
-        <p:spPr>
-          <a:xfrm>
-            <a:off x="1216152" y="3457241"/>
-            <a:ext cx="1470274" cy="461665"/>
-          </a:xfrm>
-          <a:prstGeom prst="rect">
-            <a:avLst/>
-          </a:prstGeom>
-          <a:noFill/>
-        </p:spPr>
-        <p:txBody>
-          <a:bodyPr wrap="none">
-            <a:spAutoFit/>
-          </a:bodyPr>
-          <a:lstStyle/>
-          <a:p>
-            <a:pPr>
-              <a:defRPr sz="1200" b="1">
-                <a:solidFill>
-                  <a:srgbClr val="166030"/>
-                </a:solidFill>
-                <a:latin typeface="Aptos"/>
-              </a:defRPr>
-            </a:pPr>
-            <a:r>
-              <a:rPr sz="2400"/>
-              <a:t>FINANCE</a:t>
-            </a:r>
-          </a:p>
-        </p:txBody>
-      </p:sp>
-      <p:sp>
-        <p:nvSpPr>
-          <p:cNvPr id="33" name="TextBox 32">
-            <a:extLst>
-              <a:ext uri="{FF2B5EF4-FFF2-40B4-BE49-F238E27FC236}">
-                <a16:creationId xmlns:a16="http://schemas.microsoft.com/office/drawing/2014/main" id="{21228044-C046-8F83-2983-28C7806BF95B}"/>
-              </a:ext>
-            </a:extLst>
-          </p:cNvPr>
-          <p:cNvSpPr txBox="1"/>
-          <p:nvPr/>
-        </p:nvSpPr>
-        <p:spPr>
-          <a:xfrm>
-            <a:off x="758952" y="4359712"/>
-            <a:ext cx="2310155" cy="830997"/>
-          </a:xfrm>
-          <a:prstGeom prst="rect">
-            <a:avLst/>
-          </a:prstGeom>
-          <a:noFill/>
-        </p:spPr>
-        <p:txBody>
-          <a:bodyPr wrap="square">
-            <a:spAutoFit/>
-          </a:bodyPr>
-          <a:lstStyle/>
-          <a:p>
-            <a:pPr>
-              <a:defRPr sz="1150">
-                <a:solidFill>
-                  <a:srgbClr val="1E1E1E"/>
-                </a:solidFill>
-                <a:latin typeface="Aptos"/>
-              </a:defRPr>
-            </a:pPr>
-            <a:r>
-              <a:rPr sz="2400" dirty="0"/>
-              <a:t>Your financial reality</a:t>
-            </a:r>
-          </a:p>
-        </p:txBody>
-      </p:sp>
-      <p:sp>
-        <p:nvSpPr>
-          <p:cNvPr id="35" name="Rounded Rectangle 10">
-            <a:extLst>
-              <a:ext uri="{FF2B5EF4-FFF2-40B4-BE49-F238E27FC236}">
-                <a16:creationId xmlns:a16="http://schemas.microsoft.com/office/drawing/2014/main" id="{86C34346-5507-5FC2-0CF1-1668E705FE1E}"/>
-              </a:ext>
-            </a:extLst>
-          </p:cNvPr>
-          <p:cNvSpPr/>
-          <p:nvPr/>
-        </p:nvSpPr>
-        <p:spPr>
-          <a:xfrm>
-            <a:off x="3401568" y="4222153"/>
-            <a:ext cx="2578608" cy="1234440"/>
-          </a:xfrm>
-          <a:prstGeom prst="roundRect">
-            <a:avLst/>
-          </a:prstGeom>
-          <a:solidFill>
-            <a:srgbClr val="EFF6F1"/>
-          </a:solidFill>
-          <a:ln>
-            <a:solidFill>
-              <a:srgbClr val="D2E1D6"/>
-            </a:solidFill>
-          </a:ln>
-        </p:spPr>
-        <p:style>
-          <a:lnRef idx="1">
-            <a:schemeClr val="accent1"/>
-          </a:lnRef>
-          <a:fillRef idx="3">
-            <a:schemeClr val="accent1"/>
-          </a:fillRef>
-          <a:effectRef idx="2">
-            <a:schemeClr val="accent1"/>
-          </a:effectRef>
-          <a:fontRef idx="minor">
-            <a:schemeClr val="lt1"/>
-          </a:fontRef>
-        </p:style>
-        <p:txBody>
-          <a:bodyPr rtlCol="0" anchor="ctr"/>
-          <a:lstStyle/>
-          <a:p>
-            <a:pPr algn="ctr"/>
-            <a:endParaRPr sz="2400"/>
-          </a:p>
-        </p:txBody>
-      </p:sp>
-      <p:sp>
-        <p:nvSpPr>
-          <p:cNvPr id="37" name="Oval 36">
-            <a:extLst>
-              <a:ext uri="{FF2B5EF4-FFF2-40B4-BE49-F238E27FC236}">
-                <a16:creationId xmlns:a16="http://schemas.microsoft.com/office/drawing/2014/main" id="{F54303D5-B0AF-5A2B-ABBC-42A466DA9C8B}"/>
-              </a:ext>
-            </a:extLst>
-          </p:cNvPr>
-          <p:cNvSpPr/>
-          <p:nvPr/>
-        </p:nvSpPr>
-        <p:spPr>
-          <a:xfrm>
-            <a:off x="3547872" y="3502961"/>
-            <a:ext cx="384048" cy="384048"/>
-          </a:xfrm>
-          <a:prstGeom prst="ellipse">
-            <a:avLst/>
-          </a:prstGeom>
-          <a:solidFill>
-            <a:srgbClr val="166030"/>
-          </a:solidFill>
-          <a:ln>
-            <a:solidFill>
-              <a:srgbClr val="166030"/>
-            </a:solidFill>
-          </a:ln>
-        </p:spPr>
-        <p:style>
-          <a:lnRef idx="1">
-            <a:schemeClr val="accent1"/>
-          </a:lnRef>
-          <a:fillRef idx="3">
-            <a:schemeClr val="accent1"/>
-          </a:fillRef>
-          <a:effectRef idx="2">
-            <a:schemeClr val="accent1"/>
-          </a:effectRef>
-          <a:fontRef idx="minor">
-            <a:schemeClr val="lt1"/>
-          </a:fontRef>
-        </p:style>
-        <p:txBody>
-          <a:bodyPr rtlCol="0" anchor="ctr"/>
-          <a:lstStyle/>
-          <a:p>
-            <a:pPr algn="ctr"/>
-            <a:endParaRPr sz="2400"/>
-          </a:p>
-        </p:txBody>
-      </p:sp>
-      <p:sp>
-        <p:nvSpPr>
-          <p:cNvPr id="39" name="TextBox 38">
-            <a:extLst>
-              <a:ext uri="{FF2B5EF4-FFF2-40B4-BE49-F238E27FC236}">
-                <a16:creationId xmlns:a16="http://schemas.microsoft.com/office/drawing/2014/main" id="{18F7B6F5-EA27-A63A-EF58-8CDCDBDAD37B}"/>
-              </a:ext>
-            </a:extLst>
-          </p:cNvPr>
-          <p:cNvSpPr txBox="1"/>
-          <p:nvPr/>
-        </p:nvSpPr>
-        <p:spPr>
-          <a:xfrm>
-            <a:off x="3565008" y="3530393"/>
-            <a:ext cx="349776" cy="461665"/>
-          </a:xfrm>
-          <a:prstGeom prst="rect">
-            <a:avLst/>
-          </a:prstGeom>
-          <a:noFill/>
-        </p:spPr>
-        <p:txBody>
-          <a:bodyPr wrap="none">
-            <a:spAutoFit/>
-          </a:bodyPr>
-          <a:lstStyle/>
-          <a:p>
-            <a:pPr algn="ctr">
-              <a:defRPr sz="1200" b="1">
-                <a:solidFill>
-                  <a:srgbClr val="FFFFFF"/>
-                </a:solidFill>
-                <a:latin typeface="Aptos"/>
-              </a:defRPr>
-            </a:pPr>
-            <a:r>
-              <a:rPr sz="2400"/>
-              <a:t>2</a:t>
-            </a:r>
-          </a:p>
-        </p:txBody>
-      </p:sp>
-      <p:sp>
-        <p:nvSpPr>
-          <p:cNvPr id="41" name="TextBox 40">
-            <a:extLst>
-              <a:ext uri="{FF2B5EF4-FFF2-40B4-BE49-F238E27FC236}">
-                <a16:creationId xmlns:a16="http://schemas.microsoft.com/office/drawing/2014/main" id="{FD135C1D-0529-73E7-A0D8-C22189E180BB}"/>
-              </a:ext>
-            </a:extLst>
-          </p:cNvPr>
-          <p:cNvSpPr txBox="1"/>
-          <p:nvPr/>
-        </p:nvSpPr>
-        <p:spPr>
-          <a:xfrm>
-            <a:off x="4023360" y="3457241"/>
-            <a:ext cx="1681871" cy="830997"/>
-          </a:xfrm>
-          <a:prstGeom prst="rect">
-            <a:avLst/>
-          </a:prstGeom>
-          <a:noFill/>
-        </p:spPr>
-        <p:txBody>
-          <a:bodyPr wrap="none">
-            <a:spAutoFit/>
-          </a:bodyPr>
-          <a:lstStyle/>
-          <a:p>
-            <a:pPr>
-              <a:defRPr sz="1200" b="1">
-                <a:solidFill>
-                  <a:srgbClr val="166030"/>
-                </a:solidFill>
-                <a:latin typeface="Aptos"/>
-              </a:defRPr>
-            </a:pPr>
-            <a:r>
-              <a:rPr sz="2400" dirty="0"/>
-              <a:t>MARKET &amp; </a:t>
-            </a:r>
-            <a:endParaRPr lang="en-ZA" sz="2400" dirty="0"/>
-          </a:p>
-          <a:p>
-            <a:pPr>
-              <a:defRPr sz="1200" b="1">
-                <a:solidFill>
-                  <a:srgbClr val="166030"/>
-                </a:solidFill>
-                <a:latin typeface="Aptos"/>
-              </a:defRPr>
-            </a:pPr>
-            <a:r>
-              <a:rPr sz="2400" dirty="0"/>
-              <a:t>STRATEGY</a:t>
-            </a:r>
-          </a:p>
-        </p:txBody>
-      </p:sp>
-      <p:sp>
-        <p:nvSpPr>
-          <p:cNvPr id="43" name="TextBox 42">
-            <a:extLst>
-              <a:ext uri="{FF2B5EF4-FFF2-40B4-BE49-F238E27FC236}">
-                <a16:creationId xmlns:a16="http://schemas.microsoft.com/office/drawing/2014/main" id="{9FDB820A-5138-6B60-92F5-14A42C48080A}"/>
-              </a:ext>
-            </a:extLst>
-          </p:cNvPr>
-          <p:cNvSpPr txBox="1"/>
-          <p:nvPr/>
-        </p:nvSpPr>
-        <p:spPr>
-          <a:xfrm>
-            <a:off x="3566160" y="4359712"/>
-            <a:ext cx="2400016" cy="830997"/>
-          </a:xfrm>
-          <a:prstGeom prst="rect">
-            <a:avLst/>
-          </a:prstGeom>
-          <a:noFill/>
-        </p:spPr>
-        <p:txBody>
-          <a:bodyPr wrap="none">
-            <a:spAutoFit/>
-          </a:bodyPr>
-          <a:lstStyle/>
-          <a:p>
-            <a:pPr>
-              <a:defRPr sz="1150">
-                <a:solidFill>
-                  <a:srgbClr val="1E1E1E"/>
-                </a:solidFill>
-                <a:latin typeface="Aptos"/>
-              </a:defRPr>
-            </a:pPr>
-            <a:r>
-              <a:rPr sz="2400" dirty="0"/>
-              <a:t>Your market and </a:t>
-            </a:r>
-            <a:endParaRPr lang="en-ZA" sz="2400" dirty="0"/>
-          </a:p>
-          <a:p>
-            <a:pPr>
-              <a:defRPr sz="1150">
-                <a:solidFill>
-                  <a:srgbClr val="1E1E1E"/>
-                </a:solidFill>
-                <a:latin typeface="Aptos"/>
-              </a:defRPr>
-            </a:pPr>
-            <a:r>
-              <a:rPr sz="2400" dirty="0"/>
-              <a:t>growth reality</a:t>
-            </a:r>
-          </a:p>
-        </p:txBody>
-      </p:sp>
-      <p:sp>
-        <p:nvSpPr>
-          <p:cNvPr id="45" name="Rounded Rectangle 15">
-            <a:extLst>
-              <a:ext uri="{FF2B5EF4-FFF2-40B4-BE49-F238E27FC236}">
-                <a16:creationId xmlns:a16="http://schemas.microsoft.com/office/drawing/2014/main" id="{3C797754-AB05-3008-A3E7-34E987BC015C}"/>
-              </a:ext>
-            </a:extLst>
-          </p:cNvPr>
-          <p:cNvSpPr/>
-          <p:nvPr/>
-        </p:nvSpPr>
-        <p:spPr>
-          <a:xfrm>
-            <a:off x="6208776" y="4222153"/>
-            <a:ext cx="2578608" cy="1234440"/>
-          </a:xfrm>
-          <a:prstGeom prst="roundRect">
-            <a:avLst/>
-          </a:prstGeom>
-          <a:solidFill>
-            <a:srgbClr val="EFF6F1"/>
-          </a:solidFill>
-          <a:ln>
-            <a:solidFill>
-              <a:srgbClr val="D2E1D6"/>
-            </a:solidFill>
-          </a:ln>
-        </p:spPr>
-        <p:style>
-          <a:lnRef idx="1">
-            <a:schemeClr val="accent1"/>
-          </a:lnRef>
-          <a:fillRef idx="3">
-            <a:schemeClr val="accent1"/>
-          </a:fillRef>
-          <a:effectRef idx="2">
-            <a:schemeClr val="accent1"/>
-          </a:effectRef>
-          <a:fontRef idx="minor">
-            <a:schemeClr val="lt1"/>
-          </a:fontRef>
-        </p:style>
-        <p:txBody>
-          <a:bodyPr rtlCol="0" anchor="ctr"/>
-          <a:lstStyle/>
-          <a:p>
-            <a:pPr algn="ctr"/>
-            <a:endParaRPr sz="2400"/>
-          </a:p>
-        </p:txBody>
-      </p:sp>
-      <p:sp>
-        <p:nvSpPr>
-          <p:cNvPr id="47" name="Oval 46">
-            <a:extLst>
-              <a:ext uri="{FF2B5EF4-FFF2-40B4-BE49-F238E27FC236}">
-                <a16:creationId xmlns:a16="http://schemas.microsoft.com/office/drawing/2014/main" id="{CEC3B8F7-C022-7683-6353-593A9E39A71E}"/>
-              </a:ext>
-            </a:extLst>
-          </p:cNvPr>
-          <p:cNvSpPr/>
-          <p:nvPr/>
-        </p:nvSpPr>
-        <p:spPr>
-          <a:xfrm>
-            <a:off x="6355080" y="3502961"/>
-            <a:ext cx="384048" cy="384048"/>
-          </a:xfrm>
-          <a:prstGeom prst="ellipse">
-            <a:avLst/>
-          </a:prstGeom>
-          <a:solidFill>
-            <a:srgbClr val="166030"/>
-          </a:solidFill>
-          <a:ln>
-            <a:solidFill>
-              <a:srgbClr val="166030"/>
-            </a:solidFill>
-          </a:ln>
-        </p:spPr>
-        <p:style>
-          <a:lnRef idx="1">
-            <a:schemeClr val="accent1"/>
-          </a:lnRef>
-          <a:fillRef idx="3">
-            <a:schemeClr val="accent1"/>
-          </a:fillRef>
-          <a:effectRef idx="2">
-            <a:schemeClr val="accent1"/>
-          </a:effectRef>
-          <a:fontRef idx="minor">
-            <a:schemeClr val="lt1"/>
-          </a:fontRef>
-        </p:style>
-        <p:txBody>
-          <a:bodyPr rtlCol="0" anchor="ctr"/>
-          <a:lstStyle/>
-          <a:p>
-            <a:pPr algn="ctr"/>
-            <a:endParaRPr sz="2400"/>
-          </a:p>
-        </p:txBody>
-      </p:sp>
-      <p:sp>
-        <p:nvSpPr>
-          <p:cNvPr id="49" name="TextBox 48">
-            <a:extLst>
-              <a:ext uri="{FF2B5EF4-FFF2-40B4-BE49-F238E27FC236}">
-                <a16:creationId xmlns:a16="http://schemas.microsoft.com/office/drawing/2014/main" id="{8DB0D42D-8296-C58E-B6C2-8B22CC2E0165}"/>
-              </a:ext>
-            </a:extLst>
-          </p:cNvPr>
-          <p:cNvSpPr txBox="1"/>
-          <p:nvPr/>
-        </p:nvSpPr>
-        <p:spPr>
-          <a:xfrm>
-            <a:off x="6372216" y="3530393"/>
-            <a:ext cx="349776" cy="461665"/>
-          </a:xfrm>
-          <a:prstGeom prst="rect">
-            <a:avLst/>
-          </a:prstGeom>
-          <a:noFill/>
-        </p:spPr>
-        <p:txBody>
-          <a:bodyPr wrap="none">
-            <a:spAutoFit/>
-          </a:bodyPr>
-          <a:lstStyle/>
-          <a:p>
-            <a:pPr algn="ctr">
-              <a:defRPr sz="1200" b="1">
-                <a:solidFill>
-                  <a:srgbClr val="FFFFFF"/>
-                </a:solidFill>
-                <a:latin typeface="Aptos"/>
-              </a:defRPr>
-            </a:pPr>
-            <a:r>
-              <a:rPr sz="2400"/>
-              <a:t>3</a:t>
-            </a:r>
-          </a:p>
-        </p:txBody>
-      </p:sp>
-      <p:sp>
-        <p:nvSpPr>
-          <p:cNvPr id="51" name="TextBox 50">
-            <a:extLst>
-              <a:ext uri="{FF2B5EF4-FFF2-40B4-BE49-F238E27FC236}">
-                <a16:creationId xmlns:a16="http://schemas.microsoft.com/office/drawing/2014/main" id="{28A7142A-82A7-C916-3FD5-F5C2588F6510}"/>
-              </a:ext>
-            </a:extLst>
-          </p:cNvPr>
-          <p:cNvSpPr txBox="1"/>
-          <p:nvPr/>
-        </p:nvSpPr>
-        <p:spPr>
-          <a:xfrm>
-            <a:off x="6830568" y="3457241"/>
-            <a:ext cx="2025619" cy="461665"/>
-          </a:xfrm>
-          <a:prstGeom prst="rect">
-            <a:avLst/>
-          </a:prstGeom>
-          <a:noFill/>
-        </p:spPr>
-        <p:txBody>
-          <a:bodyPr wrap="none">
-            <a:spAutoFit/>
-          </a:bodyPr>
-          <a:lstStyle/>
-          <a:p>
-            <a:pPr>
-              <a:defRPr sz="1200" b="1">
-                <a:solidFill>
-                  <a:srgbClr val="166030"/>
-                </a:solidFill>
-                <a:latin typeface="Aptos"/>
-              </a:defRPr>
-            </a:pPr>
-            <a:r>
-              <a:rPr sz="2400"/>
-              <a:t>OPERATIONS</a:t>
-            </a:r>
-          </a:p>
-        </p:txBody>
-      </p:sp>
-      <p:sp>
-        <p:nvSpPr>
-          <p:cNvPr id="53" name="TextBox 52">
-            <a:extLst>
-              <a:ext uri="{FF2B5EF4-FFF2-40B4-BE49-F238E27FC236}">
-                <a16:creationId xmlns:a16="http://schemas.microsoft.com/office/drawing/2014/main" id="{CBE60CA2-0605-2566-7762-9B71E09050B2}"/>
-              </a:ext>
-            </a:extLst>
-          </p:cNvPr>
-          <p:cNvSpPr txBox="1"/>
-          <p:nvPr/>
-        </p:nvSpPr>
-        <p:spPr>
-          <a:xfrm>
-            <a:off x="6373368" y="4359712"/>
-            <a:ext cx="2301505" cy="830997"/>
-          </a:xfrm>
-          <a:prstGeom prst="rect">
-            <a:avLst/>
-          </a:prstGeom>
-          <a:noFill/>
-        </p:spPr>
-        <p:txBody>
-          <a:bodyPr wrap="square">
-            <a:spAutoFit/>
-          </a:bodyPr>
-          <a:lstStyle/>
-          <a:p>
-            <a:pPr>
-              <a:defRPr sz="1150">
-                <a:solidFill>
-                  <a:srgbClr val="1E1E1E"/>
-                </a:solidFill>
-                <a:latin typeface="Aptos"/>
-              </a:defRPr>
-            </a:pPr>
-            <a:r>
-              <a:rPr sz="2400" dirty="0"/>
-              <a:t>Your delivery reality</a:t>
-            </a:r>
-          </a:p>
-        </p:txBody>
-      </p:sp>
-      <p:sp>
-        <p:nvSpPr>
-          <p:cNvPr id="55" name="Rounded Rectangle 20">
-            <a:extLst>
-              <a:ext uri="{FF2B5EF4-FFF2-40B4-BE49-F238E27FC236}">
-                <a16:creationId xmlns:a16="http://schemas.microsoft.com/office/drawing/2014/main" id="{275079EB-D2AD-C607-8333-3F99277B2C43}"/>
-              </a:ext>
-            </a:extLst>
-          </p:cNvPr>
-          <p:cNvSpPr/>
-          <p:nvPr/>
-        </p:nvSpPr>
-        <p:spPr>
-          <a:xfrm>
-            <a:off x="9015984" y="4222153"/>
-            <a:ext cx="2578608" cy="1234440"/>
-          </a:xfrm>
-          <a:prstGeom prst="roundRect">
-            <a:avLst/>
-          </a:prstGeom>
-          <a:solidFill>
-            <a:srgbClr val="EFF6F1"/>
-          </a:solidFill>
-          <a:ln>
-            <a:solidFill>
-              <a:srgbClr val="D2E1D6"/>
-            </a:solidFill>
-          </a:ln>
-        </p:spPr>
-        <p:style>
-          <a:lnRef idx="1">
-            <a:schemeClr val="accent1"/>
-          </a:lnRef>
-          <a:fillRef idx="3">
-            <a:schemeClr val="accent1"/>
-          </a:fillRef>
-          <a:effectRef idx="2">
-            <a:schemeClr val="accent1"/>
-          </a:effectRef>
-          <a:fontRef idx="minor">
-            <a:schemeClr val="lt1"/>
-          </a:fontRef>
-        </p:style>
-        <p:txBody>
-          <a:bodyPr rtlCol="0" anchor="ctr"/>
-          <a:lstStyle/>
-          <a:p>
-            <a:pPr algn="ctr"/>
-            <a:endParaRPr sz="2400"/>
-          </a:p>
-        </p:txBody>
-      </p:sp>
-      <p:sp>
-        <p:nvSpPr>
-          <p:cNvPr id="57" name="Oval 56">
-            <a:extLst>
-              <a:ext uri="{FF2B5EF4-FFF2-40B4-BE49-F238E27FC236}">
-                <a16:creationId xmlns:a16="http://schemas.microsoft.com/office/drawing/2014/main" id="{57817BF0-38E9-112C-94D1-B4DA6236BC3B}"/>
-              </a:ext>
-            </a:extLst>
-          </p:cNvPr>
-          <p:cNvSpPr/>
-          <p:nvPr/>
-        </p:nvSpPr>
-        <p:spPr>
-          <a:xfrm>
-            <a:off x="9162288" y="3502961"/>
-            <a:ext cx="384048" cy="384048"/>
-          </a:xfrm>
-          <a:prstGeom prst="ellipse">
-            <a:avLst/>
-          </a:prstGeom>
-          <a:solidFill>
-            <a:srgbClr val="166030"/>
-          </a:solidFill>
-          <a:ln>
-            <a:solidFill>
-              <a:srgbClr val="166030"/>
-            </a:solidFill>
-          </a:ln>
-        </p:spPr>
-        <p:style>
-          <a:lnRef idx="1">
-            <a:schemeClr val="accent1"/>
-          </a:lnRef>
-          <a:fillRef idx="3">
-            <a:schemeClr val="accent1"/>
-          </a:fillRef>
-          <a:effectRef idx="2">
-            <a:schemeClr val="accent1"/>
-          </a:effectRef>
-          <a:fontRef idx="minor">
-            <a:schemeClr val="lt1"/>
-          </a:fontRef>
-        </p:style>
-        <p:txBody>
-          <a:bodyPr rtlCol="0" anchor="ctr"/>
-          <a:lstStyle/>
-          <a:p>
-            <a:pPr algn="ctr"/>
-            <a:endParaRPr sz="2400"/>
-          </a:p>
-        </p:txBody>
-      </p:sp>
-      <p:sp>
-        <p:nvSpPr>
-          <p:cNvPr id="59" name="TextBox 58">
-            <a:extLst>
-              <a:ext uri="{FF2B5EF4-FFF2-40B4-BE49-F238E27FC236}">
-                <a16:creationId xmlns:a16="http://schemas.microsoft.com/office/drawing/2014/main" id="{60057AE7-A6FF-4093-143C-FA7D4D9A4289}"/>
-              </a:ext>
-            </a:extLst>
-          </p:cNvPr>
-          <p:cNvSpPr txBox="1"/>
-          <p:nvPr/>
-        </p:nvSpPr>
-        <p:spPr>
-          <a:xfrm>
-            <a:off x="9179424" y="3530393"/>
-            <a:ext cx="349776" cy="461665"/>
-          </a:xfrm>
-          <a:prstGeom prst="rect">
-            <a:avLst/>
-          </a:prstGeom>
-          <a:noFill/>
-        </p:spPr>
-        <p:txBody>
-          <a:bodyPr wrap="none">
-            <a:spAutoFit/>
-          </a:bodyPr>
-          <a:lstStyle/>
-          <a:p>
-            <a:pPr algn="ctr">
-              <a:defRPr sz="1200" b="1">
-                <a:solidFill>
-                  <a:srgbClr val="FFFFFF"/>
-                </a:solidFill>
-                <a:latin typeface="Aptos"/>
-              </a:defRPr>
-            </a:pPr>
-            <a:r>
-              <a:rPr sz="2400"/>
-              <a:t>4</a:t>
-            </a:r>
-          </a:p>
-        </p:txBody>
-      </p:sp>
-      <p:sp>
-        <p:nvSpPr>
-          <p:cNvPr id="61" name="TextBox 60">
-            <a:extLst>
-              <a:ext uri="{FF2B5EF4-FFF2-40B4-BE49-F238E27FC236}">
-                <a16:creationId xmlns:a16="http://schemas.microsoft.com/office/drawing/2014/main" id="{AF2ADE26-F48B-CB0B-8E8B-F4DB7D24F62B}"/>
-              </a:ext>
-            </a:extLst>
-          </p:cNvPr>
-          <p:cNvSpPr txBox="1"/>
-          <p:nvPr/>
-        </p:nvSpPr>
-        <p:spPr>
-          <a:xfrm>
-            <a:off x="9637776" y="3457241"/>
-            <a:ext cx="1624355" cy="830997"/>
-          </a:xfrm>
-          <a:prstGeom prst="rect">
-            <a:avLst/>
-          </a:prstGeom>
-          <a:noFill/>
-        </p:spPr>
-        <p:txBody>
-          <a:bodyPr wrap="none">
-            <a:spAutoFit/>
-          </a:bodyPr>
-          <a:lstStyle/>
-          <a:p>
-            <a:pPr>
-              <a:defRPr sz="1200" b="1">
-                <a:solidFill>
-                  <a:srgbClr val="166030"/>
-                </a:solidFill>
-                <a:latin typeface="Aptos"/>
-              </a:defRPr>
-            </a:pPr>
-            <a:r>
-              <a:rPr sz="2400" dirty="0"/>
-              <a:t>PEOPLE &amp; </a:t>
-            </a:r>
-            <a:endParaRPr lang="en-ZA" sz="2400" dirty="0"/>
-          </a:p>
-          <a:p>
-            <a:pPr>
-              <a:defRPr sz="1200" b="1">
-                <a:solidFill>
-                  <a:srgbClr val="166030"/>
-                </a:solidFill>
-                <a:latin typeface="Aptos"/>
-              </a:defRPr>
-            </a:pPr>
-            <a:r>
-              <a:rPr sz="2400" dirty="0"/>
-              <a:t>CULTURE</a:t>
-            </a:r>
-          </a:p>
-        </p:txBody>
-      </p:sp>
-      <p:sp>
-        <p:nvSpPr>
-          <p:cNvPr id="63" name="TextBox 62">
-            <a:extLst>
-              <a:ext uri="{FF2B5EF4-FFF2-40B4-BE49-F238E27FC236}">
-                <a16:creationId xmlns:a16="http://schemas.microsoft.com/office/drawing/2014/main" id="{E58BF566-34BC-F297-75ED-DDB74D46C799}"/>
-              </a:ext>
-            </a:extLst>
-          </p:cNvPr>
-          <p:cNvSpPr txBox="1"/>
-          <p:nvPr/>
-        </p:nvSpPr>
-        <p:spPr>
-          <a:xfrm>
-            <a:off x="9180576" y="4359712"/>
-            <a:ext cx="2081555" cy="830997"/>
-          </a:xfrm>
-          <a:prstGeom prst="rect">
-            <a:avLst/>
-          </a:prstGeom>
-          <a:noFill/>
-        </p:spPr>
-        <p:txBody>
-          <a:bodyPr wrap="square">
-            <a:spAutoFit/>
-          </a:bodyPr>
-          <a:lstStyle/>
-          <a:p>
-            <a:pPr>
-              <a:defRPr sz="1150">
-                <a:solidFill>
-                  <a:srgbClr val="1E1E1E"/>
-                </a:solidFill>
-                <a:latin typeface="Aptos"/>
-              </a:defRPr>
-            </a:pPr>
-            <a:r>
-              <a:rPr sz="2400" dirty="0"/>
-              <a:t>Your people reality</a:t>
-            </a:r>
-          </a:p>
-        </p:txBody>
-      </p:sp>
-      <p:sp>
-        <p:nvSpPr>
-          <p:cNvPr id="69" name="TextBox 68">
-            <a:extLst>
-              <a:ext uri="{FF2B5EF4-FFF2-40B4-BE49-F238E27FC236}">
-                <a16:creationId xmlns:a16="http://schemas.microsoft.com/office/drawing/2014/main" id="{B5ECEBC8-849D-254D-4C2B-12D6FC728A4A}"/>
-              </a:ext>
-            </a:extLst>
-          </p:cNvPr>
-          <p:cNvSpPr txBox="1"/>
-          <p:nvPr/>
-        </p:nvSpPr>
-        <p:spPr>
-          <a:xfrm>
-            <a:off x="685800" y="5535700"/>
-            <a:ext cx="10789920" cy="1200329"/>
-          </a:xfrm>
-          <a:prstGeom prst="rect">
-            <a:avLst/>
-          </a:prstGeom>
-          <a:noFill/>
-        </p:spPr>
-        <p:txBody>
-          <a:bodyPr wrap="square">
-            <a:spAutoFit/>
-          </a:bodyPr>
-          <a:lstStyle/>
-          <a:p>
-            <a:pPr>
-              <a:defRPr sz="1700" b="1">
-                <a:solidFill>
-                  <a:srgbClr val="1E1E1E"/>
-                </a:solidFill>
-                <a:latin typeface="Georgia"/>
-              </a:defRPr>
-            </a:pPr>
-            <a:r>
-              <a:rPr sz="2400" dirty="0"/>
-              <a:t>Based only on </a:t>
-            </a:r>
-            <a:r>
-              <a:rPr lang="en-ZA" sz="2400" dirty="0"/>
-              <a:t>the knowledge of </a:t>
-            </a:r>
-            <a:r>
-              <a:rPr sz="2400" dirty="0"/>
-              <a:t>your function, what should Apex do over the next 12–36 months?</a:t>
-            </a:r>
-          </a:p>
-          <a:p>
-            <a:pPr>
-              <a:defRPr sz="1300">
-                <a:solidFill>
-                  <a:srgbClr val="696969"/>
-                </a:solidFill>
-                <a:latin typeface="Aptos"/>
-              </a:defRPr>
-            </a:pPr>
-            <a:r>
-              <a:rPr sz="2400" dirty="0"/>
-              <a:t>Prepare one strategic recommendation and the key reason for it.</a:t>
-            </a:r>
-          </a:p>
-        </p:txBody>
-      </p:sp>
-    </p:spTree>
-  </p:cSld>
-  <p:clrMapOvr>
-    <a:masterClrMapping/>
-  </p:clrMapOvr>
-</p:sld>
-</file>
-
-<file path=ppt/slides/slide35.xml><?xml version="1.0" encoding="utf-8"?>
-<p:sld xmlns:a="http://schemas.openxmlformats.org/drawingml/2006/main" xmlns:r="http://schemas.openxmlformats.org/officeDocument/2006/relationships" xmlns:p="http://schemas.openxmlformats.org/presentationml/2006/main">
-  <p:cSld name="Slide 34">
-    <p:bg>
-      <p:bgPr>
-        <a:solidFill>
-          <a:srgbClr val="FFFFFF"/>
-        </a:solidFill>
-        <a:effectLst/>
-      </p:bgPr>
-    </p:bg>
-    <p:spTree>
-      <p:nvGrpSpPr>
-        <p:cNvPr id="1" name=""/>
-        <p:cNvGrpSpPr/>
-        <p:nvPr/>
-      </p:nvGrpSpPr>
-      <p:grpSpPr>
-        <a:xfrm>
-          <a:off x="0" y="0"/>
-          <a:ext cx="0" cy="0"/>
-          <a:chOff x="0" y="0"/>
-          <a:chExt cx="0" cy="0"/>
-        </a:xfrm>
-      </p:grpSpPr>
-      <p:sp>
-        <p:nvSpPr>
-          <p:cNvPr id="2" name="Text 0"/>
-          <p:cNvSpPr txBox="1"/>
-          <p:nvPr/>
-        </p:nvSpPr>
-        <p:spPr>
-          <a:xfrm>
-            <a:off x="548640" y="411480"/>
-            <a:ext cx="11064240" cy="868680"/>
-          </a:xfrm>
-          <a:prstGeom prst="rect">
-            <a:avLst/>
-          </a:prstGeom>
-          <a:noFill/>
-          <a:ln/>
-        </p:spPr>
-        <p:txBody>
-          <a:bodyPr wrap="square" lIns="0" tIns="0" rIns="0" bIns="0" rtlCol="0" anchor="ctr"/>
-          <a:lstStyle/>
-          <a:p>
-            <a:pPr marL="0" indent="0">
-              <a:buNone/>
-            </a:pPr>
-            <a:r>
-              <a:rPr lang="en-US" sz="3600" b="1" dirty="0">
-                <a:solidFill>
-                  <a:srgbClr val="1A5C2C"/>
-                </a:solidFill>
-                <a:latin typeface="Cambria" pitchFamily="34" charset="0"/>
-                <a:ea typeface="Cambria" pitchFamily="34" charset="-122"/>
-                <a:cs typeface="Cambria" pitchFamily="34" charset="-120"/>
-              </a:rPr>
-              <a:t>Phase 1 · Fragmented Reality</a:t>
-            </a:r>
-            <a:endParaRPr lang="en-US" sz="3600" dirty="0"/>
-          </a:p>
-        </p:txBody>
-      </p:sp>
-      <p:sp>
-        <p:nvSpPr>
-          <p:cNvPr id="3" name="Shape 1"/>
-          <p:cNvSpPr/>
-          <p:nvPr/>
-        </p:nvSpPr>
-        <p:spPr>
-          <a:xfrm>
-            <a:off x="548640" y="1508760"/>
-            <a:ext cx="5408676" cy="2286000"/>
-          </a:xfrm>
-          <a:prstGeom prst="roundRect">
-            <a:avLst>
-              <a:gd name="adj" fmla="val 4000"/>
-            </a:avLst>
-          </a:prstGeom>
-          <a:solidFill>
-            <a:srgbClr val="EEF4EF"/>
-          </a:solidFill>
-          <a:ln w="12700">
-            <a:solidFill>
-              <a:srgbClr val="EEF4EF"/>
-            </a:solidFill>
-            <a:prstDash val="solid"/>
-          </a:ln>
-        </p:spPr>
-        <p:txBody>
-          <a:bodyPr/>
-          <a:lstStyle/>
-          <a:p>
-            <a:endParaRPr lang="en-ZA"/>
-          </a:p>
-        </p:txBody>
-      </p:sp>
-      <p:sp>
-        <p:nvSpPr>
-          <p:cNvPr id="4" name="Shape 2"/>
-          <p:cNvSpPr/>
-          <p:nvPr/>
-        </p:nvSpPr>
-        <p:spPr>
-          <a:xfrm>
-            <a:off x="777240" y="1737360"/>
-            <a:ext cx="548640" cy="548640"/>
-          </a:xfrm>
-          <a:prstGeom prst="ellipse">
-            <a:avLst/>
-          </a:prstGeom>
-          <a:solidFill>
-            <a:srgbClr val="1A5C2C"/>
-          </a:solidFill>
-          <a:ln w="12700">
-            <a:solidFill>
-              <a:srgbClr val="1A5C2C"/>
-            </a:solidFill>
-            <a:prstDash val="solid"/>
-          </a:ln>
-        </p:spPr>
-        <p:txBody>
-          <a:bodyPr/>
-          <a:lstStyle/>
-          <a:p>
-            <a:endParaRPr lang="en-ZA"/>
-          </a:p>
-        </p:txBody>
-      </p:sp>
-      <p:pic>
-        <p:nvPicPr>
-          <p:cNvPr id="5" name="Image 0" descr="preencoded.png"/>
-          <p:cNvPicPr>
-            <a:picLocks noChangeAspect="1"/>
-          </p:cNvPicPr>
-          <p:nvPr/>
-        </p:nvPicPr>
-        <p:blipFill>
-          <a:blip r:embed="rId3"/>
-          <a:stretch>
-            <a:fillRect/>
-          </a:stretch>
-        </p:blipFill>
-        <p:spPr>
-          <a:xfrm>
-            <a:off x="914400" y="1874520"/>
-            <a:ext cx="274320" cy="274320"/>
-          </a:xfrm>
-          <a:prstGeom prst="rect">
-            <a:avLst/>
-          </a:prstGeom>
-        </p:spPr>
-      </p:pic>
-      <p:sp>
-        <p:nvSpPr>
-          <p:cNvPr id="6" name="Text 3"/>
-          <p:cNvSpPr txBox="1"/>
-          <p:nvPr/>
-        </p:nvSpPr>
-        <p:spPr>
-          <a:xfrm>
-            <a:off x="1508760" y="1691640"/>
-            <a:ext cx="4219956" cy="640080"/>
-          </a:xfrm>
-          <a:prstGeom prst="rect">
-            <a:avLst/>
-          </a:prstGeom>
-          <a:noFill/>
-          <a:ln/>
-        </p:spPr>
-        <p:txBody>
-          <a:bodyPr wrap="square" lIns="0" tIns="0" rIns="0" bIns="0" rtlCol="0" anchor="ctr"/>
-          <a:lstStyle/>
-          <a:p>
-            <a:pPr marL="0" indent="0">
-              <a:buNone/>
-            </a:pPr>
-            <a:r>
-              <a:rPr lang="en-US" sz="2600" b="1" dirty="0">
-                <a:solidFill>
-                  <a:srgbClr val="1A5C2C"/>
-                </a:solidFill>
-                <a:latin typeface="Cambria" pitchFamily="34" charset="0"/>
-                <a:ea typeface="Cambria" pitchFamily="34" charset="-122"/>
-                <a:cs typeface="Cambria" pitchFamily="34" charset="-120"/>
-              </a:rPr>
-              <a:t>Group 1: Finance</a:t>
-            </a:r>
-            <a:endParaRPr lang="en-US" sz="2600" dirty="0"/>
-          </a:p>
-        </p:txBody>
-      </p:sp>
-      <p:sp>
-        <p:nvSpPr>
-          <p:cNvPr id="7" name="Text 4"/>
-          <p:cNvSpPr txBox="1"/>
-          <p:nvPr/>
-        </p:nvSpPr>
-        <p:spPr>
-          <a:xfrm>
-            <a:off x="777240" y="2468880"/>
-            <a:ext cx="4951476" cy="1188720"/>
-          </a:xfrm>
-          <a:prstGeom prst="rect">
-            <a:avLst/>
-          </a:prstGeom>
-          <a:noFill/>
-          <a:ln/>
-        </p:spPr>
-        <p:txBody>
-          <a:bodyPr wrap="square" lIns="0" tIns="0" rIns="0" bIns="0" rtlCol="0" anchor="t"/>
-          <a:lstStyle/>
-          <a:p>
-            <a:pPr marL="0" indent="0">
-              <a:buNone/>
-            </a:pPr>
-            <a:r>
-              <a:rPr lang="en-US" sz="2400" dirty="0">
-                <a:solidFill>
-                  <a:srgbClr val="1F2A22"/>
-                </a:solidFill>
-                <a:latin typeface="Calibri" pitchFamily="34" charset="0"/>
-                <a:ea typeface="Calibri" pitchFamily="34" charset="-122"/>
-                <a:cs typeface="Calibri" pitchFamily="34" charset="-120"/>
-              </a:rPr>
-              <a:t>Reality: Financial sustainability is under pressure.</a:t>
-            </a:r>
-            <a:endParaRPr lang="en-US" sz="2400" dirty="0"/>
-          </a:p>
-        </p:txBody>
-      </p:sp>
-      <p:sp>
-        <p:nvSpPr>
-          <p:cNvPr id="8" name="Shape 5"/>
-          <p:cNvSpPr/>
-          <p:nvPr/>
-        </p:nvSpPr>
-        <p:spPr>
-          <a:xfrm>
-            <a:off x="6231636" y="1508760"/>
-            <a:ext cx="5408676" cy="2286000"/>
-          </a:xfrm>
-          <a:prstGeom prst="roundRect">
-            <a:avLst>
-              <a:gd name="adj" fmla="val 4000"/>
-            </a:avLst>
-          </a:prstGeom>
-          <a:solidFill>
-            <a:srgbClr val="EEF4EF"/>
-          </a:solidFill>
-          <a:ln w="12700">
-            <a:solidFill>
-              <a:srgbClr val="EEF4EF"/>
-            </a:solidFill>
-            <a:prstDash val="solid"/>
-          </a:ln>
-        </p:spPr>
-        <p:txBody>
-          <a:bodyPr/>
-          <a:lstStyle/>
-          <a:p>
-            <a:endParaRPr lang="en-ZA"/>
-          </a:p>
-        </p:txBody>
-      </p:sp>
-      <p:sp>
-        <p:nvSpPr>
-          <p:cNvPr id="9" name="Shape 6"/>
-          <p:cNvSpPr/>
-          <p:nvPr/>
-        </p:nvSpPr>
-        <p:spPr>
-          <a:xfrm>
-            <a:off x="6460236" y="1737360"/>
-            <a:ext cx="548640" cy="548640"/>
-          </a:xfrm>
-          <a:prstGeom prst="ellipse">
-            <a:avLst/>
-          </a:prstGeom>
-          <a:solidFill>
-            <a:srgbClr val="1A5C2C"/>
-          </a:solidFill>
-          <a:ln w="12700">
-            <a:solidFill>
-              <a:srgbClr val="1A5C2C"/>
-            </a:solidFill>
-            <a:prstDash val="solid"/>
-          </a:ln>
-        </p:spPr>
-        <p:txBody>
-          <a:bodyPr/>
-          <a:lstStyle/>
-          <a:p>
-            <a:endParaRPr lang="en-ZA"/>
-          </a:p>
-        </p:txBody>
-      </p:sp>
-      <p:pic>
-        <p:nvPicPr>
-          <p:cNvPr id="10" name="Image 1" descr="preencoded.png"/>
-          <p:cNvPicPr>
-            <a:picLocks noChangeAspect="1"/>
-          </p:cNvPicPr>
-          <p:nvPr/>
-        </p:nvPicPr>
-        <p:blipFill>
-          <a:blip r:embed="rId4"/>
-          <a:stretch>
-            <a:fillRect/>
-          </a:stretch>
-        </p:blipFill>
-        <p:spPr>
-          <a:xfrm>
-            <a:off x="6597396" y="1874520"/>
-            <a:ext cx="274320" cy="274320"/>
-          </a:xfrm>
-          <a:prstGeom prst="rect">
-            <a:avLst/>
-          </a:prstGeom>
-        </p:spPr>
-      </p:pic>
-      <p:sp>
-        <p:nvSpPr>
-          <p:cNvPr id="11" name="Text 7"/>
-          <p:cNvSpPr txBox="1"/>
-          <p:nvPr/>
-        </p:nvSpPr>
-        <p:spPr>
-          <a:xfrm>
-            <a:off x="7191756" y="1691640"/>
-            <a:ext cx="4219956" cy="923544"/>
-          </a:xfrm>
-          <a:prstGeom prst="rect">
-            <a:avLst/>
-          </a:prstGeom>
-          <a:noFill/>
-          <a:ln/>
-        </p:spPr>
-        <p:txBody>
-          <a:bodyPr wrap="square" lIns="0" tIns="0" rIns="0" bIns="0" rtlCol="0" anchor="ctr"/>
-          <a:lstStyle/>
-          <a:p>
-            <a:pPr marL="0" indent="0">
-              <a:buNone/>
-            </a:pPr>
-            <a:r>
-              <a:rPr lang="en-US" sz="2600" b="1" dirty="0">
-                <a:solidFill>
-                  <a:srgbClr val="1A5C2C"/>
-                </a:solidFill>
-                <a:latin typeface="Cambria" pitchFamily="34" charset="0"/>
-                <a:ea typeface="Cambria" pitchFamily="34" charset="-122"/>
-                <a:cs typeface="Cambria" pitchFamily="34" charset="-120"/>
-              </a:rPr>
-              <a:t>Group 2: Market &amp; Strategy</a:t>
-            </a:r>
-            <a:endParaRPr lang="en-US" sz="2600" dirty="0"/>
-          </a:p>
-        </p:txBody>
-      </p:sp>
-      <p:sp>
-        <p:nvSpPr>
-          <p:cNvPr id="12" name="Text 8"/>
-          <p:cNvSpPr txBox="1"/>
-          <p:nvPr/>
-        </p:nvSpPr>
-        <p:spPr>
-          <a:xfrm>
-            <a:off x="6460236" y="2752344"/>
-            <a:ext cx="4951476" cy="905256"/>
-          </a:xfrm>
-          <a:prstGeom prst="rect">
-            <a:avLst/>
-          </a:prstGeom>
-          <a:noFill/>
-          <a:ln/>
-        </p:spPr>
-        <p:txBody>
-          <a:bodyPr wrap="square" lIns="0" tIns="0" rIns="0" bIns="0" rtlCol="0" anchor="t"/>
-          <a:lstStyle/>
-          <a:p>
-            <a:pPr marL="0" indent="0">
-              <a:buNone/>
-            </a:pPr>
-            <a:r>
-              <a:rPr lang="en-US" sz="2400" dirty="0">
-                <a:solidFill>
-                  <a:srgbClr val="1F2A22"/>
-                </a:solidFill>
-                <a:latin typeface="Calibri" pitchFamily="34" charset="0"/>
-                <a:ea typeface="Calibri" pitchFamily="34" charset="-122"/>
-                <a:cs typeface="Calibri" pitchFamily="34" charset="-120"/>
-              </a:rPr>
-              <a:t>Reality: Growth acceleration is critical to remain competitive.</a:t>
-            </a:r>
-            <a:endParaRPr lang="en-US" sz="2400" dirty="0"/>
-          </a:p>
-        </p:txBody>
-      </p:sp>
-      <p:sp>
-        <p:nvSpPr>
-          <p:cNvPr id="13" name="Shape 9"/>
-          <p:cNvSpPr/>
-          <p:nvPr/>
-        </p:nvSpPr>
-        <p:spPr>
-          <a:xfrm>
-            <a:off x="548640" y="4069080"/>
-            <a:ext cx="5408676" cy="2286000"/>
-          </a:xfrm>
-          <a:prstGeom prst="roundRect">
-            <a:avLst>
-              <a:gd name="adj" fmla="val 4000"/>
-            </a:avLst>
-          </a:prstGeom>
-          <a:solidFill>
-            <a:srgbClr val="EEF4EF"/>
-          </a:solidFill>
-          <a:ln w="12700">
-            <a:solidFill>
-              <a:srgbClr val="EEF4EF"/>
-            </a:solidFill>
-            <a:prstDash val="solid"/>
-          </a:ln>
-        </p:spPr>
-        <p:txBody>
-          <a:bodyPr/>
-          <a:lstStyle/>
-          <a:p>
-            <a:endParaRPr lang="en-ZA"/>
-          </a:p>
-        </p:txBody>
-      </p:sp>
-      <p:sp>
-        <p:nvSpPr>
-          <p:cNvPr id="14" name="Shape 10"/>
-          <p:cNvSpPr/>
-          <p:nvPr/>
-        </p:nvSpPr>
-        <p:spPr>
-          <a:xfrm>
-            <a:off x="777240" y="4297680"/>
-            <a:ext cx="548640" cy="548640"/>
-          </a:xfrm>
-          <a:prstGeom prst="ellipse">
-            <a:avLst/>
-          </a:prstGeom>
-          <a:solidFill>
-            <a:srgbClr val="1A5C2C"/>
-          </a:solidFill>
-          <a:ln w="12700">
-            <a:solidFill>
-              <a:srgbClr val="1A5C2C"/>
-            </a:solidFill>
-            <a:prstDash val="solid"/>
-          </a:ln>
-        </p:spPr>
-        <p:txBody>
-          <a:bodyPr/>
-          <a:lstStyle/>
-          <a:p>
-            <a:endParaRPr lang="en-ZA"/>
-          </a:p>
-        </p:txBody>
-      </p:sp>
-      <p:pic>
-        <p:nvPicPr>
-          <p:cNvPr id="15" name="Image 2" descr="preencoded.png"/>
-          <p:cNvPicPr>
-            <a:picLocks noChangeAspect="1"/>
-          </p:cNvPicPr>
-          <p:nvPr/>
-        </p:nvPicPr>
-        <p:blipFill>
-          <a:blip r:embed="rId5"/>
-          <a:stretch>
-            <a:fillRect/>
-          </a:stretch>
-        </p:blipFill>
-        <p:spPr>
-          <a:xfrm>
-            <a:off x="914400" y="4434840"/>
-            <a:ext cx="274320" cy="274320"/>
-          </a:xfrm>
-          <a:prstGeom prst="rect">
-            <a:avLst/>
-          </a:prstGeom>
-        </p:spPr>
-      </p:pic>
-      <p:sp>
-        <p:nvSpPr>
-          <p:cNvPr id="16" name="Text 11"/>
-          <p:cNvSpPr txBox="1"/>
-          <p:nvPr/>
-        </p:nvSpPr>
-        <p:spPr>
-          <a:xfrm>
-            <a:off x="1508760" y="4251960"/>
-            <a:ext cx="4219956" cy="640080"/>
-          </a:xfrm>
-          <a:prstGeom prst="rect">
-            <a:avLst/>
-          </a:prstGeom>
-          <a:noFill/>
-          <a:ln/>
-        </p:spPr>
-        <p:txBody>
-          <a:bodyPr wrap="square" lIns="0" tIns="0" rIns="0" bIns="0" rtlCol="0" anchor="ctr"/>
-          <a:lstStyle/>
-          <a:p>
-            <a:pPr marL="0" indent="0">
-              <a:buNone/>
-            </a:pPr>
-            <a:r>
-              <a:rPr lang="en-US" sz="2600" b="1" dirty="0">
-                <a:solidFill>
-                  <a:srgbClr val="1A5C2C"/>
-                </a:solidFill>
-                <a:latin typeface="Cambria" pitchFamily="34" charset="0"/>
-                <a:ea typeface="Cambria" pitchFamily="34" charset="-122"/>
-                <a:cs typeface="Cambria" pitchFamily="34" charset="-120"/>
-              </a:rPr>
-              <a:t>Group 3: Operations</a:t>
-            </a:r>
-            <a:endParaRPr lang="en-US" sz="2600" dirty="0"/>
-          </a:p>
-        </p:txBody>
-      </p:sp>
-      <p:sp>
-        <p:nvSpPr>
-          <p:cNvPr id="17" name="Text 12"/>
-          <p:cNvSpPr txBox="1"/>
-          <p:nvPr/>
-        </p:nvSpPr>
-        <p:spPr>
-          <a:xfrm>
-            <a:off x="777240" y="5029200"/>
-            <a:ext cx="4951476" cy="1188720"/>
-          </a:xfrm>
-          <a:prstGeom prst="rect">
-            <a:avLst/>
-          </a:prstGeom>
-          <a:noFill/>
-          <a:ln/>
-        </p:spPr>
-        <p:txBody>
-          <a:bodyPr wrap="square" lIns="0" tIns="0" rIns="0" bIns="0" rtlCol="0" anchor="t"/>
-          <a:lstStyle/>
-          <a:p>
-            <a:pPr marL="0" indent="0">
-              <a:buNone/>
-            </a:pPr>
-            <a:r>
-              <a:rPr lang="en-US" sz="2400" dirty="0">
-                <a:solidFill>
-                  <a:srgbClr val="1F2A22"/>
-                </a:solidFill>
-                <a:latin typeface="Calibri" pitchFamily="34" charset="0"/>
-                <a:ea typeface="Calibri" pitchFamily="34" charset="-122"/>
-                <a:cs typeface="Calibri" pitchFamily="34" charset="-120"/>
-              </a:rPr>
-              <a:t>Reality: Operational system is stretched and fragile.</a:t>
-            </a:r>
-            <a:endParaRPr lang="en-US" sz="2400" dirty="0"/>
-          </a:p>
-        </p:txBody>
-      </p:sp>
-      <p:sp>
-        <p:nvSpPr>
-          <p:cNvPr id="18" name="Shape 13"/>
-          <p:cNvSpPr/>
-          <p:nvPr/>
-        </p:nvSpPr>
-        <p:spPr>
-          <a:xfrm>
-            <a:off x="6231636" y="4069080"/>
-            <a:ext cx="5408676" cy="2286000"/>
-          </a:xfrm>
-          <a:prstGeom prst="roundRect">
-            <a:avLst>
-              <a:gd name="adj" fmla="val 4000"/>
-            </a:avLst>
-          </a:prstGeom>
-          <a:solidFill>
-            <a:srgbClr val="EEF4EF"/>
-          </a:solidFill>
-          <a:ln w="12700">
-            <a:solidFill>
-              <a:srgbClr val="EEF4EF"/>
-            </a:solidFill>
-            <a:prstDash val="solid"/>
-          </a:ln>
-        </p:spPr>
-        <p:txBody>
-          <a:bodyPr/>
-          <a:lstStyle/>
-          <a:p>
-            <a:endParaRPr lang="en-ZA"/>
-          </a:p>
-        </p:txBody>
-      </p:sp>
-      <p:sp>
-        <p:nvSpPr>
-          <p:cNvPr id="19" name="Shape 14"/>
-          <p:cNvSpPr/>
-          <p:nvPr/>
-        </p:nvSpPr>
-        <p:spPr>
-          <a:xfrm>
-            <a:off x="6460236" y="4297680"/>
-            <a:ext cx="548640" cy="548640"/>
-          </a:xfrm>
-          <a:prstGeom prst="ellipse">
-            <a:avLst/>
-          </a:prstGeom>
-          <a:solidFill>
-            <a:srgbClr val="1A5C2C"/>
-          </a:solidFill>
-          <a:ln w="12700">
-            <a:solidFill>
-              <a:srgbClr val="1A5C2C"/>
-            </a:solidFill>
-            <a:prstDash val="solid"/>
-          </a:ln>
-        </p:spPr>
-        <p:txBody>
-          <a:bodyPr/>
-          <a:lstStyle/>
-          <a:p>
-            <a:endParaRPr lang="en-ZA"/>
-          </a:p>
-        </p:txBody>
-      </p:sp>
-      <p:pic>
-        <p:nvPicPr>
-          <p:cNvPr id="20" name="Image 3" descr="preencoded.png"/>
-          <p:cNvPicPr>
-            <a:picLocks noChangeAspect="1"/>
-          </p:cNvPicPr>
-          <p:nvPr/>
-        </p:nvPicPr>
-        <p:blipFill>
-          <a:blip r:embed="rId6"/>
-          <a:stretch>
-            <a:fillRect/>
-          </a:stretch>
-        </p:blipFill>
-        <p:spPr>
-          <a:xfrm>
-            <a:off x="6597396" y="4434840"/>
-            <a:ext cx="274320" cy="274320"/>
-          </a:xfrm>
-          <a:prstGeom prst="rect">
-            <a:avLst/>
-          </a:prstGeom>
-        </p:spPr>
-      </p:pic>
-      <p:sp>
-        <p:nvSpPr>
-          <p:cNvPr id="21" name="Text 15"/>
-          <p:cNvSpPr txBox="1"/>
-          <p:nvPr/>
-        </p:nvSpPr>
-        <p:spPr>
-          <a:xfrm>
-            <a:off x="7191756" y="4251960"/>
-            <a:ext cx="4219956" cy="923544"/>
-          </a:xfrm>
-          <a:prstGeom prst="rect">
-            <a:avLst/>
-          </a:prstGeom>
-          <a:noFill/>
-          <a:ln/>
-        </p:spPr>
-        <p:txBody>
-          <a:bodyPr wrap="square" lIns="0" tIns="0" rIns="0" bIns="0" rtlCol="0" anchor="ctr"/>
-          <a:lstStyle/>
-          <a:p>
-            <a:pPr marL="0" indent="0">
-              <a:buNone/>
-            </a:pPr>
-            <a:r>
-              <a:rPr lang="en-US" sz="2600" b="1" dirty="0">
-                <a:solidFill>
-                  <a:srgbClr val="1A5C2C"/>
-                </a:solidFill>
-                <a:latin typeface="Cambria" pitchFamily="34" charset="0"/>
-                <a:ea typeface="Cambria" pitchFamily="34" charset="-122"/>
-                <a:cs typeface="Cambria" pitchFamily="34" charset="-120"/>
-              </a:rPr>
-              <a:t>Group 4: People &amp; Culture</a:t>
-            </a:r>
-            <a:endParaRPr lang="en-US" sz="2600" dirty="0"/>
-          </a:p>
-        </p:txBody>
-      </p:sp>
-      <p:sp>
-        <p:nvSpPr>
-          <p:cNvPr id="22" name="Text 16"/>
-          <p:cNvSpPr txBox="1"/>
-          <p:nvPr/>
-        </p:nvSpPr>
-        <p:spPr>
-          <a:xfrm>
-            <a:off x="6460236" y="5312664"/>
-            <a:ext cx="4951476" cy="905256"/>
-          </a:xfrm>
-          <a:prstGeom prst="rect">
-            <a:avLst/>
-          </a:prstGeom>
-          <a:noFill/>
-          <a:ln/>
-        </p:spPr>
-        <p:txBody>
-          <a:bodyPr wrap="square" lIns="0" tIns="0" rIns="0" bIns="0" rtlCol="0" anchor="t"/>
-          <a:lstStyle/>
-          <a:p>
-            <a:pPr marL="0" indent="0">
-              <a:buNone/>
-            </a:pPr>
-            <a:r>
-              <a:rPr lang="en-US" sz="2400" dirty="0">
-                <a:solidFill>
-                  <a:srgbClr val="1F2A22"/>
-                </a:solidFill>
-                <a:latin typeface="Calibri" pitchFamily="34" charset="0"/>
-                <a:ea typeface="Calibri" pitchFamily="34" charset="-122"/>
-                <a:cs typeface="Calibri" pitchFamily="34" charset="-120"/>
-              </a:rPr>
-              <a:t>Reality: Organisation may not absorb further strain.</a:t>
-            </a:r>
-            <a:endParaRPr lang="en-US" sz="2400" dirty="0"/>
-          </a:p>
-        </p:txBody>
-      </p:sp>
-    </p:spTree>
-  </p:cSld>
-  <p:clrMapOvr>
-    <a:masterClrMapping/>
-  </p:clrMapOvr>
-</p:sld>
-</file>
-
-<file path=ppt/slides/slide36.xml><?xml version="1.0" encoding="utf-8"?>
-<p:sld xmlns:a="http://schemas.openxmlformats.org/drawingml/2006/main" xmlns:r="http://schemas.openxmlformats.org/officeDocument/2006/relationships" xmlns:p="http://schemas.openxmlformats.org/presentationml/2006/main">
-  <p:cSld name="Slide 35">
-    <p:bg>
-      <p:bgPr>
-        <a:solidFill>
-          <a:srgbClr val="FFFFFF"/>
-        </a:solidFill>
-        <a:effectLst/>
-      </p:bgPr>
-    </p:bg>
-    <p:spTree>
-      <p:nvGrpSpPr>
-        <p:cNvPr id="1" name=""/>
-        <p:cNvGrpSpPr/>
-        <p:nvPr/>
-      </p:nvGrpSpPr>
-      <p:grpSpPr>
-        <a:xfrm>
-          <a:off x="0" y="0"/>
-          <a:ext cx="0" cy="0"/>
-          <a:chOff x="0" y="0"/>
-          <a:chExt cx="0" cy="0"/>
-        </a:xfrm>
-      </p:grpSpPr>
-      <p:sp>
-        <p:nvSpPr>
-          <p:cNvPr id="2" name="Text 0"/>
-          <p:cNvSpPr txBox="1"/>
-          <p:nvPr/>
-        </p:nvSpPr>
-        <p:spPr>
-          <a:xfrm>
-            <a:off x="548640" y="411480"/>
-            <a:ext cx="11064240" cy="868680"/>
-          </a:xfrm>
-          <a:prstGeom prst="rect">
-            <a:avLst/>
-          </a:prstGeom>
-          <a:noFill/>
-          <a:ln/>
-        </p:spPr>
-        <p:txBody>
-          <a:bodyPr wrap="square" lIns="0" tIns="0" rIns="0" bIns="0" rtlCol="0" anchor="ctr"/>
-          <a:lstStyle/>
-          <a:p>
-            <a:pPr marL="0" indent="0">
-              <a:buNone/>
-            </a:pPr>
-            <a:r>
-              <a:rPr lang="en-US" sz="3600" b="1" dirty="0">
-                <a:solidFill>
-                  <a:srgbClr val="1A5C2C"/>
-                </a:solidFill>
-                <a:latin typeface="Cambria" pitchFamily="34" charset="0"/>
-                <a:ea typeface="Cambria" pitchFamily="34" charset="-122"/>
-                <a:cs typeface="Cambria" pitchFamily="34" charset="-120"/>
-              </a:rPr>
-              <a:t>Phase 2 · Board Options</a:t>
-            </a:r>
-            <a:endParaRPr lang="en-US" sz="3600" dirty="0"/>
-          </a:p>
-        </p:txBody>
-      </p:sp>
-      <p:sp>
-        <p:nvSpPr>
-          <p:cNvPr id="3" name="Shape 1"/>
-          <p:cNvSpPr/>
-          <p:nvPr/>
-        </p:nvSpPr>
-        <p:spPr>
-          <a:xfrm>
-            <a:off x="548640" y="1508760"/>
-            <a:ext cx="3514344" cy="2816750"/>
-          </a:xfrm>
-          <a:prstGeom prst="roundRect">
-            <a:avLst>
-              <a:gd name="adj" fmla="val 2602"/>
-            </a:avLst>
-          </a:prstGeom>
-          <a:solidFill>
-            <a:srgbClr val="EEF4EF"/>
-          </a:solidFill>
-          <a:ln w="12700">
-            <a:solidFill>
-              <a:srgbClr val="EEF4EF"/>
-            </a:solidFill>
-            <a:prstDash val="solid"/>
-          </a:ln>
-        </p:spPr>
-        <p:txBody>
-          <a:bodyPr/>
-          <a:lstStyle/>
-          <a:p>
-            <a:endParaRPr lang="en-ZA"/>
-          </a:p>
-        </p:txBody>
-      </p:sp>
-      <p:sp>
-        <p:nvSpPr>
-          <p:cNvPr id="4" name="Shape 2"/>
-          <p:cNvSpPr/>
-          <p:nvPr/>
-        </p:nvSpPr>
-        <p:spPr>
-          <a:xfrm>
-            <a:off x="777240" y="1737360"/>
-            <a:ext cx="640080" cy="640080"/>
-          </a:xfrm>
-          <a:prstGeom prst="ellipse">
-            <a:avLst/>
-          </a:prstGeom>
-          <a:solidFill>
-            <a:srgbClr val="1A5C2C"/>
-          </a:solidFill>
-          <a:ln w="12700">
-            <a:solidFill>
-              <a:srgbClr val="1A5C2C"/>
-            </a:solidFill>
-            <a:prstDash val="solid"/>
-          </a:ln>
-        </p:spPr>
-        <p:txBody>
-          <a:bodyPr/>
-          <a:lstStyle/>
-          <a:p>
-            <a:endParaRPr lang="en-ZA"/>
-          </a:p>
-        </p:txBody>
-      </p:sp>
-      <p:pic>
-        <p:nvPicPr>
-          <p:cNvPr id="5" name="Image 0" descr="preencoded.png"/>
-          <p:cNvPicPr>
-            <a:picLocks noChangeAspect="1"/>
-          </p:cNvPicPr>
-          <p:nvPr/>
-        </p:nvPicPr>
-        <p:blipFill>
-          <a:blip r:embed="rId3"/>
-          <a:stretch>
-            <a:fillRect/>
-          </a:stretch>
-        </p:blipFill>
-        <p:spPr>
-          <a:xfrm>
-            <a:off x="937260" y="1897380"/>
-            <a:ext cx="320040" cy="320040"/>
-          </a:xfrm>
-          <a:prstGeom prst="rect">
-            <a:avLst/>
-          </a:prstGeom>
-        </p:spPr>
-      </p:pic>
-      <p:sp>
-        <p:nvSpPr>
-          <p:cNvPr id="6" name="Text 3"/>
-          <p:cNvSpPr txBox="1"/>
-          <p:nvPr/>
-        </p:nvSpPr>
-        <p:spPr>
-          <a:xfrm>
-            <a:off x="777240" y="2514600"/>
-            <a:ext cx="3057144" cy="987552"/>
-          </a:xfrm>
-          <a:prstGeom prst="rect">
-            <a:avLst/>
-          </a:prstGeom>
-          <a:noFill/>
-          <a:ln/>
-        </p:spPr>
-        <p:txBody>
-          <a:bodyPr wrap="square" lIns="0" tIns="0" rIns="0" bIns="0" rtlCol="0" anchor="t"/>
-          <a:lstStyle/>
-          <a:p>
-            <a:pPr marL="0" indent="0">
-              <a:buNone/>
-            </a:pPr>
-            <a:r>
-              <a:rPr lang="en-US" sz="2800" b="1" dirty="0">
-                <a:solidFill>
-                  <a:srgbClr val="1A5C2C"/>
-                </a:solidFill>
-                <a:latin typeface="Cambria" pitchFamily="34" charset="0"/>
-                <a:ea typeface="Cambria" pitchFamily="34" charset="-122"/>
-                <a:cs typeface="Cambria" pitchFamily="34" charset="-120"/>
-              </a:rPr>
-              <a:t>A · Organic Growth</a:t>
-            </a:r>
-            <a:endParaRPr lang="en-US" sz="2800" dirty="0"/>
-          </a:p>
-        </p:txBody>
-      </p:sp>
-      <p:sp>
-        <p:nvSpPr>
-          <p:cNvPr id="7" name="Text 4"/>
-          <p:cNvSpPr txBox="1"/>
-          <p:nvPr/>
-        </p:nvSpPr>
-        <p:spPr>
-          <a:xfrm>
-            <a:off x="763325" y="3191256"/>
-            <a:ext cx="3057144" cy="1664208"/>
-          </a:xfrm>
-          <a:prstGeom prst="rect">
-            <a:avLst/>
-          </a:prstGeom>
-          <a:noFill/>
-          <a:ln/>
-        </p:spPr>
-        <p:txBody>
-          <a:bodyPr wrap="square" lIns="0" tIns="0" rIns="0" bIns="0" rtlCol="0" anchor="t"/>
-          <a:lstStyle/>
-          <a:p>
-            <a:pPr marL="0" indent="0">
-              <a:buNone/>
-            </a:pPr>
-            <a:r>
-              <a:rPr lang="en-US" sz="2400" dirty="0">
-                <a:solidFill>
-                  <a:srgbClr val="1F2A22"/>
-                </a:solidFill>
-                <a:latin typeface="Calibri" pitchFamily="34" charset="0"/>
-                <a:ea typeface="Calibri" pitchFamily="34" charset="-122"/>
-                <a:cs typeface="Calibri" pitchFamily="34" charset="-120"/>
-              </a:rPr>
-              <a:t>$40M capacity expansion · 18–22% growth</a:t>
-            </a:r>
-            <a:endParaRPr lang="en-US" sz="2400" dirty="0"/>
-          </a:p>
-        </p:txBody>
-      </p:sp>
-      <p:sp>
-        <p:nvSpPr>
-          <p:cNvPr id="8" name="Shape 5"/>
-          <p:cNvSpPr/>
-          <p:nvPr/>
-        </p:nvSpPr>
-        <p:spPr>
-          <a:xfrm>
-            <a:off x="4337304" y="1508760"/>
-            <a:ext cx="3514344" cy="2816750"/>
-          </a:xfrm>
-          <a:prstGeom prst="roundRect">
-            <a:avLst>
-              <a:gd name="adj" fmla="val 2602"/>
-            </a:avLst>
-          </a:prstGeom>
-          <a:solidFill>
-            <a:srgbClr val="EEF4EF"/>
-          </a:solidFill>
-          <a:ln w="12700">
-            <a:solidFill>
-              <a:srgbClr val="EEF4EF"/>
-            </a:solidFill>
-            <a:prstDash val="solid"/>
-          </a:ln>
-        </p:spPr>
-        <p:txBody>
-          <a:bodyPr/>
-          <a:lstStyle/>
-          <a:p>
-            <a:endParaRPr lang="en-ZA"/>
-          </a:p>
-        </p:txBody>
-      </p:sp>
-      <p:sp>
-        <p:nvSpPr>
-          <p:cNvPr id="9" name="Shape 6"/>
-          <p:cNvSpPr/>
-          <p:nvPr/>
-        </p:nvSpPr>
-        <p:spPr>
-          <a:xfrm>
-            <a:off x="4565904" y="1737360"/>
-            <a:ext cx="640080" cy="640080"/>
-          </a:xfrm>
-          <a:prstGeom prst="ellipse">
-            <a:avLst/>
-          </a:prstGeom>
-          <a:solidFill>
-            <a:srgbClr val="1A5C2C"/>
-          </a:solidFill>
-          <a:ln w="12700">
-            <a:solidFill>
-              <a:srgbClr val="1A5C2C"/>
-            </a:solidFill>
-            <a:prstDash val="solid"/>
-          </a:ln>
-        </p:spPr>
-        <p:txBody>
-          <a:bodyPr/>
-          <a:lstStyle/>
-          <a:p>
-            <a:endParaRPr lang="en-ZA"/>
-          </a:p>
-        </p:txBody>
-      </p:sp>
-      <p:pic>
-        <p:nvPicPr>
-          <p:cNvPr id="10" name="Image 1" descr="preencoded.png"/>
-          <p:cNvPicPr>
-            <a:picLocks noChangeAspect="1"/>
-          </p:cNvPicPr>
-          <p:nvPr/>
-        </p:nvPicPr>
-        <p:blipFill>
-          <a:blip r:embed="rId4"/>
-          <a:stretch>
-            <a:fillRect/>
-          </a:stretch>
-        </p:blipFill>
-        <p:spPr>
-          <a:xfrm>
-            <a:off x="4725924" y="1897380"/>
-            <a:ext cx="320040" cy="320040"/>
-          </a:xfrm>
-          <a:prstGeom prst="rect">
-            <a:avLst/>
-          </a:prstGeom>
-        </p:spPr>
-      </p:pic>
-      <p:sp>
-        <p:nvSpPr>
-          <p:cNvPr id="11" name="Text 7"/>
-          <p:cNvSpPr txBox="1"/>
-          <p:nvPr/>
-        </p:nvSpPr>
-        <p:spPr>
-          <a:xfrm>
-            <a:off x="4565904" y="2514600"/>
-            <a:ext cx="3057144" cy="539496"/>
-          </a:xfrm>
-          <a:prstGeom prst="rect">
-            <a:avLst/>
-          </a:prstGeom>
-          <a:noFill/>
-          <a:ln/>
-        </p:spPr>
-        <p:txBody>
-          <a:bodyPr wrap="square" lIns="0" tIns="0" rIns="0" bIns="0" rtlCol="0" anchor="t"/>
-          <a:lstStyle/>
-          <a:p>
-            <a:pPr marL="0" indent="0">
-              <a:buNone/>
-            </a:pPr>
-            <a:r>
-              <a:rPr lang="en-US" sz="2800" b="1" dirty="0">
-                <a:solidFill>
-                  <a:srgbClr val="1A5C2C"/>
-                </a:solidFill>
-                <a:latin typeface="Cambria" pitchFamily="34" charset="0"/>
-                <a:ea typeface="Cambria" pitchFamily="34" charset="-122"/>
-                <a:cs typeface="Cambria" pitchFamily="34" charset="-120"/>
-              </a:rPr>
-              <a:t>B · Acquisition</a:t>
-            </a:r>
-            <a:endParaRPr lang="en-US" sz="2800" dirty="0"/>
-          </a:p>
-        </p:txBody>
-      </p:sp>
-      <p:sp>
-        <p:nvSpPr>
-          <p:cNvPr id="12" name="Text 8"/>
-          <p:cNvSpPr txBox="1"/>
-          <p:nvPr/>
-        </p:nvSpPr>
-        <p:spPr>
-          <a:xfrm>
-            <a:off x="4565904" y="3191256"/>
-            <a:ext cx="3057144" cy="2112264"/>
-          </a:xfrm>
-          <a:prstGeom prst="rect">
-            <a:avLst/>
-          </a:prstGeom>
-          <a:noFill/>
-          <a:ln/>
-        </p:spPr>
-        <p:txBody>
-          <a:bodyPr wrap="square" lIns="0" tIns="0" rIns="0" bIns="0" rtlCol="0" anchor="t"/>
-          <a:lstStyle/>
-          <a:p>
-            <a:pPr marL="0" indent="0">
-              <a:buNone/>
-            </a:pPr>
-            <a:r>
-              <a:rPr lang="en-US" sz="2400" dirty="0">
-                <a:solidFill>
-                  <a:srgbClr val="1F2A22"/>
-                </a:solidFill>
-                <a:latin typeface="Calibri" pitchFamily="34" charset="0"/>
-                <a:ea typeface="Calibri" pitchFamily="34" charset="-122"/>
-                <a:cs typeface="Calibri" pitchFamily="34" charset="-120"/>
-              </a:rPr>
-              <a:t>$65M · 35–45% growth · 40% of similar deals underperform</a:t>
-            </a:r>
-            <a:endParaRPr lang="en-US" sz="2400" dirty="0"/>
-          </a:p>
-        </p:txBody>
-      </p:sp>
-      <p:sp>
-        <p:nvSpPr>
-          <p:cNvPr id="13" name="Shape 9"/>
-          <p:cNvSpPr/>
-          <p:nvPr/>
-        </p:nvSpPr>
-        <p:spPr>
-          <a:xfrm>
-            <a:off x="8125968" y="1508760"/>
-            <a:ext cx="3514344" cy="2816750"/>
-          </a:xfrm>
-          <a:prstGeom prst="roundRect">
-            <a:avLst>
-              <a:gd name="adj" fmla="val 2602"/>
-            </a:avLst>
-          </a:prstGeom>
-          <a:solidFill>
-            <a:srgbClr val="EEF4EF"/>
-          </a:solidFill>
-          <a:ln w="12700">
-            <a:solidFill>
-              <a:srgbClr val="EEF4EF"/>
-            </a:solidFill>
-            <a:prstDash val="solid"/>
-          </a:ln>
-        </p:spPr>
-        <p:txBody>
-          <a:bodyPr/>
-          <a:lstStyle/>
-          <a:p>
-            <a:endParaRPr lang="en-ZA"/>
-          </a:p>
-        </p:txBody>
-      </p:sp>
-      <p:sp>
-        <p:nvSpPr>
-          <p:cNvPr id="14" name="Shape 10"/>
-          <p:cNvSpPr/>
-          <p:nvPr/>
-        </p:nvSpPr>
-        <p:spPr>
-          <a:xfrm>
-            <a:off x="8354568" y="1737360"/>
-            <a:ext cx="640080" cy="640080"/>
-          </a:xfrm>
-          <a:prstGeom prst="ellipse">
-            <a:avLst/>
-          </a:prstGeom>
-          <a:solidFill>
-            <a:srgbClr val="1A5C2C"/>
-          </a:solidFill>
-          <a:ln w="12700">
-            <a:solidFill>
-              <a:srgbClr val="1A5C2C"/>
-            </a:solidFill>
-            <a:prstDash val="solid"/>
-          </a:ln>
-        </p:spPr>
-        <p:txBody>
-          <a:bodyPr/>
-          <a:lstStyle/>
-          <a:p>
-            <a:endParaRPr lang="en-ZA"/>
-          </a:p>
-        </p:txBody>
-      </p:sp>
-      <p:pic>
-        <p:nvPicPr>
-          <p:cNvPr id="15" name="Image 2" descr="preencoded.png"/>
-          <p:cNvPicPr>
-            <a:picLocks noChangeAspect="1"/>
-          </p:cNvPicPr>
-          <p:nvPr/>
-        </p:nvPicPr>
-        <p:blipFill>
-          <a:blip r:embed="rId5"/>
-          <a:stretch>
-            <a:fillRect/>
-          </a:stretch>
-        </p:blipFill>
-        <p:spPr>
-          <a:xfrm>
-            <a:off x="8514588" y="1897380"/>
-            <a:ext cx="320040" cy="320040"/>
-          </a:xfrm>
-          <a:prstGeom prst="rect">
-            <a:avLst/>
-          </a:prstGeom>
-        </p:spPr>
-      </p:pic>
-      <p:sp>
-        <p:nvSpPr>
-          <p:cNvPr id="16" name="Text 11"/>
-          <p:cNvSpPr txBox="1"/>
-          <p:nvPr/>
-        </p:nvSpPr>
-        <p:spPr>
-          <a:xfrm>
-            <a:off x="8354568" y="2514600"/>
-            <a:ext cx="3057144" cy="987552"/>
-          </a:xfrm>
-          <a:prstGeom prst="rect">
-            <a:avLst/>
-          </a:prstGeom>
-          <a:noFill/>
-          <a:ln/>
-        </p:spPr>
-        <p:txBody>
-          <a:bodyPr wrap="square" lIns="0" tIns="0" rIns="0" bIns="0" rtlCol="0" anchor="t"/>
-          <a:lstStyle/>
-          <a:p>
-            <a:pPr marL="0" indent="0">
-              <a:buNone/>
-            </a:pPr>
-            <a:r>
-              <a:rPr lang="en-US" sz="2800" b="1" dirty="0">
-                <a:solidFill>
-                  <a:srgbClr val="1A5C2C"/>
-                </a:solidFill>
-                <a:latin typeface="Cambria" pitchFamily="34" charset="0"/>
-                <a:ea typeface="Cambria" pitchFamily="34" charset="-122"/>
-                <a:cs typeface="Cambria" pitchFamily="34" charset="-120"/>
-              </a:rPr>
-              <a:t>C · Strategic Pause</a:t>
-            </a:r>
-            <a:endParaRPr lang="en-US" sz="2800" dirty="0"/>
-          </a:p>
-        </p:txBody>
-      </p:sp>
-      <p:sp>
-        <p:nvSpPr>
-          <p:cNvPr id="17" name="Text 12"/>
-          <p:cNvSpPr txBox="1"/>
-          <p:nvPr/>
-        </p:nvSpPr>
-        <p:spPr>
-          <a:xfrm>
-            <a:off x="8354568" y="3191256"/>
-            <a:ext cx="3057144" cy="1664208"/>
-          </a:xfrm>
-          <a:prstGeom prst="rect">
-            <a:avLst/>
-          </a:prstGeom>
-          <a:noFill/>
-          <a:ln/>
-        </p:spPr>
-        <p:txBody>
-          <a:bodyPr wrap="square" lIns="0" tIns="0" rIns="0" bIns="0" rtlCol="0" anchor="t"/>
-          <a:lstStyle/>
-          <a:p>
-            <a:pPr marL="0" indent="0">
-              <a:buNone/>
-            </a:pPr>
-            <a:r>
-              <a:rPr lang="en-US" sz="2400" dirty="0">
-                <a:solidFill>
-                  <a:srgbClr val="1F2A22"/>
-                </a:solidFill>
-                <a:latin typeface="Calibri" pitchFamily="34" charset="0"/>
-                <a:ea typeface="Calibri" pitchFamily="34" charset="-122"/>
-                <a:cs typeface="Calibri" pitchFamily="34" charset="-120"/>
-              </a:rPr>
-              <a:t>No major capital investment for 18 months</a:t>
-            </a:r>
-            <a:endParaRPr lang="en-US" sz="2400" dirty="0"/>
-          </a:p>
-        </p:txBody>
-      </p:sp>
-      <p:sp>
-        <p:nvSpPr>
-          <p:cNvPr id="21" name="Rounded Rectangle 18">
-            <a:extLst>
-              <a:ext uri="{FF2B5EF4-FFF2-40B4-BE49-F238E27FC236}">
-                <a16:creationId xmlns:a16="http://schemas.microsoft.com/office/drawing/2014/main" id="{94D326D5-F65C-5669-1DC9-B3D8ACEEF71C}"/>
-              </a:ext>
-            </a:extLst>
-          </p:cNvPr>
-          <p:cNvSpPr/>
-          <p:nvPr/>
-        </p:nvSpPr>
-        <p:spPr>
-          <a:xfrm>
-            <a:off x="594360" y="4414964"/>
-            <a:ext cx="10972800" cy="1691638"/>
-          </a:xfrm>
-          <a:prstGeom prst="roundRect">
-            <a:avLst/>
-          </a:prstGeom>
-          <a:solidFill>
-            <a:srgbClr val="0F4623"/>
-          </a:solidFill>
-          <a:ln>
-            <a:solidFill>
-              <a:srgbClr val="0F4623"/>
-            </a:solidFill>
-          </a:ln>
-        </p:spPr>
-        <p:style>
-          <a:lnRef idx="1">
-            <a:schemeClr val="accent1"/>
-          </a:lnRef>
-          <a:fillRef idx="3">
-            <a:schemeClr val="accent1"/>
-          </a:fillRef>
-          <a:effectRef idx="2">
-            <a:schemeClr val="accent1"/>
-          </a:effectRef>
-          <a:fontRef idx="minor">
-            <a:schemeClr val="lt1"/>
-          </a:fontRef>
-        </p:style>
-        <p:txBody>
-          <a:bodyPr rtlCol="0" anchor="ctr"/>
-          <a:lstStyle/>
-          <a:p>
-            <a:pPr algn="ctr"/>
-            <a:endParaRPr sz="2400"/>
-          </a:p>
-        </p:txBody>
-      </p:sp>
-      <p:sp>
-        <p:nvSpPr>
-          <p:cNvPr id="23" name="TextBox 22">
-            <a:extLst>
-              <a:ext uri="{FF2B5EF4-FFF2-40B4-BE49-F238E27FC236}">
-                <a16:creationId xmlns:a16="http://schemas.microsoft.com/office/drawing/2014/main" id="{3CC61B5A-FDFD-C265-F7DA-058C7AC7A795}"/>
-              </a:ext>
-            </a:extLst>
-          </p:cNvPr>
-          <p:cNvSpPr txBox="1"/>
-          <p:nvPr/>
-        </p:nvSpPr>
-        <p:spPr>
-          <a:xfrm>
-            <a:off x="868680" y="4606988"/>
-            <a:ext cx="10663362" cy="1569660"/>
-          </a:xfrm>
-          <a:prstGeom prst="rect">
-            <a:avLst/>
-          </a:prstGeom>
-          <a:noFill/>
-        </p:spPr>
-        <p:txBody>
-          <a:bodyPr wrap="square">
-            <a:spAutoFit/>
-          </a:bodyPr>
-          <a:lstStyle/>
-          <a:p>
-            <a:pPr>
-              <a:defRPr sz="1100" b="1">
-                <a:solidFill>
-                  <a:srgbClr val="ECCD69"/>
-                </a:solidFill>
-                <a:latin typeface="Aptos"/>
-              </a:defRPr>
-            </a:pPr>
-            <a:r>
-              <a:rPr sz="2400" dirty="0"/>
-              <a:t>THE ENTERPRISE TASK</a:t>
-            </a:r>
-          </a:p>
-          <a:p>
-            <a:pPr>
-              <a:defRPr sz="1800" b="1">
-                <a:solidFill>
-                  <a:srgbClr val="FFFFFF"/>
-                </a:solidFill>
-                <a:latin typeface="Georgia"/>
-              </a:defRPr>
-            </a:pPr>
-            <a:r>
-              <a:rPr lang="en-ZA" sz="2400" dirty="0"/>
-              <a:t>W</a:t>
-            </a:r>
-            <a:r>
-              <a:rPr sz="2400" dirty="0"/>
-              <a:t>hat is the right decision for Apex as a whole?</a:t>
-            </a:r>
-          </a:p>
-          <a:p>
-            <a:pPr>
-              <a:defRPr sz="1250">
-                <a:solidFill>
-                  <a:srgbClr val="FFFFFF"/>
-                </a:solidFill>
-                <a:latin typeface="Aptos"/>
-              </a:defRPr>
-            </a:pPr>
-            <a:r>
-              <a:rPr sz="2400" dirty="0"/>
-              <a:t>Your decision must address growth · financial sustainability · operational reality · people capacity.</a:t>
-            </a:r>
-          </a:p>
-        </p:txBody>
-      </p:sp>
-      <p:sp>
-        <p:nvSpPr>
-          <p:cNvPr id="25" name="TextBox 24">
-            <a:extLst>
-              <a:ext uri="{FF2B5EF4-FFF2-40B4-BE49-F238E27FC236}">
-                <a16:creationId xmlns:a16="http://schemas.microsoft.com/office/drawing/2014/main" id="{C0E2D656-5BB9-19C6-46C9-657084509706}"/>
-              </a:ext>
-            </a:extLst>
-          </p:cNvPr>
-          <p:cNvSpPr txBox="1"/>
-          <p:nvPr/>
-        </p:nvSpPr>
-        <p:spPr>
-          <a:xfrm>
-            <a:off x="659958" y="6033452"/>
-            <a:ext cx="10907202" cy="830997"/>
-          </a:xfrm>
-          <a:prstGeom prst="rect">
-            <a:avLst/>
-          </a:prstGeom>
-          <a:noFill/>
-        </p:spPr>
-        <p:txBody>
-          <a:bodyPr wrap="square">
-            <a:spAutoFit/>
-          </a:bodyPr>
-          <a:lstStyle/>
-          <a:p>
-            <a:pPr>
-              <a:defRPr sz="1200" b="1">
-                <a:solidFill>
-                  <a:srgbClr val="166030"/>
-                </a:solidFill>
-                <a:latin typeface="Aptos"/>
-              </a:defRPr>
-            </a:pPr>
-            <a:r>
-              <a:rPr sz="2400" dirty="0"/>
-              <a:t>You may select, combine, sequence or challenge the options to form ONE integrated enterprise decision.</a:t>
-            </a:r>
           </a:p>
         </p:txBody>
       </p:sp>
@@ -33526,7 +30370,7 @@
                 <a:ea typeface="+mj-ea"/>
                 <a:cs typeface="+mj-cs"/>
               </a:rPr>
-              <a:t>Section 6 Reflections</a:t>
+              <a:t>Section 6 · On the Portal</a:t>
             </a:r>
             <a:endParaRPr lang="en-US" sz="6600" kern="1200" dirty="0">
               <a:solidFill>
@@ -33571,88 +30415,22 @@
       </p:pic>
       <p:pic>
         <p:nvPicPr>
-          <p:cNvPr id="12" name="Picture 11">
-            <a:extLst>
-              <a:ext uri="{FF2B5EF4-FFF2-40B4-BE49-F238E27FC236}">
-                <a16:creationId xmlns:a16="http://schemas.microsoft.com/office/drawing/2014/main" id="{983E7308-312A-B6D5-2B93-612EDC3C8DEC}"/>
-              </a:ext>
-            </a:extLst>
-          </p:cNvPr>
+          <p:cNvPr id="10" name="Picture 9" descr="img62.png"/>
           <p:cNvPicPr>
             <a:picLocks noChangeAspect="1"/>
           </p:cNvPicPr>
           <p:nvPr/>
         </p:nvPicPr>
         <p:blipFill>
-          <a:blip r:embed="rId4"/>
+          <a:blip r:embed="rId7"/>
           <a:stretch>
             <a:fillRect/>
           </a:stretch>
         </p:blipFill>
         <p:spPr>
           <a:xfrm>
-            <a:off x="1107322" y="3093563"/>
-            <a:ext cx="10541339" cy="939555"/>
-          </a:xfrm>
-          <a:prstGeom prst="rect">
-            <a:avLst/>
-          </a:prstGeom>
-        </p:spPr>
-      </p:pic>
-      <p:pic>
-        <p:nvPicPr>
-          <p:cNvPr id="14" name="Picture 13">
-            <a:extLst>
-              <a:ext uri="{FF2B5EF4-FFF2-40B4-BE49-F238E27FC236}">
-                <a16:creationId xmlns:a16="http://schemas.microsoft.com/office/drawing/2014/main" id="{BD684DB9-0954-82F7-186E-F799E8C485FE}"/>
-              </a:ext>
-            </a:extLst>
-          </p:cNvPr>
-          <p:cNvPicPr>
-            <a:picLocks noChangeAspect="1"/>
-          </p:cNvPicPr>
-          <p:nvPr/>
-        </p:nvPicPr>
-        <p:blipFill>
-          <a:blip r:embed="rId5"/>
-          <a:stretch>
-            <a:fillRect/>
-          </a:stretch>
-        </p:blipFill>
-        <p:spPr>
-          <a:xfrm>
-            <a:off x="1107321" y="4285188"/>
-            <a:ext cx="10541339" cy="881538"/>
-          </a:xfrm>
-          <a:prstGeom prst="rect">
-            <a:avLst/>
-          </a:prstGeom>
-        </p:spPr>
-      </p:pic>
-      <p:pic>
-        <p:nvPicPr>
-          <p:cNvPr id="17" name="Picture 16">
-            <a:extLst>
-              <a:ext uri="{FF2B5EF4-FFF2-40B4-BE49-F238E27FC236}">
-                <a16:creationId xmlns:a16="http://schemas.microsoft.com/office/drawing/2014/main" id="{020CEB8F-66B2-B780-ED06-3F4DF6EDD096}"/>
-              </a:ext>
-            </a:extLst>
-          </p:cNvPr>
-          <p:cNvPicPr>
-            <a:picLocks noChangeAspect="1"/>
-          </p:cNvPicPr>
-          <p:nvPr/>
-        </p:nvPicPr>
-        <p:blipFill>
-          <a:blip r:embed="rId6"/>
-          <a:stretch>
-            <a:fillRect/>
-          </a:stretch>
-        </p:blipFill>
-        <p:spPr>
-          <a:xfrm>
-            <a:off x="1107322" y="5418797"/>
-            <a:ext cx="10541338" cy="970912"/>
+            <a:off x="1107322" y="3291493"/>
+            <a:ext cx="10541339" cy="1457231"/>
           </a:xfrm>
           <a:prstGeom prst="rect">
             <a:avLst/>

</xml_diff>

<commit_message>
Shared group record for all Capstone group work; Unit 2 worked example and capstone build
Co-Authored-By: Claude Opus 5.5 <noreply@anthropic.com>

Claude-Session: https://claude.ai/code/session_01ShK1hu3dF2CBVtuJTTXtyg
</commit_message>
<xml_diff>
--- a/Unit decks/Unit 01 - Behavioural Strategy Fundamentals.pptx
+++ b/Unit decks/Unit 01 - Behavioural Strategy Fundamentals.pptx
@@ -12303,7 +12303,7 @@
           <a:p/>
           <a:p>
             <a:r>
-              <a:t>Then, as a group, write the Problem Charter in Section 6.2: create your simulated company and record your simulated executive team (Step 1), set out your shared reality (Step 2) and determine the central problem your executive team will address (Step 3). Confirm the Charter record: it becomes Section 1 of your team’s Capstone Blueprint.</a:t>
+              <a:t>Then, as a group, write the Problem Charter in Section 6.2: create your simulated company and record your simulated executive team (Step 1), set out your shared reality (Step 2) and determine the central problem your executive team will address (Step 3). In the Charter record each member selects Agree: when every member has agreed, it becomes Section 1 of your team’s Capstone Blueprint.</a:t>
             </a:r>
           </a:p>
           <a:p/>
@@ -30300,7 +30300,7 @@
 </p:sld>
 </file>
 
-<file path=ppt/slides/slide37.xml><?xml version="1.0" encoding="utf-8"?>
+<file path=ppt/slides/slide34.xml><?xml version="1.0" encoding="utf-8"?>
 <p:sld xmlns:a="http://schemas.openxmlformats.org/drawingml/2006/main" xmlns:r="http://schemas.openxmlformats.org/officeDocument/2006/relationships" xmlns:p="http://schemas.openxmlformats.org/presentationml/2006/main">
   <p:cSld>
     <p:spTree>
@@ -30450,7 +30450,7 @@
 </p:sld>
 </file>
 
-<file path=ppt/slides/slide38.xml><?xml version="1.0" encoding="utf-8"?>
+<file path=ppt/slides/slide35.xml><?xml version="1.0" encoding="utf-8"?>
 <p:sld xmlns:a="http://schemas.openxmlformats.org/drawingml/2006/main" xmlns:r="http://schemas.openxmlformats.org/officeDocument/2006/relationships" xmlns:p="http://schemas.openxmlformats.org/presentationml/2006/main">
   <p:cSld name="Slide 40">
     <p:bg>

</xml_diff>

<commit_message>
Unit decks clean-up for all units; Unit 4 CTO blind spot set to Value Proposition
</commit_message>
<xml_diff>
--- a/Unit decks/Unit 01 - Behavioural Strategy Fundamentals.pptx
+++ b/Unit decks/Unit 01 - Behavioural Strategy Fundamentals.pptx
@@ -21177,7 +21177,7 @@
               <a:tabLst/>
               <a:defRPr/>
             </a:pPr>
-            <a:endParaRPr kumimoji="0" sz="2000" b="0" i="0" u="none" strike="noStrike" kern="1200" cap="none" spc="0" normalizeH="0" baseline="0" noProof="0">
+            <a:endParaRPr kumimoji="0" sz="2400" b="0" i="0" u="none" strike="noStrike" kern="1200" cap="none" spc="0" normalizeH="0" baseline="0" noProof="0">
               <a:ln>
                 <a:noFill/>
               </a:ln>
@@ -21255,7 +21255,7 @@
               <a:buFontTx/>
               <a:buNone/>
               <a:tabLst/>
-              <a:defRPr sz="1600" b="1">
+              <a:defRPr sz="2400" b="1">
                 <a:solidFill>
                   <a:srgbClr val="FFFFFF"/>
                 </a:solidFill>
@@ -21322,7 +21322,7 @@
               <a:buFontTx/>
               <a:buNone/>
               <a:tabLst/>
-              <a:defRPr sz="1400" b="1">
+              <a:defRPr sz="2400" b="1">
                 <a:solidFill>
                   <a:srgbClr val="166030"/>
                 </a:solidFill>
@@ -21389,7 +21389,7 @@
               <a:buFontTx/>
               <a:buNone/>
               <a:tabLst/>
-              <a:defRPr sz="1150">
+              <a:defRPr sz="2400">
                 <a:solidFill>
                   <a:srgbClr val="1E1E1E"/>
                 </a:solidFill>
@@ -21479,7 +21479,7 @@
               <a:tabLst/>
               <a:defRPr/>
             </a:pPr>
-            <a:endParaRPr kumimoji="0" sz="2000" b="0" i="0" u="none" strike="noStrike" kern="1200" cap="none" spc="0" normalizeH="0" baseline="0" noProof="0">
+            <a:endParaRPr kumimoji="0" sz="2400" b="0" i="0" u="none" strike="noStrike" kern="1200" cap="none" spc="0" normalizeH="0" baseline="0" noProof="0">
               <a:ln>
                 <a:noFill/>
               </a:ln>
@@ -21557,7 +21557,7 @@
               <a:buFontTx/>
               <a:buNone/>
               <a:tabLst/>
-              <a:defRPr sz="1600" b="1">
+              <a:defRPr sz="2400" b="1">
                 <a:solidFill>
                   <a:srgbClr val="FFFFFF"/>
                 </a:solidFill>
@@ -21624,7 +21624,7 @@
               <a:buFontTx/>
               <a:buNone/>
               <a:tabLst/>
-              <a:defRPr sz="1400" b="1">
+              <a:defRPr sz="2400" b="1">
                 <a:solidFill>
                   <a:srgbClr val="166030"/>
                 </a:solidFill>
@@ -21691,7 +21691,7 @@
               <a:buFontTx/>
               <a:buNone/>
               <a:tabLst/>
-              <a:defRPr sz="1150">
+              <a:defRPr sz="2400">
                 <a:solidFill>
                   <a:srgbClr val="1E1E1E"/>
                 </a:solidFill>
@@ -21781,7 +21781,7 @@
               <a:tabLst/>
               <a:defRPr/>
             </a:pPr>
-            <a:endParaRPr kumimoji="0" sz="2000" b="0" i="0" u="none" strike="noStrike" kern="1200" cap="none" spc="0" normalizeH="0" baseline="0" noProof="0">
+            <a:endParaRPr kumimoji="0" sz="2400" b="0" i="0" u="none" strike="noStrike" kern="1200" cap="none" spc="0" normalizeH="0" baseline="0" noProof="0">
               <a:ln>
                 <a:noFill/>
               </a:ln>
@@ -21859,7 +21859,7 @@
               <a:buFontTx/>
               <a:buNone/>
               <a:tabLst/>
-              <a:defRPr sz="1600" b="1">
+              <a:defRPr sz="2400" b="1">
                 <a:solidFill>
                   <a:srgbClr val="FFFFFF"/>
                 </a:solidFill>
@@ -21926,7 +21926,7 @@
               <a:buFontTx/>
               <a:buNone/>
               <a:tabLst/>
-              <a:defRPr sz="1400" b="1">
+              <a:defRPr sz="2400" b="1">
                 <a:solidFill>
                   <a:srgbClr val="166030"/>
                 </a:solidFill>
@@ -21993,7 +21993,7 @@
               <a:buFontTx/>
               <a:buNone/>
               <a:tabLst/>
-              <a:defRPr sz="1150">
+              <a:defRPr sz="2400">
                 <a:solidFill>
                   <a:srgbClr val="1E1E1E"/>
                 </a:solidFill>
@@ -22083,7 +22083,7 @@
               <a:tabLst/>
               <a:defRPr/>
             </a:pPr>
-            <a:endParaRPr kumimoji="0" sz="2000" b="0" i="0" u="none" strike="noStrike" kern="1200" cap="none" spc="0" normalizeH="0" baseline="0" noProof="0">
+            <a:endParaRPr kumimoji="0" sz="2400" b="0" i="0" u="none" strike="noStrike" kern="1200" cap="none" spc="0" normalizeH="0" baseline="0" noProof="0">
               <a:ln>
                 <a:noFill/>
               </a:ln>
@@ -22161,7 +22161,7 @@
               <a:buFontTx/>
               <a:buNone/>
               <a:tabLst/>
-              <a:defRPr sz="1600" b="1">
+              <a:defRPr sz="2400" b="1">
                 <a:solidFill>
                   <a:srgbClr val="FFFFFF"/>
                 </a:solidFill>
@@ -22228,7 +22228,7 @@
               <a:buFontTx/>
               <a:buNone/>
               <a:tabLst/>
-              <a:defRPr sz="1400" b="1">
+              <a:defRPr sz="2400" b="1">
                 <a:solidFill>
                   <a:srgbClr val="166030"/>
                 </a:solidFill>
@@ -22295,7 +22295,7 @@
               <a:buFontTx/>
               <a:buNone/>
               <a:tabLst/>
-              <a:defRPr sz="1150">
+              <a:defRPr sz="2400">
                 <a:solidFill>
                   <a:srgbClr val="1E1E1E"/>
                 </a:solidFill>
@@ -27623,7 +27623,7 @@
               <a:tabLst/>
               <a:defRPr/>
             </a:pPr>
-            <a:endParaRPr kumimoji="0" sz="2000" b="0" i="0" u="none" strike="noStrike" kern="1200" cap="none" spc="0" normalizeH="0" baseline="0" noProof="0">
+            <a:endParaRPr kumimoji="0" sz="2400" b="0" i="0" u="none" strike="noStrike" kern="1200" cap="none" spc="0" normalizeH="0" baseline="0" noProof="0">
               <a:ln>
                 <a:noFill/>
               </a:ln>
@@ -27701,7 +27701,7 @@
               <a:buFontTx/>
               <a:buNone/>
               <a:tabLst/>
-              <a:defRPr sz="1600" b="1">
+              <a:defRPr sz="2400" b="1">
                 <a:solidFill>
                   <a:srgbClr val="FFFFFF"/>
                 </a:solidFill>
@@ -27768,7 +27768,7 @@
               <a:buFontTx/>
               <a:buNone/>
               <a:tabLst/>
-              <a:defRPr sz="1400" b="1">
+              <a:defRPr sz="2400" b="1">
                 <a:solidFill>
                   <a:srgbClr val="166030"/>
                 </a:solidFill>
@@ -27835,7 +27835,7 @@
               <a:buFontTx/>
               <a:buNone/>
               <a:tabLst/>
-              <a:defRPr sz="1150">
+              <a:defRPr sz="2400">
                 <a:solidFill>
                   <a:srgbClr val="1E1E1E"/>
                 </a:solidFill>
@@ -27925,7 +27925,7 @@
               <a:tabLst/>
               <a:defRPr/>
             </a:pPr>
-            <a:endParaRPr kumimoji="0" sz="2000" b="0" i="0" u="none" strike="noStrike" kern="1200" cap="none" spc="0" normalizeH="0" baseline="0" noProof="0">
+            <a:endParaRPr kumimoji="0" sz="2400" b="0" i="0" u="none" strike="noStrike" kern="1200" cap="none" spc="0" normalizeH="0" baseline="0" noProof="0">
               <a:ln>
                 <a:noFill/>
               </a:ln>
@@ -28003,7 +28003,7 @@
               <a:buFontTx/>
               <a:buNone/>
               <a:tabLst/>
-              <a:defRPr sz="1600" b="1">
+              <a:defRPr sz="2400" b="1">
                 <a:solidFill>
                   <a:srgbClr val="FFFFFF"/>
                 </a:solidFill>
@@ -28070,7 +28070,7 @@
               <a:buFontTx/>
               <a:buNone/>
               <a:tabLst/>
-              <a:defRPr sz="1400" b="1">
+              <a:defRPr sz="2400" b="1">
                 <a:solidFill>
                   <a:srgbClr val="166030"/>
                 </a:solidFill>
@@ -28137,7 +28137,7 @@
               <a:buFontTx/>
               <a:buNone/>
               <a:tabLst/>
-              <a:defRPr sz="1150">
+              <a:defRPr sz="2400">
                 <a:solidFill>
                   <a:srgbClr val="1E1E1E"/>
                 </a:solidFill>
@@ -28227,7 +28227,7 @@
               <a:tabLst/>
               <a:defRPr/>
             </a:pPr>
-            <a:endParaRPr kumimoji="0" sz="2000" b="0" i="0" u="none" strike="noStrike" kern="1200" cap="none" spc="0" normalizeH="0" baseline="0" noProof="0">
+            <a:endParaRPr kumimoji="0" sz="2400" b="0" i="0" u="none" strike="noStrike" kern="1200" cap="none" spc="0" normalizeH="0" baseline="0" noProof="0">
               <a:ln>
                 <a:noFill/>
               </a:ln>
@@ -28305,7 +28305,7 @@
               <a:buFontTx/>
               <a:buNone/>
               <a:tabLst/>
-              <a:defRPr sz="1600" b="1">
+              <a:defRPr sz="2400" b="1">
                 <a:solidFill>
                   <a:srgbClr val="FFFFFF"/>
                 </a:solidFill>
@@ -28372,7 +28372,7 @@
               <a:buFontTx/>
               <a:buNone/>
               <a:tabLst/>
-              <a:defRPr sz="1400" b="1">
+              <a:defRPr sz="2400" b="1">
                 <a:solidFill>
                   <a:srgbClr val="166030"/>
                 </a:solidFill>
@@ -28439,7 +28439,7 @@
               <a:buFontTx/>
               <a:buNone/>
               <a:tabLst/>
-              <a:defRPr sz="1150">
+              <a:defRPr sz="2400">
                 <a:solidFill>
                   <a:srgbClr val="1E1E1E"/>
                 </a:solidFill>

</xml_diff>

<commit_message>
Capstone redesign, Our Position in every unit, Unit 6 CEO Performance Scorecard, certificate wording
</commit_message>
<xml_diff>
--- a/Unit decks/Unit 01 - Behavioural Strategy Fundamentals.pptx
+++ b/Unit decks/Unit 01 - Behavioural Strategy Fundamentals.pptx
@@ -9829,6 +9829,12 @@
             <a:r>
               <a:rPr lang="en-GB" dirty="0"/>
               <a:t>Your role is to guide how the work is completed. The Charter is Capstone work and is assessed independently at the capstone. Help groups keep to the three ground rules, choose their scribe, complete all three steps in order and reach Agree from every member.</a:t>
+            </a:r>
+          </a:p>
+          <a:p>
+            <a:r>
+              <a:rPr lang="en-GB" dirty="0"/>
+              <a:t>Close the group work with Our Position. Say: "When your record is complete, write as a group a short summary statement of your team's position from this unit, in the unit's own terms. Every member agrees it with the rest of the record. It closes this unit's section of your Capstone S2R Blueprint and guides the assessors through your work."</a:t>
             </a:r>
           </a:p>
         </p:txBody>
@@ -22335,6 +22341,975 @@
 </file>
 
 <file path=ppt/slides/slide25.xml><?xml version="1.0" encoding="utf-8"?>
+<p:sld xmlns:a="http://schemas.openxmlformats.org/drawingml/2006/main" xmlns:p="http://schemas.openxmlformats.org/presentationml/2006/main" xmlns:r="http://schemas.openxmlformats.org/officeDocument/2006/relationships">
+  <p:cSld>
+    <p:spTree>
+      <p:nvGrpSpPr>
+        <p:cNvPr id="1" name=""/>
+        <p:cNvGrpSpPr/>
+        <p:nvPr/>
+      </p:nvGrpSpPr>
+      <p:grpSpPr/>
+      <p:sp>
+        <p:nvSpPr>
+          <p:cNvPr id="2" name="Text 0">
+            <a:extLst>
+              <a:ext uri="{FF2B5EF4-FFF2-40B4-BE49-F238E27FC236}">
+                <a16:creationId xmlns:a16="http://schemas.microsoft.com/office/drawing/2014/main" id="{A5095F15-E299-D75F-09CE-331DF34C6272}"/>
+              </a:ext>
+            </a:extLst>
+          </p:cNvPr>
+          <p:cNvSpPr txBox="1"/>
+          <p:nvPr/>
+        </p:nvSpPr>
+        <p:spPr>
+          <a:xfrm>
+            <a:off x="548640" y="411480"/>
+            <a:ext cx="11064240" cy="868680"/>
+          </a:xfrm>
+          <a:prstGeom prst="rect">
+            <a:avLst/>
+          </a:prstGeom>
+          <a:noFill/>
+          <a:ln/>
+        </p:spPr>
+        <p:txBody>
+          <a:bodyPr wrap="square" lIns="0" tIns="0" rIns="0" bIns="0" rtlCol="0" anchor="ctr"/>
+          <a:lstStyle/>
+          <a:p>
+            <a:pPr marL="0" indent="0">
+              <a:buNone/>
+            </a:pPr>
+            <a:r>
+              <a:rPr lang="en-US" sz="3600" b="1" dirty="0">
+                <a:solidFill>
+                  <a:srgbClr val="1A5C2C"/>
+                </a:solidFill>
+                <a:latin typeface="Cambria" pitchFamily="34" charset="0"/>
+                <a:ea typeface="Cambria" pitchFamily="34" charset="-122"/>
+                <a:cs typeface="Cambria" pitchFamily="34" charset="-120"/>
+              </a:rPr>
+              <a:t>4.2.2c · Emotional Alignment: The State Of Being</a:t>
+            </a:r>
+            <a:endParaRPr lang="en-US" sz="3600" dirty="0"/>
+          </a:p>
+        </p:txBody>
+      </p:sp>
+      <p:sp>
+        <p:nvSpPr>
+          <p:cNvPr id="55" name="Rounded Rectangle 19">
+            <a:extLst>
+              <a:ext uri="{FF2B5EF4-FFF2-40B4-BE49-F238E27FC236}">
+                <a16:creationId xmlns:a16="http://schemas.microsoft.com/office/drawing/2014/main" id="{A0CA4807-EAC8-DC18-BADF-C8139AC7D9FD}"/>
+              </a:ext>
+            </a:extLst>
+          </p:cNvPr>
+          <p:cNvSpPr/>
+          <p:nvPr/>
+        </p:nvSpPr>
+        <p:spPr>
+          <a:xfrm>
+            <a:off x="548640" y="1371600"/>
+            <a:ext cx="5440680" cy="2560320"/>
+          </a:xfrm>
+          <a:prstGeom prst="roundRect">
+            <a:avLst/>
+          </a:prstGeom>
+          <a:solidFill>
+            <a:srgbClr val="F1F6F2"/>
+          </a:solidFill>
+          <a:ln>
+            <a:solidFill>
+              <a:srgbClr val="D7E1D9"/>
+            </a:solidFill>
+          </a:ln>
+        </p:spPr>
+        <p:style>
+          <a:lnRef idx="1">
+            <a:schemeClr val="accent1"/>
+          </a:lnRef>
+          <a:fillRef idx="3">
+            <a:schemeClr val="accent1"/>
+          </a:fillRef>
+          <a:effectRef idx="2">
+            <a:schemeClr val="accent1"/>
+          </a:effectRef>
+          <a:fontRef idx="minor">
+            <a:schemeClr val="lt1"/>
+          </a:fontRef>
+        </p:style>
+        <p:txBody>
+          <a:bodyPr rtlCol="0" anchor="ctr"/>
+          <a:lstStyle/>
+          <a:p>
+            <a:pPr marL="0" marR="0" lvl="0" indent="0" algn="ctr" defTabSz="457200" rtl="0" eaLnBrk="1" fontAlgn="auto" latinLnBrk="0" hangingPunct="1">
+              <a:lnSpc>
+                <a:spcPct val="100000"/>
+              </a:lnSpc>
+              <a:spcBef>
+                <a:spcPts val="0"/>
+              </a:spcBef>
+              <a:spcAft>
+                <a:spcPts val="0"/>
+              </a:spcAft>
+              <a:buClrTx/>
+              <a:buSzTx/>
+              <a:buFontTx/>
+              <a:buNone/>
+              <a:tabLst/>
+              <a:defRPr/>
+            </a:pPr>
+            <a:endParaRPr kumimoji="0" sz="2400" b="0" i="0" u="none" strike="noStrike" kern="1200" cap="none" spc="0" normalizeH="0" baseline="0" noProof="0">
+              <a:ln>
+                <a:noFill/>
+              </a:ln>
+              <a:solidFill>
+                <a:prstClr val="white"/>
+              </a:solidFill>
+              <a:effectLst/>
+              <a:uLnTx/>
+              <a:uFillTx/>
+              <a:ea typeface="+mn-ea"/>
+              <a:cs typeface="+mn-cs"/>
+            </a:endParaRPr>
+          </a:p>
+        </p:txBody>
+      </p:sp>
+      <p:sp>
+        <p:nvSpPr>
+          <p:cNvPr id="57" name="Oval 56">
+            <a:extLst>
+              <a:ext uri="{FF2B5EF4-FFF2-40B4-BE49-F238E27FC236}">
+                <a16:creationId xmlns:a16="http://schemas.microsoft.com/office/drawing/2014/main" id="{3ACBAC87-D574-07A5-2F02-46C69DCF9BB0}"/>
+              </a:ext>
+            </a:extLst>
+          </p:cNvPr>
+          <p:cNvSpPr/>
+          <p:nvPr/>
+        </p:nvSpPr>
+        <p:spPr>
+          <a:xfrm>
+            <a:off x="731520" y="1572768"/>
+            <a:ext cx="566928" cy="566928"/>
+          </a:xfrm>
+          <a:prstGeom prst="ellipse">
+            <a:avLst/>
+          </a:prstGeom>
+          <a:solidFill>
+            <a:srgbClr val="166030"/>
+          </a:solidFill>
+          <a:ln>
+            <a:solidFill>
+              <a:srgbClr val="166030"/>
+            </a:solidFill>
+          </a:ln>
+        </p:spPr>
+        <p:style>
+          <a:lnRef idx="1">
+            <a:schemeClr val="accent1"/>
+          </a:lnRef>
+          <a:fillRef idx="3">
+            <a:schemeClr val="accent1"/>
+          </a:fillRef>
+          <a:effectRef idx="2">
+            <a:schemeClr val="accent1"/>
+          </a:effectRef>
+          <a:fontRef idx="minor">
+            <a:schemeClr val="lt1"/>
+          </a:fontRef>
+        </p:style>
+        <p:txBody>
+          <a:bodyPr rtlCol="0" anchor="ctr" lIns="0" rIns="0" tIns="0" bIns="0"/>
+          <a:lstStyle/>
+          <a:p>
+            <a:pPr marL="0" marR="0" lvl="0" indent="0" algn="ctr" defTabSz="457200" rtl="0" eaLnBrk="1" fontAlgn="auto" latinLnBrk="0" hangingPunct="1">
+              <a:lnSpc>
+                <a:spcPct val="100000"/>
+              </a:lnSpc>
+              <a:spcBef>
+                <a:spcPts val="0"/>
+              </a:spcBef>
+              <a:spcAft>
+                <a:spcPts val="0"/>
+              </a:spcAft>
+              <a:buClrTx/>
+              <a:buSzTx/>
+              <a:buFontTx/>
+              <a:buNone/>
+              <a:tabLst/>
+              <a:defRPr sz="2400" b="1">
+                <a:solidFill>
+                  <a:srgbClr val="FFFFFF"/>
+                </a:solidFill>
+                <a:latin typeface="Aptos"/>
+              </a:defRPr>
+            </a:pPr>
+            <a:r>
+              <a:rPr kumimoji="0" sz="2400" b="1" i="0" u="none" strike="noStrike" kern="1200" cap="none" spc="0" normalizeH="0" baseline="0" noProof="0">
+                <a:ln>
+                  <a:noFill/>
+                </a:ln>
+                <a:solidFill>
+                  <a:srgbClr val="FFFFFF"/>
+                </a:solidFill>
+                <a:effectLst/>
+                <a:uLnTx/>
+                <a:uFillTx/>
+                <a:ea typeface="+mn-ea"/>
+                <a:cs typeface="+mn-cs"/>
+              </a:rPr>
+              <a:t>5</a:t>
+            </a:r>
+          </a:p>
+        </p:txBody>
+      </p:sp>
+      <p:sp>
+        <p:nvSpPr>
+          <p:cNvPr id="59" name="TextBox 58">
+            <a:extLst>
+              <a:ext uri="{FF2B5EF4-FFF2-40B4-BE49-F238E27FC236}">
+                <a16:creationId xmlns:a16="http://schemas.microsoft.com/office/drawing/2014/main" id="{1A58470D-F74B-2E33-5122-85F4D4E62386}"/>
+              </a:ext>
+            </a:extLst>
+          </p:cNvPr>
+          <p:cNvSpPr txBox="1"/>
+          <p:nvPr/>
+        </p:nvSpPr>
+        <p:spPr>
+          <a:xfrm>
+            <a:off x="1444752" y="1481328"/>
+            <a:ext cx="4389120" cy="777240"/>
+          </a:xfrm>
+          <a:prstGeom prst="rect">
+            <a:avLst/>
+          </a:prstGeom>
+          <a:noFill/>
+        </p:spPr>
+        <p:txBody>
+          <a:bodyPr wrap="square"/>
+          <a:lstStyle/>
+          <a:p>
+            <a:pPr marL="0" marR="0" lvl="0" indent="0" algn="l" defTabSz="457200" rtl="0" eaLnBrk="1" fontAlgn="auto" latinLnBrk="0" hangingPunct="1">
+              <a:lnSpc>
+                <a:spcPct val="100000"/>
+              </a:lnSpc>
+              <a:spcBef>
+                <a:spcPts val="0"/>
+              </a:spcBef>
+              <a:spcAft>
+                <a:spcPts val="0"/>
+              </a:spcAft>
+              <a:buClrTx/>
+              <a:buSzTx/>
+              <a:buFontTx/>
+              <a:buNone/>
+              <a:tabLst/>
+              <a:defRPr sz="2400" b="1">
+                <a:solidFill>
+                  <a:srgbClr val="166030"/>
+                </a:solidFill>
+                <a:latin typeface="Aptos"/>
+              </a:defRPr>
+            </a:pPr>
+            <a:r>
+              <a:rPr kumimoji="0" sz="2400" b="1" i="0" u="none" strike="noStrike" kern="1200" cap="none" spc="0" normalizeH="0" baseline="0" noProof="0">
+                <a:ln>
+                  <a:noFill/>
+                </a:ln>
+                <a:solidFill>
+                  <a:srgbClr val="166030"/>
+                </a:solidFill>
+                <a:effectLst/>
+                <a:uLnTx/>
+                <a:uFillTx/>
+                <a:ea typeface="+mn-ea"/>
+                <a:cs typeface="+mn-cs"/>
+              </a:rPr>
+              <a:t>WATCH — Watch energy &amp; challenge</a:t>
+            </a:r>
+          </a:p>
+        </p:txBody>
+      </p:sp>
+      <p:sp>
+        <p:nvSpPr>
+          <p:cNvPr id="61" name="TextBox 60">
+            <a:extLst>
+              <a:ext uri="{FF2B5EF4-FFF2-40B4-BE49-F238E27FC236}">
+                <a16:creationId xmlns:a16="http://schemas.microsoft.com/office/drawing/2014/main" id="{F42A507B-28D7-FA98-1242-70C640D488CB}"/>
+              </a:ext>
+            </a:extLst>
+          </p:cNvPr>
+          <p:cNvSpPr txBox="1"/>
+          <p:nvPr/>
+        </p:nvSpPr>
+        <p:spPr>
+          <a:xfrm>
+            <a:off x="1444752" y="2286000"/>
+            <a:ext cx="4389120" cy="1572767"/>
+          </a:xfrm>
+          <a:prstGeom prst="rect">
+            <a:avLst/>
+          </a:prstGeom>
+          <a:noFill/>
+        </p:spPr>
+        <p:txBody>
+          <a:bodyPr wrap="square"/>
+          <a:lstStyle/>
+          <a:p>
+            <a:pPr marL="0" marR="0" lvl="0" indent="0" algn="l" defTabSz="457200" rtl="0" eaLnBrk="1" fontAlgn="auto" latinLnBrk="0" hangingPunct="1">
+              <a:lnSpc>
+                <a:spcPct val="100000"/>
+              </a:lnSpc>
+              <a:spcBef>
+                <a:spcPts val="0"/>
+              </a:spcBef>
+              <a:spcAft>
+                <a:spcPts val="0"/>
+              </a:spcAft>
+              <a:buClrTx/>
+              <a:buSzTx/>
+              <a:buFontTx/>
+              <a:buNone/>
+              <a:tabLst/>
+              <a:defRPr sz="2400">
+                <a:solidFill>
+                  <a:srgbClr val="1E1E1E"/>
+                </a:solidFill>
+                <a:latin typeface="Aptos"/>
+              </a:defRPr>
+            </a:pPr>
+            <a:r>
+              <a:rPr kumimoji="0" sz="2400" b="0" i="0" u="none" strike="noStrike" kern="1200" cap="none" spc="0" normalizeH="0" baseline="0" noProof="0">
+                <a:ln>
+                  <a:noFill/>
+                </a:ln>
+                <a:solidFill>
+                  <a:srgbClr val="1E1E1E"/>
+                </a:solidFill>
+                <a:effectLst/>
+                <a:uLnTx/>
+                <a:uFillTx/>
+                <a:ea typeface="+mn-ea"/>
+                <a:cs typeface="+mn-cs"/>
+              </a:rPr>
+              <a:t>Low contribution, slipping deadlines or defensive debate may signal fatigue, anger or frustration.</a:t>
+            </a:r>
+          </a:p>
+        </p:txBody>
+      </p:sp>
+      <p:sp>
+        <p:nvSpPr>
+          <p:cNvPr id="63" name="Rounded Rectangle 23">
+            <a:extLst>
+              <a:ext uri="{FF2B5EF4-FFF2-40B4-BE49-F238E27FC236}">
+                <a16:creationId xmlns:a16="http://schemas.microsoft.com/office/drawing/2014/main" id="{AFC9623B-F15A-927E-EBE7-1A710E206B5E}"/>
+              </a:ext>
+            </a:extLst>
+          </p:cNvPr>
+          <p:cNvSpPr/>
+          <p:nvPr/>
+        </p:nvSpPr>
+        <p:spPr>
+          <a:xfrm>
+            <a:off x="6199632" y="1371600"/>
+            <a:ext cx="5440680" cy="2560320"/>
+          </a:xfrm>
+          <a:prstGeom prst="roundRect">
+            <a:avLst/>
+          </a:prstGeom>
+          <a:solidFill>
+            <a:srgbClr val="F1F6F2"/>
+          </a:solidFill>
+          <a:ln>
+            <a:solidFill>
+              <a:srgbClr val="D7E1D9"/>
+            </a:solidFill>
+          </a:ln>
+        </p:spPr>
+        <p:style>
+          <a:lnRef idx="1">
+            <a:schemeClr val="accent1"/>
+          </a:lnRef>
+          <a:fillRef idx="3">
+            <a:schemeClr val="accent1"/>
+          </a:fillRef>
+          <a:effectRef idx="2">
+            <a:schemeClr val="accent1"/>
+          </a:effectRef>
+          <a:fontRef idx="minor">
+            <a:schemeClr val="lt1"/>
+          </a:fontRef>
+        </p:style>
+        <p:txBody>
+          <a:bodyPr rtlCol="0" anchor="ctr"/>
+          <a:lstStyle/>
+          <a:p>
+            <a:pPr marL="0" marR="0" lvl="0" indent="0" algn="ctr" defTabSz="457200" rtl="0" eaLnBrk="1" fontAlgn="auto" latinLnBrk="0" hangingPunct="1">
+              <a:lnSpc>
+                <a:spcPct val="100000"/>
+              </a:lnSpc>
+              <a:spcBef>
+                <a:spcPts val="0"/>
+              </a:spcBef>
+              <a:spcAft>
+                <a:spcPts val="0"/>
+              </a:spcAft>
+              <a:buClrTx/>
+              <a:buSzTx/>
+              <a:buFontTx/>
+              <a:buNone/>
+              <a:tabLst/>
+              <a:defRPr/>
+            </a:pPr>
+            <a:endParaRPr kumimoji="0" sz="2400" b="0" i="0" u="none" strike="noStrike" kern="1200" cap="none" spc="0" normalizeH="0" baseline="0" noProof="0">
+              <a:ln>
+                <a:noFill/>
+              </a:ln>
+              <a:solidFill>
+                <a:prstClr val="white"/>
+              </a:solidFill>
+              <a:effectLst/>
+              <a:uLnTx/>
+              <a:uFillTx/>
+              <a:ea typeface="+mn-ea"/>
+              <a:cs typeface="+mn-cs"/>
+            </a:endParaRPr>
+          </a:p>
+        </p:txBody>
+      </p:sp>
+      <p:sp>
+        <p:nvSpPr>
+          <p:cNvPr id="65" name="Oval 64">
+            <a:extLst>
+              <a:ext uri="{FF2B5EF4-FFF2-40B4-BE49-F238E27FC236}">
+                <a16:creationId xmlns:a16="http://schemas.microsoft.com/office/drawing/2014/main" id="{BE6C456C-05C6-6E78-2630-261C42F98F81}"/>
+              </a:ext>
+            </a:extLst>
+          </p:cNvPr>
+          <p:cNvSpPr/>
+          <p:nvPr/>
+        </p:nvSpPr>
+        <p:spPr>
+          <a:xfrm>
+            <a:off x="6382512" y="1572768"/>
+            <a:ext cx="566928" cy="566928"/>
+          </a:xfrm>
+          <a:prstGeom prst="ellipse">
+            <a:avLst/>
+          </a:prstGeom>
+          <a:solidFill>
+            <a:srgbClr val="166030"/>
+          </a:solidFill>
+          <a:ln>
+            <a:solidFill>
+              <a:srgbClr val="166030"/>
+            </a:solidFill>
+          </a:ln>
+        </p:spPr>
+        <p:style>
+          <a:lnRef idx="1">
+            <a:schemeClr val="accent1"/>
+          </a:lnRef>
+          <a:fillRef idx="3">
+            <a:schemeClr val="accent1"/>
+          </a:fillRef>
+          <a:effectRef idx="2">
+            <a:schemeClr val="accent1"/>
+          </a:effectRef>
+          <a:fontRef idx="minor">
+            <a:schemeClr val="lt1"/>
+          </a:fontRef>
+        </p:style>
+        <p:txBody>
+          <a:bodyPr rtlCol="0" anchor="ctr" lIns="0" rIns="0" tIns="0" bIns="0"/>
+          <a:lstStyle/>
+          <a:p>
+            <a:pPr marL="0" marR="0" lvl="0" indent="0" algn="ctr" defTabSz="457200" rtl="0" eaLnBrk="1" fontAlgn="auto" latinLnBrk="0" hangingPunct="1">
+              <a:lnSpc>
+                <a:spcPct val="100000"/>
+              </a:lnSpc>
+              <a:spcBef>
+                <a:spcPts val="0"/>
+              </a:spcBef>
+              <a:spcAft>
+                <a:spcPts val="0"/>
+              </a:spcAft>
+              <a:buClrTx/>
+              <a:buSzTx/>
+              <a:buFontTx/>
+              <a:buNone/>
+              <a:tabLst/>
+              <a:defRPr sz="2400" b="1">
+                <a:solidFill>
+                  <a:srgbClr val="FFFFFF"/>
+                </a:solidFill>
+                <a:latin typeface="Aptos"/>
+              </a:defRPr>
+            </a:pPr>
+            <a:r>
+              <a:rPr kumimoji="0" sz="2400" b="1" i="0" u="none" strike="noStrike" kern="1200" cap="none" spc="0" normalizeH="0" baseline="0" noProof="0">
+                <a:ln>
+                  <a:noFill/>
+                </a:ln>
+                <a:solidFill>
+                  <a:srgbClr val="FFFFFF"/>
+                </a:solidFill>
+                <a:effectLst/>
+                <a:uLnTx/>
+                <a:uFillTx/>
+                <a:ea typeface="+mn-ea"/>
+                <a:cs typeface="+mn-cs"/>
+              </a:rPr>
+              <a:t>6</a:t>
+            </a:r>
+          </a:p>
+        </p:txBody>
+      </p:sp>
+      <p:sp>
+        <p:nvSpPr>
+          <p:cNvPr id="67" name="TextBox 66">
+            <a:extLst>
+              <a:ext uri="{FF2B5EF4-FFF2-40B4-BE49-F238E27FC236}">
+                <a16:creationId xmlns:a16="http://schemas.microsoft.com/office/drawing/2014/main" id="{29870982-BF94-6454-B100-5CC9313058A2}"/>
+              </a:ext>
+            </a:extLst>
+          </p:cNvPr>
+          <p:cNvSpPr txBox="1"/>
+          <p:nvPr/>
+        </p:nvSpPr>
+        <p:spPr>
+          <a:xfrm>
+            <a:off x="7095744" y="1481328"/>
+            <a:ext cx="4389120" cy="777240"/>
+          </a:xfrm>
+          <a:prstGeom prst="rect">
+            <a:avLst/>
+          </a:prstGeom>
+          <a:noFill/>
+        </p:spPr>
+        <p:txBody>
+          <a:bodyPr wrap="square"/>
+          <a:lstStyle/>
+          <a:p>
+            <a:pPr marL="0" marR="0" lvl="0" indent="0" algn="l" defTabSz="457200" rtl="0" eaLnBrk="1" fontAlgn="auto" latinLnBrk="0" hangingPunct="1">
+              <a:lnSpc>
+                <a:spcPct val="100000"/>
+              </a:lnSpc>
+              <a:spcBef>
+                <a:spcPts val="0"/>
+              </a:spcBef>
+              <a:spcAft>
+                <a:spcPts val="0"/>
+              </a:spcAft>
+              <a:buClrTx/>
+              <a:buSzTx/>
+              <a:buFontTx/>
+              <a:buNone/>
+              <a:tabLst/>
+              <a:defRPr sz="2400" b="1">
+                <a:solidFill>
+                  <a:srgbClr val="166030"/>
+                </a:solidFill>
+                <a:latin typeface="Aptos"/>
+              </a:defRPr>
+            </a:pPr>
+            <a:r>
+              <a:rPr kumimoji="0" sz="2400" b="1" i="0" u="none" strike="noStrike" kern="1200" cap="none" spc="0" normalizeH="0" baseline="0" noProof="0">
+                <a:ln>
+                  <a:noFill/>
+                </a:ln>
+                <a:solidFill>
+                  <a:srgbClr val="166030"/>
+                </a:solidFill>
+                <a:effectLst/>
+                <a:uLnTx/>
+                <a:uFillTx/>
+                <a:ea typeface="+mn-ea"/>
+                <a:cs typeface="+mn-cs"/>
+              </a:rPr>
+              <a:t>LISTEN — Listen to the language</a:t>
+            </a:r>
+          </a:p>
+        </p:txBody>
+      </p:sp>
+      <p:sp>
+        <p:nvSpPr>
+          <p:cNvPr id="69" name="TextBox 68">
+            <a:extLst>
+              <a:ext uri="{FF2B5EF4-FFF2-40B4-BE49-F238E27FC236}">
+                <a16:creationId xmlns:a16="http://schemas.microsoft.com/office/drawing/2014/main" id="{DA67B124-BCDF-FDAC-9E12-D090FAEC0E02}"/>
+              </a:ext>
+            </a:extLst>
+          </p:cNvPr>
+          <p:cNvSpPr txBox="1"/>
+          <p:nvPr/>
+        </p:nvSpPr>
+        <p:spPr>
+          <a:xfrm>
+            <a:off x="7095744" y="2286000"/>
+            <a:ext cx="4389120" cy="1572767"/>
+          </a:xfrm>
+          <a:prstGeom prst="rect">
+            <a:avLst/>
+          </a:prstGeom>
+          <a:noFill/>
+        </p:spPr>
+        <p:txBody>
+          <a:bodyPr wrap="square"/>
+          <a:lstStyle/>
+          <a:p>
+            <a:pPr marL="0" marR="0" lvl="0" indent="0" algn="l" defTabSz="457200" rtl="0" eaLnBrk="1" fontAlgn="auto" latinLnBrk="0" hangingPunct="1">
+              <a:lnSpc>
+                <a:spcPct val="100000"/>
+              </a:lnSpc>
+              <a:spcBef>
+                <a:spcPts val="0"/>
+              </a:spcBef>
+              <a:spcAft>
+                <a:spcPts val="0"/>
+              </a:spcAft>
+              <a:buClrTx/>
+              <a:buSzTx/>
+              <a:buFontTx/>
+              <a:buNone/>
+              <a:tabLst/>
+              <a:defRPr sz="2400">
+                <a:solidFill>
+                  <a:srgbClr val="1E1E1E"/>
+                </a:solidFill>
+                <a:latin typeface="Aptos"/>
+              </a:defRPr>
+            </a:pPr>
+            <a:r>
+              <a:rPr kumimoji="0" sz="2400" b="0" i="0" u="none" strike="noStrike" kern="1200" cap="none" spc="0" normalizeH="0" baseline="0" noProof="0">
+                <a:ln>
+                  <a:noFill/>
+                </a:ln>
+                <a:solidFill>
+                  <a:srgbClr val="1E1E1E"/>
+                </a:solidFill>
+                <a:effectLst/>
+                <a:uLnTx/>
+                <a:uFillTx/>
+                <a:ea typeface="+mn-ea"/>
+                <a:cs typeface="+mn-cs"/>
+              </a:rPr>
+              <a:t>“What is the point?” · “They have already decided.” · “Just do what they want.”</a:t>
+            </a:r>
+          </a:p>
+        </p:txBody>
+      </p:sp>
+      <p:sp>
+        <p:nvSpPr>
+          <p:cNvPr id="71" name="Rounded Rectangle 27">
+            <a:extLst>
+              <a:ext uri="{FF2B5EF4-FFF2-40B4-BE49-F238E27FC236}">
+                <a16:creationId xmlns:a16="http://schemas.microsoft.com/office/drawing/2014/main" id="{13974345-241F-EDC9-D95E-80DCB737543B}"/>
+              </a:ext>
+            </a:extLst>
+          </p:cNvPr>
+          <p:cNvSpPr/>
+          <p:nvPr/>
+        </p:nvSpPr>
+        <p:spPr>
+          <a:xfrm>
+            <a:off x="548640" y="4069080"/>
+            <a:ext cx="11091672" cy="1828800"/>
+          </a:xfrm>
+          <a:prstGeom prst="roundRect">
+            <a:avLst/>
+          </a:prstGeom>
+          <a:solidFill>
+            <a:srgbClr val="F1F6F2"/>
+          </a:solidFill>
+          <a:ln>
+            <a:solidFill>
+              <a:srgbClr val="D7E1D9"/>
+            </a:solidFill>
+          </a:ln>
+        </p:spPr>
+        <p:style>
+          <a:lnRef idx="1">
+            <a:schemeClr val="accent1"/>
+          </a:lnRef>
+          <a:fillRef idx="3">
+            <a:schemeClr val="accent1"/>
+          </a:fillRef>
+          <a:effectRef idx="2">
+            <a:schemeClr val="accent1"/>
+          </a:effectRef>
+          <a:fontRef idx="minor">
+            <a:schemeClr val="lt1"/>
+          </a:fontRef>
+        </p:style>
+        <p:txBody>
+          <a:bodyPr rtlCol="0" anchor="ctr"/>
+          <a:lstStyle/>
+          <a:p>
+            <a:pPr marL="0" marR="0" lvl="0" indent="0" algn="ctr" defTabSz="457200" rtl="0" eaLnBrk="1" fontAlgn="auto" latinLnBrk="0" hangingPunct="1">
+              <a:lnSpc>
+                <a:spcPct val="100000"/>
+              </a:lnSpc>
+              <a:spcBef>
+                <a:spcPts val="0"/>
+              </a:spcBef>
+              <a:spcAft>
+                <a:spcPts val="0"/>
+              </a:spcAft>
+              <a:buClrTx/>
+              <a:buSzTx/>
+              <a:buFontTx/>
+              <a:buNone/>
+              <a:tabLst/>
+              <a:defRPr/>
+            </a:pPr>
+            <a:endParaRPr kumimoji="0" sz="2400" b="0" i="0" u="none" strike="noStrike" kern="1200" cap="none" spc="0" normalizeH="0" baseline="0" noProof="0">
+              <a:ln>
+                <a:noFill/>
+              </a:ln>
+              <a:solidFill>
+                <a:prstClr val="white"/>
+              </a:solidFill>
+              <a:effectLst/>
+              <a:uLnTx/>
+              <a:uFillTx/>
+              <a:ea typeface="+mn-ea"/>
+              <a:cs typeface="+mn-cs"/>
+            </a:endParaRPr>
+          </a:p>
+        </p:txBody>
+      </p:sp>
+      <p:sp>
+        <p:nvSpPr>
+          <p:cNvPr id="73" name="Oval 72">
+            <a:extLst>
+              <a:ext uri="{FF2B5EF4-FFF2-40B4-BE49-F238E27FC236}">
+                <a16:creationId xmlns:a16="http://schemas.microsoft.com/office/drawing/2014/main" id="{4AB77C67-64EE-303C-4FC0-2749EAE72EAF}"/>
+              </a:ext>
+            </a:extLst>
+          </p:cNvPr>
+          <p:cNvSpPr/>
+          <p:nvPr/>
+        </p:nvSpPr>
+        <p:spPr>
+          <a:xfrm>
+            <a:off x="731520" y="4270248"/>
+            <a:ext cx="566928" cy="566928"/>
+          </a:xfrm>
+          <a:prstGeom prst="ellipse">
+            <a:avLst/>
+          </a:prstGeom>
+          <a:solidFill>
+            <a:srgbClr val="166030"/>
+          </a:solidFill>
+          <a:ln>
+            <a:solidFill>
+              <a:srgbClr val="166030"/>
+            </a:solidFill>
+          </a:ln>
+        </p:spPr>
+        <p:style>
+          <a:lnRef idx="1">
+            <a:schemeClr val="accent1"/>
+          </a:lnRef>
+          <a:fillRef idx="3">
+            <a:schemeClr val="accent1"/>
+          </a:fillRef>
+          <a:effectRef idx="2">
+            <a:schemeClr val="accent1"/>
+          </a:effectRef>
+          <a:fontRef idx="minor">
+            <a:schemeClr val="lt1"/>
+          </a:fontRef>
+        </p:style>
+        <p:txBody>
+          <a:bodyPr rtlCol="0" anchor="ctr" lIns="0" rIns="0" tIns="0" bIns="0"/>
+          <a:lstStyle/>
+          <a:p>
+            <a:pPr marL="0" marR="0" lvl="0" indent="0" algn="ctr" defTabSz="457200" rtl="0" eaLnBrk="1" fontAlgn="auto" latinLnBrk="0" hangingPunct="1">
+              <a:lnSpc>
+                <a:spcPct val="100000"/>
+              </a:lnSpc>
+              <a:spcBef>
+                <a:spcPts val="0"/>
+              </a:spcBef>
+              <a:spcAft>
+                <a:spcPts val="0"/>
+              </a:spcAft>
+              <a:buClrTx/>
+              <a:buSzTx/>
+              <a:buFontTx/>
+              <a:buNone/>
+              <a:tabLst/>
+              <a:defRPr sz="2400" b="1">
+                <a:solidFill>
+                  <a:srgbClr val="FFFFFF"/>
+                </a:solidFill>
+                <a:latin typeface="Aptos"/>
+              </a:defRPr>
+            </a:pPr>
+            <a:r>
+              <a:rPr kumimoji="0" sz="2400" b="1" i="0" u="none" strike="noStrike" kern="1200" cap="none" spc="0" normalizeH="0" baseline="0" noProof="0">
+                <a:ln>
+                  <a:noFill/>
+                </a:ln>
+                <a:solidFill>
+                  <a:srgbClr val="FFFFFF"/>
+                </a:solidFill>
+                <a:effectLst/>
+                <a:uLnTx/>
+                <a:uFillTx/>
+                <a:ea typeface="+mn-ea"/>
+                <a:cs typeface="+mn-cs"/>
+              </a:rPr>
+              <a:t>7</a:t>
+            </a:r>
+          </a:p>
+        </p:txBody>
+      </p:sp>
+      <p:sp>
+        <p:nvSpPr>
+          <p:cNvPr id="75" name="TextBox 74">
+            <a:extLst>
+              <a:ext uri="{FF2B5EF4-FFF2-40B4-BE49-F238E27FC236}">
+                <a16:creationId xmlns:a16="http://schemas.microsoft.com/office/drawing/2014/main" id="{11B3D9FE-0EAD-E72D-45E4-2DE34891ED7B}"/>
+              </a:ext>
+            </a:extLst>
+          </p:cNvPr>
+          <p:cNvSpPr txBox="1"/>
+          <p:nvPr/>
+        </p:nvSpPr>
+        <p:spPr>
+          <a:xfrm>
+            <a:off x="1444752" y="4178808"/>
+            <a:ext cx="10040112" cy="457200"/>
+          </a:xfrm>
+          <a:prstGeom prst="rect">
+            <a:avLst/>
+          </a:prstGeom>
+          <a:noFill/>
+        </p:spPr>
+        <p:txBody>
+          <a:bodyPr wrap="square"/>
+          <a:lstStyle/>
+          <a:p>
+            <a:pPr marL="0" marR="0" lvl="0" indent="0" algn="l" defTabSz="457200" rtl="0" eaLnBrk="1" fontAlgn="auto" latinLnBrk="0" hangingPunct="1">
+              <a:lnSpc>
+                <a:spcPct val="100000"/>
+              </a:lnSpc>
+              <a:spcBef>
+                <a:spcPts val="0"/>
+              </a:spcBef>
+              <a:spcAft>
+                <a:spcPts val="0"/>
+              </a:spcAft>
+              <a:buClrTx/>
+              <a:buSzTx/>
+              <a:buFontTx/>
+              <a:buNone/>
+              <a:tabLst/>
+              <a:defRPr sz="2400" b="1">
+                <a:solidFill>
+                  <a:srgbClr val="166030"/>
+                </a:solidFill>
+                <a:latin typeface="Aptos"/>
+              </a:defRPr>
+            </a:pPr>
+            <a:r>
+              <a:rPr kumimoji="0" sz="2400" b="1" i="0" u="none" strike="noStrike" kern="1200" cap="none" spc="0" normalizeH="0" baseline="0" noProof="0">
+                <a:ln>
+                  <a:noFill/>
+                </a:ln>
+                <a:solidFill>
+                  <a:srgbClr val="166030"/>
+                </a:solidFill>
+                <a:effectLst/>
+                <a:uLnTx/>
+                <a:uFillTx/>
+                <a:ea typeface="+mn-ea"/>
+                <a:cs typeface="+mn-cs"/>
+              </a:rPr>
+              <a:t>CONNECT — Connect emotion to behaviour</a:t>
+            </a:r>
+          </a:p>
+        </p:txBody>
+      </p:sp>
+      <p:sp>
+        <p:nvSpPr>
+          <p:cNvPr id="77" name="TextBox 76">
+            <a:extLst>
+              <a:ext uri="{FF2B5EF4-FFF2-40B4-BE49-F238E27FC236}">
+                <a16:creationId xmlns:a16="http://schemas.microsoft.com/office/drawing/2014/main" id="{E746D57D-9211-B886-18CF-209A86FA0D16}"/>
+              </a:ext>
+            </a:extLst>
+          </p:cNvPr>
+          <p:cNvSpPr txBox="1"/>
+          <p:nvPr/>
+        </p:nvSpPr>
+        <p:spPr>
+          <a:xfrm>
+            <a:off x="1444752" y="4709160"/>
+            <a:ext cx="10040112" cy="1097280"/>
+          </a:xfrm>
+          <a:prstGeom prst="rect">
+            <a:avLst/>
+          </a:prstGeom>
+          <a:noFill/>
+        </p:spPr>
+        <p:txBody>
+          <a:bodyPr wrap="square"/>
+          <a:lstStyle/>
+          <a:p>
+            <a:pPr marL="0" marR="0" lvl="0" indent="0" algn="l" defTabSz="457200" rtl="0" eaLnBrk="1" fontAlgn="auto" latinLnBrk="0" hangingPunct="1">
+              <a:lnSpc>
+                <a:spcPct val="100000"/>
+              </a:lnSpc>
+              <a:spcBef>
+                <a:spcPts val="0"/>
+              </a:spcBef>
+              <a:spcAft>
+                <a:spcPts val="0"/>
+              </a:spcAft>
+              <a:buClrTx/>
+              <a:buSzTx/>
+              <a:buFontTx/>
+              <a:buNone/>
+              <a:tabLst/>
+              <a:defRPr sz="2400">
+                <a:solidFill>
+                  <a:srgbClr val="1E1E1E"/>
+                </a:solidFill>
+                <a:latin typeface="Aptos"/>
+              </a:defRPr>
+            </a:pPr>
+            <a:r>
+              <a:rPr kumimoji="0" sz="2400" b="0" i="0" u="none" strike="noStrike" kern="1200" cap="none" spc="0" normalizeH="0" baseline="0" noProof="0" dirty="0">
+                <a:ln>
+                  <a:noFill/>
+                </a:ln>
+                <a:solidFill>
+                  <a:srgbClr val="1E1E1E"/>
+                </a:solidFill>
+                <a:effectLst/>
+                <a:uLnTx/>
+                <a:uFillTx/>
+                <a:ea typeface="+mn-ea"/>
+                <a:cs typeface="+mn-cs"/>
+              </a:rPr>
+              <a:t>“Where is this emotion showing up—in collaboration, decisions, effort or willingness to speak?”</a:t>
+            </a:r>
+          </a:p>
+        </p:txBody>
+      </p:sp>
+    </p:spTree>
+  </p:cSld>
+  <p:clrMapOvr>
+    <a:masterClrMapping/>
+  </p:clrMapOvr>
+</p:sld>
+</file>
+
+<file path=ppt/slides/slide26.xml><?xml version="1.0" encoding="utf-8"?>
 <p:sld xmlns:a="http://schemas.openxmlformats.org/drawingml/2006/main" xmlns:r="http://schemas.openxmlformats.org/officeDocument/2006/relationships" xmlns:p="http://schemas.openxmlformats.org/presentationml/2006/main">
   <p:cSld name="Slide 26">
     <p:bg>
@@ -23042,7 +24017,7 @@
 </p:sld>
 </file>
 
-<file path=ppt/slides/slide26.xml><?xml version="1.0" encoding="utf-8"?>
+<file path=ppt/slides/slide27.xml><?xml version="1.0" encoding="utf-8"?>
 <p:sld xmlns:a="http://schemas.openxmlformats.org/drawingml/2006/main" xmlns:r="http://schemas.openxmlformats.org/officeDocument/2006/relationships" xmlns:p="http://schemas.openxmlformats.org/presentationml/2006/main">
   <p:cSld>
     <p:spTree>
@@ -23255,7 +24230,7 @@
 </p:sld>
 </file>
 
-<file path=ppt/slides/slide27.xml><?xml version="1.0" encoding="utf-8"?>
+<file path=ppt/slides/slide28.xml><?xml version="1.0" encoding="utf-8"?>
 <p:sld xmlns:a="http://schemas.openxmlformats.org/drawingml/2006/main" xmlns:r="http://schemas.openxmlformats.org/officeDocument/2006/relationships" xmlns:p="http://schemas.openxmlformats.org/presentationml/2006/main">
   <p:cSld name="Slide 27">
     <p:bg>
@@ -23673,7 +24648,7 @@
 </p:sld>
 </file>
 
-<file path=ppt/slides/slide28.xml><?xml version="1.0" encoding="utf-8"?>
+<file path=ppt/slides/slide29.xml><?xml version="1.0" encoding="utf-8"?>
 <p:sld xmlns:a="http://schemas.openxmlformats.org/drawingml/2006/main" xmlns:r="http://schemas.openxmlformats.org/officeDocument/2006/relationships" xmlns:p="http://schemas.openxmlformats.org/presentationml/2006/main">
   <p:cSld name="Slide 28">
     <p:bg>
@@ -23866,655 +24841,6 @@
                 <a:cs typeface="Calibri" pitchFamily="34" charset="-120"/>
               </a:rPr>
               <a:t>At which phase in your current strategy process are you most exposed?</a:t>
-            </a:r>
-            <a:endParaRPr lang="en-US" sz="2400" dirty="0"/>
-          </a:p>
-        </p:txBody>
-      </p:sp>
-    </p:spTree>
-  </p:cSld>
-  <p:clrMapOvr>
-    <a:masterClrMapping/>
-  </p:clrMapOvr>
-</p:sld>
-</file>
-
-<file path=ppt/slides/slide29.xml><?xml version="1.0" encoding="utf-8"?>
-<p:sld xmlns:a="http://schemas.openxmlformats.org/drawingml/2006/main" xmlns:r="http://schemas.openxmlformats.org/officeDocument/2006/relationships" xmlns:p="http://schemas.openxmlformats.org/presentationml/2006/main">
-  <p:cSld name="Slide 29">
-    <p:bg>
-      <p:bgPr>
-        <a:solidFill>
-          <a:srgbClr val="FFFFFF"/>
-        </a:solidFill>
-        <a:effectLst/>
-      </p:bgPr>
-    </p:bg>
-    <p:spTree>
-      <p:nvGrpSpPr>
-        <p:cNvPr id="1" name=""/>
-        <p:cNvGrpSpPr/>
-        <p:nvPr/>
-      </p:nvGrpSpPr>
-      <p:grpSpPr>
-        <a:xfrm>
-          <a:off x="0" y="0"/>
-          <a:ext cx="0" cy="0"/>
-          <a:chOff x="0" y="0"/>
-          <a:chExt cx="0" cy="0"/>
-        </a:xfrm>
-      </p:grpSpPr>
-      <p:sp>
-        <p:nvSpPr>
-          <p:cNvPr id="2" name="Text 0"/>
-          <p:cNvSpPr txBox="1"/>
-          <p:nvPr/>
-        </p:nvSpPr>
-        <p:spPr>
-          <a:xfrm>
-            <a:off x="548640" y="411480"/>
-            <a:ext cx="11064240" cy="868680"/>
-          </a:xfrm>
-          <a:prstGeom prst="rect">
-            <a:avLst/>
-          </a:prstGeom>
-          <a:noFill/>
-          <a:ln/>
-        </p:spPr>
-        <p:txBody>
-          <a:bodyPr wrap="square" lIns="0" tIns="0" rIns="0" bIns="0" rtlCol="0" anchor="ctr"/>
-          <a:lstStyle/>
-          <a:p>
-            <a:pPr marL="0" indent="0">
-              <a:buNone/>
-            </a:pPr>
-            <a:r>
-              <a:rPr lang="en-US" sz="3600" b="1" dirty="0">
-                <a:solidFill>
-                  <a:srgbClr val="1A5C2C"/>
-                </a:solidFill>
-                <a:latin typeface="Cambria" pitchFamily="34" charset="0"/>
-                <a:ea typeface="Cambria" pitchFamily="34" charset="-122"/>
-                <a:cs typeface="Cambria" pitchFamily="34" charset="-120"/>
-              </a:rPr>
-              <a:t>5.1 · The Three Pillars Of Integration</a:t>
-            </a:r>
-            <a:endParaRPr lang="en-US" sz="3600" dirty="0"/>
-          </a:p>
-        </p:txBody>
-      </p:sp>
-      <p:sp>
-        <p:nvSpPr>
-          <p:cNvPr id="3" name="Shape 1"/>
-          <p:cNvSpPr/>
-          <p:nvPr/>
-        </p:nvSpPr>
-        <p:spPr>
-          <a:xfrm>
-            <a:off x="548640" y="1508760"/>
-            <a:ext cx="3514344" cy="3931920"/>
-          </a:xfrm>
-          <a:prstGeom prst="roundRect">
-            <a:avLst>
-              <a:gd name="adj" fmla="val 2602"/>
-            </a:avLst>
-          </a:prstGeom>
-          <a:solidFill>
-            <a:srgbClr val="EEF4EF"/>
-          </a:solidFill>
-          <a:ln w="12700">
-            <a:solidFill>
-              <a:srgbClr val="EEF4EF"/>
-            </a:solidFill>
-            <a:prstDash val="solid"/>
-          </a:ln>
-        </p:spPr>
-        <p:txBody>
-          <a:bodyPr/>
-          <a:lstStyle/>
-          <a:p>
-            <a:endParaRPr lang="en-ZA"/>
-          </a:p>
-        </p:txBody>
-      </p:sp>
-      <p:sp>
-        <p:nvSpPr>
-          <p:cNvPr id="4" name="Shape 2"/>
-          <p:cNvSpPr/>
-          <p:nvPr/>
-        </p:nvSpPr>
-        <p:spPr>
-          <a:xfrm>
-            <a:off x="777240" y="1737360"/>
-            <a:ext cx="640080" cy="640080"/>
-          </a:xfrm>
-          <a:prstGeom prst="ellipse">
-            <a:avLst/>
-          </a:prstGeom>
-          <a:solidFill>
-            <a:srgbClr val="1A5C2C"/>
-          </a:solidFill>
-          <a:ln w="12700">
-            <a:solidFill>
-              <a:srgbClr val="1A5C2C"/>
-            </a:solidFill>
-            <a:prstDash val="solid"/>
-          </a:ln>
-        </p:spPr>
-        <p:txBody>
-          <a:bodyPr/>
-          <a:lstStyle/>
-          <a:p>
-            <a:endParaRPr lang="en-ZA"/>
-          </a:p>
-        </p:txBody>
-      </p:sp>
-      <p:pic>
-        <p:nvPicPr>
-          <p:cNvPr id="5" name="Image 0" descr="preencoded.png"/>
-          <p:cNvPicPr>
-            <a:picLocks noChangeAspect="1"/>
-          </p:cNvPicPr>
-          <p:nvPr/>
-        </p:nvPicPr>
-        <p:blipFill>
-          <a:blip r:embed="rId3"/>
-          <a:stretch>
-            <a:fillRect/>
-          </a:stretch>
-        </p:blipFill>
-        <p:spPr>
-          <a:xfrm>
-            <a:off x="937260" y="1897380"/>
-            <a:ext cx="320040" cy="320040"/>
-          </a:xfrm>
-          <a:prstGeom prst="rect">
-            <a:avLst/>
-          </a:prstGeom>
-        </p:spPr>
-      </p:pic>
-      <p:sp>
-        <p:nvSpPr>
-          <p:cNvPr id="6" name="Text 3"/>
-          <p:cNvSpPr txBox="1"/>
-          <p:nvPr/>
-        </p:nvSpPr>
-        <p:spPr>
-          <a:xfrm>
-            <a:off x="777240" y="2514600"/>
-            <a:ext cx="3057144" cy="923544"/>
-          </a:xfrm>
-          <a:prstGeom prst="rect">
-            <a:avLst/>
-          </a:prstGeom>
-          <a:noFill/>
-          <a:ln/>
-        </p:spPr>
-        <p:txBody>
-          <a:bodyPr wrap="square" lIns="0" tIns="0" rIns="0" bIns="0" rtlCol="0" anchor="t"/>
-          <a:lstStyle/>
-          <a:p>
-            <a:pPr marL="0" indent="0">
-              <a:buNone/>
-            </a:pPr>
-            <a:r>
-              <a:rPr lang="en-US" sz="2600" b="1" dirty="0">
-                <a:solidFill>
-                  <a:srgbClr val="1A5C2C"/>
-                </a:solidFill>
-                <a:latin typeface="Cambria" pitchFamily="34" charset="0"/>
-                <a:ea typeface="Cambria" pitchFamily="34" charset="-122"/>
-                <a:cs typeface="Cambria" pitchFamily="34" charset="-120"/>
-              </a:rPr>
-              <a:t>Cognitive Integration</a:t>
-            </a:r>
-            <a:endParaRPr lang="en-US" sz="2600" dirty="0"/>
-          </a:p>
-        </p:txBody>
-      </p:sp>
-      <p:sp>
-        <p:nvSpPr>
-          <p:cNvPr id="7" name="Text 4"/>
-          <p:cNvSpPr txBox="1"/>
-          <p:nvPr/>
-        </p:nvSpPr>
-        <p:spPr>
-          <a:xfrm>
-            <a:off x="777240" y="3575304"/>
-            <a:ext cx="3057144" cy="1728216"/>
-          </a:xfrm>
-          <a:prstGeom prst="rect">
-            <a:avLst/>
-          </a:prstGeom>
-          <a:noFill/>
-          <a:ln/>
-        </p:spPr>
-        <p:txBody>
-          <a:bodyPr wrap="square" lIns="0" tIns="0" rIns="0" bIns="0" rtlCol="0" anchor="t"/>
-          <a:lstStyle/>
-          <a:p>
-            <a:pPr marL="0" indent="0">
-              <a:buNone/>
-            </a:pPr>
-            <a:r>
-              <a:rPr lang="en-US" sz="2400" dirty="0">
-                <a:solidFill>
-                  <a:srgbClr val="1F2A22"/>
-                </a:solidFill>
-                <a:latin typeface="Calibri" pitchFamily="34" charset="0"/>
-                <a:ea typeface="Calibri" pitchFamily="34" charset="-122"/>
-                <a:cs typeface="Calibri" pitchFamily="34" charset="-120"/>
-              </a:rPr>
-              <a:t>Build a single version of the truth.</a:t>
-            </a:r>
-            <a:endParaRPr lang="en-US" sz="2400" dirty="0"/>
-          </a:p>
-        </p:txBody>
-      </p:sp>
-      <p:sp>
-        <p:nvSpPr>
-          <p:cNvPr id="8" name="Shape 5"/>
-          <p:cNvSpPr/>
-          <p:nvPr/>
-        </p:nvSpPr>
-        <p:spPr>
-          <a:xfrm>
-            <a:off x="4337304" y="1508760"/>
-            <a:ext cx="3514344" cy="3931920"/>
-          </a:xfrm>
-          <a:prstGeom prst="roundRect">
-            <a:avLst>
-              <a:gd name="adj" fmla="val 2602"/>
-            </a:avLst>
-          </a:prstGeom>
-          <a:solidFill>
-            <a:srgbClr val="EEF4EF"/>
-          </a:solidFill>
-          <a:ln w="12700">
-            <a:solidFill>
-              <a:srgbClr val="EEF4EF"/>
-            </a:solidFill>
-            <a:prstDash val="solid"/>
-          </a:ln>
-        </p:spPr>
-        <p:txBody>
-          <a:bodyPr/>
-          <a:lstStyle/>
-          <a:p>
-            <a:endParaRPr lang="en-ZA"/>
-          </a:p>
-        </p:txBody>
-      </p:sp>
-      <p:sp>
-        <p:nvSpPr>
-          <p:cNvPr id="9" name="Shape 6"/>
-          <p:cNvSpPr/>
-          <p:nvPr/>
-        </p:nvSpPr>
-        <p:spPr>
-          <a:xfrm>
-            <a:off x="4565904" y="1737360"/>
-            <a:ext cx="640080" cy="640080"/>
-          </a:xfrm>
-          <a:prstGeom prst="ellipse">
-            <a:avLst/>
-          </a:prstGeom>
-          <a:solidFill>
-            <a:srgbClr val="1A5C2C"/>
-          </a:solidFill>
-          <a:ln w="12700">
-            <a:solidFill>
-              <a:srgbClr val="1A5C2C"/>
-            </a:solidFill>
-            <a:prstDash val="solid"/>
-          </a:ln>
-        </p:spPr>
-        <p:txBody>
-          <a:bodyPr/>
-          <a:lstStyle/>
-          <a:p>
-            <a:endParaRPr lang="en-ZA"/>
-          </a:p>
-        </p:txBody>
-      </p:sp>
-      <p:pic>
-        <p:nvPicPr>
-          <p:cNvPr id="10" name="Image 1" descr="preencoded.png"/>
-          <p:cNvPicPr>
-            <a:picLocks noChangeAspect="1"/>
-          </p:cNvPicPr>
-          <p:nvPr/>
-        </p:nvPicPr>
-        <p:blipFill>
-          <a:blip r:embed="rId4"/>
-          <a:stretch>
-            <a:fillRect/>
-          </a:stretch>
-        </p:blipFill>
-        <p:spPr>
-          <a:xfrm>
-            <a:off x="4725924" y="1897380"/>
-            <a:ext cx="320040" cy="320040"/>
-          </a:xfrm>
-          <a:prstGeom prst="rect">
-            <a:avLst/>
-          </a:prstGeom>
-        </p:spPr>
-      </p:pic>
-      <p:sp>
-        <p:nvSpPr>
-          <p:cNvPr id="11" name="Text 7"/>
-          <p:cNvSpPr txBox="1"/>
-          <p:nvPr/>
-        </p:nvSpPr>
-        <p:spPr>
-          <a:xfrm>
-            <a:off x="4565904" y="2514600"/>
-            <a:ext cx="3057144" cy="923544"/>
-          </a:xfrm>
-          <a:prstGeom prst="rect">
-            <a:avLst/>
-          </a:prstGeom>
-          <a:noFill/>
-          <a:ln/>
-        </p:spPr>
-        <p:txBody>
-          <a:bodyPr wrap="square" lIns="0" tIns="0" rIns="0" bIns="0" rtlCol="0" anchor="t"/>
-          <a:lstStyle/>
-          <a:p>
-            <a:pPr marL="0" indent="0">
-              <a:buNone/>
-            </a:pPr>
-            <a:r>
-              <a:rPr lang="en-US" sz="2600" b="1" dirty="0">
-                <a:solidFill>
-                  <a:srgbClr val="1A5C2C"/>
-                </a:solidFill>
-                <a:latin typeface="Cambria" pitchFamily="34" charset="0"/>
-                <a:ea typeface="Cambria" pitchFamily="34" charset="-122"/>
-                <a:cs typeface="Cambria" pitchFamily="34" charset="-120"/>
-              </a:rPr>
-              <a:t>Behavioural Guardrails</a:t>
-            </a:r>
-            <a:endParaRPr lang="en-US" sz="2600" dirty="0"/>
-          </a:p>
-        </p:txBody>
-      </p:sp>
-      <p:sp>
-        <p:nvSpPr>
-          <p:cNvPr id="12" name="Text 8"/>
-          <p:cNvSpPr txBox="1"/>
-          <p:nvPr/>
-        </p:nvSpPr>
-        <p:spPr>
-          <a:xfrm>
-            <a:off x="4565904" y="3575304"/>
-            <a:ext cx="3057144" cy="1728216"/>
-          </a:xfrm>
-          <a:prstGeom prst="rect">
-            <a:avLst/>
-          </a:prstGeom>
-          <a:noFill/>
-          <a:ln/>
-        </p:spPr>
-        <p:txBody>
-          <a:bodyPr wrap="square" lIns="0" tIns="0" rIns="0" bIns="0" rtlCol="0" anchor="t"/>
-          <a:lstStyle/>
-          <a:p>
-            <a:pPr marL="0" indent="0">
-              <a:buNone/>
-            </a:pPr>
-            <a:r>
-              <a:rPr lang="en-US" sz="2400" dirty="0">
-                <a:solidFill>
-                  <a:srgbClr val="1F2A22"/>
-                </a:solidFill>
-                <a:latin typeface="Calibri" pitchFamily="34" charset="0"/>
-                <a:ea typeface="Calibri" pitchFamily="34" charset="-122"/>
-                <a:cs typeface="Calibri" pitchFamily="34" charset="-120"/>
-              </a:rPr>
-              <a:t>Stop the “loudest voice” winning by default.</a:t>
-            </a:r>
-            <a:endParaRPr lang="en-US" sz="2400" dirty="0"/>
-          </a:p>
-        </p:txBody>
-      </p:sp>
-      <p:sp>
-        <p:nvSpPr>
-          <p:cNvPr id="13" name="Shape 9"/>
-          <p:cNvSpPr/>
-          <p:nvPr/>
-        </p:nvSpPr>
-        <p:spPr>
-          <a:xfrm>
-            <a:off x="8125968" y="1508760"/>
-            <a:ext cx="3514344" cy="3931920"/>
-          </a:xfrm>
-          <a:prstGeom prst="roundRect">
-            <a:avLst>
-              <a:gd name="adj" fmla="val 2602"/>
-            </a:avLst>
-          </a:prstGeom>
-          <a:solidFill>
-            <a:srgbClr val="EEF4EF"/>
-          </a:solidFill>
-          <a:ln w="12700">
-            <a:solidFill>
-              <a:srgbClr val="EEF4EF"/>
-            </a:solidFill>
-            <a:prstDash val="solid"/>
-          </a:ln>
-        </p:spPr>
-        <p:txBody>
-          <a:bodyPr/>
-          <a:lstStyle/>
-          <a:p>
-            <a:endParaRPr lang="en-ZA"/>
-          </a:p>
-        </p:txBody>
-      </p:sp>
-      <p:sp>
-        <p:nvSpPr>
-          <p:cNvPr id="14" name="Shape 10"/>
-          <p:cNvSpPr/>
-          <p:nvPr/>
-        </p:nvSpPr>
-        <p:spPr>
-          <a:xfrm>
-            <a:off x="8354568" y="1737360"/>
-            <a:ext cx="640080" cy="640080"/>
-          </a:xfrm>
-          <a:prstGeom prst="ellipse">
-            <a:avLst/>
-          </a:prstGeom>
-          <a:solidFill>
-            <a:srgbClr val="1A5C2C"/>
-          </a:solidFill>
-          <a:ln w="12700">
-            <a:solidFill>
-              <a:srgbClr val="1A5C2C"/>
-            </a:solidFill>
-            <a:prstDash val="solid"/>
-          </a:ln>
-        </p:spPr>
-        <p:txBody>
-          <a:bodyPr/>
-          <a:lstStyle/>
-          <a:p>
-            <a:endParaRPr lang="en-ZA"/>
-          </a:p>
-        </p:txBody>
-      </p:sp>
-      <p:pic>
-        <p:nvPicPr>
-          <p:cNvPr id="15" name="Image 2" descr="preencoded.png"/>
-          <p:cNvPicPr>
-            <a:picLocks noChangeAspect="1"/>
-          </p:cNvPicPr>
-          <p:nvPr/>
-        </p:nvPicPr>
-        <p:blipFill>
-          <a:blip r:embed="rId5"/>
-          <a:stretch>
-            <a:fillRect/>
-          </a:stretch>
-        </p:blipFill>
-        <p:spPr>
-          <a:xfrm>
-            <a:off x="8514588" y="1897380"/>
-            <a:ext cx="320040" cy="320040"/>
-          </a:xfrm>
-          <a:prstGeom prst="rect">
-            <a:avLst/>
-          </a:prstGeom>
-        </p:spPr>
-      </p:pic>
-      <p:sp>
-        <p:nvSpPr>
-          <p:cNvPr id="16" name="Text 11"/>
-          <p:cNvSpPr txBox="1"/>
-          <p:nvPr/>
-        </p:nvSpPr>
-        <p:spPr>
-          <a:xfrm>
-            <a:off x="8354568" y="2514600"/>
-            <a:ext cx="3057144" cy="923544"/>
-          </a:xfrm>
-          <a:prstGeom prst="rect">
-            <a:avLst/>
-          </a:prstGeom>
-          <a:noFill/>
-          <a:ln/>
-        </p:spPr>
-        <p:txBody>
-          <a:bodyPr wrap="square" lIns="0" tIns="0" rIns="0" bIns="0" rtlCol="0" anchor="t"/>
-          <a:lstStyle/>
-          <a:p>
-            <a:pPr marL="0" indent="0">
-              <a:buNone/>
-            </a:pPr>
-            <a:r>
-              <a:rPr lang="en-US" sz="2600" b="1" dirty="0">
-                <a:solidFill>
-                  <a:srgbClr val="1A5C2C"/>
-                </a:solidFill>
-                <a:latin typeface="Cambria" pitchFamily="34" charset="0"/>
-                <a:ea typeface="Cambria" pitchFamily="34" charset="-122"/>
-                <a:cs typeface="Cambria" pitchFamily="34" charset="-120"/>
-              </a:rPr>
-              <a:t>Emotional Stabilisation</a:t>
-            </a:r>
-            <a:endParaRPr lang="en-US" sz="2600" dirty="0"/>
-          </a:p>
-        </p:txBody>
-      </p:sp>
-      <p:sp>
-        <p:nvSpPr>
-          <p:cNvPr id="17" name="Text 12"/>
-          <p:cNvSpPr txBox="1"/>
-          <p:nvPr/>
-        </p:nvSpPr>
-        <p:spPr>
-          <a:xfrm>
-            <a:off x="8354568" y="3575304"/>
-            <a:ext cx="3057144" cy="1728216"/>
-          </a:xfrm>
-          <a:prstGeom prst="rect">
-            <a:avLst/>
-          </a:prstGeom>
-          <a:noFill/>
-          <a:ln/>
-        </p:spPr>
-        <p:txBody>
-          <a:bodyPr wrap="square" lIns="0" tIns="0" rIns="0" bIns="0" rtlCol="0" anchor="t"/>
-          <a:lstStyle/>
-          <a:p>
-            <a:pPr marL="0" indent="0">
-              <a:buNone/>
-            </a:pPr>
-            <a:r>
-              <a:rPr lang="en-US" sz="2400" dirty="0">
-                <a:solidFill>
-                  <a:srgbClr val="1F2A22"/>
-                </a:solidFill>
-                <a:latin typeface="Calibri" pitchFamily="34" charset="0"/>
-                <a:ea typeface="Calibri" pitchFamily="34" charset="-122"/>
-                <a:cs typeface="Calibri" pitchFamily="34" charset="-120"/>
-              </a:rPr>
-              <a:t>Move the team from defensiveness to curiosity.</a:t>
-            </a:r>
-            <a:endParaRPr lang="en-US" sz="2400" dirty="0"/>
-          </a:p>
-        </p:txBody>
-      </p:sp>
-      <p:sp>
-        <p:nvSpPr>
-          <p:cNvPr id="18" name="Shape 13"/>
-          <p:cNvSpPr/>
-          <p:nvPr/>
-        </p:nvSpPr>
-        <p:spPr>
-          <a:xfrm>
-            <a:off x="548640" y="5623560"/>
-            <a:ext cx="11091672" cy="777240"/>
-          </a:xfrm>
-          <a:prstGeom prst="roundRect">
-            <a:avLst>
-              <a:gd name="adj" fmla="val 11765"/>
-            </a:avLst>
-          </a:prstGeom>
-          <a:solidFill>
-            <a:srgbClr val="0F3B1C"/>
-          </a:solidFill>
-          <a:ln w="12700">
-            <a:solidFill>
-              <a:srgbClr val="0F3B1C"/>
-            </a:solidFill>
-            <a:prstDash val="solid"/>
-          </a:ln>
-        </p:spPr>
-        <p:txBody>
-          <a:bodyPr/>
-          <a:lstStyle/>
-          <a:p>
-            <a:endParaRPr lang="en-ZA"/>
-          </a:p>
-        </p:txBody>
-      </p:sp>
-      <p:sp>
-        <p:nvSpPr>
-          <p:cNvPr id="19" name="Text 14"/>
-          <p:cNvSpPr txBox="1"/>
-          <p:nvPr/>
-        </p:nvSpPr>
-        <p:spPr>
-          <a:xfrm>
-            <a:off x="822960" y="5623560"/>
-            <a:ext cx="10607040" cy="777240"/>
-          </a:xfrm>
-          <a:prstGeom prst="rect">
-            <a:avLst/>
-          </a:prstGeom>
-          <a:noFill/>
-          <a:ln/>
-        </p:spPr>
-        <p:txBody>
-          <a:bodyPr wrap="square" lIns="0" tIns="0" rIns="0" bIns="0" rtlCol="0" anchor="ctr"/>
-          <a:lstStyle/>
-          <a:p>
-            <a:pPr marL="0" indent="0">
-              <a:buNone/>
-            </a:pPr>
-            <a:r>
-              <a:rPr lang="en-US" sz="2400" i="1" dirty="0">
-                <a:solidFill>
-                  <a:srgbClr val="FFFFFF"/>
-                </a:solidFill>
-                <a:latin typeface="Calibri" pitchFamily="34" charset="0"/>
-                <a:ea typeface="Calibri" pitchFamily="34" charset="-122"/>
-                <a:cs typeface="Calibri" pitchFamily="34" charset="-120"/>
-              </a:rPr>
-              <a:t>The pillars reinforce each other.</a:t>
             </a:r>
             <a:endParaRPr lang="en-US" sz="2400" dirty="0"/>
           </a:p>
@@ -25238,6 +25564,655 @@
 
 <file path=ppt/slides/slide30.xml><?xml version="1.0" encoding="utf-8"?>
 <p:sld xmlns:a="http://schemas.openxmlformats.org/drawingml/2006/main" xmlns:r="http://schemas.openxmlformats.org/officeDocument/2006/relationships" xmlns:p="http://schemas.openxmlformats.org/presentationml/2006/main">
+  <p:cSld name="Slide 29">
+    <p:bg>
+      <p:bgPr>
+        <a:solidFill>
+          <a:srgbClr val="FFFFFF"/>
+        </a:solidFill>
+        <a:effectLst/>
+      </p:bgPr>
+    </p:bg>
+    <p:spTree>
+      <p:nvGrpSpPr>
+        <p:cNvPr id="1" name=""/>
+        <p:cNvGrpSpPr/>
+        <p:nvPr/>
+      </p:nvGrpSpPr>
+      <p:grpSpPr>
+        <a:xfrm>
+          <a:off x="0" y="0"/>
+          <a:ext cx="0" cy="0"/>
+          <a:chOff x="0" y="0"/>
+          <a:chExt cx="0" cy="0"/>
+        </a:xfrm>
+      </p:grpSpPr>
+      <p:sp>
+        <p:nvSpPr>
+          <p:cNvPr id="2" name="Text 0"/>
+          <p:cNvSpPr txBox="1"/>
+          <p:nvPr/>
+        </p:nvSpPr>
+        <p:spPr>
+          <a:xfrm>
+            <a:off x="548640" y="411480"/>
+            <a:ext cx="11064240" cy="868680"/>
+          </a:xfrm>
+          <a:prstGeom prst="rect">
+            <a:avLst/>
+          </a:prstGeom>
+          <a:noFill/>
+          <a:ln/>
+        </p:spPr>
+        <p:txBody>
+          <a:bodyPr wrap="square" lIns="0" tIns="0" rIns="0" bIns="0" rtlCol="0" anchor="ctr"/>
+          <a:lstStyle/>
+          <a:p>
+            <a:pPr marL="0" indent="0">
+              <a:buNone/>
+            </a:pPr>
+            <a:r>
+              <a:rPr lang="en-US" sz="3600" b="1" dirty="0">
+                <a:solidFill>
+                  <a:srgbClr val="1A5C2C"/>
+                </a:solidFill>
+                <a:latin typeface="Cambria" pitchFamily="34" charset="0"/>
+                <a:ea typeface="Cambria" pitchFamily="34" charset="-122"/>
+                <a:cs typeface="Cambria" pitchFamily="34" charset="-120"/>
+              </a:rPr>
+              <a:t>5.1 · The Three Pillars Of Integration</a:t>
+            </a:r>
+            <a:endParaRPr lang="en-US" sz="3600" dirty="0"/>
+          </a:p>
+        </p:txBody>
+      </p:sp>
+      <p:sp>
+        <p:nvSpPr>
+          <p:cNvPr id="3" name="Shape 1"/>
+          <p:cNvSpPr/>
+          <p:nvPr/>
+        </p:nvSpPr>
+        <p:spPr>
+          <a:xfrm>
+            <a:off x="548640" y="1508760"/>
+            <a:ext cx="3514344" cy="3931920"/>
+          </a:xfrm>
+          <a:prstGeom prst="roundRect">
+            <a:avLst>
+              <a:gd name="adj" fmla="val 2602"/>
+            </a:avLst>
+          </a:prstGeom>
+          <a:solidFill>
+            <a:srgbClr val="EEF4EF"/>
+          </a:solidFill>
+          <a:ln w="12700">
+            <a:solidFill>
+              <a:srgbClr val="EEF4EF"/>
+            </a:solidFill>
+            <a:prstDash val="solid"/>
+          </a:ln>
+        </p:spPr>
+        <p:txBody>
+          <a:bodyPr/>
+          <a:lstStyle/>
+          <a:p>
+            <a:endParaRPr lang="en-ZA"/>
+          </a:p>
+        </p:txBody>
+      </p:sp>
+      <p:sp>
+        <p:nvSpPr>
+          <p:cNvPr id="4" name="Shape 2"/>
+          <p:cNvSpPr/>
+          <p:nvPr/>
+        </p:nvSpPr>
+        <p:spPr>
+          <a:xfrm>
+            <a:off x="777240" y="1737360"/>
+            <a:ext cx="640080" cy="640080"/>
+          </a:xfrm>
+          <a:prstGeom prst="ellipse">
+            <a:avLst/>
+          </a:prstGeom>
+          <a:solidFill>
+            <a:srgbClr val="1A5C2C"/>
+          </a:solidFill>
+          <a:ln w="12700">
+            <a:solidFill>
+              <a:srgbClr val="1A5C2C"/>
+            </a:solidFill>
+            <a:prstDash val="solid"/>
+          </a:ln>
+        </p:spPr>
+        <p:txBody>
+          <a:bodyPr/>
+          <a:lstStyle/>
+          <a:p>
+            <a:endParaRPr lang="en-ZA"/>
+          </a:p>
+        </p:txBody>
+      </p:sp>
+      <p:pic>
+        <p:nvPicPr>
+          <p:cNvPr id="5" name="Image 0" descr="preencoded.png"/>
+          <p:cNvPicPr>
+            <a:picLocks noChangeAspect="1"/>
+          </p:cNvPicPr>
+          <p:nvPr/>
+        </p:nvPicPr>
+        <p:blipFill>
+          <a:blip r:embed="rId3"/>
+          <a:stretch>
+            <a:fillRect/>
+          </a:stretch>
+        </p:blipFill>
+        <p:spPr>
+          <a:xfrm>
+            <a:off x="937260" y="1897380"/>
+            <a:ext cx="320040" cy="320040"/>
+          </a:xfrm>
+          <a:prstGeom prst="rect">
+            <a:avLst/>
+          </a:prstGeom>
+        </p:spPr>
+      </p:pic>
+      <p:sp>
+        <p:nvSpPr>
+          <p:cNvPr id="6" name="Text 3"/>
+          <p:cNvSpPr txBox="1"/>
+          <p:nvPr/>
+        </p:nvSpPr>
+        <p:spPr>
+          <a:xfrm>
+            <a:off x="777240" y="2514600"/>
+            <a:ext cx="3057144" cy="923544"/>
+          </a:xfrm>
+          <a:prstGeom prst="rect">
+            <a:avLst/>
+          </a:prstGeom>
+          <a:noFill/>
+          <a:ln/>
+        </p:spPr>
+        <p:txBody>
+          <a:bodyPr wrap="square" lIns="0" tIns="0" rIns="0" bIns="0" rtlCol="0" anchor="t"/>
+          <a:lstStyle/>
+          <a:p>
+            <a:pPr marL="0" indent="0">
+              <a:buNone/>
+            </a:pPr>
+            <a:r>
+              <a:rPr lang="en-US" sz="2600" b="1" dirty="0">
+                <a:solidFill>
+                  <a:srgbClr val="1A5C2C"/>
+                </a:solidFill>
+                <a:latin typeface="Cambria" pitchFamily="34" charset="0"/>
+                <a:ea typeface="Cambria" pitchFamily="34" charset="-122"/>
+                <a:cs typeface="Cambria" pitchFamily="34" charset="-120"/>
+              </a:rPr>
+              <a:t>Cognitive Integration</a:t>
+            </a:r>
+            <a:endParaRPr lang="en-US" sz="2600" dirty="0"/>
+          </a:p>
+        </p:txBody>
+      </p:sp>
+      <p:sp>
+        <p:nvSpPr>
+          <p:cNvPr id="7" name="Text 4"/>
+          <p:cNvSpPr txBox="1"/>
+          <p:nvPr/>
+        </p:nvSpPr>
+        <p:spPr>
+          <a:xfrm>
+            <a:off x="777240" y="3575304"/>
+            <a:ext cx="3057144" cy="1728216"/>
+          </a:xfrm>
+          <a:prstGeom prst="rect">
+            <a:avLst/>
+          </a:prstGeom>
+          <a:noFill/>
+          <a:ln/>
+        </p:spPr>
+        <p:txBody>
+          <a:bodyPr wrap="square" lIns="0" tIns="0" rIns="0" bIns="0" rtlCol="0" anchor="t"/>
+          <a:lstStyle/>
+          <a:p>
+            <a:pPr marL="0" indent="0">
+              <a:buNone/>
+            </a:pPr>
+            <a:r>
+              <a:rPr lang="en-US" sz="2400" dirty="0">
+                <a:solidFill>
+                  <a:srgbClr val="1F2A22"/>
+                </a:solidFill>
+                <a:latin typeface="Calibri" pitchFamily="34" charset="0"/>
+                <a:ea typeface="Calibri" pitchFamily="34" charset="-122"/>
+                <a:cs typeface="Calibri" pitchFamily="34" charset="-120"/>
+              </a:rPr>
+              <a:t>Build a single version of the truth.</a:t>
+            </a:r>
+            <a:endParaRPr lang="en-US" sz="2400" dirty="0"/>
+          </a:p>
+        </p:txBody>
+      </p:sp>
+      <p:sp>
+        <p:nvSpPr>
+          <p:cNvPr id="8" name="Shape 5"/>
+          <p:cNvSpPr/>
+          <p:nvPr/>
+        </p:nvSpPr>
+        <p:spPr>
+          <a:xfrm>
+            <a:off x="4337304" y="1508760"/>
+            <a:ext cx="3514344" cy="3931920"/>
+          </a:xfrm>
+          <a:prstGeom prst="roundRect">
+            <a:avLst>
+              <a:gd name="adj" fmla="val 2602"/>
+            </a:avLst>
+          </a:prstGeom>
+          <a:solidFill>
+            <a:srgbClr val="EEF4EF"/>
+          </a:solidFill>
+          <a:ln w="12700">
+            <a:solidFill>
+              <a:srgbClr val="EEF4EF"/>
+            </a:solidFill>
+            <a:prstDash val="solid"/>
+          </a:ln>
+        </p:spPr>
+        <p:txBody>
+          <a:bodyPr/>
+          <a:lstStyle/>
+          <a:p>
+            <a:endParaRPr lang="en-ZA"/>
+          </a:p>
+        </p:txBody>
+      </p:sp>
+      <p:sp>
+        <p:nvSpPr>
+          <p:cNvPr id="9" name="Shape 6"/>
+          <p:cNvSpPr/>
+          <p:nvPr/>
+        </p:nvSpPr>
+        <p:spPr>
+          <a:xfrm>
+            <a:off x="4565904" y="1737360"/>
+            <a:ext cx="640080" cy="640080"/>
+          </a:xfrm>
+          <a:prstGeom prst="ellipse">
+            <a:avLst/>
+          </a:prstGeom>
+          <a:solidFill>
+            <a:srgbClr val="1A5C2C"/>
+          </a:solidFill>
+          <a:ln w="12700">
+            <a:solidFill>
+              <a:srgbClr val="1A5C2C"/>
+            </a:solidFill>
+            <a:prstDash val="solid"/>
+          </a:ln>
+        </p:spPr>
+        <p:txBody>
+          <a:bodyPr/>
+          <a:lstStyle/>
+          <a:p>
+            <a:endParaRPr lang="en-ZA"/>
+          </a:p>
+        </p:txBody>
+      </p:sp>
+      <p:pic>
+        <p:nvPicPr>
+          <p:cNvPr id="10" name="Image 1" descr="preencoded.png"/>
+          <p:cNvPicPr>
+            <a:picLocks noChangeAspect="1"/>
+          </p:cNvPicPr>
+          <p:nvPr/>
+        </p:nvPicPr>
+        <p:blipFill>
+          <a:blip r:embed="rId4"/>
+          <a:stretch>
+            <a:fillRect/>
+          </a:stretch>
+        </p:blipFill>
+        <p:spPr>
+          <a:xfrm>
+            <a:off x="4725924" y="1897380"/>
+            <a:ext cx="320040" cy="320040"/>
+          </a:xfrm>
+          <a:prstGeom prst="rect">
+            <a:avLst/>
+          </a:prstGeom>
+        </p:spPr>
+      </p:pic>
+      <p:sp>
+        <p:nvSpPr>
+          <p:cNvPr id="11" name="Text 7"/>
+          <p:cNvSpPr txBox="1"/>
+          <p:nvPr/>
+        </p:nvSpPr>
+        <p:spPr>
+          <a:xfrm>
+            <a:off x="4565904" y="2514600"/>
+            <a:ext cx="3057144" cy="923544"/>
+          </a:xfrm>
+          <a:prstGeom prst="rect">
+            <a:avLst/>
+          </a:prstGeom>
+          <a:noFill/>
+          <a:ln/>
+        </p:spPr>
+        <p:txBody>
+          <a:bodyPr wrap="square" lIns="0" tIns="0" rIns="0" bIns="0" rtlCol="0" anchor="t"/>
+          <a:lstStyle/>
+          <a:p>
+            <a:pPr marL="0" indent="0">
+              <a:buNone/>
+            </a:pPr>
+            <a:r>
+              <a:rPr lang="en-US" sz="2600" b="1" dirty="0">
+                <a:solidFill>
+                  <a:srgbClr val="1A5C2C"/>
+                </a:solidFill>
+                <a:latin typeface="Cambria" pitchFamily="34" charset="0"/>
+                <a:ea typeface="Cambria" pitchFamily="34" charset="-122"/>
+                <a:cs typeface="Cambria" pitchFamily="34" charset="-120"/>
+              </a:rPr>
+              <a:t>Behavioural Guardrails</a:t>
+            </a:r>
+            <a:endParaRPr lang="en-US" sz="2600" dirty="0"/>
+          </a:p>
+        </p:txBody>
+      </p:sp>
+      <p:sp>
+        <p:nvSpPr>
+          <p:cNvPr id="12" name="Text 8"/>
+          <p:cNvSpPr txBox="1"/>
+          <p:nvPr/>
+        </p:nvSpPr>
+        <p:spPr>
+          <a:xfrm>
+            <a:off x="4565904" y="3575304"/>
+            <a:ext cx="3057144" cy="1728216"/>
+          </a:xfrm>
+          <a:prstGeom prst="rect">
+            <a:avLst/>
+          </a:prstGeom>
+          <a:noFill/>
+          <a:ln/>
+        </p:spPr>
+        <p:txBody>
+          <a:bodyPr wrap="square" lIns="0" tIns="0" rIns="0" bIns="0" rtlCol="0" anchor="t"/>
+          <a:lstStyle/>
+          <a:p>
+            <a:pPr marL="0" indent="0">
+              <a:buNone/>
+            </a:pPr>
+            <a:r>
+              <a:rPr lang="en-US" sz="2400" dirty="0">
+                <a:solidFill>
+                  <a:srgbClr val="1F2A22"/>
+                </a:solidFill>
+                <a:latin typeface="Calibri" pitchFamily="34" charset="0"/>
+                <a:ea typeface="Calibri" pitchFamily="34" charset="-122"/>
+                <a:cs typeface="Calibri" pitchFamily="34" charset="-120"/>
+              </a:rPr>
+              <a:t>Stop the “loudest voice” winning by default.</a:t>
+            </a:r>
+            <a:endParaRPr lang="en-US" sz="2400" dirty="0"/>
+          </a:p>
+        </p:txBody>
+      </p:sp>
+      <p:sp>
+        <p:nvSpPr>
+          <p:cNvPr id="13" name="Shape 9"/>
+          <p:cNvSpPr/>
+          <p:nvPr/>
+        </p:nvSpPr>
+        <p:spPr>
+          <a:xfrm>
+            <a:off x="8125968" y="1508760"/>
+            <a:ext cx="3514344" cy="3931920"/>
+          </a:xfrm>
+          <a:prstGeom prst="roundRect">
+            <a:avLst>
+              <a:gd name="adj" fmla="val 2602"/>
+            </a:avLst>
+          </a:prstGeom>
+          <a:solidFill>
+            <a:srgbClr val="EEF4EF"/>
+          </a:solidFill>
+          <a:ln w="12700">
+            <a:solidFill>
+              <a:srgbClr val="EEF4EF"/>
+            </a:solidFill>
+            <a:prstDash val="solid"/>
+          </a:ln>
+        </p:spPr>
+        <p:txBody>
+          <a:bodyPr/>
+          <a:lstStyle/>
+          <a:p>
+            <a:endParaRPr lang="en-ZA"/>
+          </a:p>
+        </p:txBody>
+      </p:sp>
+      <p:sp>
+        <p:nvSpPr>
+          <p:cNvPr id="14" name="Shape 10"/>
+          <p:cNvSpPr/>
+          <p:nvPr/>
+        </p:nvSpPr>
+        <p:spPr>
+          <a:xfrm>
+            <a:off x="8354568" y="1737360"/>
+            <a:ext cx="640080" cy="640080"/>
+          </a:xfrm>
+          <a:prstGeom prst="ellipse">
+            <a:avLst/>
+          </a:prstGeom>
+          <a:solidFill>
+            <a:srgbClr val="1A5C2C"/>
+          </a:solidFill>
+          <a:ln w="12700">
+            <a:solidFill>
+              <a:srgbClr val="1A5C2C"/>
+            </a:solidFill>
+            <a:prstDash val="solid"/>
+          </a:ln>
+        </p:spPr>
+        <p:txBody>
+          <a:bodyPr/>
+          <a:lstStyle/>
+          <a:p>
+            <a:endParaRPr lang="en-ZA"/>
+          </a:p>
+        </p:txBody>
+      </p:sp>
+      <p:pic>
+        <p:nvPicPr>
+          <p:cNvPr id="15" name="Image 2" descr="preencoded.png"/>
+          <p:cNvPicPr>
+            <a:picLocks noChangeAspect="1"/>
+          </p:cNvPicPr>
+          <p:nvPr/>
+        </p:nvPicPr>
+        <p:blipFill>
+          <a:blip r:embed="rId5"/>
+          <a:stretch>
+            <a:fillRect/>
+          </a:stretch>
+        </p:blipFill>
+        <p:spPr>
+          <a:xfrm>
+            <a:off x="8514588" y="1897380"/>
+            <a:ext cx="320040" cy="320040"/>
+          </a:xfrm>
+          <a:prstGeom prst="rect">
+            <a:avLst/>
+          </a:prstGeom>
+        </p:spPr>
+      </p:pic>
+      <p:sp>
+        <p:nvSpPr>
+          <p:cNvPr id="16" name="Text 11"/>
+          <p:cNvSpPr txBox="1"/>
+          <p:nvPr/>
+        </p:nvSpPr>
+        <p:spPr>
+          <a:xfrm>
+            <a:off x="8354568" y="2514600"/>
+            <a:ext cx="3057144" cy="923544"/>
+          </a:xfrm>
+          <a:prstGeom prst="rect">
+            <a:avLst/>
+          </a:prstGeom>
+          <a:noFill/>
+          <a:ln/>
+        </p:spPr>
+        <p:txBody>
+          <a:bodyPr wrap="square" lIns="0" tIns="0" rIns="0" bIns="0" rtlCol="0" anchor="t"/>
+          <a:lstStyle/>
+          <a:p>
+            <a:pPr marL="0" indent="0">
+              <a:buNone/>
+            </a:pPr>
+            <a:r>
+              <a:rPr lang="en-US" sz="2600" b="1" dirty="0">
+                <a:solidFill>
+                  <a:srgbClr val="1A5C2C"/>
+                </a:solidFill>
+                <a:latin typeface="Cambria" pitchFamily="34" charset="0"/>
+                <a:ea typeface="Cambria" pitchFamily="34" charset="-122"/>
+                <a:cs typeface="Cambria" pitchFamily="34" charset="-120"/>
+              </a:rPr>
+              <a:t>Emotional Stabilisation</a:t>
+            </a:r>
+            <a:endParaRPr lang="en-US" sz="2600" dirty="0"/>
+          </a:p>
+        </p:txBody>
+      </p:sp>
+      <p:sp>
+        <p:nvSpPr>
+          <p:cNvPr id="17" name="Text 12"/>
+          <p:cNvSpPr txBox="1"/>
+          <p:nvPr/>
+        </p:nvSpPr>
+        <p:spPr>
+          <a:xfrm>
+            <a:off x="8354568" y="3575304"/>
+            <a:ext cx="3057144" cy="1728216"/>
+          </a:xfrm>
+          <a:prstGeom prst="rect">
+            <a:avLst/>
+          </a:prstGeom>
+          <a:noFill/>
+          <a:ln/>
+        </p:spPr>
+        <p:txBody>
+          <a:bodyPr wrap="square" lIns="0" tIns="0" rIns="0" bIns="0" rtlCol="0" anchor="t"/>
+          <a:lstStyle/>
+          <a:p>
+            <a:pPr marL="0" indent="0">
+              <a:buNone/>
+            </a:pPr>
+            <a:r>
+              <a:rPr lang="en-US" sz="2400" dirty="0">
+                <a:solidFill>
+                  <a:srgbClr val="1F2A22"/>
+                </a:solidFill>
+                <a:latin typeface="Calibri" pitchFamily="34" charset="0"/>
+                <a:ea typeface="Calibri" pitchFamily="34" charset="-122"/>
+                <a:cs typeface="Calibri" pitchFamily="34" charset="-120"/>
+              </a:rPr>
+              <a:t>Move the team from defensiveness to curiosity.</a:t>
+            </a:r>
+            <a:endParaRPr lang="en-US" sz="2400" dirty="0"/>
+          </a:p>
+        </p:txBody>
+      </p:sp>
+      <p:sp>
+        <p:nvSpPr>
+          <p:cNvPr id="18" name="Shape 13"/>
+          <p:cNvSpPr/>
+          <p:nvPr/>
+        </p:nvSpPr>
+        <p:spPr>
+          <a:xfrm>
+            <a:off x="548640" y="5623560"/>
+            <a:ext cx="11091672" cy="777240"/>
+          </a:xfrm>
+          <a:prstGeom prst="roundRect">
+            <a:avLst>
+              <a:gd name="adj" fmla="val 11765"/>
+            </a:avLst>
+          </a:prstGeom>
+          <a:solidFill>
+            <a:srgbClr val="0F3B1C"/>
+          </a:solidFill>
+          <a:ln w="12700">
+            <a:solidFill>
+              <a:srgbClr val="0F3B1C"/>
+            </a:solidFill>
+            <a:prstDash val="solid"/>
+          </a:ln>
+        </p:spPr>
+        <p:txBody>
+          <a:bodyPr/>
+          <a:lstStyle/>
+          <a:p>
+            <a:endParaRPr lang="en-ZA"/>
+          </a:p>
+        </p:txBody>
+      </p:sp>
+      <p:sp>
+        <p:nvSpPr>
+          <p:cNvPr id="19" name="Text 14"/>
+          <p:cNvSpPr txBox="1"/>
+          <p:nvPr/>
+        </p:nvSpPr>
+        <p:spPr>
+          <a:xfrm>
+            <a:off x="822960" y="5623560"/>
+            <a:ext cx="10607040" cy="777240"/>
+          </a:xfrm>
+          <a:prstGeom prst="rect">
+            <a:avLst/>
+          </a:prstGeom>
+          <a:noFill/>
+          <a:ln/>
+        </p:spPr>
+        <p:txBody>
+          <a:bodyPr wrap="square" lIns="0" tIns="0" rIns="0" bIns="0" rtlCol="0" anchor="ctr"/>
+          <a:lstStyle/>
+          <a:p>
+            <a:pPr marL="0" indent="0">
+              <a:buNone/>
+            </a:pPr>
+            <a:r>
+              <a:rPr lang="en-US" sz="2400" i="1" dirty="0">
+                <a:solidFill>
+                  <a:srgbClr val="FFFFFF"/>
+                </a:solidFill>
+                <a:latin typeface="Calibri" pitchFamily="34" charset="0"/>
+                <a:ea typeface="Calibri" pitchFamily="34" charset="-122"/>
+                <a:cs typeface="Calibri" pitchFamily="34" charset="-120"/>
+              </a:rPr>
+              <a:t>The pillars reinforce each other.</a:t>
+            </a:r>
+            <a:endParaRPr lang="en-US" sz="2400" dirty="0"/>
+          </a:p>
+        </p:txBody>
+      </p:sp>
+    </p:spTree>
+  </p:cSld>
+  <p:clrMapOvr>
+    <a:masterClrMapping/>
+  </p:clrMapOvr>
+</p:sld>
+</file>
+
+<file path=ppt/slides/slide31.xml><?xml version="1.0" encoding="utf-8"?>
+<p:sld xmlns:a="http://schemas.openxmlformats.org/drawingml/2006/main" xmlns:r="http://schemas.openxmlformats.org/officeDocument/2006/relationships" xmlns:p="http://schemas.openxmlformats.org/presentationml/2006/main">
   <p:cSld name="Slide 30">
     <p:bg>
       <p:bgPr>
@@ -25838,7 +26813,7 @@
 </p:sld>
 </file>
 
-<file path=ppt/slides/slide31.xml><?xml version="1.0" encoding="utf-8"?>
+<file path=ppt/slides/slide32.xml><?xml version="1.0" encoding="utf-8"?>
 <p:sld xmlns:a="http://schemas.openxmlformats.org/drawingml/2006/main" xmlns:r="http://schemas.openxmlformats.org/officeDocument/2006/relationships" xmlns:p="http://schemas.openxmlformats.org/presentationml/2006/main">
   <p:cSld name="Slide 31">
     <p:bg>
@@ -26440,7 +27415,7 @@
 </p:sld>
 </file>
 
-<file path=ppt/slides/slide32.xml><?xml version="1.0" encoding="utf-8"?>
+<file path=ppt/slides/slide33.xml><?xml version="1.0" encoding="utf-8"?>
 <p:sld xmlns:a="http://schemas.openxmlformats.org/drawingml/2006/main" xmlns:r="http://schemas.openxmlformats.org/officeDocument/2006/relationships" xmlns:p="http://schemas.openxmlformats.org/presentationml/2006/main">
   <p:cSld>
     <p:spTree>
@@ -26740,7 +27715,7 @@
 </p:sld>
 </file>
 
-<file path=ppt/slides/slide33.xml><?xml version="1.0" encoding="utf-8"?>
+<file path=ppt/slides/slide34.xml><?xml version="1.0" encoding="utf-8"?>
 <p:sld xmlns:a="http://schemas.openxmlformats.org/drawingml/2006/main" xmlns:r="http://schemas.openxmlformats.org/officeDocument/2006/relationships" xmlns:p="http://schemas.openxmlformats.org/presentationml/2006/main">
   <p:cSld name="Slide 32">
     <p:bg>
@@ -27158,7 +28133,7 @@
 </p:sld>
 </file>
 
-<file path=ppt/slides/slide34.xml><?xml version="1.0" encoding="utf-8"?>
+<file path=ppt/slides/slide35.xml><?xml version="1.0" encoding="utf-8"?>
 <p:sld xmlns:a="http://schemas.openxmlformats.org/drawingml/2006/main" xmlns:r="http://schemas.openxmlformats.org/officeDocument/2006/relationships" xmlns:p="http://schemas.openxmlformats.org/presentationml/2006/main">
   <p:cSld>
     <p:spTree>
@@ -27308,7 +28283,7 @@
 </p:sld>
 </file>
 
-<file path=ppt/slides/slide35.xml><?xml version="1.0" encoding="utf-8"?>
+<file path=ppt/slides/slide36.xml><?xml version="1.0" encoding="utf-8"?>
 <p:sld xmlns:a="http://schemas.openxmlformats.org/drawingml/2006/main" xmlns:r="http://schemas.openxmlformats.org/officeDocument/2006/relationships" xmlns:p="http://schemas.openxmlformats.org/presentationml/2006/main">
   <p:cSld name="Slide 40">
     <p:bg>
@@ -27493,975 +28468,6 @@
                 <a:schemeClr val="bg1"/>
               </a:solidFill>
             </a:endParaRPr>
-          </a:p>
-        </p:txBody>
-      </p:sp>
-    </p:spTree>
-  </p:cSld>
-  <p:clrMapOvr>
-    <a:masterClrMapping/>
-  </p:clrMapOvr>
-</p:sld>
-</file>
-
-<file path=ppt/slides/slide36.xml><?xml version="1.0" encoding="utf-8"?>
-<p:sld xmlns:a="http://schemas.openxmlformats.org/drawingml/2006/main" xmlns:p="http://schemas.openxmlformats.org/presentationml/2006/main" xmlns:r="http://schemas.openxmlformats.org/officeDocument/2006/relationships">
-  <p:cSld>
-    <p:spTree>
-      <p:nvGrpSpPr>
-        <p:cNvPr id="1" name=""/>
-        <p:cNvGrpSpPr/>
-        <p:nvPr/>
-      </p:nvGrpSpPr>
-      <p:grpSpPr/>
-      <p:sp>
-        <p:nvSpPr>
-          <p:cNvPr id="2" name="Text 0">
-            <a:extLst>
-              <a:ext uri="{FF2B5EF4-FFF2-40B4-BE49-F238E27FC236}">
-                <a16:creationId xmlns:a16="http://schemas.microsoft.com/office/drawing/2014/main" id="{A5095F15-E299-D75F-09CE-331DF34C6272}"/>
-              </a:ext>
-            </a:extLst>
-          </p:cNvPr>
-          <p:cNvSpPr txBox="1"/>
-          <p:nvPr/>
-        </p:nvSpPr>
-        <p:spPr>
-          <a:xfrm>
-            <a:off x="548640" y="411480"/>
-            <a:ext cx="11064240" cy="868680"/>
-          </a:xfrm>
-          <a:prstGeom prst="rect">
-            <a:avLst/>
-          </a:prstGeom>
-          <a:noFill/>
-          <a:ln/>
-        </p:spPr>
-        <p:txBody>
-          <a:bodyPr wrap="square" lIns="0" tIns="0" rIns="0" bIns="0" rtlCol="0" anchor="ctr"/>
-          <a:lstStyle/>
-          <a:p>
-            <a:pPr marL="0" indent="0">
-              <a:buNone/>
-            </a:pPr>
-            <a:r>
-              <a:rPr lang="en-US" sz="3600" b="1" dirty="0">
-                <a:solidFill>
-                  <a:srgbClr val="1A5C2C"/>
-                </a:solidFill>
-                <a:latin typeface="Cambria" pitchFamily="34" charset="0"/>
-                <a:ea typeface="Cambria" pitchFamily="34" charset="-122"/>
-                <a:cs typeface="Cambria" pitchFamily="34" charset="-120"/>
-              </a:rPr>
-              <a:t>4.2.2c · Emotional Alignment: The State Of Being</a:t>
-            </a:r>
-            <a:endParaRPr lang="en-US" sz="3600" dirty="0"/>
-          </a:p>
-        </p:txBody>
-      </p:sp>
-      <p:sp>
-        <p:nvSpPr>
-          <p:cNvPr id="55" name="Rounded Rectangle 19">
-            <a:extLst>
-              <a:ext uri="{FF2B5EF4-FFF2-40B4-BE49-F238E27FC236}">
-                <a16:creationId xmlns:a16="http://schemas.microsoft.com/office/drawing/2014/main" id="{A0CA4807-EAC8-DC18-BADF-C8139AC7D9FD}"/>
-              </a:ext>
-            </a:extLst>
-          </p:cNvPr>
-          <p:cNvSpPr/>
-          <p:nvPr/>
-        </p:nvSpPr>
-        <p:spPr>
-          <a:xfrm>
-            <a:off x="548640" y="1371600"/>
-            <a:ext cx="5440680" cy="2560320"/>
-          </a:xfrm>
-          <a:prstGeom prst="roundRect">
-            <a:avLst/>
-          </a:prstGeom>
-          <a:solidFill>
-            <a:srgbClr val="F1F6F2"/>
-          </a:solidFill>
-          <a:ln>
-            <a:solidFill>
-              <a:srgbClr val="D7E1D9"/>
-            </a:solidFill>
-          </a:ln>
-        </p:spPr>
-        <p:style>
-          <a:lnRef idx="1">
-            <a:schemeClr val="accent1"/>
-          </a:lnRef>
-          <a:fillRef idx="3">
-            <a:schemeClr val="accent1"/>
-          </a:fillRef>
-          <a:effectRef idx="2">
-            <a:schemeClr val="accent1"/>
-          </a:effectRef>
-          <a:fontRef idx="minor">
-            <a:schemeClr val="lt1"/>
-          </a:fontRef>
-        </p:style>
-        <p:txBody>
-          <a:bodyPr rtlCol="0" anchor="ctr"/>
-          <a:lstStyle/>
-          <a:p>
-            <a:pPr marL="0" marR="0" lvl="0" indent="0" algn="ctr" defTabSz="457200" rtl="0" eaLnBrk="1" fontAlgn="auto" latinLnBrk="0" hangingPunct="1">
-              <a:lnSpc>
-                <a:spcPct val="100000"/>
-              </a:lnSpc>
-              <a:spcBef>
-                <a:spcPts val="0"/>
-              </a:spcBef>
-              <a:spcAft>
-                <a:spcPts val="0"/>
-              </a:spcAft>
-              <a:buClrTx/>
-              <a:buSzTx/>
-              <a:buFontTx/>
-              <a:buNone/>
-              <a:tabLst/>
-              <a:defRPr/>
-            </a:pPr>
-            <a:endParaRPr kumimoji="0" sz="2400" b="0" i="0" u="none" strike="noStrike" kern="1200" cap="none" spc="0" normalizeH="0" baseline="0" noProof="0">
-              <a:ln>
-                <a:noFill/>
-              </a:ln>
-              <a:solidFill>
-                <a:prstClr val="white"/>
-              </a:solidFill>
-              <a:effectLst/>
-              <a:uLnTx/>
-              <a:uFillTx/>
-              <a:ea typeface="+mn-ea"/>
-              <a:cs typeface="+mn-cs"/>
-            </a:endParaRPr>
-          </a:p>
-        </p:txBody>
-      </p:sp>
-      <p:sp>
-        <p:nvSpPr>
-          <p:cNvPr id="57" name="Oval 56">
-            <a:extLst>
-              <a:ext uri="{FF2B5EF4-FFF2-40B4-BE49-F238E27FC236}">
-                <a16:creationId xmlns:a16="http://schemas.microsoft.com/office/drawing/2014/main" id="{3ACBAC87-D574-07A5-2F02-46C69DCF9BB0}"/>
-              </a:ext>
-            </a:extLst>
-          </p:cNvPr>
-          <p:cNvSpPr/>
-          <p:nvPr/>
-        </p:nvSpPr>
-        <p:spPr>
-          <a:xfrm>
-            <a:off x="731520" y="1572768"/>
-            <a:ext cx="566928" cy="566928"/>
-          </a:xfrm>
-          <a:prstGeom prst="ellipse">
-            <a:avLst/>
-          </a:prstGeom>
-          <a:solidFill>
-            <a:srgbClr val="166030"/>
-          </a:solidFill>
-          <a:ln>
-            <a:solidFill>
-              <a:srgbClr val="166030"/>
-            </a:solidFill>
-          </a:ln>
-        </p:spPr>
-        <p:style>
-          <a:lnRef idx="1">
-            <a:schemeClr val="accent1"/>
-          </a:lnRef>
-          <a:fillRef idx="3">
-            <a:schemeClr val="accent1"/>
-          </a:fillRef>
-          <a:effectRef idx="2">
-            <a:schemeClr val="accent1"/>
-          </a:effectRef>
-          <a:fontRef idx="minor">
-            <a:schemeClr val="lt1"/>
-          </a:fontRef>
-        </p:style>
-        <p:txBody>
-          <a:bodyPr rtlCol="0" anchor="ctr" lIns="0" rIns="0" tIns="0" bIns="0"/>
-          <a:lstStyle/>
-          <a:p>
-            <a:pPr marL="0" marR="0" lvl="0" indent="0" algn="ctr" defTabSz="457200" rtl="0" eaLnBrk="1" fontAlgn="auto" latinLnBrk="0" hangingPunct="1">
-              <a:lnSpc>
-                <a:spcPct val="100000"/>
-              </a:lnSpc>
-              <a:spcBef>
-                <a:spcPts val="0"/>
-              </a:spcBef>
-              <a:spcAft>
-                <a:spcPts val="0"/>
-              </a:spcAft>
-              <a:buClrTx/>
-              <a:buSzTx/>
-              <a:buFontTx/>
-              <a:buNone/>
-              <a:tabLst/>
-              <a:defRPr sz="2400" b="1">
-                <a:solidFill>
-                  <a:srgbClr val="FFFFFF"/>
-                </a:solidFill>
-                <a:latin typeface="Aptos"/>
-              </a:defRPr>
-            </a:pPr>
-            <a:r>
-              <a:rPr kumimoji="0" sz="2400" b="1" i="0" u="none" strike="noStrike" kern="1200" cap="none" spc="0" normalizeH="0" baseline="0" noProof="0">
-                <a:ln>
-                  <a:noFill/>
-                </a:ln>
-                <a:solidFill>
-                  <a:srgbClr val="FFFFFF"/>
-                </a:solidFill>
-                <a:effectLst/>
-                <a:uLnTx/>
-                <a:uFillTx/>
-                <a:ea typeface="+mn-ea"/>
-                <a:cs typeface="+mn-cs"/>
-              </a:rPr>
-              <a:t>5</a:t>
-            </a:r>
-          </a:p>
-        </p:txBody>
-      </p:sp>
-      <p:sp>
-        <p:nvSpPr>
-          <p:cNvPr id="59" name="TextBox 58">
-            <a:extLst>
-              <a:ext uri="{FF2B5EF4-FFF2-40B4-BE49-F238E27FC236}">
-                <a16:creationId xmlns:a16="http://schemas.microsoft.com/office/drawing/2014/main" id="{1A58470D-F74B-2E33-5122-85F4D4E62386}"/>
-              </a:ext>
-            </a:extLst>
-          </p:cNvPr>
-          <p:cNvSpPr txBox="1"/>
-          <p:nvPr/>
-        </p:nvSpPr>
-        <p:spPr>
-          <a:xfrm>
-            <a:off x="1444752" y="1481328"/>
-            <a:ext cx="4389120" cy="777240"/>
-          </a:xfrm>
-          <a:prstGeom prst="rect">
-            <a:avLst/>
-          </a:prstGeom>
-          <a:noFill/>
-        </p:spPr>
-        <p:txBody>
-          <a:bodyPr wrap="square"/>
-          <a:lstStyle/>
-          <a:p>
-            <a:pPr marL="0" marR="0" lvl="0" indent="0" algn="l" defTabSz="457200" rtl="0" eaLnBrk="1" fontAlgn="auto" latinLnBrk="0" hangingPunct="1">
-              <a:lnSpc>
-                <a:spcPct val="100000"/>
-              </a:lnSpc>
-              <a:spcBef>
-                <a:spcPts val="0"/>
-              </a:spcBef>
-              <a:spcAft>
-                <a:spcPts val="0"/>
-              </a:spcAft>
-              <a:buClrTx/>
-              <a:buSzTx/>
-              <a:buFontTx/>
-              <a:buNone/>
-              <a:tabLst/>
-              <a:defRPr sz="2400" b="1">
-                <a:solidFill>
-                  <a:srgbClr val="166030"/>
-                </a:solidFill>
-                <a:latin typeface="Aptos"/>
-              </a:defRPr>
-            </a:pPr>
-            <a:r>
-              <a:rPr kumimoji="0" sz="2400" b="1" i="0" u="none" strike="noStrike" kern="1200" cap="none" spc="0" normalizeH="0" baseline="0" noProof="0">
-                <a:ln>
-                  <a:noFill/>
-                </a:ln>
-                <a:solidFill>
-                  <a:srgbClr val="166030"/>
-                </a:solidFill>
-                <a:effectLst/>
-                <a:uLnTx/>
-                <a:uFillTx/>
-                <a:ea typeface="+mn-ea"/>
-                <a:cs typeface="+mn-cs"/>
-              </a:rPr>
-              <a:t>WATCH — Watch energy &amp; challenge</a:t>
-            </a:r>
-          </a:p>
-        </p:txBody>
-      </p:sp>
-      <p:sp>
-        <p:nvSpPr>
-          <p:cNvPr id="61" name="TextBox 60">
-            <a:extLst>
-              <a:ext uri="{FF2B5EF4-FFF2-40B4-BE49-F238E27FC236}">
-                <a16:creationId xmlns:a16="http://schemas.microsoft.com/office/drawing/2014/main" id="{F42A507B-28D7-FA98-1242-70C640D488CB}"/>
-              </a:ext>
-            </a:extLst>
-          </p:cNvPr>
-          <p:cNvSpPr txBox="1"/>
-          <p:nvPr/>
-        </p:nvSpPr>
-        <p:spPr>
-          <a:xfrm>
-            <a:off x="1444752" y="2286000"/>
-            <a:ext cx="4389120" cy="1572767"/>
-          </a:xfrm>
-          <a:prstGeom prst="rect">
-            <a:avLst/>
-          </a:prstGeom>
-          <a:noFill/>
-        </p:spPr>
-        <p:txBody>
-          <a:bodyPr wrap="square"/>
-          <a:lstStyle/>
-          <a:p>
-            <a:pPr marL="0" marR="0" lvl="0" indent="0" algn="l" defTabSz="457200" rtl="0" eaLnBrk="1" fontAlgn="auto" latinLnBrk="0" hangingPunct="1">
-              <a:lnSpc>
-                <a:spcPct val="100000"/>
-              </a:lnSpc>
-              <a:spcBef>
-                <a:spcPts val="0"/>
-              </a:spcBef>
-              <a:spcAft>
-                <a:spcPts val="0"/>
-              </a:spcAft>
-              <a:buClrTx/>
-              <a:buSzTx/>
-              <a:buFontTx/>
-              <a:buNone/>
-              <a:tabLst/>
-              <a:defRPr sz="2400">
-                <a:solidFill>
-                  <a:srgbClr val="1E1E1E"/>
-                </a:solidFill>
-                <a:latin typeface="Aptos"/>
-              </a:defRPr>
-            </a:pPr>
-            <a:r>
-              <a:rPr kumimoji="0" sz="2400" b="0" i="0" u="none" strike="noStrike" kern="1200" cap="none" spc="0" normalizeH="0" baseline="0" noProof="0">
-                <a:ln>
-                  <a:noFill/>
-                </a:ln>
-                <a:solidFill>
-                  <a:srgbClr val="1E1E1E"/>
-                </a:solidFill>
-                <a:effectLst/>
-                <a:uLnTx/>
-                <a:uFillTx/>
-                <a:ea typeface="+mn-ea"/>
-                <a:cs typeface="+mn-cs"/>
-              </a:rPr>
-              <a:t>Low contribution, slipping deadlines or defensive debate may signal fatigue, anger or frustration.</a:t>
-            </a:r>
-          </a:p>
-        </p:txBody>
-      </p:sp>
-      <p:sp>
-        <p:nvSpPr>
-          <p:cNvPr id="63" name="Rounded Rectangle 23">
-            <a:extLst>
-              <a:ext uri="{FF2B5EF4-FFF2-40B4-BE49-F238E27FC236}">
-                <a16:creationId xmlns:a16="http://schemas.microsoft.com/office/drawing/2014/main" id="{AFC9623B-F15A-927E-EBE7-1A710E206B5E}"/>
-              </a:ext>
-            </a:extLst>
-          </p:cNvPr>
-          <p:cNvSpPr/>
-          <p:nvPr/>
-        </p:nvSpPr>
-        <p:spPr>
-          <a:xfrm>
-            <a:off x="6199632" y="1371600"/>
-            <a:ext cx="5440680" cy="2560320"/>
-          </a:xfrm>
-          <a:prstGeom prst="roundRect">
-            <a:avLst/>
-          </a:prstGeom>
-          <a:solidFill>
-            <a:srgbClr val="F1F6F2"/>
-          </a:solidFill>
-          <a:ln>
-            <a:solidFill>
-              <a:srgbClr val="D7E1D9"/>
-            </a:solidFill>
-          </a:ln>
-        </p:spPr>
-        <p:style>
-          <a:lnRef idx="1">
-            <a:schemeClr val="accent1"/>
-          </a:lnRef>
-          <a:fillRef idx="3">
-            <a:schemeClr val="accent1"/>
-          </a:fillRef>
-          <a:effectRef idx="2">
-            <a:schemeClr val="accent1"/>
-          </a:effectRef>
-          <a:fontRef idx="minor">
-            <a:schemeClr val="lt1"/>
-          </a:fontRef>
-        </p:style>
-        <p:txBody>
-          <a:bodyPr rtlCol="0" anchor="ctr"/>
-          <a:lstStyle/>
-          <a:p>
-            <a:pPr marL="0" marR="0" lvl="0" indent="0" algn="ctr" defTabSz="457200" rtl="0" eaLnBrk="1" fontAlgn="auto" latinLnBrk="0" hangingPunct="1">
-              <a:lnSpc>
-                <a:spcPct val="100000"/>
-              </a:lnSpc>
-              <a:spcBef>
-                <a:spcPts val="0"/>
-              </a:spcBef>
-              <a:spcAft>
-                <a:spcPts val="0"/>
-              </a:spcAft>
-              <a:buClrTx/>
-              <a:buSzTx/>
-              <a:buFontTx/>
-              <a:buNone/>
-              <a:tabLst/>
-              <a:defRPr/>
-            </a:pPr>
-            <a:endParaRPr kumimoji="0" sz="2400" b="0" i="0" u="none" strike="noStrike" kern="1200" cap="none" spc="0" normalizeH="0" baseline="0" noProof="0">
-              <a:ln>
-                <a:noFill/>
-              </a:ln>
-              <a:solidFill>
-                <a:prstClr val="white"/>
-              </a:solidFill>
-              <a:effectLst/>
-              <a:uLnTx/>
-              <a:uFillTx/>
-              <a:ea typeface="+mn-ea"/>
-              <a:cs typeface="+mn-cs"/>
-            </a:endParaRPr>
-          </a:p>
-        </p:txBody>
-      </p:sp>
-      <p:sp>
-        <p:nvSpPr>
-          <p:cNvPr id="65" name="Oval 64">
-            <a:extLst>
-              <a:ext uri="{FF2B5EF4-FFF2-40B4-BE49-F238E27FC236}">
-                <a16:creationId xmlns:a16="http://schemas.microsoft.com/office/drawing/2014/main" id="{BE6C456C-05C6-6E78-2630-261C42F98F81}"/>
-              </a:ext>
-            </a:extLst>
-          </p:cNvPr>
-          <p:cNvSpPr/>
-          <p:nvPr/>
-        </p:nvSpPr>
-        <p:spPr>
-          <a:xfrm>
-            <a:off x="6382512" y="1572768"/>
-            <a:ext cx="566928" cy="566928"/>
-          </a:xfrm>
-          <a:prstGeom prst="ellipse">
-            <a:avLst/>
-          </a:prstGeom>
-          <a:solidFill>
-            <a:srgbClr val="166030"/>
-          </a:solidFill>
-          <a:ln>
-            <a:solidFill>
-              <a:srgbClr val="166030"/>
-            </a:solidFill>
-          </a:ln>
-        </p:spPr>
-        <p:style>
-          <a:lnRef idx="1">
-            <a:schemeClr val="accent1"/>
-          </a:lnRef>
-          <a:fillRef idx="3">
-            <a:schemeClr val="accent1"/>
-          </a:fillRef>
-          <a:effectRef idx="2">
-            <a:schemeClr val="accent1"/>
-          </a:effectRef>
-          <a:fontRef idx="minor">
-            <a:schemeClr val="lt1"/>
-          </a:fontRef>
-        </p:style>
-        <p:txBody>
-          <a:bodyPr rtlCol="0" anchor="ctr" lIns="0" rIns="0" tIns="0" bIns="0"/>
-          <a:lstStyle/>
-          <a:p>
-            <a:pPr marL="0" marR="0" lvl="0" indent="0" algn="ctr" defTabSz="457200" rtl="0" eaLnBrk="1" fontAlgn="auto" latinLnBrk="0" hangingPunct="1">
-              <a:lnSpc>
-                <a:spcPct val="100000"/>
-              </a:lnSpc>
-              <a:spcBef>
-                <a:spcPts val="0"/>
-              </a:spcBef>
-              <a:spcAft>
-                <a:spcPts val="0"/>
-              </a:spcAft>
-              <a:buClrTx/>
-              <a:buSzTx/>
-              <a:buFontTx/>
-              <a:buNone/>
-              <a:tabLst/>
-              <a:defRPr sz="2400" b="1">
-                <a:solidFill>
-                  <a:srgbClr val="FFFFFF"/>
-                </a:solidFill>
-                <a:latin typeface="Aptos"/>
-              </a:defRPr>
-            </a:pPr>
-            <a:r>
-              <a:rPr kumimoji="0" sz="2400" b="1" i="0" u="none" strike="noStrike" kern="1200" cap="none" spc="0" normalizeH="0" baseline="0" noProof="0">
-                <a:ln>
-                  <a:noFill/>
-                </a:ln>
-                <a:solidFill>
-                  <a:srgbClr val="FFFFFF"/>
-                </a:solidFill>
-                <a:effectLst/>
-                <a:uLnTx/>
-                <a:uFillTx/>
-                <a:ea typeface="+mn-ea"/>
-                <a:cs typeface="+mn-cs"/>
-              </a:rPr>
-              <a:t>6</a:t>
-            </a:r>
-          </a:p>
-        </p:txBody>
-      </p:sp>
-      <p:sp>
-        <p:nvSpPr>
-          <p:cNvPr id="67" name="TextBox 66">
-            <a:extLst>
-              <a:ext uri="{FF2B5EF4-FFF2-40B4-BE49-F238E27FC236}">
-                <a16:creationId xmlns:a16="http://schemas.microsoft.com/office/drawing/2014/main" id="{29870982-BF94-6454-B100-5CC9313058A2}"/>
-              </a:ext>
-            </a:extLst>
-          </p:cNvPr>
-          <p:cNvSpPr txBox="1"/>
-          <p:nvPr/>
-        </p:nvSpPr>
-        <p:spPr>
-          <a:xfrm>
-            <a:off x="7095744" y="1481328"/>
-            <a:ext cx="4389120" cy="777240"/>
-          </a:xfrm>
-          <a:prstGeom prst="rect">
-            <a:avLst/>
-          </a:prstGeom>
-          <a:noFill/>
-        </p:spPr>
-        <p:txBody>
-          <a:bodyPr wrap="square"/>
-          <a:lstStyle/>
-          <a:p>
-            <a:pPr marL="0" marR="0" lvl="0" indent="0" algn="l" defTabSz="457200" rtl="0" eaLnBrk="1" fontAlgn="auto" latinLnBrk="0" hangingPunct="1">
-              <a:lnSpc>
-                <a:spcPct val="100000"/>
-              </a:lnSpc>
-              <a:spcBef>
-                <a:spcPts val="0"/>
-              </a:spcBef>
-              <a:spcAft>
-                <a:spcPts val="0"/>
-              </a:spcAft>
-              <a:buClrTx/>
-              <a:buSzTx/>
-              <a:buFontTx/>
-              <a:buNone/>
-              <a:tabLst/>
-              <a:defRPr sz="2400" b="1">
-                <a:solidFill>
-                  <a:srgbClr val="166030"/>
-                </a:solidFill>
-                <a:latin typeface="Aptos"/>
-              </a:defRPr>
-            </a:pPr>
-            <a:r>
-              <a:rPr kumimoji="0" sz="2400" b="1" i="0" u="none" strike="noStrike" kern="1200" cap="none" spc="0" normalizeH="0" baseline="0" noProof="0">
-                <a:ln>
-                  <a:noFill/>
-                </a:ln>
-                <a:solidFill>
-                  <a:srgbClr val="166030"/>
-                </a:solidFill>
-                <a:effectLst/>
-                <a:uLnTx/>
-                <a:uFillTx/>
-                <a:ea typeface="+mn-ea"/>
-                <a:cs typeface="+mn-cs"/>
-              </a:rPr>
-              <a:t>LISTEN — Listen to the language</a:t>
-            </a:r>
-          </a:p>
-        </p:txBody>
-      </p:sp>
-      <p:sp>
-        <p:nvSpPr>
-          <p:cNvPr id="69" name="TextBox 68">
-            <a:extLst>
-              <a:ext uri="{FF2B5EF4-FFF2-40B4-BE49-F238E27FC236}">
-                <a16:creationId xmlns:a16="http://schemas.microsoft.com/office/drawing/2014/main" id="{DA67B124-BCDF-FDAC-9E12-D090FAEC0E02}"/>
-              </a:ext>
-            </a:extLst>
-          </p:cNvPr>
-          <p:cNvSpPr txBox="1"/>
-          <p:nvPr/>
-        </p:nvSpPr>
-        <p:spPr>
-          <a:xfrm>
-            <a:off x="7095744" y="2286000"/>
-            <a:ext cx="4389120" cy="1572767"/>
-          </a:xfrm>
-          <a:prstGeom prst="rect">
-            <a:avLst/>
-          </a:prstGeom>
-          <a:noFill/>
-        </p:spPr>
-        <p:txBody>
-          <a:bodyPr wrap="square"/>
-          <a:lstStyle/>
-          <a:p>
-            <a:pPr marL="0" marR="0" lvl="0" indent="0" algn="l" defTabSz="457200" rtl="0" eaLnBrk="1" fontAlgn="auto" latinLnBrk="0" hangingPunct="1">
-              <a:lnSpc>
-                <a:spcPct val="100000"/>
-              </a:lnSpc>
-              <a:spcBef>
-                <a:spcPts val="0"/>
-              </a:spcBef>
-              <a:spcAft>
-                <a:spcPts val="0"/>
-              </a:spcAft>
-              <a:buClrTx/>
-              <a:buSzTx/>
-              <a:buFontTx/>
-              <a:buNone/>
-              <a:tabLst/>
-              <a:defRPr sz="2400">
-                <a:solidFill>
-                  <a:srgbClr val="1E1E1E"/>
-                </a:solidFill>
-                <a:latin typeface="Aptos"/>
-              </a:defRPr>
-            </a:pPr>
-            <a:r>
-              <a:rPr kumimoji="0" sz="2400" b="0" i="0" u="none" strike="noStrike" kern="1200" cap="none" spc="0" normalizeH="0" baseline="0" noProof="0">
-                <a:ln>
-                  <a:noFill/>
-                </a:ln>
-                <a:solidFill>
-                  <a:srgbClr val="1E1E1E"/>
-                </a:solidFill>
-                <a:effectLst/>
-                <a:uLnTx/>
-                <a:uFillTx/>
-                <a:ea typeface="+mn-ea"/>
-                <a:cs typeface="+mn-cs"/>
-              </a:rPr>
-              <a:t>“What is the point?” · “They have already decided.” · “Just do what they want.”</a:t>
-            </a:r>
-          </a:p>
-        </p:txBody>
-      </p:sp>
-      <p:sp>
-        <p:nvSpPr>
-          <p:cNvPr id="71" name="Rounded Rectangle 27">
-            <a:extLst>
-              <a:ext uri="{FF2B5EF4-FFF2-40B4-BE49-F238E27FC236}">
-                <a16:creationId xmlns:a16="http://schemas.microsoft.com/office/drawing/2014/main" id="{13974345-241F-EDC9-D95E-80DCB737543B}"/>
-              </a:ext>
-            </a:extLst>
-          </p:cNvPr>
-          <p:cNvSpPr/>
-          <p:nvPr/>
-        </p:nvSpPr>
-        <p:spPr>
-          <a:xfrm>
-            <a:off x="548640" y="4069080"/>
-            <a:ext cx="11091672" cy="1828800"/>
-          </a:xfrm>
-          <a:prstGeom prst="roundRect">
-            <a:avLst/>
-          </a:prstGeom>
-          <a:solidFill>
-            <a:srgbClr val="F1F6F2"/>
-          </a:solidFill>
-          <a:ln>
-            <a:solidFill>
-              <a:srgbClr val="D7E1D9"/>
-            </a:solidFill>
-          </a:ln>
-        </p:spPr>
-        <p:style>
-          <a:lnRef idx="1">
-            <a:schemeClr val="accent1"/>
-          </a:lnRef>
-          <a:fillRef idx="3">
-            <a:schemeClr val="accent1"/>
-          </a:fillRef>
-          <a:effectRef idx="2">
-            <a:schemeClr val="accent1"/>
-          </a:effectRef>
-          <a:fontRef idx="minor">
-            <a:schemeClr val="lt1"/>
-          </a:fontRef>
-        </p:style>
-        <p:txBody>
-          <a:bodyPr rtlCol="0" anchor="ctr"/>
-          <a:lstStyle/>
-          <a:p>
-            <a:pPr marL="0" marR="0" lvl="0" indent="0" algn="ctr" defTabSz="457200" rtl="0" eaLnBrk="1" fontAlgn="auto" latinLnBrk="0" hangingPunct="1">
-              <a:lnSpc>
-                <a:spcPct val="100000"/>
-              </a:lnSpc>
-              <a:spcBef>
-                <a:spcPts val="0"/>
-              </a:spcBef>
-              <a:spcAft>
-                <a:spcPts val="0"/>
-              </a:spcAft>
-              <a:buClrTx/>
-              <a:buSzTx/>
-              <a:buFontTx/>
-              <a:buNone/>
-              <a:tabLst/>
-              <a:defRPr/>
-            </a:pPr>
-            <a:endParaRPr kumimoji="0" sz="2400" b="0" i="0" u="none" strike="noStrike" kern="1200" cap="none" spc="0" normalizeH="0" baseline="0" noProof="0">
-              <a:ln>
-                <a:noFill/>
-              </a:ln>
-              <a:solidFill>
-                <a:prstClr val="white"/>
-              </a:solidFill>
-              <a:effectLst/>
-              <a:uLnTx/>
-              <a:uFillTx/>
-              <a:ea typeface="+mn-ea"/>
-              <a:cs typeface="+mn-cs"/>
-            </a:endParaRPr>
-          </a:p>
-        </p:txBody>
-      </p:sp>
-      <p:sp>
-        <p:nvSpPr>
-          <p:cNvPr id="73" name="Oval 72">
-            <a:extLst>
-              <a:ext uri="{FF2B5EF4-FFF2-40B4-BE49-F238E27FC236}">
-                <a16:creationId xmlns:a16="http://schemas.microsoft.com/office/drawing/2014/main" id="{4AB77C67-64EE-303C-4FC0-2749EAE72EAF}"/>
-              </a:ext>
-            </a:extLst>
-          </p:cNvPr>
-          <p:cNvSpPr/>
-          <p:nvPr/>
-        </p:nvSpPr>
-        <p:spPr>
-          <a:xfrm>
-            <a:off x="731520" y="4270248"/>
-            <a:ext cx="566928" cy="566928"/>
-          </a:xfrm>
-          <a:prstGeom prst="ellipse">
-            <a:avLst/>
-          </a:prstGeom>
-          <a:solidFill>
-            <a:srgbClr val="166030"/>
-          </a:solidFill>
-          <a:ln>
-            <a:solidFill>
-              <a:srgbClr val="166030"/>
-            </a:solidFill>
-          </a:ln>
-        </p:spPr>
-        <p:style>
-          <a:lnRef idx="1">
-            <a:schemeClr val="accent1"/>
-          </a:lnRef>
-          <a:fillRef idx="3">
-            <a:schemeClr val="accent1"/>
-          </a:fillRef>
-          <a:effectRef idx="2">
-            <a:schemeClr val="accent1"/>
-          </a:effectRef>
-          <a:fontRef idx="minor">
-            <a:schemeClr val="lt1"/>
-          </a:fontRef>
-        </p:style>
-        <p:txBody>
-          <a:bodyPr rtlCol="0" anchor="ctr" lIns="0" rIns="0" tIns="0" bIns="0"/>
-          <a:lstStyle/>
-          <a:p>
-            <a:pPr marL="0" marR="0" lvl="0" indent="0" algn="ctr" defTabSz="457200" rtl="0" eaLnBrk="1" fontAlgn="auto" latinLnBrk="0" hangingPunct="1">
-              <a:lnSpc>
-                <a:spcPct val="100000"/>
-              </a:lnSpc>
-              <a:spcBef>
-                <a:spcPts val="0"/>
-              </a:spcBef>
-              <a:spcAft>
-                <a:spcPts val="0"/>
-              </a:spcAft>
-              <a:buClrTx/>
-              <a:buSzTx/>
-              <a:buFontTx/>
-              <a:buNone/>
-              <a:tabLst/>
-              <a:defRPr sz="2400" b="1">
-                <a:solidFill>
-                  <a:srgbClr val="FFFFFF"/>
-                </a:solidFill>
-                <a:latin typeface="Aptos"/>
-              </a:defRPr>
-            </a:pPr>
-            <a:r>
-              <a:rPr kumimoji="0" sz="2400" b="1" i="0" u="none" strike="noStrike" kern="1200" cap="none" spc="0" normalizeH="0" baseline="0" noProof="0">
-                <a:ln>
-                  <a:noFill/>
-                </a:ln>
-                <a:solidFill>
-                  <a:srgbClr val="FFFFFF"/>
-                </a:solidFill>
-                <a:effectLst/>
-                <a:uLnTx/>
-                <a:uFillTx/>
-                <a:ea typeface="+mn-ea"/>
-                <a:cs typeface="+mn-cs"/>
-              </a:rPr>
-              <a:t>7</a:t>
-            </a:r>
-          </a:p>
-        </p:txBody>
-      </p:sp>
-      <p:sp>
-        <p:nvSpPr>
-          <p:cNvPr id="75" name="TextBox 74">
-            <a:extLst>
-              <a:ext uri="{FF2B5EF4-FFF2-40B4-BE49-F238E27FC236}">
-                <a16:creationId xmlns:a16="http://schemas.microsoft.com/office/drawing/2014/main" id="{11B3D9FE-0EAD-E72D-45E4-2DE34891ED7B}"/>
-              </a:ext>
-            </a:extLst>
-          </p:cNvPr>
-          <p:cNvSpPr txBox="1"/>
-          <p:nvPr/>
-        </p:nvSpPr>
-        <p:spPr>
-          <a:xfrm>
-            <a:off x="1444752" y="4178808"/>
-            <a:ext cx="10040112" cy="457200"/>
-          </a:xfrm>
-          <a:prstGeom prst="rect">
-            <a:avLst/>
-          </a:prstGeom>
-          <a:noFill/>
-        </p:spPr>
-        <p:txBody>
-          <a:bodyPr wrap="square"/>
-          <a:lstStyle/>
-          <a:p>
-            <a:pPr marL="0" marR="0" lvl="0" indent="0" algn="l" defTabSz="457200" rtl="0" eaLnBrk="1" fontAlgn="auto" latinLnBrk="0" hangingPunct="1">
-              <a:lnSpc>
-                <a:spcPct val="100000"/>
-              </a:lnSpc>
-              <a:spcBef>
-                <a:spcPts val="0"/>
-              </a:spcBef>
-              <a:spcAft>
-                <a:spcPts val="0"/>
-              </a:spcAft>
-              <a:buClrTx/>
-              <a:buSzTx/>
-              <a:buFontTx/>
-              <a:buNone/>
-              <a:tabLst/>
-              <a:defRPr sz="2400" b="1">
-                <a:solidFill>
-                  <a:srgbClr val="166030"/>
-                </a:solidFill>
-                <a:latin typeface="Aptos"/>
-              </a:defRPr>
-            </a:pPr>
-            <a:r>
-              <a:rPr kumimoji="0" sz="2400" b="1" i="0" u="none" strike="noStrike" kern="1200" cap="none" spc="0" normalizeH="0" baseline="0" noProof="0">
-                <a:ln>
-                  <a:noFill/>
-                </a:ln>
-                <a:solidFill>
-                  <a:srgbClr val="166030"/>
-                </a:solidFill>
-                <a:effectLst/>
-                <a:uLnTx/>
-                <a:uFillTx/>
-                <a:ea typeface="+mn-ea"/>
-                <a:cs typeface="+mn-cs"/>
-              </a:rPr>
-              <a:t>CONNECT — Connect emotion to behaviour</a:t>
-            </a:r>
-          </a:p>
-        </p:txBody>
-      </p:sp>
-      <p:sp>
-        <p:nvSpPr>
-          <p:cNvPr id="77" name="TextBox 76">
-            <a:extLst>
-              <a:ext uri="{FF2B5EF4-FFF2-40B4-BE49-F238E27FC236}">
-                <a16:creationId xmlns:a16="http://schemas.microsoft.com/office/drawing/2014/main" id="{E746D57D-9211-B886-18CF-209A86FA0D16}"/>
-              </a:ext>
-            </a:extLst>
-          </p:cNvPr>
-          <p:cNvSpPr txBox="1"/>
-          <p:nvPr/>
-        </p:nvSpPr>
-        <p:spPr>
-          <a:xfrm>
-            <a:off x="1444752" y="4709160"/>
-            <a:ext cx="10040112" cy="1097280"/>
-          </a:xfrm>
-          <a:prstGeom prst="rect">
-            <a:avLst/>
-          </a:prstGeom>
-          <a:noFill/>
-        </p:spPr>
-        <p:txBody>
-          <a:bodyPr wrap="square"/>
-          <a:lstStyle/>
-          <a:p>
-            <a:pPr marL="0" marR="0" lvl="0" indent="0" algn="l" defTabSz="457200" rtl="0" eaLnBrk="1" fontAlgn="auto" latinLnBrk="0" hangingPunct="1">
-              <a:lnSpc>
-                <a:spcPct val="100000"/>
-              </a:lnSpc>
-              <a:spcBef>
-                <a:spcPts val="0"/>
-              </a:spcBef>
-              <a:spcAft>
-                <a:spcPts val="0"/>
-              </a:spcAft>
-              <a:buClrTx/>
-              <a:buSzTx/>
-              <a:buFontTx/>
-              <a:buNone/>
-              <a:tabLst/>
-              <a:defRPr sz="2400">
-                <a:solidFill>
-                  <a:srgbClr val="1E1E1E"/>
-                </a:solidFill>
-                <a:latin typeface="Aptos"/>
-              </a:defRPr>
-            </a:pPr>
-            <a:r>
-              <a:rPr kumimoji="0" sz="2400" b="0" i="0" u="none" strike="noStrike" kern="1200" cap="none" spc="0" normalizeH="0" baseline="0" noProof="0" dirty="0">
-                <a:ln>
-                  <a:noFill/>
-                </a:ln>
-                <a:solidFill>
-                  <a:srgbClr val="1E1E1E"/>
-                </a:solidFill>
-                <a:effectLst/>
-                <a:uLnTx/>
-                <a:uFillTx/>
-                <a:ea typeface="+mn-ea"/>
-                <a:cs typeface="+mn-cs"/>
-              </a:rPr>
-              <a:t>“Where is this emotion showing up—in collaboration, decisions, effort or willingness to speak?”</a:t>
-            </a:r>
           </a:p>
         </p:txBody>
       </p:sp>

</xml_diff>